<commit_message>
préparation des données (en cours)
</commit_message>
<xml_diff>
--- a/Presentation.pptx
+++ b/Presentation.pptx
@@ -5,18 +5,19 @@
     <p:sldMasterId id="2147483672" r:id="rId1"/>
   </p:sldMasterIdLst>
   <p:notesMasterIdLst>
-    <p:notesMasterId r:id="rId8"/>
+    <p:notesMasterId r:id="rId9"/>
   </p:notesMasterIdLst>
   <p:handoutMasterIdLst>
-    <p:handoutMasterId r:id="rId9"/>
+    <p:handoutMasterId r:id="rId10"/>
   </p:handoutMasterIdLst>
   <p:sldIdLst>
     <p:sldId id="256" r:id="rId2"/>
     <p:sldId id="262" r:id="rId3"/>
-    <p:sldId id="261" r:id="rId4"/>
-    <p:sldId id="258" r:id="rId5"/>
-    <p:sldId id="259" r:id="rId6"/>
-    <p:sldId id="260" r:id="rId7"/>
+    <p:sldId id="263" r:id="rId4"/>
+    <p:sldId id="261" r:id="rId5"/>
+    <p:sldId id="258" r:id="rId6"/>
+    <p:sldId id="259" r:id="rId7"/>
+    <p:sldId id="260" r:id="rId8"/>
   </p:sldIdLst>
   <p:sldSz cx="12192000" cy="6858000"/>
   <p:notesSz cx="6858000" cy="9144000"/>
@@ -7246,7 +7247,7 @@
             <a:pPr rtl="0"/>
             <a:fld id="{C6B3AB32-59DF-41F1-9618-EDFBF5049629}" type="slidenum">
               <a:rPr lang="fr-FR" smtClean="0"/>
-              <a:t>3</a:t>
+              <a:t>4</a:t>
             </a:fld>
             <a:endParaRPr lang="fr-FR"/>
           </a:p>
@@ -7331,7 +7332,7 @@
             <a:pPr rtl="0"/>
             <a:fld id="{C6B3AB32-59DF-41F1-9618-EDFBF5049629}" type="slidenum">
               <a:rPr lang="fr-FR" smtClean="0"/>
-              <a:t>4</a:t>
+              <a:t>5</a:t>
             </a:fld>
             <a:endParaRPr lang="fr-FR"/>
           </a:p>
@@ -7417,7 +7418,7 @@
             <a:pPr rtl="0"/>
             <a:fld id="{C6B3AB32-59DF-41F1-9618-EDFBF5049629}" type="slidenum">
               <a:rPr lang="fr-FR" smtClean="0"/>
-              <a:t>5</a:t>
+              <a:t>6</a:t>
             </a:fld>
             <a:endParaRPr lang="fr-FR"/>
           </a:p>
@@ -7503,7 +7504,7 @@
             <a:pPr rtl="0"/>
             <a:fld id="{C6B3AB32-59DF-41F1-9618-EDFBF5049629}" type="slidenum">
               <a:rPr lang="fr-FR" smtClean="0"/>
-              <a:t>6</a:t>
+              <a:t>7</a:t>
             </a:fld>
             <a:endParaRPr lang="fr-FR"/>
           </a:p>
@@ -12061,6 +12062,112 @@
 <file path=ppt/slides/slide3.xml><?xml version="1.0" encoding="utf-8"?>
 <p:sld xmlns:a="http://schemas.openxmlformats.org/drawingml/2006/main" xmlns:r="http://schemas.openxmlformats.org/officeDocument/2006/relationships" xmlns:p="http://schemas.openxmlformats.org/presentationml/2006/main">
   <p:cSld>
+    <p:spTree>
+      <p:nvGrpSpPr>
+        <p:cNvPr id="1" name=""/>
+        <p:cNvGrpSpPr/>
+        <p:nvPr/>
+      </p:nvGrpSpPr>
+      <p:grpSpPr>
+        <a:xfrm>
+          <a:off x="0" y="0"/>
+          <a:ext cx="0" cy="0"/>
+          <a:chOff x="0" y="0"/>
+          <a:chExt cx="0" cy="0"/>
+        </a:xfrm>
+      </p:grpSpPr>
+      <p:sp>
+        <p:nvSpPr>
+          <p:cNvPr id="2" name="Titre 1">
+            <a:extLst>
+              <a:ext uri="{FF2B5EF4-FFF2-40B4-BE49-F238E27FC236}">
+                <a16:creationId xmlns:a16="http://schemas.microsoft.com/office/drawing/2014/main" id="{183C07D0-0DE7-7EEF-51B0-721C25DAEA84}"/>
+              </a:ext>
+            </a:extLst>
+          </p:cNvPr>
+          <p:cNvSpPr>
+            <a:spLocks noGrp="1"/>
+          </p:cNvSpPr>
+          <p:nvPr>
+            <p:ph type="title"/>
+          </p:nvPr>
+        </p:nvSpPr>
+        <p:spPr/>
+        <p:txBody>
+          <a:bodyPr/>
+          <a:lstStyle/>
+          <a:p>
+            <a:r>
+              <a:rPr lang="fr-FR" dirty="0"/>
+              <a:t>Nettoyage des données</a:t>
+            </a:r>
+          </a:p>
+        </p:txBody>
+      </p:sp>
+      <p:sp>
+        <p:nvSpPr>
+          <p:cNvPr id="3" name="Espace réservé du contenu 2">
+            <a:extLst>
+              <a:ext uri="{FF2B5EF4-FFF2-40B4-BE49-F238E27FC236}">
+                <a16:creationId xmlns:a16="http://schemas.microsoft.com/office/drawing/2014/main" id="{A7520F13-1BC0-00E5-A8FA-348EA6DCC45F}"/>
+              </a:ext>
+            </a:extLst>
+          </p:cNvPr>
+          <p:cNvSpPr>
+            <a:spLocks noGrp="1"/>
+          </p:cNvSpPr>
+          <p:nvPr>
+            <p:ph idx="1"/>
+          </p:nvPr>
+        </p:nvSpPr>
+        <p:spPr/>
+        <p:txBody>
+          <a:bodyPr/>
+          <a:lstStyle/>
+          <a:p>
+            <a:r>
+              <a:rPr lang="fr-FR" dirty="0" err="1"/>
+              <a:t>nombre_heures_travailless</a:t>
+            </a:r>
+            <a:r>
+              <a:rPr lang="fr-FR" dirty="0"/>
+              <a:t> n’est pas exploitable car toujours égale à 80</a:t>
+            </a:r>
+          </a:p>
+          <a:p>
+            <a:r>
+              <a:rPr lang="fr-FR" dirty="0" err="1"/>
+              <a:t>nombre_employee_sous_responsabilite</a:t>
+            </a:r>
+            <a:r>
+              <a:rPr lang="fr-FR" dirty="0"/>
+              <a:t> n’est pas exploitable car toujours égale à 1</a:t>
+            </a:r>
+          </a:p>
+          <a:p>
+            <a:endParaRPr lang="fr-FR" dirty="0"/>
+          </a:p>
+          <a:p>
+            <a:endParaRPr lang="fr-FR" dirty="0"/>
+          </a:p>
+        </p:txBody>
+      </p:sp>
+    </p:spTree>
+    <p:extLst>
+      <p:ext uri="{BB962C8B-B14F-4D97-AF65-F5344CB8AC3E}">
+        <p14:creationId xmlns:p14="http://schemas.microsoft.com/office/powerpoint/2010/main" val="1521905127"/>
+      </p:ext>
+    </p:extLst>
+  </p:cSld>
+  <p:clrMapOvr>
+    <a:masterClrMapping/>
+  </p:clrMapOvr>
+</p:sld>
+</file>
+
+<file path=ppt/slides/slide4.xml><?xml version="1.0" encoding="utf-8"?>
+<p:sld xmlns:a="http://schemas.openxmlformats.org/drawingml/2006/main" xmlns:r="http://schemas.openxmlformats.org/officeDocument/2006/relationships" xmlns:p="http://schemas.openxmlformats.org/presentationml/2006/main">
+  <p:cSld>
     <p:bg>
       <p:bgPr>
         <a:solidFill>
@@ -12281,7 +12388,7 @@
 </p:sld>
 </file>
 
-<file path=ppt/slides/slide4.xml><?xml version="1.0" encoding="utf-8"?>
+<file path=ppt/slides/slide5.xml><?xml version="1.0" encoding="utf-8"?>
 <p:sld xmlns:a="http://schemas.openxmlformats.org/drawingml/2006/main" xmlns:r="http://schemas.openxmlformats.org/officeDocument/2006/relationships" xmlns:p="http://schemas.openxmlformats.org/presentationml/2006/main">
   <p:cSld>
     <p:spTree>
@@ -12404,7 +12511,7 @@
 </p:sld>
 </file>
 
-<file path=ppt/slides/slide5.xml><?xml version="1.0" encoding="utf-8"?>
+<file path=ppt/slides/slide6.xml><?xml version="1.0" encoding="utf-8"?>
 <p:sld xmlns:a="http://schemas.openxmlformats.org/drawingml/2006/main" xmlns:r="http://schemas.openxmlformats.org/officeDocument/2006/relationships" xmlns:p="http://schemas.openxmlformats.org/presentationml/2006/main">
   <p:cSld>
     <p:bg>
@@ -12800,7 +12907,7 @@
 </p:sld>
 </file>
 
-<file path=ppt/slides/slide6.xml><?xml version="1.0" encoding="utf-8"?>
+<file path=ppt/slides/slide7.xml><?xml version="1.0" encoding="utf-8"?>
 <p:sld xmlns:a="http://schemas.openxmlformats.org/drawingml/2006/main" xmlns:r="http://schemas.openxmlformats.org/officeDocument/2006/relationships" xmlns:p="http://schemas.openxmlformats.org/presentationml/2006/main">
   <p:cSld>
     <p:bg>

</xml_diff>

<commit_message>
Nettoyage et conversion des données dans un fichier optimisé 'parquet'
</commit_message>
<xml_diff>
--- a/Presentation.pptx
+++ b/Presentation.pptx
@@ -5,19 +5,23 @@
     <p:sldMasterId id="2147483672" r:id="rId1"/>
   </p:sldMasterIdLst>
   <p:notesMasterIdLst>
-    <p:notesMasterId r:id="rId9"/>
+    <p:notesMasterId r:id="rId13"/>
   </p:notesMasterIdLst>
   <p:handoutMasterIdLst>
-    <p:handoutMasterId r:id="rId10"/>
+    <p:handoutMasterId r:id="rId14"/>
   </p:handoutMasterIdLst>
   <p:sldIdLst>
     <p:sldId id="256" r:id="rId2"/>
     <p:sldId id="262" r:id="rId3"/>
     <p:sldId id="263" r:id="rId4"/>
-    <p:sldId id="261" r:id="rId5"/>
-    <p:sldId id="258" r:id="rId6"/>
-    <p:sldId id="259" r:id="rId7"/>
-    <p:sldId id="260" r:id="rId8"/>
+    <p:sldId id="264" r:id="rId5"/>
+    <p:sldId id="265" r:id="rId6"/>
+    <p:sldId id="266" r:id="rId7"/>
+    <p:sldId id="267" r:id="rId8"/>
+    <p:sldId id="261" r:id="rId9"/>
+    <p:sldId id="258" r:id="rId10"/>
+    <p:sldId id="259" r:id="rId11"/>
+    <p:sldId id="260" r:id="rId12"/>
   </p:sldIdLst>
   <p:sldSz cx="12192000" cy="6858000"/>
   <p:notesSz cx="6858000" cy="9144000"/>
@@ -6641,7 +6645,7 @@
             <a:pPr rtl="0"/>
             <a:fld id="{43367168-A7C3-4A51-ACFE-4D76B720982F}" type="datetime1">
               <a:rPr lang="fr-FR" smtClean="0"/>
-              <a:t>01/06/2026</a:t>
+              <a:t>02/06/2026</a:t>
             </a:fld>
             <a:endParaRPr lang="fr-FR"/>
           </a:p>
@@ -6823,7 +6827,7 @@
             <a:pPr rtl="0"/>
             <a:fld id="{CB4F1169-1988-463B-A52C-EF5C9A50040C}" type="datetime1">
               <a:rPr lang="fr-FR" noProof="0" smtClean="0"/>
-              <a:t>01/06/2026</a:t>
+              <a:t>02/06/2026</a:t>
             </a:fld>
             <a:endParaRPr lang="fr-FR" noProof="0"/>
           </a:p>
@@ -7122,6 +7126,13 @@
           </p:nvPr>
         </p:nvSpPr>
         <p:spPr/>
+        <p:txBody>
+          <a:bodyPr/>
+          <a:lstStyle/>
+          <a:p>
+            <a:endParaRPr lang="fr-FR"/>
+          </a:p>
+        </p:txBody>
       </p:sp>
       <p:sp>
         <p:nvSpPr>
@@ -7208,6 +7219,13 @@
           </p:nvPr>
         </p:nvSpPr>
         <p:spPr/>
+        <p:txBody>
+          <a:bodyPr/>
+          <a:lstStyle/>
+          <a:p>
+            <a:endParaRPr lang="fr-FR"/>
+          </a:p>
+        </p:txBody>
       </p:sp>
       <p:sp>
         <p:nvSpPr>
@@ -7247,7 +7265,7 @@
             <a:pPr rtl="0"/>
             <a:fld id="{C6B3AB32-59DF-41F1-9618-EDFBF5049629}" type="slidenum">
               <a:rPr lang="fr-FR" smtClean="0"/>
-              <a:t>4</a:t>
+              <a:t>8</a:t>
             </a:fld>
             <a:endParaRPr lang="fr-FR"/>
           </a:p>
@@ -7294,6 +7312,13 @@
           </p:nvPr>
         </p:nvSpPr>
         <p:spPr/>
+        <p:txBody>
+          <a:bodyPr/>
+          <a:lstStyle/>
+          <a:p>
+            <a:endParaRPr lang="fr-FR"/>
+          </a:p>
+        </p:txBody>
       </p:sp>
       <p:sp>
         <p:nvSpPr>
@@ -7332,7 +7357,7 @@
             <a:pPr rtl="0"/>
             <a:fld id="{C6B3AB32-59DF-41F1-9618-EDFBF5049629}" type="slidenum">
               <a:rPr lang="fr-FR" smtClean="0"/>
-              <a:t>5</a:t>
+              <a:t>9</a:t>
             </a:fld>
             <a:endParaRPr lang="fr-FR"/>
           </a:p>
@@ -7379,6 +7404,13 @@
           </p:nvPr>
         </p:nvSpPr>
         <p:spPr/>
+        <p:txBody>
+          <a:bodyPr/>
+          <a:lstStyle/>
+          <a:p>
+            <a:endParaRPr lang="fr-FR"/>
+          </a:p>
+        </p:txBody>
       </p:sp>
       <p:sp>
         <p:nvSpPr>
@@ -7418,7 +7450,7 @@
             <a:pPr rtl="0"/>
             <a:fld id="{C6B3AB32-59DF-41F1-9618-EDFBF5049629}" type="slidenum">
               <a:rPr lang="fr-FR" smtClean="0"/>
-              <a:t>6</a:t>
+              <a:t>10</a:t>
             </a:fld>
             <a:endParaRPr lang="fr-FR"/>
           </a:p>
@@ -7465,6 +7497,13 @@
           </p:nvPr>
         </p:nvSpPr>
         <p:spPr/>
+        <p:txBody>
+          <a:bodyPr/>
+          <a:lstStyle/>
+          <a:p>
+            <a:endParaRPr lang="fr-FR"/>
+          </a:p>
+        </p:txBody>
       </p:sp>
       <p:sp>
         <p:nvSpPr>
@@ -7504,7 +7543,7 @@
             <a:pPr rtl="0"/>
             <a:fld id="{C6B3AB32-59DF-41F1-9618-EDFBF5049629}" type="slidenum">
               <a:rPr lang="fr-FR" smtClean="0"/>
-              <a:t>7</a:t>
+              <a:t>11</a:t>
             </a:fld>
             <a:endParaRPr lang="fr-FR"/>
           </a:p>
@@ -7576,6 +7615,13 @@
             <a:schemeClr val="lt1"/>
           </a:fontRef>
         </p:style>
+        <p:txBody>
+          <a:bodyPr/>
+          <a:lstStyle/>
+          <a:p>
+            <a:endParaRPr lang="fr-FR"/>
+          </a:p>
+        </p:txBody>
       </p:sp>
       <p:sp>
         <p:nvSpPr>
@@ -7769,7 +7815,7 @@
             <a:pPr rtl="0"/>
             <a:fld id="{3F3B20A7-A3FE-46B9-84EA-B4257BA7E60C}" type="datetime1">
               <a:rPr lang="fr-FR" noProof="0" smtClean="0"/>
-              <a:t>01/06/2026</a:t>
+              <a:t>02/06/2026</a:t>
             </a:fld>
             <a:endParaRPr lang="fr-FR" noProof="0"/>
           </a:p>
@@ -7920,6 +7966,13 @@
             <a:schemeClr val="lt1"/>
           </a:fontRef>
         </p:style>
+        <p:txBody>
+          <a:bodyPr/>
+          <a:lstStyle/>
+          <a:p>
+            <a:endParaRPr lang="fr-FR"/>
+          </a:p>
+        </p:txBody>
       </p:sp>
       <p:sp>
         <p:nvSpPr>
@@ -8034,7 +8087,7 @@
             <a:pPr rtl="0"/>
             <a:fld id="{7E5E3FBB-57D2-4FB3-B51E-0FDE8CEE6791}" type="datetime1">
               <a:rPr lang="fr-FR" noProof="0" smtClean="0"/>
-              <a:t>01/06/2026</a:t>
+              <a:t>02/06/2026</a:t>
             </a:fld>
             <a:endParaRPr lang="fr-FR" noProof="0"/>
           </a:p>
@@ -8153,6 +8206,13 @@
             <a:schemeClr val="lt1"/>
           </a:fontRef>
         </p:style>
+        <p:txBody>
+          <a:bodyPr/>
+          <a:lstStyle/>
+          <a:p>
+            <a:endParaRPr lang="fr-FR"/>
+          </a:p>
+        </p:txBody>
       </p:sp>
       <p:sp>
         <p:nvSpPr>
@@ -8272,7 +8332,7 @@
             <a:pPr rtl="0"/>
             <a:fld id="{BE9F9435-70D7-42BA-8564-5EC34B97B69E}" type="datetime1">
               <a:rPr lang="fr-FR" noProof="0" smtClean="0"/>
-              <a:t>01/06/2026</a:t>
+              <a:t>02/06/2026</a:t>
             </a:fld>
             <a:endParaRPr lang="fr-FR" noProof="0"/>
           </a:p>
@@ -8412,6 +8472,13 @@
             <a:schemeClr val="lt1"/>
           </a:fontRef>
         </p:style>
+        <p:txBody>
+          <a:bodyPr/>
+          <a:lstStyle/>
+          <a:p>
+            <a:endParaRPr lang="fr-FR"/>
+          </a:p>
+        </p:txBody>
       </p:sp>
       <p:sp>
         <p:nvSpPr>
@@ -8515,7 +8582,7 @@
             <a:pPr rtl="0"/>
             <a:fld id="{29B34D2F-0B02-482E-ABD2-95D8C2FF2A58}" type="datetime1">
               <a:rPr lang="fr-FR" noProof="0" smtClean="0"/>
-              <a:t>01/06/2026</a:t>
+              <a:t>02/06/2026</a:t>
             </a:fld>
             <a:endParaRPr lang="fr-FR" noProof="0"/>
           </a:p>
@@ -8639,6 +8706,13 @@
             <a:schemeClr val="lt1"/>
           </a:fontRef>
         </p:style>
+        <p:txBody>
+          <a:bodyPr/>
+          <a:lstStyle/>
+          <a:p>
+            <a:endParaRPr lang="fr-FR"/>
+          </a:p>
+        </p:txBody>
       </p:sp>
       <p:sp>
         <p:nvSpPr>
@@ -8826,7 +8900,7 @@
             <a:pPr rtl="0"/>
             <a:fld id="{126ECFBB-4871-428F-B4AE-1EF357E63674}" type="datetime1">
               <a:rPr lang="fr-FR" noProof="0" smtClean="0"/>
-              <a:t>01/06/2026</a:t>
+              <a:t>02/06/2026</a:t>
             </a:fld>
             <a:endParaRPr lang="fr-FR" noProof="0"/>
           </a:p>
@@ -8967,6 +9041,13 @@
             <a:schemeClr val="lt1"/>
           </a:fontRef>
         </p:style>
+        <p:txBody>
+          <a:bodyPr/>
+          <a:lstStyle/>
+          <a:p>
+            <a:endParaRPr lang="fr-FR"/>
+          </a:p>
+        </p:txBody>
       </p:sp>
       <p:sp>
         <p:nvSpPr>
@@ -9130,7 +9211,7 @@
             <a:pPr rtl="0"/>
             <a:fld id="{75517F14-0D9C-452E-A596-36902551AE9C}" type="datetime1">
               <a:rPr lang="fr-FR" noProof="0" smtClean="0"/>
-              <a:t>01/06/2026</a:t>
+              <a:t>02/06/2026</a:t>
             </a:fld>
             <a:endParaRPr lang="fr-FR" noProof="0"/>
           </a:p>
@@ -9249,6 +9330,13 @@
             <a:schemeClr val="lt1"/>
           </a:fontRef>
         </p:style>
+        <p:txBody>
+          <a:bodyPr/>
+          <a:lstStyle/>
+          <a:p>
+            <a:endParaRPr lang="fr-FR"/>
+          </a:p>
+        </p:txBody>
       </p:sp>
       <p:sp>
         <p:nvSpPr>
@@ -9554,7 +9642,7 @@
             <a:pPr rtl="0"/>
             <a:fld id="{FA9BF800-A62B-4735-B9A7-5450007C0A78}" type="datetime1">
               <a:rPr lang="fr-FR" noProof="0" smtClean="0"/>
-              <a:t>01/06/2026</a:t>
+              <a:t>02/06/2026</a:t>
             </a:fld>
             <a:endParaRPr lang="fr-FR" noProof="0"/>
           </a:p>
@@ -9653,7 +9741,7 @@
             <a:pPr rtl="0"/>
             <a:fld id="{F47267E0-A979-4430-94B4-54611641D8EE}" type="datetime1">
               <a:rPr lang="fr-FR" noProof="0" smtClean="0"/>
-              <a:t>01/06/2026</a:t>
+              <a:t>02/06/2026</a:t>
             </a:fld>
             <a:endParaRPr lang="fr-FR" noProof="0"/>
           </a:p>
@@ -9742,6 +9830,13 @@
             <a:schemeClr val="lt1"/>
           </a:fontRef>
         </p:style>
+        <p:txBody>
+          <a:bodyPr/>
+          <a:lstStyle/>
+          <a:p>
+            <a:endParaRPr lang="fr-FR"/>
+          </a:p>
+        </p:txBody>
       </p:sp>
       <p:sp>
         <p:nvSpPr>
@@ -9819,7 +9914,7 @@
             <a:pPr rtl="0"/>
             <a:fld id="{C58A73B6-B077-488D-82CF-3056D5BAC73E}" type="datetime1">
               <a:rPr lang="fr-FR" noProof="0" smtClean="0"/>
-              <a:t>01/06/2026</a:t>
+              <a:t>02/06/2026</a:t>
             </a:fld>
             <a:endParaRPr lang="fr-FR" noProof="0"/>
           </a:p>
@@ -9938,6 +10033,13 @@
             <a:schemeClr val="lt1"/>
           </a:fontRef>
         </p:style>
+        <p:txBody>
+          <a:bodyPr/>
+          <a:lstStyle/>
+          <a:p>
+            <a:endParaRPr lang="fr-FR"/>
+          </a:p>
+        </p:txBody>
       </p:sp>
       <p:sp>
         <p:nvSpPr>
@@ -10200,7 +10302,7 @@
             <a:pPr rtl="0"/>
             <a:fld id="{98F108A3-3495-404B-9869-1BA62DF0E465}" type="datetime1">
               <a:rPr lang="fr-FR" noProof="0" smtClean="0"/>
-              <a:t>01/06/2026</a:t>
+              <a:t>02/06/2026</a:t>
             </a:fld>
             <a:endParaRPr lang="fr-FR" noProof="0"/>
           </a:p>
@@ -10493,7 +10595,7 @@
             <a:pPr rtl="0"/>
             <a:fld id="{94B550F6-4238-41AE-B6F4-4D375745C983}" type="datetime1">
               <a:rPr lang="fr-FR" noProof="0" smtClean="0"/>
-              <a:t>01/06/2026</a:t>
+              <a:t>02/06/2026</a:t>
             </a:fld>
             <a:endParaRPr lang="fr-FR" noProof="0"/>
           </a:p>
@@ -10707,7 +10809,7 @@
             <a:pPr rtl="0"/>
             <a:fld id="{BBB97F02-5EDD-4BF6-BE41-AB41D1FEABF8}" type="datetime1">
               <a:rPr lang="fr-FR" noProof="0" smtClean="0"/>
-              <a:t>01/06/2026</a:t>
+              <a:t>02/06/2026</a:t>
             </a:fld>
             <a:endParaRPr lang="fr-FR" noProof="0"/>
           </a:p>
@@ -10826,6 +10928,13 @@
             <a:schemeClr val="lt1"/>
           </a:fontRef>
         </p:style>
+        <p:txBody>
+          <a:bodyPr/>
+          <a:lstStyle/>
+          <a:p>
+            <a:endParaRPr lang="fr-FR"/>
+          </a:p>
+        </p:txBody>
       </p:sp>
       <p:sp>
         <p:nvSpPr>
@@ -10863,6 +10972,13 @@
             <a:schemeClr val="lt1"/>
           </a:fontRef>
         </p:style>
+        <p:txBody>
+          <a:bodyPr/>
+          <a:lstStyle/>
+          <a:p>
+            <a:endParaRPr lang="fr-FR"/>
+          </a:p>
+        </p:txBody>
       </p:sp>
       <p:sp>
         <p:nvSpPr>
@@ -10900,6 +11016,13 @@
             <a:schemeClr val="lt1"/>
           </a:fontRef>
         </p:style>
+        <p:txBody>
+          <a:bodyPr/>
+          <a:lstStyle/>
+          <a:p>
+            <a:endParaRPr lang="fr-FR"/>
+          </a:p>
+        </p:txBody>
       </p:sp>
     </p:spTree>
     <p:extLst>
@@ -11499,6 +11622,13 @@
               <a:schemeClr val="lt1"/>
             </a:fontRef>
           </p:style>
+          <p:txBody>
+            <a:bodyPr/>
+            <a:lstStyle/>
+            <a:p>
+              <a:endParaRPr lang="fr-FR"/>
+            </a:p>
+          </p:txBody>
         </p:sp>
         <p:sp>
           <p:nvSpPr>
@@ -11553,6 +11683,13 @@
               <a:schemeClr val="lt1"/>
             </a:fontRef>
           </p:style>
+          <p:txBody>
+            <a:bodyPr/>
+            <a:lstStyle/>
+            <a:p>
+              <a:endParaRPr lang="fr-FR"/>
+            </a:p>
+          </p:txBody>
         </p:sp>
         <p:sp>
           <p:nvSpPr>
@@ -11607,6 +11744,13 @@
               <a:schemeClr val="lt1"/>
             </a:fontRef>
           </p:style>
+          <p:txBody>
+            <a:bodyPr/>
+            <a:lstStyle/>
+            <a:p>
+              <a:endParaRPr lang="fr-FR"/>
+            </a:p>
+          </p:txBody>
         </p:sp>
       </p:grpSp>
       <p:sp>
@@ -11664,6 +11808,13 @@
             <a:schemeClr val="lt1"/>
           </a:fontRef>
         </p:style>
+        <p:txBody>
+          <a:bodyPr/>
+          <a:lstStyle/>
+          <a:p>
+            <a:endParaRPr lang="fr-FR"/>
+          </a:p>
+        </p:txBody>
       </p:sp>
       <p:sp>
         <p:nvSpPr>
@@ -11757,6 +11908,928 @@
     <p:extLst>
       <p:ext uri="{BB962C8B-B14F-4D97-AF65-F5344CB8AC3E}">
         <p14:creationId xmlns:p14="http://schemas.microsoft.com/office/powerpoint/2010/main" val="1487700712"/>
+      </p:ext>
+    </p:extLst>
+  </p:cSld>
+  <p:clrMapOvr>
+    <a:masterClrMapping/>
+  </p:clrMapOvr>
+</p:sld>
+</file>
+
+<file path=ppt/slides/slide10.xml><?xml version="1.0" encoding="utf-8"?>
+<p:sld xmlns:a="http://schemas.openxmlformats.org/drawingml/2006/main" xmlns:r="http://schemas.openxmlformats.org/officeDocument/2006/relationships" xmlns:p="http://schemas.openxmlformats.org/presentationml/2006/main">
+  <p:cSld>
+    <p:bg>
+      <p:bgPr>
+        <a:solidFill>
+          <a:schemeClr val="bg1"/>
+        </a:solidFill>
+        <a:effectLst/>
+      </p:bgPr>
+    </p:bg>
+    <p:spTree>
+      <p:nvGrpSpPr>
+        <p:cNvPr id="1" name=""/>
+        <p:cNvGrpSpPr/>
+        <p:nvPr/>
+      </p:nvGrpSpPr>
+      <p:grpSpPr>
+        <a:xfrm>
+          <a:off x="0" y="0"/>
+          <a:ext cx="0" cy="0"/>
+          <a:chOff x="0" y="0"/>
+          <a:chExt cx="0" cy="0"/>
+        </a:xfrm>
+      </p:grpSpPr>
+      <p:sp useBgFill="1">
+        <p:nvSpPr>
+          <p:cNvPr id="13" name="Rectangle 12">
+            <a:extLst>
+              <a:ext uri="{FF2B5EF4-FFF2-40B4-BE49-F238E27FC236}">
+                <a16:creationId xmlns:a16="http://schemas.microsoft.com/office/drawing/2014/main" id="{4AE9D071-98CF-435C-BD2B-976514544DC5}"/>
+              </a:ext>
+              <a:ext uri="{C183D7F6-B498-43B3-948B-1728B52AA6E4}">
+                <adec:decorative xmlns:adec="http://schemas.microsoft.com/office/drawing/2017/decorative" val="1"/>
+              </a:ext>
+            </a:extLst>
+          </p:cNvPr>
+          <p:cNvSpPr>
+            <a:spLocks noGrp="1" noRot="1" noChangeAspect="1" noMove="1" noResize="1" noEditPoints="1" noAdjustHandles="1" noChangeArrowheads="1" noChangeShapeType="1"/>
+          </p:cNvSpPr>
+          <p:nvPr>
+            <p:extLst>
+              <p:ext uri="{386F3935-93C4-4BCD-93E2-E3B085C9AB24}">
+                <p16:designElem xmlns:p16="http://schemas.microsoft.com/office/powerpoint/2015/main" val="1"/>
+              </p:ext>
+            </p:extLst>
+          </p:nvPr>
+        </p:nvSpPr>
+        <p:spPr>
+          <a:xfrm>
+            <a:off x="0" y="0"/>
+            <a:ext cx="12192000" cy="6858000"/>
+          </a:xfrm>
+          <a:prstGeom prst="rect">
+            <a:avLst/>
+          </a:prstGeom>
+          <a:ln>
+            <a:noFill/>
+          </a:ln>
+        </p:spPr>
+        <p:style>
+          <a:lnRef idx="2">
+            <a:schemeClr val="accent1">
+              <a:shade val="50000"/>
+            </a:schemeClr>
+          </a:lnRef>
+          <a:fillRef idx="1">
+            <a:schemeClr val="accent1"/>
+          </a:fillRef>
+          <a:effectRef idx="0">
+            <a:schemeClr val="accent1"/>
+          </a:effectRef>
+          <a:fontRef idx="minor">
+            <a:schemeClr val="lt1"/>
+          </a:fontRef>
+        </p:style>
+        <p:txBody>
+          <a:bodyPr rtlCol="0" anchor="ctr"/>
+          <a:lstStyle/>
+          <a:p>
+            <a:pPr algn="ctr" rtl="0"/>
+            <a:endParaRPr lang="fr-FR" dirty="0"/>
+          </a:p>
+        </p:txBody>
+      </p:sp>
+      <p:pic>
+        <p:nvPicPr>
+          <p:cNvPr id="8" name="Espace réservé du contenu 4" descr="Valeurs numériques">
+            <a:extLst>
+              <a:ext uri="{FF2B5EF4-FFF2-40B4-BE49-F238E27FC236}">
+                <a16:creationId xmlns:a16="http://schemas.microsoft.com/office/drawing/2014/main" id="{EA70616B-E344-4856-8DF9-707C26236613}"/>
+              </a:ext>
+            </a:extLst>
+          </p:cNvPr>
+          <p:cNvPicPr>
+            <a:picLocks noChangeAspect="1"/>
+          </p:cNvPicPr>
+          <p:nvPr/>
+        </p:nvPicPr>
+        <p:blipFill rotWithShape="1">
+          <a:blip r:embed="rId3" cstate="screen">
+            <a:extLst>
+              <a:ext uri="{28A0092B-C50C-407E-A947-70E740481C1C}">
+                <a14:useLocalDpi xmlns:a14="http://schemas.microsoft.com/office/drawing/2010/main"/>
+              </a:ext>
+            </a:extLst>
+          </a:blip>
+          <a:srcRect t="10681" r="9091" b="12711"/>
+          <a:stretch/>
+        </p:blipFill>
+        <p:spPr>
+          <a:xfrm>
+            <a:off x="20" y="10"/>
+            <a:ext cx="12191980" cy="6857990"/>
+          </a:xfrm>
+          <a:prstGeom prst="rect">
+            <a:avLst/>
+          </a:prstGeom>
+        </p:spPr>
+      </p:pic>
+      <p:grpSp>
+        <p:nvGrpSpPr>
+          <p:cNvPr id="15" name="Groupe 14">
+            <a:extLst>
+              <a:ext uri="{FF2B5EF4-FFF2-40B4-BE49-F238E27FC236}">
+                <a16:creationId xmlns:a16="http://schemas.microsoft.com/office/drawing/2014/main" id="{D619FC33-16ED-4246-9596-BEFEB55E4CF6}"/>
+              </a:ext>
+              <a:ext uri="{C183D7F6-B498-43B3-948B-1728B52AA6E4}">
+                <adec:decorative xmlns:adec="http://schemas.microsoft.com/office/drawing/2017/decorative" val="1"/>
+              </a:ext>
+            </a:extLst>
+          </p:cNvPr>
+          <p:cNvGrpSpPr>
+            <a:grpSpLocks noGrp="1" noUngrp="1" noRot="1" noChangeAspect="1" noMove="1" noResize="1"/>
+          </p:cNvGrpSpPr>
+          <p:nvPr>
+            <p:extLst>
+              <p:ext uri="{386F3935-93C4-4BCD-93E2-E3B085C9AB24}">
+                <p16:designElem xmlns:p16="http://schemas.microsoft.com/office/powerpoint/2015/main" val="1"/>
+              </p:ext>
+            </p:extLst>
+          </p:nvPr>
+        </p:nvGrpSpPr>
+        <p:grpSpPr>
+          <a:xfrm>
+            <a:off x="438067" y="457200"/>
+            <a:ext cx="7507083" cy="5935132"/>
+            <a:chOff x="438067" y="457200"/>
+            <a:chExt cx="7507083" cy="5935132"/>
+          </a:xfrm>
+        </p:grpSpPr>
+        <p:sp>
+          <p:nvSpPr>
+            <p:cNvPr id="16" name="Rectangle 15">
+              <a:extLst>
+                <a:ext uri="{FF2B5EF4-FFF2-40B4-BE49-F238E27FC236}">
+                  <a16:creationId xmlns:a16="http://schemas.microsoft.com/office/drawing/2014/main" id="{2EEA80E1-F99F-4009-837F-2F72F8A5D580}"/>
+                </a:ext>
+                <a:ext uri="{C183D7F6-B498-43B3-948B-1728B52AA6E4}">
+                  <adec:decorative xmlns:adec="http://schemas.microsoft.com/office/drawing/2017/decorative" val="1"/>
+                </a:ext>
+              </a:extLst>
+            </p:cNvPr>
+            <p:cNvSpPr>
+              <a:spLocks/>
+            </p:cNvSpPr>
+            <p:nvPr>
+              <p:extLst>
+                <p:ext uri="{386F3935-93C4-4BCD-93E2-E3B085C9AB24}">
+                  <p16:designElem xmlns:p16="http://schemas.microsoft.com/office/powerpoint/2015/main" val="1"/>
+                </p:ext>
+              </p:extLst>
+            </p:nvPr>
+          </p:nvSpPr>
+          <p:spPr>
+            <a:xfrm>
+              <a:off x="438067" y="618067"/>
+              <a:ext cx="7503665" cy="5774265"/>
+            </a:xfrm>
+            <a:prstGeom prst="rect">
+              <a:avLst/>
+            </a:prstGeom>
+            <a:solidFill>
+              <a:schemeClr val="accent1">
+                <a:alpha val="97000"/>
+              </a:schemeClr>
+            </a:solidFill>
+            <a:ln w="6350" cmpd="sng">
+              <a:noFill/>
+            </a:ln>
+            <a:effectLst/>
+          </p:spPr>
+          <p:style>
+            <a:lnRef idx="1">
+              <a:schemeClr val="accent1"/>
+            </a:lnRef>
+            <a:fillRef idx="3">
+              <a:schemeClr val="accent1"/>
+            </a:fillRef>
+            <a:effectRef idx="2">
+              <a:schemeClr val="accent1"/>
+            </a:effectRef>
+            <a:fontRef idx="minor">
+              <a:schemeClr val="lt1"/>
+            </a:fontRef>
+          </p:style>
+          <p:txBody>
+            <a:bodyPr/>
+            <a:lstStyle/>
+            <a:p>
+              <a:endParaRPr lang="fr-FR"/>
+            </a:p>
+          </p:txBody>
+        </p:sp>
+        <p:sp>
+          <p:nvSpPr>
+            <p:cNvPr id="17" name="Rectangle 16">
+              <a:extLst>
+                <a:ext uri="{FF2B5EF4-FFF2-40B4-BE49-F238E27FC236}">
+                  <a16:creationId xmlns:a16="http://schemas.microsoft.com/office/drawing/2014/main" id="{0230AF9A-4641-4BD8-9F95-9607CD304039}"/>
+                </a:ext>
+                <a:ext uri="{C183D7F6-B498-43B3-948B-1728B52AA6E4}">
+                  <adec:decorative xmlns:adec="http://schemas.microsoft.com/office/drawing/2017/decorative" val="1"/>
+                </a:ext>
+              </a:extLst>
+            </p:cNvPr>
+            <p:cNvSpPr>
+              <a:spLocks/>
+            </p:cNvSpPr>
+            <p:nvPr>
+              <p:extLst>
+                <p:ext uri="{386F3935-93C4-4BCD-93E2-E3B085C9AB24}">
+                  <p16:designElem xmlns:p16="http://schemas.microsoft.com/office/powerpoint/2015/main" val="1"/>
+                </p:ext>
+              </p:extLst>
+            </p:nvPr>
+          </p:nvSpPr>
+          <p:spPr>
+            <a:xfrm>
+              <a:off x="438068" y="457200"/>
+              <a:ext cx="3703320" cy="94997"/>
+            </a:xfrm>
+            <a:prstGeom prst="rect">
+              <a:avLst/>
+            </a:prstGeom>
+            <a:solidFill>
+              <a:schemeClr val="accent1"/>
+            </a:solidFill>
+            <a:ln>
+              <a:noFill/>
+            </a:ln>
+            <a:effectLst/>
+          </p:spPr>
+          <p:style>
+            <a:lnRef idx="1">
+              <a:schemeClr val="accent1"/>
+            </a:lnRef>
+            <a:fillRef idx="3">
+              <a:schemeClr val="accent1"/>
+            </a:fillRef>
+            <a:effectRef idx="2">
+              <a:schemeClr val="accent1"/>
+            </a:effectRef>
+            <a:fontRef idx="minor">
+              <a:schemeClr val="lt1"/>
+            </a:fontRef>
+          </p:style>
+          <p:txBody>
+            <a:bodyPr/>
+            <a:lstStyle/>
+            <a:p>
+              <a:endParaRPr lang="fr-FR"/>
+            </a:p>
+          </p:txBody>
+        </p:sp>
+        <p:sp>
+          <p:nvSpPr>
+            <p:cNvPr id="18" name="Rectangle 17">
+              <a:extLst>
+                <a:ext uri="{FF2B5EF4-FFF2-40B4-BE49-F238E27FC236}">
+                  <a16:creationId xmlns:a16="http://schemas.microsoft.com/office/drawing/2014/main" id="{8703D4EC-9389-41B6-B88B-B6FDC8CD3330}"/>
+                </a:ext>
+                <a:ext uri="{C183D7F6-B498-43B3-948B-1728B52AA6E4}">
+                  <adec:decorative xmlns:adec="http://schemas.microsoft.com/office/drawing/2017/decorative" val="1"/>
+                </a:ext>
+              </a:extLst>
+            </p:cNvPr>
+            <p:cNvSpPr>
+              <a:spLocks/>
+            </p:cNvSpPr>
+            <p:nvPr>
+              <p:extLst>
+                <p:ext uri="{386F3935-93C4-4BCD-93E2-E3B085C9AB24}">
+                  <p16:designElem xmlns:p16="http://schemas.microsoft.com/office/powerpoint/2015/main" val="1"/>
+                </p:ext>
+              </p:extLst>
+            </p:nvPr>
+          </p:nvSpPr>
+          <p:spPr>
+            <a:xfrm>
+              <a:off x="4241830" y="457200"/>
+              <a:ext cx="3703320" cy="91440"/>
+            </a:xfrm>
+            <a:prstGeom prst="rect">
+              <a:avLst/>
+            </a:prstGeom>
+            <a:solidFill>
+              <a:schemeClr val="accent2"/>
+            </a:solidFill>
+            <a:ln>
+              <a:noFill/>
+            </a:ln>
+            <a:effectLst/>
+          </p:spPr>
+          <p:style>
+            <a:lnRef idx="1">
+              <a:schemeClr val="accent1"/>
+            </a:lnRef>
+            <a:fillRef idx="3">
+              <a:schemeClr val="accent1"/>
+            </a:fillRef>
+            <a:effectRef idx="2">
+              <a:schemeClr val="accent1"/>
+            </a:effectRef>
+            <a:fontRef idx="minor">
+              <a:schemeClr val="lt1"/>
+            </a:fontRef>
+          </p:style>
+          <p:txBody>
+            <a:bodyPr/>
+            <a:lstStyle/>
+            <a:p>
+              <a:endParaRPr lang="fr-FR"/>
+            </a:p>
+          </p:txBody>
+        </p:sp>
+      </p:grpSp>
+      <p:sp>
+        <p:nvSpPr>
+          <p:cNvPr id="2" name="Titre 1">
+            <a:extLst>
+              <a:ext uri="{FF2B5EF4-FFF2-40B4-BE49-F238E27FC236}">
+                <a16:creationId xmlns:a16="http://schemas.microsoft.com/office/drawing/2014/main" id="{7F2616EE-270D-4F4C-BA1F-2708D387B800}"/>
+              </a:ext>
+            </a:extLst>
+          </p:cNvPr>
+          <p:cNvSpPr>
+            <a:spLocks noGrp="1"/>
+          </p:cNvSpPr>
+          <p:nvPr>
+            <p:ph type="title"/>
+          </p:nvPr>
+        </p:nvSpPr>
+        <p:spPr>
+          <a:xfrm>
+            <a:off x="584200" y="1006956"/>
+            <a:ext cx="7213600" cy="1121871"/>
+          </a:xfrm>
+        </p:spPr>
+        <p:txBody>
+          <a:bodyPr rtlCol="0" anchor="ctr">
+            <a:normAutofit/>
+          </a:bodyPr>
+          <a:lstStyle/>
+          <a:p>
+            <a:pPr algn="ctr" rtl="0"/>
+            <a:r>
+              <a:rPr lang="fr-FR" dirty="0"/>
+              <a:t>Communications numériques</a:t>
+            </a:r>
+          </a:p>
+        </p:txBody>
+      </p:sp>
+      <p:graphicFrame>
+        <p:nvGraphicFramePr>
+          <p:cNvPr id="6" name="Espace réservé du contenu 5" descr="Graphique SmartArt">
+            <a:extLst>
+              <a:ext uri="{FF2B5EF4-FFF2-40B4-BE49-F238E27FC236}">
+                <a16:creationId xmlns:a16="http://schemas.microsoft.com/office/drawing/2014/main" id="{BF629521-FFD2-45DA-9D1D-A5F09BD5A2D9}"/>
+              </a:ext>
+            </a:extLst>
+          </p:cNvPr>
+          <p:cNvGraphicFramePr>
+            <a:graphicFrameLocks noGrp="1"/>
+          </p:cNvGraphicFramePr>
+          <p:nvPr>
+            <p:ph idx="1"/>
+            <p:extLst>
+              <p:ext uri="{D42A27DB-BD31-4B8C-83A1-F6EECF244321}">
+                <p14:modId xmlns:p14="http://schemas.microsoft.com/office/powerpoint/2010/main" val="407969185"/>
+              </p:ext>
+            </p:extLst>
+          </p:nvPr>
+        </p:nvGraphicFramePr>
+        <p:xfrm>
+          <a:off x="719571" y="2198254"/>
+          <a:ext cx="6854248" cy="3563938"/>
+        </p:xfrm>
+        <a:graphic>
+          <a:graphicData uri="http://schemas.openxmlformats.org/drawingml/2006/diagram">
+            <dgm:relIds xmlns:dgm="http://schemas.openxmlformats.org/drawingml/2006/diagram" xmlns:r="http://schemas.openxmlformats.org/officeDocument/2006/relationships" r:dm="rId4" r:lo="rId5" r:qs="rId6" r:cs="rId7"/>
+          </a:graphicData>
+        </a:graphic>
+      </p:graphicFrame>
+    </p:spTree>
+    <p:extLst>
+      <p:ext uri="{BB962C8B-B14F-4D97-AF65-F5344CB8AC3E}">
+        <p14:creationId xmlns:p14="http://schemas.microsoft.com/office/powerpoint/2010/main" val="4209322005"/>
+      </p:ext>
+    </p:extLst>
+  </p:cSld>
+  <p:clrMapOvr>
+    <a:masterClrMapping/>
+  </p:clrMapOvr>
+</p:sld>
+</file>
+
+<file path=ppt/slides/slide11.xml><?xml version="1.0" encoding="utf-8"?>
+<p:sld xmlns:a="http://schemas.openxmlformats.org/drawingml/2006/main" xmlns:r="http://schemas.openxmlformats.org/officeDocument/2006/relationships" xmlns:p="http://schemas.openxmlformats.org/presentationml/2006/main">
+  <p:cSld>
+    <p:bg>
+      <p:bgPr>
+        <a:solidFill>
+          <a:schemeClr val="bg1"/>
+        </a:solidFill>
+        <a:effectLst/>
+      </p:bgPr>
+    </p:bg>
+    <p:spTree>
+      <p:nvGrpSpPr>
+        <p:cNvPr id="1" name=""/>
+        <p:cNvGrpSpPr/>
+        <p:nvPr/>
+      </p:nvGrpSpPr>
+      <p:grpSpPr>
+        <a:xfrm>
+          <a:off x="0" y="0"/>
+          <a:ext cx="0" cy="0"/>
+          <a:chOff x="0" y="0"/>
+          <a:chExt cx="0" cy="0"/>
+        </a:xfrm>
+      </p:grpSpPr>
+      <p:sp useBgFill="1">
+        <p:nvSpPr>
+          <p:cNvPr id="10" name="Rectangle 9">
+            <a:extLst>
+              <a:ext uri="{FF2B5EF4-FFF2-40B4-BE49-F238E27FC236}">
+                <a16:creationId xmlns:a16="http://schemas.microsoft.com/office/drawing/2014/main" id="{379F11E2-8BA5-4C5C-AE7C-361E5EA011FF}"/>
+              </a:ext>
+              <a:ext uri="{C183D7F6-B498-43B3-948B-1728B52AA6E4}">
+                <adec:decorative xmlns:adec="http://schemas.microsoft.com/office/drawing/2017/decorative" val="1"/>
+              </a:ext>
+            </a:extLst>
+          </p:cNvPr>
+          <p:cNvSpPr>
+            <a:spLocks noGrp="1" noRot="1" noChangeAspect="1" noMove="1" noResize="1" noEditPoints="1" noAdjustHandles="1" noChangeArrowheads="1" noChangeShapeType="1"/>
+          </p:cNvSpPr>
+          <p:nvPr>
+            <p:extLst>
+              <p:ext uri="{386F3935-93C4-4BCD-93E2-E3B085C9AB24}">
+                <p16:designElem xmlns:p16="http://schemas.microsoft.com/office/powerpoint/2015/main" val="1"/>
+              </p:ext>
+            </p:extLst>
+          </p:nvPr>
+        </p:nvSpPr>
+        <p:spPr>
+          <a:xfrm>
+            <a:off x="0" y="1"/>
+            <a:ext cx="12191999" cy="6858000"/>
+          </a:xfrm>
+          <a:prstGeom prst="rect">
+            <a:avLst/>
+          </a:prstGeom>
+          <a:ln>
+            <a:noFill/>
+          </a:ln>
+        </p:spPr>
+        <p:style>
+          <a:lnRef idx="2">
+            <a:schemeClr val="accent1">
+              <a:shade val="50000"/>
+            </a:schemeClr>
+          </a:lnRef>
+          <a:fillRef idx="1">
+            <a:schemeClr val="accent1"/>
+          </a:fillRef>
+          <a:effectRef idx="0">
+            <a:schemeClr val="accent1"/>
+          </a:effectRef>
+          <a:fontRef idx="minor">
+            <a:schemeClr val="lt1"/>
+          </a:fontRef>
+        </p:style>
+        <p:txBody>
+          <a:bodyPr rtlCol="0" anchor="ctr"/>
+          <a:lstStyle/>
+          <a:p>
+            <a:pPr algn="ctr" rtl="0"/>
+            <a:endParaRPr lang="fr-FR"/>
+          </a:p>
+        </p:txBody>
+      </p:sp>
+      <p:sp>
+        <p:nvSpPr>
+          <p:cNvPr id="12" name="Rectangle 11">
+            <a:extLst>
+              <a:ext uri="{FF2B5EF4-FFF2-40B4-BE49-F238E27FC236}">
+                <a16:creationId xmlns:a16="http://schemas.microsoft.com/office/drawing/2014/main" id="{7C00E1DA-EC7C-40FC-95E3-11FDCD2E4291}"/>
+              </a:ext>
+              <a:ext uri="{C183D7F6-B498-43B3-948B-1728B52AA6E4}">
+                <adec:decorative xmlns:adec="http://schemas.microsoft.com/office/drawing/2017/decorative" val="1"/>
+              </a:ext>
+            </a:extLst>
+          </p:cNvPr>
+          <p:cNvSpPr>
+            <a:spLocks noGrp="1" noRot="1" noChangeAspect="1" noMove="1" noResize="1" noEditPoints="1" noAdjustHandles="1" noChangeArrowheads="1" noChangeShapeType="1"/>
+          </p:cNvSpPr>
+          <p:nvPr>
+            <p:extLst>
+              <p:ext uri="{386F3935-93C4-4BCD-93E2-E3B085C9AB24}">
+                <p16:designElem xmlns:p16="http://schemas.microsoft.com/office/powerpoint/2015/main" val="1"/>
+              </p:ext>
+            </p:extLst>
+          </p:nvPr>
+        </p:nvSpPr>
+        <p:spPr>
+          <a:xfrm>
+            <a:off x="8042147" y="723899"/>
+            <a:ext cx="3703320" cy="5666666"/>
+          </a:xfrm>
+          <a:prstGeom prst="rect">
+            <a:avLst/>
+          </a:prstGeom>
+          <a:solidFill>
+            <a:schemeClr val="accent1"/>
+          </a:solidFill>
+          <a:ln>
+            <a:noFill/>
+          </a:ln>
+          <a:effectLst/>
+        </p:spPr>
+        <p:style>
+          <a:lnRef idx="1">
+            <a:schemeClr val="accent1"/>
+          </a:lnRef>
+          <a:fillRef idx="3">
+            <a:schemeClr val="accent1"/>
+          </a:fillRef>
+          <a:effectRef idx="2">
+            <a:schemeClr val="accent1"/>
+          </a:effectRef>
+          <a:fontRef idx="minor">
+            <a:schemeClr val="lt1"/>
+          </a:fontRef>
+        </p:style>
+        <p:txBody>
+          <a:bodyPr/>
+          <a:lstStyle/>
+          <a:p>
+            <a:endParaRPr lang="fr-FR"/>
+          </a:p>
+        </p:txBody>
+      </p:sp>
+      <p:grpSp>
+        <p:nvGrpSpPr>
+          <p:cNvPr id="14" name="Groupe 13">
+            <a:extLst>
+              <a:ext uri="{FF2B5EF4-FFF2-40B4-BE49-F238E27FC236}">
+                <a16:creationId xmlns:a16="http://schemas.microsoft.com/office/drawing/2014/main" id="{9A421166-2996-41A7-B094-AE5316F347DD}"/>
+              </a:ext>
+              <a:ext uri="{C183D7F6-B498-43B3-948B-1728B52AA6E4}">
+                <adec:decorative xmlns:adec="http://schemas.microsoft.com/office/drawing/2017/decorative" val="1"/>
+              </a:ext>
+            </a:extLst>
+          </p:cNvPr>
+          <p:cNvGrpSpPr>
+            <a:grpSpLocks noGrp="1" noUngrp="1" noRot="1" noChangeAspect="1" noMove="1" noResize="1"/>
+          </p:cNvGrpSpPr>
+          <p:nvPr>
+            <p:extLst>
+              <p:ext uri="{386F3935-93C4-4BCD-93E2-E3B085C9AB24}">
+                <p16:designElem xmlns:p16="http://schemas.microsoft.com/office/powerpoint/2015/main" val="1"/>
+              </p:ext>
+            </p:extLst>
+          </p:nvPr>
+        </p:nvGrpSpPr>
+        <p:grpSpPr>
+          <a:xfrm>
+            <a:off x="446534" y="453643"/>
+            <a:ext cx="11298933" cy="98554"/>
+            <a:chOff x="446534" y="453643"/>
+            <a:chExt cx="11298933" cy="98554"/>
+          </a:xfrm>
+        </p:grpSpPr>
+        <p:sp>
+          <p:nvSpPr>
+            <p:cNvPr id="15" name="Rectangle 14">
+              <a:extLst>
+                <a:ext uri="{FF2B5EF4-FFF2-40B4-BE49-F238E27FC236}">
+                  <a16:creationId xmlns:a16="http://schemas.microsoft.com/office/drawing/2014/main" id="{FDBB1B92-A3EB-43E4-8FAB-D20E8ED14CEF}"/>
+                </a:ext>
+                <a:ext uri="{C183D7F6-B498-43B3-948B-1728B52AA6E4}">
+                  <adec:decorative xmlns:adec="http://schemas.microsoft.com/office/drawing/2017/decorative" val="1"/>
+                </a:ext>
+              </a:extLst>
+            </p:cNvPr>
+            <p:cNvSpPr>
+              <a:spLocks/>
+            </p:cNvSpPr>
+            <p:nvPr>
+              <p:extLst>
+                <p:ext uri="{386F3935-93C4-4BCD-93E2-E3B085C9AB24}">
+                  <p16:designElem xmlns:p16="http://schemas.microsoft.com/office/powerpoint/2015/main" val="1"/>
+                </p:ext>
+              </p:extLst>
+            </p:nvPr>
+          </p:nvSpPr>
+          <p:spPr>
+            <a:xfrm>
+              <a:off x="446534" y="457200"/>
+              <a:ext cx="3703320" cy="94997"/>
+            </a:xfrm>
+            <a:prstGeom prst="rect">
+              <a:avLst/>
+            </a:prstGeom>
+            <a:solidFill>
+              <a:schemeClr val="accent1"/>
+            </a:solidFill>
+            <a:ln>
+              <a:noFill/>
+            </a:ln>
+            <a:effectLst/>
+          </p:spPr>
+          <p:style>
+            <a:lnRef idx="1">
+              <a:schemeClr val="accent1"/>
+            </a:lnRef>
+            <a:fillRef idx="3">
+              <a:schemeClr val="accent1"/>
+            </a:fillRef>
+            <a:effectRef idx="2">
+              <a:schemeClr val="accent1"/>
+            </a:effectRef>
+            <a:fontRef idx="minor">
+              <a:schemeClr val="lt1"/>
+            </a:fontRef>
+          </p:style>
+          <p:txBody>
+            <a:bodyPr/>
+            <a:lstStyle/>
+            <a:p>
+              <a:endParaRPr lang="fr-FR"/>
+            </a:p>
+          </p:txBody>
+        </p:sp>
+        <p:sp>
+          <p:nvSpPr>
+            <p:cNvPr id="16" name="Rectangle 15">
+              <a:extLst>
+                <a:ext uri="{FF2B5EF4-FFF2-40B4-BE49-F238E27FC236}">
+                  <a16:creationId xmlns:a16="http://schemas.microsoft.com/office/drawing/2014/main" id="{3F3972F4-FE7E-48EA-AAD8-9BE5750A6672}"/>
+                </a:ext>
+                <a:ext uri="{C183D7F6-B498-43B3-948B-1728B52AA6E4}">
+                  <adec:decorative xmlns:adec="http://schemas.microsoft.com/office/drawing/2017/decorative" val="1"/>
+                </a:ext>
+              </a:extLst>
+            </p:cNvPr>
+            <p:cNvSpPr>
+              <a:spLocks/>
+            </p:cNvSpPr>
+            <p:nvPr>
+              <p:extLst>
+                <p:ext uri="{386F3935-93C4-4BCD-93E2-E3B085C9AB24}">
+                  <p16:designElem xmlns:p16="http://schemas.microsoft.com/office/powerpoint/2015/main" val="1"/>
+                </p:ext>
+              </p:extLst>
+            </p:nvPr>
+          </p:nvSpPr>
+          <p:spPr>
+            <a:xfrm>
+              <a:off x="8042147" y="453643"/>
+              <a:ext cx="3703320" cy="98554"/>
+            </a:xfrm>
+            <a:prstGeom prst="rect">
+              <a:avLst/>
+            </a:prstGeom>
+            <a:solidFill>
+              <a:schemeClr val="accent4"/>
+            </a:solidFill>
+            <a:ln>
+              <a:noFill/>
+            </a:ln>
+            <a:effectLst/>
+          </p:spPr>
+          <p:style>
+            <a:lnRef idx="1">
+              <a:schemeClr val="accent1"/>
+            </a:lnRef>
+            <a:fillRef idx="3">
+              <a:schemeClr val="accent1"/>
+            </a:fillRef>
+            <a:effectRef idx="2">
+              <a:schemeClr val="accent1"/>
+            </a:effectRef>
+            <a:fontRef idx="minor">
+              <a:schemeClr val="lt1"/>
+            </a:fontRef>
+          </p:style>
+          <p:txBody>
+            <a:bodyPr/>
+            <a:lstStyle/>
+            <a:p>
+              <a:endParaRPr lang="fr-FR"/>
+            </a:p>
+          </p:txBody>
+        </p:sp>
+        <p:sp>
+          <p:nvSpPr>
+            <p:cNvPr id="17" name="Rectangle 16">
+              <a:extLst>
+                <a:ext uri="{FF2B5EF4-FFF2-40B4-BE49-F238E27FC236}">
+                  <a16:creationId xmlns:a16="http://schemas.microsoft.com/office/drawing/2014/main" id="{221614E5-870B-4D5E-A43B-8FF7E5323484}"/>
+                </a:ext>
+                <a:ext uri="{C183D7F6-B498-43B3-948B-1728B52AA6E4}">
+                  <adec:decorative xmlns:adec="http://schemas.microsoft.com/office/drawing/2017/decorative" val="1"/>
+                </a:ext>
+              </a:extLst>
+            </p:cNvPr>
+            <p:cNvSpPr>
+              <a:spLocks/>
+            </p:cNvSpPr>
+            <p:nvPr>
+              <p:extLst>
+                <p:ext uri="{386F3935-93C4-4BCD-93E2-E3B085C9AB24}">
+                  <p16:designElem xmlns:p16="http://schemas.microsoft.com/office/powerpoint/2015/main" val="1"/>
+                </p:ext>
+              </p:extLst>
+            </p:nvPr>
+          </p:nvSpPr>
+          <p:spPr>
+            <a:xfrm>
+              <a:off x="4241830" y="457200"/>
+              <a:ext cx="3703320" cy="91440"/>
+            </a:xfrm>
+            <a:prstGeom prst="rect">
+              <a:avLst/>
+            </a:prstGeom>
+            <a:solidFill>
+              <a:schemeClr val="accent2"/>
+            </a:solidFill>
+            <a:ln>
+              <a:noFill/>
+            </a:ln>
+            <a:effectLst/>
+          </p:spPr>
+          <p:style>
+            <a:lnRef idx="1">
+              <a:schemeClr val="accent1"/>
+            </a:lnRef>
+            <a:fillRef idx="3">
+              <a:schemeClr val="accent1"/>
+            </a:fillRef>
+            <a:effectRef idx="2">
+              <a:schemeClr val="accent1"/>
+            </a:effectRef>
+            <a:fontRef idx="minor">
+              <a:schemeClr val="lt1"/>
+            </a:fontRef>
+          </p:style>
+          <p:txBody>
+            <a:bodyPr/>
+            <a:lstStyle/>
+            <a:p>
+              <a:endParaRPr lang="fr-FR"/>
+            </a:p>
+          </p:txBody>
+        </p:sp>
+      </p:grpSp>
+      <p:sp>
+        <p:nvSpPr>
+          <p:cNvPr id="2" name="Titre 1">
+            <a:extLst>
+              <a:ext uri="{FF2B5EF4-FFF2-40B4-BE49-F238E27FC236}">
+                <a16:creationId xmlns:a16="http://schemas.microsoft.com/office/drawing/2014/main" id="{0F87E73C-2B1A-4602-BFBE-CFE1E55D9B38}"/>
+              </a:ext>
+            </a:extLst>
+          </p:cNvPr>
+          <p:cNvSpPr>
+            <a:spLocks noGrp="1"/>
+          </p:cNvSpPr>
+          <p:nvPr>
+            <p:ph type="ctrTitle"/>
+          </p:nvPr>
+        </p:nvSpPr>
+        <p:spPr>
+          <a:xfrm>
+            <a:off x="8296275" y="1419226"/>
+            <a:ext cx="3081576" cy="1746762"/>
+          </a:xfrm>
+        </p:spPr>
+        <p:txBody>
+          <a:bodyPr rtlCol="0">
+            <a:normAutofit/>
+          </a:bodyPr>
+          <a:lstStyle/>
+          <a:p>
+            <a:pPr rtl="0"/>
+            <a:r>
+              <a:rPr lang="fr-FR">
+                <a:solidFill>
+                  <a:srgbClr val="FFFFFF"/>
+                </a:solidFill>
+              </a:rPr>
+              <a:t>Merci</a:t>
+            </a:r>
+          </a:p>
+        </p:txBody>
+      </p:sp>
+      <p:sp>
+        <p:nvSpPr>
+          <p:cNvPr id="3" name="Sous-titre 2">
+            <a:extLst>
+              <a:ext uri="{FF2B5EF4-FFF2-40B4-BE49-F238E27FC236}">
+                <a16:creationId xmlns:a16="http://schemas.microsoft.com/office/drawing/2014/main" id="{A9CB511D-EA45-4336-847C-1252667143B5}"/>
+              </a:ext>
+            </a:extLst>
+          </p:cNvPr>
+          <p:cNvSpPr>
+            <a:spLocks noGrp="1"/>
+          </p:cNvSpPr>
+          <p:nvPr>
+            <p:ph type="subTitle" idx="1"/>
+          </p:nvPr>
+        </p:nvSpPr>
+        <p:spPr>
+          <a:xfrm>
+            <a:off x="8296275" y="3505095"/>
+            <a:ext cx="3081576" cy="2629006"/>
+          </a:xfrm>
+        </p:spPr>
+        <p:txBody>
+          <a:bodyPr rtlCol="0">
+            <a:normAutofit/>
+          </a:bodyPr>
+          <a:lstStyle/>
+          <a:p>
+            <a:pPr rtl="0"/>
+            <a:r>
+              <a:rPr lang="fr-FR">
+                <a:solidFill>
+                  <a:schemeClr val="bg2"/>
+                </a:solidFill>
+              </a:rPr>
+              <a:t>someone@example.com</a:t>
+            </a:r>
+          </a:p>
+          <a:p>
+            <a:pPr rtl="0"/>
+            <a:endParaRPr lang="fr-FR">
+              <a:solidFill>
+                <a:schemeClr val="bg2"/>
+              </a:solidFill>
+            </a:endParaRPr>
+          </a:p>
+          <a:p>
+            <a:pPr rtl="0"/>
+            <a:endParaRPr lang="fr-FR">
+              <a:solidFill>
+                <a:schemeClr val="bg2"/>
+              </a:solidFill>
+            </a:endParaRPr>
+          </a:p>
+        </p:txBody>
+      </p:sp>
+      <p:pic>
+        <p:nvPicPr>
+          <p:cNvPr id="5" name="Image 4" descr="Valeurs numériques">
+            <a:extLst>
+              <a:ext uri="{FF2B5EF4-FFF2-40B4-BE49-F238E27FC236}">
+                <a16:creationId xmlns:a16="http://schemas.microsoft.com/office/drawing/2014/main" id="{A21EA617-6D48-425F-97A8-7FEC82C8F401}"/>
+              </a:ext>
+            </a:extLst>
+          </p:cNvPr>
+          <p:cNvPicPr>
+            <a:picLocks noChangeAspect="1"/>
+          </p:cNvPicPr>
+          <p:nvPr/>
+        </p:nvPicPr>
+        <p:blipFill rotWithShape="1">
+          <a:blip r:embed="rId3" cstate="screen">
+            <a:extLst>
+              <a:ext uri="{28A0092B-C50C-407E-A947-70E740481C1C}">
+                <a14:useLocalDpi xmlns:a14="http://schemas.microsoft.com/office/drawing/2010/main"/>
+              </a:ext>
+            </a:extLst>
+          </a:blip>
+          <a:srcRect l="2189" r="9642" b="1"/>
+          <a:stretch/>
+        </p:blipFill>
+        <p:spPr>
+          <a:xfrm>
+            <a:off x="446534" y="723899"/>
+            <a:ext cx="7498616" cy="5676901"/>
+          </a:xfrm>
+          <a:prstGeom prst="rect">
+            <a:avLst/>
+          </a:prstGeom>
+        </p:spPr>
+      </p:pic>
+    </p:spTree>
+    <p:extLst>
+      <p:ext uri="{BB962C8B-B14F-4D97-AF65-F5344CB8AC3E}">
+        <p14:creationId xmlns:p14="http://schemas.microsoft.com/office/powerpoint/2010/main" val="3501347425"/>
       </p:ext>
     </p:extLst>
   </p:cSld>
@@ -12099,7 +13172,7 @@
           <a:p>
             <a:r>
               <a:rPr lang="fr-FR" dirty="0"/>
-              <a:t>Nettoyage des données</a:t>
+              <a:t>Analyse des données</a:t>
             </a:r>
           </a:p>
         </p:txBody>
@@ -12127,22 +13200,65 @@
           <a:p>
             <a:r>
               <a:rPr lang="fr-FR" dirty="0" err="1"/>
+              <a:t>ayant_enfants</a:t>
+            </a:r>
+            <a:r>
+              <a:rPr lang="fr-FR" dirty="0"/>
+              <a:t>, </a:t>
+            </a:r>
+            <a:r>
+              <a:rPr lang="fr-FR" dirty="0" err="1"/>
               <a:t>nombre_heures_travailless</a:t>
             </a:r>
             <a:r>
               <a:rPr lang="fr-FR" dirty="0"/>
-              <a:t> n’est pas exploitable car toujours égale à 80</a:t>
+              <a:t>, </a:t>
             </a:r>
-          </a:p>
-          <a:p>
             <a:r>
               <a:rPr lang="fr-FR" dirty="0" err="1"/>
               <a:t>nombre_employee_sous_responsabilite</a:t>
             </a:r>
             <a:r>
               <a:rPr lang="fr-FR" dirty="0"/>
-              <a:t> n’est pas exploitable car toujours égale à 1</a:t>
+              <a:t> ne sont pas exploitables car toujours la même valeur</a:t>
             </a:r>
+          </a:p>
+          <a:p>
+            <a:r>
+              <a:rPr lang="fr-FR" dirty="0" err="1"/>
+              <a:t>code_sondage</a:t>
+            </a:r>
+            <a:r>
+              <a:rPr lang="fr-FR" dirty="0"/>
+              <a:t>, </a:t>
+            </a:r>
+            <a:r>
+              <a:rPr lang="fr-FR" dirty="0" err="1"/>
+              <a:t>id_employee</a:t>
+            </a:r>
+            <a:r>
+              <a:rPr lang="fr-FR" dirty="0"/>
+              <a:t> et </a:t>
+            </a:r>
+            <a:r>
+              <a:rPr lang="fr-FR" dirty="0" err="1"/>
+              <a:t>eval_number</a:t>
+            </a:r>
+            <a:r>
+              <a:rPr lang="fr-FR" dirty="0"/>
+              <a:t> </a:t>
+            </a:r>
+            <a:r>
+              <a:rPr lang="fr-FR" dirty="0" err="1"/>
+              <a:t>répéte</a:t>
+            </a:r>
+            <a:r>
+              <a:rPr lang="fr-FR" dirty="0"/>
+              <a:t> le même schéma de codification, il est utilisé pour réaliser la jointure des données. NOTE: le nombre d’individus est identique</a:t>
+            </a:r>
+          </a:p>
+          <a:p>
+            <a:endParaRPr lang="fr-FR" dirty="0"/>
           </a:p>
           <a:p>
             <a:endParaRPr lang="fr-FR" dirty="0"/>
@@ -12166,6 +13282,1552 @@
 </file>
 
 <file path=ppt/slides/slide4.xml><?xml version="1.0" encoding="utf-8"?>
+<p:sld xmlns:a="http://schemas.openxmlformats.org/drawingml/2006/main" xmlns:r="http://schemas.openxmlformats.org/officeDocument/2006/relationships" xmlns:p="http://schemas.openxmlformats.org/presentationml/2006/main">
+  <p:cSld>
+    <p:spTree>
+      <p:nvGrpSpPr>
+        <p:cNvPr id="1" name="">
+          <a:extLst>
+            <a:ext uri="{FF2B5EF4-FFF2-40B4-BE49-F238E27FC236}">
+              <a16:creationId xmlns:a16="http://schemas.microsoft.com/office/drawing/2014/main" id="{0F11944E-D976-AFD6-A029-2AB9320292A1}"/>
+            </a:ext>
+          </a:extLst>
+        </p:cNvPr>
+        <p:cNvGrpSpPr/>
+        <p:nvPr/>
+      </p:nvGrpSpPr>
+      <p:grpSpPr>
+        <a:xfrm>
+          <a:off x="0" y="0"/>
+          <a:ext cx="0" cy="0"/>
+          <a:chOff x="0" y="0"/>
+          <a:chExt cx="0" cy="0"/>
+        </a:xfrm>
+      </p:grpSpPr>
+      <p:sp>
+        <p:nvSpPr>
+          <p:cNvPr id="2" name="Titre 1">
+            <a:extLst>
+              <a:ext uri="{FF2B5EF4-FFF2-40B4-BE49-F238E27FC236}">
+                <a16:creationId xmlns:a16="http://schemas.microsoft.com/office/drawing/2014/main" id="{81FBCABC-2343-6D2B-8B60-2CE36432EF80}"/>
+              </a:ext>
+            </a:extLst>
+          </p:cNvPr>
+          <p:cNvSpPr>
+            <a:spLocks noGrp="1"/>
+          </p:cNvSpPr>
+          <p:nvPr>
+            <p:ph type="title"/>
+          </p:nvPr>
+        </p:nvSpPr>
+        <p:spPr/>
+        <p:txBody>
+          <a:bodyPr/>
+          <a:lstStyle/>
+          <a:p>
+            <a:r>
+              <a:rPr lang="fr-FR" dirty="0"/>
+              <a:t>Nettoyage des données</a:t>
+            </a:r>
+          </a:p>
+        </p:txBody>
+      </p:sp>
+      <p:pic>
+        <p:nvPicPr>
+          <p:cNvPr id="7" name="Image 6">
+            <a:extLst>
+              <a:ext uri="{FF2B5EF4-FFF2-40B4-BE49-F238E27FC236}">
+                <a16:creationId xmlns:a16="http://schemas.microsoft.com/office/drawing/2014/main" id="{FC0BAC50-24AD-96BC-3D5C-F452D7802D3C}"/>
+              </a:ext>
+            </a:extLst>
+          </p:cNvPr>
+          <p:cNvPicPr>
+            <a:picLocks noChangeAspect="1"/>
+          </p:cNvPicPr>
+          <p:nvPr/>
+        </p:nvPicPr>
+        <p:blipFill>
+          <a:blip r:embed="rId2"/>
+          <a:stretch>
+            <a:fillRect/>
+          </a:stretch>
+        </p:blipFill>
+        <p:spPr>
+          <a:xfrm>
+            <a:off x="781217" y="2137634"/>
+            <a:ext cx="3619333" cy="4362523"/>
+          </a:xfrm>
+          <a:prstGeom prst="rect">
+            <a:avLst/>
+          </a:prstGeom>
+        </p:spPr>
+      </p:pic>
+      <p:sp>
+        <p:nvSpPr>
+          <p:cNvPr id="9" name="Rectangle 8">
+            <a:extLst>
+              <a:ext uri="{FF2B5EF4-FFF2-40B4-BE49-F238E27FC236}">
+                <a16:creationId xmlns:a16="http://schemas.microsoft.com/office/drawing/2014/main" id="{09F2BC9D-C56A-8848-61AE-D43BAE42B800}"/>
+              </a:ext>
+            </a:extLst>
+          </p:cNvPr>
+          <p:cNvSpPr/>
+          <p:nvPr/>
+        </p:nvSpPr>
+        <p:spPr>
+          <a:xfrm>
+            <a:off x="5427558" y="3069000"/>
+            <a:ext cx="3945041" cy="1345838"/>
+          </a:xfrm>
+          <a:prstGeom prst="rect">
+            <a:avLst/>
+          </a:prstGeom>
+        </p:spPr>
+        <p:style>
+          <a:lnRef idx="0">
+            <a:schemeClr val="dk1">
+              <a:alpha val="0"/>
+              <a:hueOff val="0"/>
+              <a:satOff val="0"/>
+              <a:lumOff val="0"/>
+              <a:alphaOff val="0"/>
+            </a:schemeClr>
+          </a:lnRef>
+          <a:fillRef idx="0">
+            <a:schemeClr val="lt1">
+              <a:alpha val="0"/>
+              <a:hueOff val="0"/>
+              <a:satOff val="0"/>
+              <a:lumOff val="0"/>
+              <a:alphaOff val="0"/>
+            </a:schemeClr>
+          </a:fillRef>
+          <a:effectRef idx="0">
+            <a:schemeClr val="lt1">
+              <a:alpha val="0"/>
+              <a:hueOff val="0"/>
+              <a:satOff val="0"/>
+              <a:lumOff val="0"/>
+              <a:alphaOff val="0"/>
+            </a:schemeClr>
+          </a:effectRef>
+          <a:fontRef idx="minor">
+            <a:schemeClr val="tx1">
+              <a:hueOff val="0"/>
+              <a:satOff val="0"/>
+              <a:lumOff val="0"/>
+              <a:alphaOff val="0"/>
+            </a:schemeClr>
+          </a:fontRef>
+        </p:style>
+        <p:txBody>
+          <a:bodyPr/>
+          <a:lstStyle/>
+          <a:p>
+            <a:endParaRPr lang="fr-FR"/>
+          </a:p>
+        </p:txBody>
+      </p:sp>
+      <p:sp>
+        <p:nvSpPr>
+          <p:cNvPr id="10" name="ZoneTexte 9">
+            <a:extLst>
+              <a:ext uri="{FF2B5EF4-FFF2-40B4-BE49-F238E27FC236}">
+                <a16:creationId xmlns:a16="http://schemas.microsoft.com/office/drawing/2014/main" id="{BF8671AB-ACF1-DA62-0A87-0265F27AE949}"/>
+              </a:ext>
+            </a:extLst>
+          </p:cNvPr>
+          <p:cNvSpPr txBox="1"/>
+          <p:nvPr/>
+        </p:nvSpPr>
+        <p:spPr>
+          <a:xfrm>
+            <a:off x="6096000" y="2510381"/>
+            <a:ext cx="3945041" cy="1117238"/>
+          </a:xfrm>
+          <a:prstGeom prst="rect">
+            <a:avLst/>
+          </a:prstGeom>
+        </p:spPr>
+        <p:style>
+          <a:lnRef idx="0">
+            <a:scrgbClr r="0" g="0" b="0"/>
+          </a:lnRef>
+          <a:fillRef idx="0">
+            <a:scrgbClr r="0" g="0" b="0"/>
+          </a:fillRef>
+          <a:effectRef idx="0">
+            <a:scrgbClr r="0" g="0" b="0"/>
+          </a:effectRef>
+          <a:fontRef idx="minor">
+            <a:schemeClr val="tx1">
+              <a:hueOff val="0"/>
+              <a:satOff val="0"/>
+              <a:lumOff val="0"/>
+              <a:alphaOff val="0"/>
+            </a:schemeClr>
+          </a:fontRef>
+        </p:style>
+        <p:txBody>
+          <a:bodyPr spcFirstLastPara="0" vert="horz" wrap="square" lIns="0" tIns="0" rIns="0" bIns="0" numCol="1" spcCol="1270" rtlCol="0" anchor="t" anchorCtr="0">
+            <a:noAutofit/>
+          </a:bodyPr>
+          <a:lstStyle/>
+          <a:p>
+            <a:pPr marL="0" lvl="0" indent="0" algn="ctr" defTabSz="1600200" rtl="0">
+              <a:lnSpc>
+                <a:spcPct val="90000"/>
+              </a:lnSpc>
+              <a:spcBef>
+                <a:spcPct val="0"/>
+              </a:spcBef>
+              <a:spcAft>
+                <a:spcPct val="35000"/>
+              </a:spcAft>
+              <a:buNone/>
+            </a:pPr>
+            <a:r>
+              <a:rPr lang="fr-FR" sz="3600" kern="1200" noProof="0" dirty="0"/>
+              <a:t>Vérification des </a:t>
+            </a:r>
+            <a:r>
+              <a:rPr lang="fr-FR" sz="3600" kern="1200" noProof="0" dirty="0" err="1"/>
+              <a:t>outliers</a:t>
+            </a:r>
+            <a:endParaRPr lang="fr-FR" sz="3600" kern="1200" noProof="0" dirty="0"/>
+          </a:p>
+        </p:txBody>
+      </p:sp>
+      <p:sp>
+        <p:nvSpPr>
+          <p:cNvPr id="11" name="ZoneTexte 10">
+            <a:extLst>
+              <a:ext uri="{FF2B5EF4-FFF2-40B4-BE49-F238E27FC236}">
+                <a16:creationId xmlns:a16="http://schemas.microsoft.com/office/drawing/2014/main" id="{2BB2067E-1D19-2FC9-933D-31E2378F6476}"/>
+              </a:ext>
+            </a:extLst>
+          </p:cNvPr>
+          <p:cNvSpPr txBox="1"/>
+          <p:nvPr/>
+        </p:nvSpPr>
+        <p:spPr>
+          <a:xfrm>
+            <a:off x="6095999" y="4318895"/>
+            <a:ext cx="3945041" cy="1117238"/>
+          </a:xfrm>
+          <a:prstGeom prst="rect">
+            <a:avLst/>
+          </a:prstGeom>
+        </p:spPr>
+        <p:style>
+          <a:lnRef idx="0">
+            <a:scrgbClr r="0" g="0" b="0"/>
+          </a:lnRef>
+          <a:fillRef idx="0">
+            <a:scrgbClr r="0" g="0" b="0"/>
+          </a:fillRef>
+          <a:effectRef idx="0">
+            <a:scrgbClr r="0" g="0" b="0"/>
+          </a:effectRef>
+          <a:fontRef idx="minor">
+            <a:schemeClr val="tx1">
+              <a:hueOff val="0"/>
+              <a:satOff val="0"/>
+              <a:lumOff val="0"/>
+              <a:alphaOff val="0"/>
+            </a:schemeClr>
+          </a:fontRef>
+        </p:style>
+        <p:txBody>
+          <a:bodyPr spcFirstLastPara="0" vert="horz" wrap="square" lIns="0" tIns="0" rIns="0" bIns="0" numCol="1" spcCol="1270" rtlCol="0" anchor="t" anchorCtr="0">
+            <a:noAutofit/>
+          </a:bodyPr>
+          <a:lstStyle/>
+          <a:p>
+            <a:pPr marL="0" lvl="0" indent="0" algn="ctr" defTabSz="1600200" rtl="0">
+              <a:lnSpc>
+                <a:spcPct val="90000"/>
+              </a:lnSpc>
+              <a:spcBef>
+                <a:spcPct val="0"/>
+              </a:spcBef>
+              <a:spcAft>
+                <a:spcPct val="35000"/>
+              </a:spcAft>
+              <a:buNone/>
+            </a:pPr>
+            <a:r>
+              <a:rPr lang="fr-FR" sz="3600" kern="1200" noProof="0" dirty="0"/>
+              <a:t>Sondages</a:t>
+            </a:r>
+          </a:p>
+        </p:txBody>
+      </p:sp>
+    </p:spTree>
+    <p:extLst>
+      <p:ext uri="{BB962C8B-B14F-4D97-AF65-F5344CB8AC3E}">
+        <p14:creationId xmlns:p14="http://schemas.microsoft.com/office/powerpoint/2010/main" val="2483046686"/>
+      </p:ext>
+    </p:extLst>
+  </p:cSld>
+  <p:clrMapOvr>
+    <a:masterClrMapping/>
+  </p:clrMapOvr>
+</p:sld>
+</file>
+
+<file path=ppt/slides/slide5.xml><?xml version="1.0" encoding="utf-8"?>
+<p:sld xmlns:a="http://schemas.openxmlformats.org/drawingml/2006/main" xmlns:r="http://schemas.openxmlformats.org/officeDocument/2006/relationships" xmlns:p="http://schemas.openxmlformats.org/presentationml/2006/main">
+  <p:cSld>
+    <p:spTree>
+      <p:nvGrpSpPr>
+        <p:cNvPr id="1" name="">
+          <a:extLst>
+            <a:ext uri="{FF2B5EF4-FFF2-40B4-BE49-F238E27FC236}">
+              <a16:creationId xmlns:a16="http://schemas.microsoft.com/office/drawing/2014/main" id="{B5A566E3-C82F-DF66-8759-7733BF5689EF}"/>
+            </a:ext>
+          </a:extLst>
+        </p:cNvPr>
+        <p:cNvGrpSpPr/>
+        <p:nvPr/>
+      </p:nvGrpSpPr>
+      <p:grpSpPr>
+        <a:xfrm>
+          <a:off x="0" y="0"/>
+          <a:ext cx="0" cy="0"/>
+          <a:chOff x="0" y="0"/>
+          <a:chExt cx="0" cy="0"/>
+        </a:xfrm>
+      </p:grpSpPr>
+      <p:sp>
+        <p:nvSpPr>
+          <p:cNvPr id="2" name="Titre 1">
+            <a:extLst>
+              <a:ext uri="{FF2B5EF4-FFF2-40B4-BE49-F238E27FC236}">
+                <a16:creationId xmlns:a16="http://schemas.microsoft.com/office/drawing/2014/main" id="{20ACA291-9CD1-A847-9743-258B65A620DC}"/>
+              </a:ext>
+            </a:extLst>
+          </p:cNvPr>
+          <p:cNvSpPr>
+            <a:spLocks noGrp="1"/>
+          </p:cNvSpPr>
+          <p:nvPr>
+            <p:ph type="title"/>
+          </p:nvPr>
+        </p:nvSpPr>
+        <p:spPr/>
+        <p:txBody>
+          <a:bodyPr/>
+          <a:lstStyle/>
+          <a:p>
+            <a:r>
+              <a:rPr lang="fr-FR" dirty="0"/>
+              <a:t>Nettoyage des données</a:t>
+            </a:r>
+          </a:p>
+        </p:txBody>
+      </p:sp>
+      <p:sp>
+        <p:nvSpPr>
+          <p:cNvPr id="9" name="Rectangle 8">
+            <a:extLst>
+              <a:ext uri="{FF2B5EF4-FFF2-40B4-BE49-F238E27FC236}">
+                <a16:creationId xmlns:a16="http://schemas.microsoft.com/office/drawing/2014/main" id="{26FB824A-C73C-67EA-8E29-DCF74DA8EF15}"/>
+              </a:ext>
+            </a:extLst>
+          </p:cNvPr>
+          <p:cNvSpPr/>
+          <p:nvPr/>
+        </p:nvSpPr>
+        <p:spPr>
+          <a:xfrm>
+            <a:off x="5427558" y="3069000"/>
+            <a:ext cx="3945041" cy="1345838"/>
+          </a:xfrm>
+          <a:prstGeom prst="rect">
+            <a:avLst/>
+          </a:prstGeom>
+        </p:spPr>
+        <p:style>
+          <a:lnRef idx="0">
+            <a:schemeClr val="dk1">
+              <a:alpha val="0"/>
+              <a:hueOff val="0"/>
+              <a:satOff val="0"/>
+              <a:lumOff val="0"/>
+              <a:alphaOff val="0"/>
+            </a:schemeClr>
+          </a:lnRef>
+          <a:fillRef idx="0">
+            <a:schemeClr val="lt1">
+              <a:alpha val="0"/>
+              <a:hueOff val="0"/>
+              <a:satOff val="0"/>
+              <a:lumOff val="0"/>
+              <a:alphaOff val="0"/>
+            </a:schemeClr>
+          </a:fillRef>
+          <a:effectRef idx="0">
+            <a:schemeClr val="lt1">
+              <a:alpha val="0"/>
+              <a:hueOff val="0"/>
+              <a:satOff val="0"/>
+              <a:lumOff val="0"/>
+              <a:alphaOff val="0"/>
+            </a:schemeClr>
+          </a:effectRef>
+          <a:fontRef idx="minor">
+            <a:schemeClr val="tx1">
+              <a:hueOff val="0"/>
+              <a:satOff val="0"/>
+              <a:lumOff val="0"/>
+              <a:alphaOff val="0"/>
+            </a:schemeClr>
+          </a:fontRef>
+        </p:style>
+        <p:txBody>
+          <a:bodyPr/>
+          <a:lstStyle/>
+          <a:p>
+            <a:endParaRPr lang="fr-FR"/>
+          </a:p>
+        </p:txBody>
+      </p:sp>
+      <p:sp>
+        <p:nvSpPr>
+          <p:cNvPr id="10" name="ZoneTexte 9">
+            <a:extLst>
+              <a:ext uri="{FF2B5EF4-FFF2-40B4-BE49-F238E27FC236}">
+                <a16:creationId xmlns:a16="http://schemas.microsoft.com/office/drawing/2014/main" id="{0687BD56-18D9-EE09-2D7B-FF4969DC6BB6}"/>
+              </a:ext>
+            </a:extLst>
+          </p:cNvPr>
+          <p:cNvSpPr txBox="1"/>
+          <p:nvPr/>
+        </p:nvSpPr>
+        <p:spPr>
+          <a:xfrm>
+            <a:off x="7851505" y="768196"/>
+            <a:ext cx="3945041" cy="1117238"/>
+          </a:xfrm>
+          <a:prstGeom prst="rect">
+            <a:avLst/>
+          </a:prstGeom>
+        </p:spPr>
+        <p:style>
+          <a:lnRef idx="0">
+            <a:scrgbClr r="0" g="0" b="0"/>
+          </a:lnRef>
+          <a:fillRef idx="0">
+            <a:scrgbClr r="0" g="0" b="0"/>
+          </a:fillRef>
+          <a:effectRef idx="0">
+            <a:scrgbClr r="0" g="0" b="0"/>
+          </a:effectRef>
+          <a:fontRef idx="minor">
+            <a:schemeClr val="tx1">
+              <a:hueOff val="0"/>
+              <a:satOff val="0"/>
+              <a:lumOff val="0"/>
+              <a:alphaOff val="0"/>
+            </a:schemeClr>
+          </a:fontRef>
+        </p:style>
+        <p:txBody>
+          <a:bodyPr spcFirstLastPara="0" vert="horz" wrap="square" lIns="0" tIns="0" rIns="0" bIns="0" numCol="1" spcCol="1270" rtlCol="0" anchor="t" anchorCtr="0">
+            <a:noAutofit/>
+          </a:bodyPr>
+          <a:lstStyle/>
+          <a:p>
+            <a:pPr marL="0" lvl="0" indent="0" algn="ctr" defTabSz="1600200" rtl="0">
+              <a:lnSpc>
+                <a:spcPct val="90000"/>
+              </a:lnSpc>
+              <a:spcBef>
+                <a:spcPct val="0"/>
+              </a:spcBef>
+              <a:spcAft>
+                <a:spcPct val="35000"/>
+              </a:spcAft>
+              <a:buNone/>
+            </a:pPr>
+            <a:r>
+              <a:rPr lang="fr-FR" sz="3600" kern="1200" noProof="0" dirty="0">
+                <a:solidFill>
+                  <a:schemeClr val="bg1"/>
+                </a:solidFill>
+              </a:rPr>
+              <a:t>Vérification des </a:t>
+            </a:r>
+            <a:r>
+              <a:rPr lang="fr-FR" sz="3600" kern="1200" noProof="0" dirty="0" err="1">
+                <a:solidFill>
+                  <a:schemeClr val="bg1"/>
+                </a:solidFill>
+              </a:rPr>
+              <a:t>outliers</a:t>
+            </a:r>
+            <a:endParaRPr lang="fr-FR" sz="3600" kern="1200" noProof="0" dirty="0">
+              <a:solidFill>
+                <a:schemeClr val="bg1"/>
+              </a:solidFill>
+            </a:endParaRPr>
+          </a:p>
+        </p:txBody>
+      </p:sp>
+      <p:sp>
+        <p:nvSpPr>
+          <p:cNvPr id="11" name="ZoneTexte 10">
+            <a:extLst>
+              <a:ext uri="{FF2B5EF4-FFF2-40B4-BE49-F238E27FC236}">
+                <a16:creationId xmlns:a16="http://schemas.microsoft.com/office/drawing/2014/main" id="{1F9AAE34-936D-333F-445E-135C0D9BF84D}"/>
+              </a:ext>
+            </a:extLst>
+          </p:cNvPr>
+          <p:cNvSpPr txBox="1"/>
+          <p:nvPr/>
+        </p:nvSpPr>
+        <p:spPr>
+          <a:xfrm>
+            <a:off x="5972174" y="936943"/>
+            <a:ext cx="1879331" cy="563245"/>
+          </a:xfrm>
+          <a:prstGeom prst="rect">
+            <a:avLst/>
+          </a:prstGeom>
+        </p:spPr>
+        <p:style>
+          <a:lnRef idx="0">
+            <a:scrgbClr r="0" g="0" b="0"/>
+          </a:lnRef>
+          <a:fillRef idx="0">
+            <a:scrgbClr r="0" g="0" b="0"/>
+          </a:fillRef>
+          <a:effectRef idx="0">
+            <a:scrgbClr r="0" g="0" b="0"/>
+          </a:effectRef>
+          <a:fontRef idx="minor">
+            <a:schemeClr val="tx1">
+              <a:hueOff val="0"/>
+              <a:satOff val="0"/>
+              <a:lumOff val="0"/>
+              <a:alphaOff val="0"/>
+            </a:schemeClr>
+          </a:fontRef>
+        </p:style>
+        <p:txBody>
+          <a:bodyPr spcFirstLastPara="0" vert="horz" wrap="square" lIns="0" tIns="0" rIns="0" bIns="0" numCol="1" spcCol="1270" rtlCol="0" anchor="t" anchorCtr="0">
+            <a:noAutofit/>
+          </a:bodyPr>
+          <a:lstStyle/>
+          <a:p>
+            <a:pPr marL="0" lvl="0" indent="0" algn="ctr" defTabSz="1600200" rtl="0">
+              <a:lnSpc>
+                <a:spcPct val="90000"/>
+              </a:lnSpc>
+              <a:spcBef>
+                <a:spcPct val="0"/>
+              </a:spcBef>
+              <a:spcAft>
+                <a:spcPct val="35000"/>
+              </a:spcAft>
+              <a:buNone/>
+            </a:pPr>
+            <a:r>
+              <a:rPr lang="fr-FR" sz="3600" kern="1200" noProof="0" dirty="0">
+                <a:solidFill>
+                  <a:schemeClr val="bg1"/>
+                </a:solidFill>
+              </a:rPr>
+              <a:t>sirh</a:t>
+            </a:r>
+          </a:p>
+        </p:txBody>
+      </p:sp>
+      <p:pic>
+        <p:nvPicPr>
+          <p:cNvPr id="6" name="Image 5">
+            <a:extLst>
+              <a:ext uri="{FF2B5EF4-FFF2-40B4-BE49-F238E27FC236}">
+                <a16:creationId xmlns:a16="http://schemas.microsoft.com/office/drawing/2014/main" id="{D964BAB3-7C64-7797-96F1-1E1C6729BDCD}"/>
+              </a:ext>
+            </a:extLst>
+          </p:cNvPr>
+          <p:cNvPicPr>
+            <a:picLocks noChangeAspect="1"/>
+          </p:cNvPicPr>
+          <p:nvPr/>
+        </p:nvPicPr>
+        <p:blipFill>
+          <a:blip r:embed="rId2"/>
+          <a:stretch>
+            <a:fillRect/>
+          </a:stretch>
+        </p:blipFill>
+        <p:spPr>
+          <a:xfrm>
+            <a:off x="472884" y="2120220"/>
+            <a:ext cx="11267451" cy="4223429"/>
+          </a:xfrm>
+          <a:prstGeom prst="rect">
+            <a:avLst/>
+          </a:prstGeom>
+        </p:spPr>
+      </p:pic>
+    </p:spTree>
+    <p:extLst>
+      <p:ext uri="{BB962C8B-B14F-4D97-AF65-F5344CB8AC3E}">
+        <p14:creationId xmlns:p14="http://schemas.microsoft.com/office/powerpoint/2010/main" val="2438794806"/>
+      </p:ext>
+    </p:extLst>
+  </p:cSld>
+  <p:clrMapOvr>
+    <a:masterClrMapping/>
+  </p:clrMapOvr>
+</p:sld>
+</file>
+
+<file path=ppt/slides/slide6.xml><?xml version="1.0" encoding="utf-8"?>
+<p:sld xmlns:a="http://schemas.openxmlformats.org/drawingml/2006/main" xmlns:r="http://schemas.openxmlformats.org/officeDocument/2006/relationships" xmlns:p="http://schemas.openxmlformats.org/presentationml/2006/main">
+  <p:cSld>
+    <p:spTree>
+      <p:nvGrpSpPr>
+        <p:cNvPr id="1" name="">
+          <a:extLst>
+            <a:ext uri="{FF2B5EF4-FFF2-40B4-BE49-F238E27FC236}">
+              <a16:creationId xmlns:a16="http://schemas.microsoft.com/office/drawing/2014/main" id="{6026A3C0-92CB-8C29-7135-24F70C2B071A}"/>
+            </a:ext>
+          </a:extLst>
+        </p:cNvPr>
+        <p:cNvGrpSpPr/>
+        <p:nvPr/>
+      </p:nvGrpSpPr>
+      <p:grpSpPr>
+        <a:xfrm>
+          <a:off x="0" y="0"/>
+          <a:ext cx="0" cy="0"/>
+          <a:chOff x="0" y="0"/>
+          <a:chExt cx="0" cy="0"/>
+        </a:xfrm>
+      </p:grpSpPr>
+      <p:sp>
+        <p:nvSpPr>
+          <p:cNvPr id="2" name="Titre 1">
+            <a:extLst>
+              <a:ext uri="{FF2B5EF4-FFF2-40B4-BE49-F238E27FC236}">
+                <a16:creationId xmlns:a16="http://schemas.microsoft.com/office/drawing/2014/main" id="{0EA4323E-4134-FB1C-BE87-E5678A804402}"/>
+              </a:ext>
+            </a:extLst>
+          </p:cNvPr>
+          <p:cNvSpPr>
+            <a:spLocks noGrp="1"/>
+          </p:cNvSpPr>
+          <p:nvPr>
+            <p:ph type="title"/>
+          </p:nvPr>
+        </p:nvSpPr>
+        <p:spPr/>
+        <p:txBody>
+          <a:bodyPr/>
+          <a:lstStyle/>
+          <a:p>
+            <a:r>
+              <a:rPr lang="fr-FR" dirty="0"/>
+              <a:t>Nettoyage des données</a:t>
+            </a:r>
+          </a:p>
+        </p:txBody>
+      </p:sp>
+      <p:sp>
+        <p:nvSpPr>
+          <p:cNvPr id="9" name="Rectangle 8">
+            <a:extLst>
+              <a:ext uri="{FF2B5EF4-FFF2-40B4-BE49-F238E27FC236}">
+                <a16:creationId xmlns:a16="http://schemas.microsoft.com/office/drawing/2014/main" id="{685B9582-4D22-9528-D283-4327CC401327}"/>
+              </a:ext>
+            </a:extLst>
+          </p:cNvPr>
+          <p:cNvSpPr/>
+          <p:nvPr/>
+        </p:nvSpPr>
+        <p:spPr>
+          <a:xfrm>
+            <a:off x="5427558" y="3069000"/>
+            <a:ext cx="3945041" cy="1345838"/>
+          </a:xfrm>
+          <a:prstGeom prst="rect">
+            <a:avLst/>
+          </a:prstGeom>
+        </p:spPr>
+        <p:style>
+          <a:lnRef idx="0">
+            <a:schemeClr val="dk1">
+              <a:alpha val="0"/>
+              <a:hueOff val="0"/>
+              <a:satOff val="0"/>
+              <a:lumOff val="0"/>
+              <a:alphaOff val="0"/>
+            </a:schemeClr>
+          </a:lnRef>
+          <a:fillRef idx="0">
+            <a:schemeClr val="lt1">
+              <a:alpha val="0"/>
+              <a:hueOff val="0"/>
+              <a:satOff val="0"/>
+              <a:lumOff val="0"/>
+              <a:alphaOff val="0"/>
+            </a:schemeClr>
+          </a:fillRef>
+          <a:effectRef idx="0">
+            <a:schemeClr val="lt1">
+              <a:alpha val="0"/>
+              <a:hueOff val="0"/>
+              <a:satOff val="0"/>
+              <a:lumOff val="0"/>
+              <a:alphaOff val="0"/>
+            </a:schemeClr>
+          </a:effectRef>
+          <a:fontRef idx="minor">
+            <a:schemeClr val="tx1">
+              <a:hueOff val="0"/>
+              <a:satOff val="0"/>
+              <a:lumOff val="0"/>
+              <a:alphaOff val="0"/>
+            </a:schemeClr>
+          </a:fontRef>
+        </p:style>
+        <p:txBody>
+          <a:bodyPr/>
+          <a:lstStyle/>
+          <a:p>
+            <a:endParaRPr lang="fr-FR"/>
+          </a:p>
+        </p:txBody>
+      </p:sp>
+      <p:sp>
+        <p:nvSpPr>
+          <p:cNvPr id="10" name="ZoneTexte 9">
+            <a:extLst>
+              <a:ext uri="{FF2B5EF4-FFF2-40B4-BE49-F238E27FC236}">
+                <a16:creationId xmlns:a16="http://schemas.microsoft.com/office/drawing/2014/main" id="{0DCCCBF1-DDEE-4EF0-F209-1D9A007FFD5A}"/>
+              </a:ext>
+            </a:extLst>
+          </p:cNvPr>
+          <p:cNvSpPr txBox="1"/>
+          <p:nvPr/>
+        </p:nvSpPr>
+        <p:spPr>
+          <a:xfrm>
+            <a:off x="7851505" y="768196"/>
+            <a:ext cx="3945041" cy="1117238"/>
+          </a:xfrm>
+          <a:prstGeom prst="rect">
+            <a:avLst/>
+          </a:prstGeom>
+        </p:spPr>
+        <p:style>
+          <a:lnRef idx="0">
+            <a:scrgbClr r="0" g="0" b="0"/>
+          </a:lnRef>
+          <a:fillRef idx="0">
+            <a:scrgbClr r="0" g="0" b="0"/>
+          </a:fillRef>
+          <a:effectRef idx="0">
+            <a:scrgbClr r="0" g="0" b="0"/>
+          </a:effectRef>
+          <a:fontRef idx="minor">
+            <a:schemeClr val="tx1">
+              <a:hueOff val="0"/>
+              <a:satOff val="0"/>
+              <a:lumOff val="0"/>
+              <a:alphaOff val="0"/>
+            </a:schemeClr>
+          </a:fontRef>
+        </p:style>
+        <p:txBody>
+          <a:bodyPr spcFirstLastPara="0" vert="horz" wrap="square" lIns="0" tIns="0" rIns="0" bIns="0" numCol="1" spcCol="1270" rtlCol="0" anchor="t" anchorCtr="0">
+            <a:noAutofit/>
+          </a:bodyPr>
+          <a:lstStyle/>
+          <a:p>
+            <a:pPr marL="0" lvl="0" indent="0" algn="ctr" defTabSz="1600200" rtl="0">
+              <a:lnSpc>
+                <a:spcPct val="90000"/>
+              </a:lnSpc>
+              <a:spcBef>
+                <a:spcPct val="0"/>
+              </a:spcBef>
+              <a:spcAft>
+                <a:spcPct val="35000"/>
+              </a:spcAft>
+              <a:buNone/>
+            </a:pPr>
+            <a:r>
+              <a:rPr lang="fr-FR" sz="3600" kern="1200" noProof="0" dirty="0">
+                <a:solidFill>
+                  <a:schemeClr val="bg1"/>
+                </a:solidFill>
+              </a:rPr>
+              <a:t>Vérification des </a:t>
+            </a:r>
+            <a:r>
+              <a:rPr lang="fr-FR" sz="3600" kern="1200" noProof="0" dirty="0" err="1">
+                <a:solidFill>
+                  <a:schemeClr val="bg1"/>
+                </a:solidFill>
+              </a:rPr>
+              <a:t>outliers</a:t>
+            </a:r>
+            <a:endParaRPr lang="fr-FR" sz="3600" kern="1200" noProof="0" dirty="0">
+              <a:solidFill>
+                <a:schemeClr val="bg1"/>
+              </a:solidFill>
+            </a:endParaRPr>
+          </a:p>
+        </p:txBody>
+      </p:sp>
+      <p:sp>
+        <p:nvSpPr>
+          <p:cNvPr id="11" name="ZoneTexte 10">
+            <a:extLst>
+              <a:ext uri="{FF2B5EF4-FFF2-40B4-BE49-F238E27FC236}">
+                <a16:creationId xmlns:a16="http://schemas.microsoft.com/office/drawing/2014/main" id="{0EFA856A-AF51-55C0-9A2C-28548C5A30E7}"/>
+              </a:ext>
+            </a:extLst>
+          </p:cNvPr>
+          <p:cNvSpPr txBox="1"/>
+          <p:nvPr/>
+        </p:nvSpPr>
+        <p:spPr>
+          <a:xfrm>
+            <a:off x="5972174" y="936943"/>
+            <a:ext cx="1879331" cy="563245"/>
+          </a:xfrm>
+          <a:prstGeom prst="rect">
+            <a:avLst/>
+          </a:prstGeom>
+        </p:spPr>
+        <p:style>
+          <a:lnRef idx="0">
+            <a:scrgbClr r="0" g="0" b="0"/>
+          </a:lnRef>
+          <a:fillRef idx="0">
+            <a:scrgbClr r="0" g="0" b="0"/>
+          </a:fillRef>
+          <a:effectRef idx="0">
+            <a:scrgbClr r="0" g="0" b="0"/>
+          </a:effectRef>
+          <a:fontRef idx="minor">
+            <a:schemeClr val="tx1">
+              <a:hueOff val="0"/>
+              <a:satOff val="0"/>
+              <a:lumOff val="0"/>
+              <a:alphaOff val="0"/>
+            </a:schemeClr>
+          </a:fontRef>
+        </p:style>
+        <p:txBody>
+          <a:bodyPr spcFirstLastPara="0" vert="horz" wrap="square" lIns="0" tIns="0" rIns="0" bIns="0" numCol="1" spcCol="1270" rtlCol="0" anchor="t" anchorCtr="0">
+            <a:noAutofit/>
+          </a:bodyPr>
+          <a:lstStyle/>
+          <a:p>
+            <a:pPr marL="0" lvl="0" indent="0" algn="ctr" defTabSz="1600200" rtl="0">
+              <a:lnSpc>
+                <a:spcPct val="90000"/>
+              </a:lnSpc>
+              <a:spcBef>
+                <a:spcPct val="0"/>
+              </a:spcBef>
+              <a:spcAft>
+                <a:spcPct val="35000"/>
+              </a:spcAft>
+              <a:buNone/>
+            </a:pPr>
+            <a:r>
+              <a:rPr lang="fr-FR" sz="3600" kern="1200" noProof="0" dirty="0" err="1">
+                <a:solidFill>
+                  <a:schemeClr val="bg1"/>
+                </a:solidFill>
+              </a:rPr>
+              <a:t>evaluation</a:t>
+            </a:r>
+            <a:endParaRPr lang="fr-FR" sz="3600" kern="1200" noProof="0" dirty="0">
+              <a:solidFill>
+                <a:schemeClr val="bg1"/>
+              </a:solidFill>
+            </a:endParaRPr>
+          </a:p>
+        </p:txBody>
+      </p:sp>
+      <p:pic>
+        <p:nvPicPr>
+          <p:cNvPr id="4" name="Image 3">
+            <a:extLst>
+              <a:ext uri="{FF2B5EF4-FFF2-40B4-BE49-F238E27FC236}">
+                <a16:creationId xmlns:a16="http://schemas.microsoft.com/office/drawing/2014/main" id="{4C48D5BB-E63D-DD3A-E76E-277ADD6A921B}"/>
+              </a:ext>
+            </a:extLst>
+          </p:cNvPr>
+          <p:cNvPicPr>
+            <a:picLocks noChangeAspect="1"/>
+          </p:cNvPicPr>
+          <p:nvPr/>
+        </p:nvPicPr>
+        <p:blipFill>
+          <a:blip r:embed="rId2"/>
+          <a:stretch>
+            <a:fillRect/>
+          </a:stretch>
+        </p:blipFill>
+        <p:spPr>
+          <a:xfrm>
+            <a:off x="581192" y="2054181"/>
+            <a:ext cx="11099482" cy="4101663"/>
+          </a:xfrm>
+          <a:prstGeom prst="rect">
+            <a:avLst/>
+          </a:prstGeom>
+        </p:spPr>
+      </p:pic>
+    </p:spTree>
+    <p:extLst>
+      <p:ext uri="{BB962C8B-B14F-4D97-AF65-F5344CB8AC3E}">
+        <p14:creationId xmlns:p14="http://schemas.microsoft.com/office/powerpoint/2010/main" val="1454930920"/>
+      </p:ext>
+    </p:extLst>
+  </p:cSld>
+  <p:clrMapOvr>
+    <a:masterClrMapping/>
+  </p:clrMapOvr>
+</p:sld>
+</file>
+
+<file path=ppt/slides/slide7.xml><?xml version="1.0" encoding="utf-8"?>
+<p:sld xmlns:a="http://schemas.openxmlformats.org/drawingml/2006/main" xmlns:r="http://schemas.openxmlformats.org/officeDocument/2006/relationships" xmlns:p="http://schemas.openxmlformats.org/presentationml/2006/main">
+  <p:cSld>
+    <p:spTree>
+      <p:nvGrpSpPr>
+        <p:cNvPr id="1" name="">
+          <a:extLst>
+            <a:ext uri="{FF2B5EF4-FFF2-40B4-BE49-F238E27FC236}">
+              <a16:creationId xmlns:a16="http://schemas.microsoft.com/office/drawing/2014/main" id="{28F98046-2BF9-5B7C-A704-4B1650CF47B8}"/>
+            </a:ext>
+          </a:extLst>
+        </p:cNvPr>
+        <p:cNvGrpSpPr/>
+        <p:nvPr/>
+      </p:nvGrpSpPr>
+      <p:grpSpPr>
+        <a:xfrm>
+          <a:off x="0" y="0"/>
+          <a:ext cx="0" cy="0"/>
+          <a:chOff x="0" y="0"/>
+          <a:chExt cx="0" cy="0"/>
+        </a:xfrm>
+      </p:grpSpPr>
+      <p:sp>
+        <p:nvSpPr>
+          <p:cNvPr id="2" name="Titre 1">
+            <a:extLst>
+              <a:ext uri="{FF2B5EF4-FFF2-40B4-BE49-F238E27FC236}">
+                <a16:creationId xmlns:a16="http://schemas.microsoft.com/office/drawing/2014/main" id="{AC0B02E4-8809-9679-899B-CFFDD72BB2B2}"/>
+              </a:ext>
+            </a:extLst>
+          </p:cNvPr>
+          <p:cNvSpPr>
+            <a:spLocks noGrp="1"/>
+          </p:cNvSpPr>
+          <p:nvPr>
+            <p:ph type="title"/>
+          </p:nvPr>
+        </p:nvSpPr>
+        <p:spPr/>
+        <p:txBody>
+          <a:bodyPr/>
+          <a:lstStyle/>
+          <a:p>
+            <a:r>
+              <a:rPr lang="fr-FR" dirty="0"/>
+              <a:t>Nettoyage des données</a:t>
+            </a:r>
+          </a:p>
+        </p:txBody>
+      </p:sp>
+      <p:sp>
+        <p:nvSpPr>
+          <p:cNvPr id="9" name="Rectangle 8">
+            <a:extLst>
+              <a:ext uri="{FF2B5EF4-FFF2-40B4-BE49-F238E27FC236}">
+                <a16:creationId xmlns:a16="http://schemas.microsoft.com/office/drawing/2014/main" id="{67FF2D77-324E-B715-B171-719BB1129C12}"/>
+              </a:ext>
+            </a:extLst>
+          </p:cNvPr>
+          <p:cNvSpPr/>
+          <p:nvPr/>
+        </p:nvSpPr>
+        <p:spPr>
+          <a:xfrm>
+            <a:off x="5427558" y="3069000"/>
+            <a:ext cx="3945041" cy="1345838"/>
+          </a:xfrm>
+          <a:prstGeom prst="rect">
+            <a:avLst/>
+          </a:prstGeom>
+        </p:spPr>
+        <p:style>
+          <a:lnRef idx="0">
+            <a:schemeClr val="dk1">
+              <a:alpha val="0"/>
+              <a:hueOff val="0"/>
+              <a:satOff val="0"/>
+              <a:lumOff val="0"/>
+              <a:alphaOff val="0"/>
+            </a:schemeClr>
+          </a:lnRef>
+          <a:fillRef idx="0">
+            <a:schemeClr val="lt1">
+              <a:alpha val="0"/>
+              <a:hueOff val="0"/>
+              <a:satOff val="0"/>
+              <a:lumOff val="0"/>
+              <a:alphaOff val="0"/>
+            </a:schemeClr>
+          </a:fillRef>
+          <a:effectRef idx="0">
+            <a:schemeClr val="lt1">
+              <a:alpha val="0"/>
+              <a:hueOff val="0"/>
+              <a:satOff val="0"/>
+              <a:lumOff val="0"/>
+              <a:alphaOff val="0"/>
+            </a:schemeClr>
+          </a:effectRef>
+          <a:fontRef idx="minor">
+            <a:schemeClr val="tx1">
+              <a:hueOff val="0"/>
+              <a:satOff val="0"/>
+              <a:lumOff val="0"/>
+              <a:alphaOff val="0"/>
+            </a:schemeClr>
+          </a:fontRef>
+        </p:style>
+        <p:txBody>
+          <a:bodyPr/>
+          <a:lstStyle/>
+          <a:p>
+            <a:endParaRPr lang="fr-FR"/>
+          </a:p>
+        </p:txBody>
+      </p:sp>
+      <p:sp>
+        <p:nvSpPr>
+          <p:cNvPr id="10" name="ZoneTexte 9">
+            <a:extLst>
+              <a:ext uri="{FF2B5EF4-FFF2-40B4-BE49-F238E27FC236}">
+                <a16:creationId xmlns:a16="http://schemas.microsoft.com/office/drawing/2014/main" id="{484AD649-9B82-FC7E-CECE-2FA50AD8B7E4}"/>
+              </a:ext>
+            </a:extLst>
+          </p:cNvPr>
+          <p:cNvSpPr txBox="1"/>
+          <p:nvPr/>
+        </p:nvSpPr>
+        <p:spPr>
+          <a:xfrm>
+            <a:off x="7851505" y="768196"/>
+            <a:ext cx="3945041" cy="1117238"/>
+          </a:xfrm>
+          <a:prstGeom prst="rect">
+            <a:avLst/>
+          </a:prstGeom>
+        </p:spPr>
+        <p:style>
+          <a:lnRef idx="0">
+            <a:scrgbClr r="0" g="0" b="0"/>
+          </a:lnRef>
+          <a:fillRef idx="0">
+            <a:scrgbClr r="0" g="0" b="0"/>
+          </a:fillRef>
+          <a:effectRef idx="0">
+            <a:scrgbClr r="0" g="0" b="0"/>
+          </a:effectRef>
+          <a:fontRef idx="minor">
+            <a:schemeClr val="tx1">
+              <a:hueOff val="0"/>
+              <a:satOff val="0"/>
+              <a:lumOff val="0"/>
+              <a:alphaOff val="0"/>
+            </a:schemeClr>
+          </a:fontRef>
+        </p:style>
+        <p:txBody>
+          <a:bodyPr spcFirstLastPara="0" vert="horz" wrap="square" lIns="0" tIns="0" rIns="0" bIns="0" numCol="1" spcCol="1270" rtlCol="0" anchor="t" anchorCtr="0">
+            <a:noAutofit/>
+          </a:bodyPr>
+          <a:lstStyle/>
+          <a:p>
+            <a:pPr marL="0" lvl="0" indent="0" algn="ctr" defTabSz="1600200" rtl="0">
+              <a:lnSpc>
+                <a:spcPct val="90000"/>
+              </a:lnSpc>
+              <a:spcBef>
+                <a:spcPct val="0"/>
+              </a:spcBef>
+              <a:spcAft>
+                <a:spcPct val="35000"/>
+              </a:spcAft>
+              <a:buNone/>
+            </a:pPr>
+            <a:r>
+              <a:rPr lang="fr-FR" sz="3600" kern="1200" noProof="0" dirty="0">
+                <a:solidFill>
+                  <a:schemeClr val="bg1"/>
+                </a:solidFill>
+              </a:rPr>
+              <a:t>Vérification des erreurs</a:t>
+            </a:r>
+          </a:p>
+        </p:txBody>
+      </p:sp>
+      <p:sp>
+        <p:nvSpPr>
+          <p:cNvPr id="5" name="ZoneTexte 4">
+            <a:extLst>
+              <a:ext uri="{FF2B5EF4-FFF2-40B4-BE49-F238E27FC236}">
+                <a16:creationId xmlns:a16="http://schemas.microsoft.com/office/drawing/2014/main" id="{FC6EEE0F-3724-2B60-9E4D-7BA17A12791C}"/>
+              </a:ext>
+            </a:extLst>
+          </p:cNvPr>
+          <p:cNvSpPr txBox="1"/>
+          <p:nvPr/>
+        </p:nvSpPr>
+        <p:spPr>
+          <a:xfrm>
+            <a:off x="581192" y="2937510"/>
+            <a:ext cx="4789540" cy="1477328"/>
+          </a:xfrm>
+          <a:prstGeom prst="rect">
+            <a:avLst/>
+          </a:prstGeom>
+          <a:noFill/>
+        </p:spPr>
+        <p:txBody>
+          <a:bodyPr wrap="square">
+            <a:spAutoFit/>
+          </a:bodyPr>
+          <a:lstStyle/>
+          <a:p>
+            <a:r>
+              <a:rPr lang="fr-FR" b="0" i="0" dirty="0">
+                <a:effectLst/>
+                <a:latin typeface="Consolas" panose="020B0609020204030204" pitchFamily="49" charset="0"/>
+              </a:rPr>
+              <a:t>Pas de présence de:</a:t>
+            </a:r>
+          </a:p>
+          <a:p>
+            <a:pPr marL="285750" indent="-285750">
+              <a:buFont typeface="Arial" panose="020B0604020202020204" pitchFamily="34" charset="0"/>
+              <a:buChar char="•"/>
+            </a:pPr>
+            <a:r>
+              <a:rPr lang="fr-FR" dirty="0">
+                <a:latin typeface="Consolas" panose="020B0609020204030204" pitchFamily="49" charset="0"/>
+              </a:rPr>
+              <a:t>Format invalide</a:t>
+            </a:r>
+          </a:p>
+          <a:p>
+            <a:pPr marL="285750" indent="-285750">
+              <a:buFont typeface="Arial" panose="020B0604020202020204" pitchFamily="34" charset="0"/>
+              <a:buChar char="•"/>
+            </a:pPr>
+            <a:r>
+              <a:rPr lang="fr-FR" dirty="0">
+                <a:latin typeface="Consolas" panose="020B0609020204030204" pitchFamily="49" charset="0"/>
+              </a:rPr>
+              <a:t>Valeurs aberrantes</a:t>
+            </a:r>
+          </a:p>
+          <a:p>
+            <a:pPr marL="285750" indent="-285750">
+              <a:buFont typeface="Arial" panose="020B0604020202020204" pitchFamily="34" charset="0"/>
+              <a:buChar char="•"/>
+            </a:pPr>
+            <a:r>
+              <a:rPr lang="fr-FR" dirty="0">
+                <a:latin typeface="Consolas" panose="020B0609020204030204" pitchFamily="49" charset="0"/>
+              </a:rPr>
+              <a:t>Valeurs vides ou manquantes</a:t>
+            </a:r>
+          </a:p>
+          <a:p>
+            <a:pPr marL="285750" indent="-285750">
+              <a:buFont typeface="Arial" panose="020B0604020202020204" pitchFamily="34" charset="0"/>
+              <a:buChar char="•"/>
+            </a:pPr>
+            <a:r>
+              <a:rPr lang="fr-FR" dirty="0">
+                <a:latin typeface="Consolas" panose="020B0609020204030204" pitchFamily="49" charset="0"/>
+              </a:rPr>
+              <a:t>Pas de doublons dans les Id</a:t>
+            </a:r>
+            <a:endParaRPr lang="fr-FR" dirty="0"/>
+          </a:p>
+        </p:txBody>
+      </p:sp>
+      <p:sp>
+        <p:nvSpPr>
+          <p:cNvPr id="6" name="ZoneTexte 5">
+            <a:extLst>
+              <a:ext uri="{FF2B5EF4-FFF2-40B4-BE49-F238E27FC236}">
+                <a16:creationId xmlns:a16="http://schemas.microsoft.com/office/drawing/2014/main" id="{B04CE598-C601-97DC-E5BA-EC500C98AF17}"/>
+              </a:ext>
+            </a:extLst>
+          </p:cNvPr>
+          <p:cNvSpPr txBox="1"/>
+          <p:nvPr/>
+        </p:nvSpPr>
+        <p:spPr>
+          <a:xfrm>
+            <a:off x="4825615" y="2845177"/>
+            <a:ext cx="6970931" cy="3416320"/>
+          </a:xfrm>
+          <a:prstGeom prst="rect">
+            <a:avLst/>
+          </a:prstGeom>
+          <a:noFill/>
+        </p:spPr>
+        <p:txBody>
+          <a:bodyPr wrap="square">
+            <a:spAutoFit/>
+          </a:bodyPr>
+          <a:lstStyle/>
+          <a:p>
+            <a:r>
+              <a:rPr lang="fr-FR" dirty="0">
+                <a:latin typeface="Consolas" panose="020B0609020204030204" pitchFamily="49" charset="0"/>
+              </a:rPr>
+              <a:t>Conversions</a:t>
+            </a:r>
+          </a:p>
+          <a:p>
+            <a:r>
+              <a:rPr lang="fr-FR" dirty="0">
+                <a:latin typeface="Consolas" panose="020B0609020204030204" pitchFamily="49" charset="0"/>
+              </a:rPr>
+              <a:t>0	</a:t>
+            </a:r>
+            <a:r>
+              <a:rPr lang="fr-FR" dirty="0" err="1">
+                <a:latin typeface="Consolas" panose="020B0609020204030204" pitchFamily="49" charset="0"/>
+              </a:rPr>
+              <a:t>a_quitte_l_entreprise</a:t>
+            </a:r>
+            <a:r>
+              <a:rPr lang="fr-FR" dirty="0">
+                <a:latin typeface="Consolas" panose="020B0609020204030204" pitchFamily="49" charset="0"/>
+              </a:rPr>
+              <a:t>	</a:t>
+            </a:r>
+            <a:r>
+              <a:rPr lang="fr-FR" dirty="0" err="1">
+                <a:latin typeface="Consolas" panose="020B0609020204030204" pitchFamily="49" charset="0"/>
+              </a:rPr>
+              <a:t>str</a:t>
+            </a:r>
+            <a:r>
+              <a:rPr lang="fr-FR" dirty="0">
+                <a:latin typeface="Consolas" panose="020B0609020204030204" pitchFamily="49" charset="0"/>
+              </a:rPr>
+              <a:t>	Oui/Non =&gt; bin</a:t>
+            </a:r>
+          </a:p>
+          <a:p>
+            <a:r>
+              <a:rPr lang="fr-FR" dirty="0">
+                <a:latin typeface="Consolas" panose="020B0609020204030204" pitchFamily="49" charset="0"/>
+              </a:rPr>
+              <a:t>7	</a:t>
+            </a:r>
+            <a:r>
+              <a:rPr lang="fr-FR" dirty="0" err="1">
+                <a:latin typeface="Consolas" panose="020B0609020204030204" pitchFamily="49" charset="0"/>
+              </a:rPr>
+              <a:t>domaine_etude</a:t>
+            </a:r>
+            <a:r>
+              <a:rPr lang="fr-FR" dirty="0">
+                <a:latin typeface="Consolas" panose="020B0609020204030204" pitchFamily="49" charset="0"/>
+              </a:rPr>
+              <a:t>	</a:t>
+            </a:r>
+            <a:r>
+              <a:rPr lang="fr-FR" dirty="0" err="1">
+                <a:latin typeface="Consolas" panose="020B0609020204030204" pitchFamily="49" charset="0"/>
+              </a:rPr>
+              <a:t>str</a:t>
+            </a:r>
+            <a:endParaRPr lang="fr-FR" dirty="0">
+              <a:latin typeface="Consolas" panose="020B0609020204030204" pitchFamily="49" charset="0"/>
+            </a:endParaRPr>
+          </a:p>
+          <a:p>
+            <a:r>
+              <a:rPr lang="fr-FR" dirty="0">
+                <a:latin typeface="Consolas" panose="020B0609020204030204" pitchFamily="49" charset="0"/>
+              </a:rPr>
+              <a:t>8	</a:t>
+            </a:r>
+            <a:r>
+              <a:rPr lang="fr-FR" dirty="0" err="1">
+                <a:latin typeface="Consolas" panose="020B0609020204030204" pitchFamily="49" charset="0"/>
+              </a:rPr>
+              <a:t>ayant_enfants</a:t>
+            </a:r>
+            <a:r>
+              <a:rPr lang="fr-FR" dirty="0">
+                <a:latin typeface="Consolas" panose="020B0609020204030204" pitchFamily="49" charset="0"/>
+              </a:rPr>
+              <a:t>	</a:t>
+            </a:r>
+            <a:r>
+              <a:rPr lang="fr-FR" dirty="0" err="1">
+                <a:latin typeface="Consolas" panose="020B0609020204030204" pitchFamily="49" charset="0"/>
+              </a:rPr>
+              <a:t>str</a:t>
+            </a:r>
+            <a:endParaRPr lang="fr-FR" dirty="0">
+              <a:latin typeface="Consolas" panose="020B0609020204030204" pitchFamily="49" charset="0"/>
+            </a:endParaRPr>
+          </a:p>
+          <a:p>
+            <a:r>
+              <a:rPr lang="fr-FR" dirty="0">
+                <a:latin typeface="Consolas" panose="020B0609020204030204" pitchFamily="49" charset="0"/>
+              </a:rPr>
+              <a:t>9	</a:t>
+            </a:r>
+            <a:r>
+              <a:rPr lang="fr-FR" dirty="0" err="1">
+                <a:latin typeface="Consolas" panose="020B0609020204030204" pitchFamily="49" charset="0"/>
+              </a:rPr>
+              <a:t>frequence_deplacement</a:t>
+            </a:r>
+            <a:r>
+              <a:rPr lang="fr-FR" dirty="0">
+                <a:latin typeface="Consolas" panose="020B0609020204030204" pitchFamily="49" charset="0"/>
+              </a:rPr>
+              <a:t>	</a:t>
+            </a:r>
+            <a:r>
+              <a:rPr lang="fr-FR" dirty="0" err="1">
+                <a:latin typeface="Consolas" panose="020B0609020204030204" pitchFamily="49" charset="0"/>
+              </a:rPr>
+              <a:t>str</a:t>
+            </a:r>
+            <a:endParaRPr lang="fr-FR" dirty="0">
+              <a:latin typeface="Consolas" panose="020B0609020204030204" pitchFamily="49" charset="0"/>
+            </a:endParaRPr>
+          </a:p>
+          <a:p>
+            <a:r>
+              <a:rPr lang="fr-FR" dirty="0">
+                <a:latin typeface="Consolas" panose="020B0609020204030204" pitchFamily="49" charset="0"/>
+              </a:rPr>
+              <a:t>13	genre	</a:t>
+            </a:r>
+            <a:r>
+              <a:rPr lang="fr-FR" dirty="0" err="1">
+                <a:latin typeface="Consolas" panose="020B0609020204030204" pitchFamily="49" charset="0"/>
+              </a:rPr>
+              <a:t>str</a:t>
+            </a:r>
+            <a:r>
+              <a:rPr lang="fr-FR" dirty="0">
+                <a:latin typeface="Consolas" panose="020B0609020204030204" pitchFamily="49" charset="0"/>
+              </a:rPr>
+              <a:t>	M/F =&gt; bin</a:t>
+            </a:r>
+          </a:p>
+          <a:p>
+            <a:r>
+              <a:rPr lang="fr-FR" dirty="0">
+                <a:latin typeface="Consolas" panose="020B0609020204030204" pitchFamily="49" charset="0"/>
+              </a:rPr>
+              <a:t>15	</a:t>
+            </a:r>
+            <a:r>
+              <a:rPr lang="fr-FR" dirty="0" err="1">
+                <a:latin typeface="Consolas" panose="020B0609020204030204" pitchFamily="49" charset="0"/>
+              </a:rPr>
+              <a:t>statut_marital</a:t>
+            </a:r>
+            <a:r>
+              <a:rPr lang="fr-FR" dirty="0">
+                <a:latin typeface="Consolas" panose="020B0609020204030204" pitchFamily="49" charset="0"/>
+              </a:rPr>
+              <a:t>	</a:t>
+            </a:r>
+            <a:r>
+              <a:rPr lang="fr-FR" dirty="0" err="1">
+                <a:latin typeface="Consolas" panose="020B0609020204030204" pitchFamily="49" charset="0"/>
+              </a:rPr>
+              <a:t>str</a:t>
+            </a:r>
+            <a:r>
+              <a:rPr lang="fr-FR" dirty="0">
+                <a:latin typeface="Consolas" panose="020B0609020204030204" pitchFamily="49" charset="0"/>
+              </a:rPr>
+              <a:t> =&gt; classe</a:t>
+            </a:r>
+          </a:p>
+          <a:p>
+            <a:r>
+              <a:rPr lang="fr-FR" dirty="0">
+                <a:latin typeface="Consolas" panose="020B0609020204030204" pitchFamily="49" charset="0"/>
+              </a:rPr>
+              <a:t>16	</a:t>
+            </a:r>
+            <a:r>
+              <a:rPr lang="fr-FR" dirty="0" err="1">
+                <a:latin typeface="Consolas" panose="020B0609020204030204" pitchFamily="49" charset="0"/>
+              </a:rPr>
+              <a:t>departement</a:t>
+            </a:r>
+            <a:r>
+              <a:rPr lang="fr-FR" dirty="0">
+                <a:latin typeface="Consolas" panose="020B0609020204030204" pitchFamily="49" charset="0"/>
+              </a:rPr>
+              <a:t>	</a:t>
+            </a:r>
+            <a:r>
+              <a:rPr lang="fr-FR" dirty="0" err="1">
+                <a:latin typeface="Consolas" panose="020B0609020204030204" pitchFamily="49" charset="0"/>
+              </a:rPr>
+              <a:t>str</a:t>
+            </a:r>
+            <a:r>
+              <a:rPr lang="fr-FR" dirty="0">
+                <a:latin typeface="Consolas" panose="020B0609020204030204" pitchFamily="49" charset="0"/>
+              </a:rPr>
+              <a:t> =&gt; classe</a:t>
+            </a:r>
+          </a:p>
+          <a:p>
+            <a:r>
+              <a:rPr lang="fr-FR" dirty="0">
+                <a:latin typeface="Consolas" panose="020B0609020204030204" pitchFamily="49" charset="0"/>
+              </a:rPr>
+              <a:t>17	poste	</a:t>
+            </a:r>
+            <a:r>
+              <a:rPr lang="fr-FR" dirty="0" err="1">
+                <a:latin typeface="Consolas" panose="020B0609020204030204" pitchFamily="49" charset="0"/>
+              </a:rPr>
+              <a:t>str</a:t>
+            </a:r>
+            <a:r>
+              <a:rPr lang="fr-FR" dirty="0">
+                <a:latin typeface="Consolas" panose="020B0609020204030204" pitchFamily="49" charset="0"/>
+              </a:rPr>
+              <a:t> =&gt; classe</a:t>
+            </a:r>
+          </a:p>
+          <a:p>
+            <a:r>
+              <a:rPr lang="fr-FR" dirty="0">
+                <a:latin typeface="Consolas" panose="020B0609020204030204" pitchFamily="49" charset="0"/>
+              </a:rPr>
+              <a:t>30	</a:t>
+            </a:r>
+            <a:r>
+              <a:rPr lang="fr-FR" dirty="0" err="1">
+                <a:latin typeface="Consolas" panose="020B0609020204030204" pitchFamily="49" charset="0"/>
+              </a:rPr>
+              <a:t>heure_supplementaires</a:t>
+            </a:r>
+            <a:r>
+              <a:rPr lang="fr-FR" dirty="0">
+                <a:latin typeface="Consolas" panose="020B0609020204030204" pitchFamily="49" charset="0"/>
+              </a:rPr>
+              <a:t>	</a:t>
+            </a:r>
+            <a:r>
+              <a:rPr lang="fr-FR" dirty="0" err="1">
+                <a:latin typeface="Consolas" panose="020B0609020204030204" pitchFamily="49" charset="0"/>
+              </a:rPr>
+              <a:t>str</a:t>
+            </a:r>
+            <a:r>
+              <a:rPr lang="fr-FR" dirty="0">
+                <a:latin typeface="Consolas" panose="020B0609020204030204" pitchFamily="49" charset="0"/>
+              </a:rPr>
+              <a:t>	Oui/Non =&gt; bin</a:t>
+            </a:r>
+          </a:p>
+          <a:p>
+            <a:r>
+              <a:rPr lang="fr-FR" dirty="0">
+                <a:latin typeface="Consolas" panose="020B0609020204030204" pitchFamily="49" charset="0"/>
+              </a:rPr>
+              <a:t>31	</a:t>
+            </a:r>
+            <a:r>
+              <a:rPr lang="fr-FR" dirty="0" err="1">
+                <a:latin typeface="Consolas" panose="020B0609020204030204" pitchFamily="49" charset="0"/>
+              </a:rPr>
+              <a:t>augementation_salaire_precedente</a:t>
+            </a:r>
+            <a:r>
+              <a:rPr lang="fr-FR" dirty="0">
+                <a:latin typeface="Consolas" panose="020B0609020204030204" pitchFamily="49" charset="0"/>
+              </a:rPr>
+              <a:t>	</a:t>
+            </a:r>
+            <a:r>
+              <a:rPr lang="fr-FR" dirty="0" err="1">
+                <a:latin typeface="Consolas" panose="020B0609020204030204" pitchFamily="49" charset="0"/>
+              </a:rPr>
+              <a:t>str</a:t>
+            </a:r>
+            <a:r>
+              <a:rPr lang="fr-FR" dirty="0">
+                <a:latin typeface="Consolas" panose="020B0609020204030204" pitchFamily="49" charset="0"/>
+              </a:rPr>
+              <a:t>	% =&gt; </a:t>
+            </a:r>
+            <a:r>
+              <a:rPr lang="fr-FR" dirty="0" err="1">
+                <a:latin typeface="Consolas" panose="020B0609020204030204" pitchFamily="49" charset="0"/>
+              </a:rPr>
+              <a:t>int</a:t>
+            </a:r>
+            <a:endParaRPr lang="fr-FR" dirty="0">
+              <a:latin typeface="Consolas" panose="020B0609020204030204" pitchFamily="49" charset="0"/>
+            </a:endParaRPr>
+          </a:p>
+          <a:p>
+            <a:endParaRPr lang="fr-FR" dirty="0">
+              <a:latin typeface="Consolas" panose="020B0609020204030204" pitchFamily="49" charset="0"/>
+            </a:endParaRPr>
+          </a:p>
+        </p:txBody>
+      </p:sp>
+    </p:spTree>
+    <p:extLst>
+      <p:ext uri="{BB962C8B-B14F-4D97-AF65-F5344CB8AC3E}">
+        <p14:creationId xmlns:p14="http://schemas.microsoft.com/office/powerpoint/2010/main" val="55430248"/>
+      </p:ext>
+    </p:extLst>
+  </p:cSld>
+  <p:clrMapOvr>
+    <a:masterClrMapping/>
+  </p:clrMapOvr>
+</p:sld>
+</file>
+
+<file path=ppt/slides/slide8.xml><?xml version="1.0" encoding="utf-8"?>
 <p:sld xmlns:a="http://schemas.openxmlformats.org/drawingml/2006/main" xmlns:r="http://schemas.openxmlformats.org/officeDocument/2006/relationships" xmlns:p="http://schemas.openxmlformats.org/presentationml/2006/main">
   <p:cSld>
     <p:bg>
@@ -12303,6 +14965,13 @@
             <a:schemeClr val="lt1"/>
           </a:fontRef>
         </p:style>
+        <p:txBody>
+          <a:bodyPr/>
+          <a:lstStyle/>
+          <a:p>
+            <a:endParaRPr lang="fr-FR"/>
+          </a:p>
+        </p:txBody>
       </p:sp>
       <p:sp>
         <p:nvSpPr>
@@ -12388,7 +15057,7 @@
 </p:sld>
 </file>
 
-<file path=ppt/slides/slide5.xml><?xml version="1.0" encoding="utf-8"?>
+<file path=ppt/slides/slide9.xml><?xml version="1.0" encoding="utf-8"?>
 <p:sld xmlns:a="http://schemas.openxmlformats.org/drawingml/2006/main" xmlns:r="http://schemas.openxmlformats.org/officeDocument/2006/relationships" xmlns:p="http://schemas.openxmlformats.org/presentationml/2006/main">
   <p:cSld>
     <p:spTree>
@@ -12502,879 +15171,6 @@
     <p:extLst>
       <p:ext uri="{BB962C8B-B14F-4D97-AF65-F5344CB8AC3E}">
         <p14:creationId xmlns:p14="http://schemas.microsoft.com/office/powerpoint/2010/main" val="497607547"/>
-      </p:ext>
-    </p:extLst>
-  </p:cSld>
-  <p:clrMapOvr>
-    <a:masterClrMapping/>
-  </p:clrMapOvr>
-</p:sld>
-</file>
-
-<file path=ppt/slides/slide6.xml><?xml version="1.0" encoding="utf-8"?>
-<p:sld xmlns:a="http://schemas.openxmlformats.org/drawingml/2006/main" xmlns:r="http://schemas.openxmlformats.org/officeDocument/2006/relationships" xmlns:p="http://schemas.openxmlformats.org/presentationml/2006/main">
-  <p:cSld>
-    <p:bg>
-      <p:bgPr>
-        <a:solidFill>
-          <a:schemeClr val="bg1"/>
-        </a:solidFill>
-        <a:effectLst/>
-      </p:bgPr>
-    </p:bg>
-    <p:spTree>
-      <p:nvGrpSpPr>
-        <p:cNvPr id="1" name=""/>
-        <p:cNvGrpSpPr/>
-        <p:nvPr/>
-      </p:nvGrpSpPr>
-      <p:grpSpPr>
-        <a:xfrm>
-          <a:off x="0" y="0"/>
-          <a:ext cx="0" cy="0"/>
-          <a:chOff x="0" y="0"/>
-          <a:chExt cx="0" cy="0"/>
-        </a:xfrm>
-      </p:grpSpPr>
-      <p:sp useBgFill="1">
-        <p:nvSpPr>
-          <p:cNvPr id="13" name="Rectangle 12">
-            <a:extLst>
-              <a:ext uri="{FF2B5EF4-FFF2-40B4-BE49-F238E27FC236}">
-                <a16:creationId xmlns:a16="http://schemas.microsoft.com/office/drawing/2014/main" id="{4AE9D071-98CF-435C-BD2B-976514544DC5}"/>
-              </a:ext>
-              <a:ext uri="{C183D7F6-B498-43B3-948B-1728B52AA6E4}">
-                <adec:decorative xmlns:adec="http://schemas.microsoft.com/office/drawing/2017/decorative" val="1"/>
-              </a:ext>
-            </a:extLst>
-          </p:cNvPr>
-          <p:cNvSpPr>
-            <a:spLocks noGrp="1" noRot="1" noChangeAspect="1" noMove="1" noResize="1" noEditPoints="1" noAdjustHandles="1" noChangeArrowheads="1" noChangeShapeType="1"/>
-          </p:cNvSpPr>
-          <p:nvPr>
-            <p:extLst>
-              <p:ext uri="{386F3935-93C4-4BCD-93E2-E3B085C9AB24}">
-                <p16:designElem xmlns:p16="http://schemas.microsoft.com/office/powerpoint/2015/main" val="1"/>
-              </p:ext>
-            </p:extLst>
-          </p:nvPr>
-        </p:nvSpPr>
-        <p:spPr>
-          <a:xfrm>
-            <a:off x="0" y="0"/>
-            <a:ext cx="12192000" cy="6858000"/>
-          </a:xfrm>
-          <a:prstGeom prst="rect">
-            <a:avLst/>
-          </a:prstGeom>
-          <a:ln>
-            <a:noFill/>
-          </a:ln>
-        </p:spPr>
-        <p:style>
-          <a:lnRef idx="2">
-            <a:schemeClr val="accent1">
-              <a:shade val="50000"/>
-            </a:schemeClr>
-          </a:lnRef>
-          <a:fillRef idx="1">
-            <a:schemeClr val="accent1"/>
-          </a:fillRef>
-          <a:effectRef idx="0">
-            <a:schemeClr val="accent1"/>
-          </a:effectRef>
-          <a:fontRef idx="minor">
-            <a:schemeClr val="lt1"/>
-          </a:fontRef>
-        </p:style>
-        <p:txBody>
-          <a:bodyPr rtlCol="0" anchor="ctr"/>
-          <a:lstStyle/>
-          <a:p>
-            <a:pPr algn="ctr" rtl="0"/>
-            <a:endParaRPr lang="fr-FR" dirty="0"/>
-          </a:p>
-        </p:txBody>
-      </p:sp>
-      <p:pic>
-        <p:nvPicPr>
-          <p:cNvPr id="8" name="Espace réservé du contenu 4" descr="Valeurs numériques">
-            <a:extLst>
-              <a:ext uri="{FF2B5EF4-FFF2-40B4-BE49-F238E27FC236}">
-                <a16:creationId xmlns:a16="http://schemas.microsoft.com/office/drawing/2014/main" id="{EA70616B-E344-4856-8DF9-707C26236613}"/>
-              </a:ext>
-            </a:extLst>
-          </p:cNvPr>
-          <p:cNvPicPr>
-            <a:picLocks noChangeAspect="1"/>
-          </p:cNvPicPr>
-          <p:nvPr/>
-        </p:nvPicPr>
-        <p:blipFill rotWithShape="1">
-          <a:blip r:embed="rId3" cstate="screen">
-            <a:extLst>
-              <a:ext uri="{28A0092B-C50C-407E-A947-70E740481C1C}">
-                <a14:useLocalDpi xmlns:a14="http://schemas.microsoft.com/office/drawing/2010/main"/>
-              </a:ext>
-            </a:extLst>
-          </a:blip>
-          <a:srcRect t="10681" r="9091" b="12711"/>
-          <a:stretch/>
-        </p:blipFill>
-        <p:spPr>
-          <a:xfrm>
-            <a:off x="20" y="10"/>
-            <a:ext cx="12191980" cy="6857990"/>
-          </a:xfrm>
-          <a:prstGeom prst="rect">
-            <a:avLst/>
-          </a:prstGeom>
-        </p:spPr>
-      </p:pic>
-      <p:grpSp>
-        <p:nvGrpSpPr>
-          <p:cNvPr id="15" name="Groupe 14">
-            <a:extLst>
-              <a:ext uri="{FF2B5EF4-FFF2-40B4-BE49-F238E27FC236}">
-                <a16:creationId xmlns:a16="http://schemas.microsoft.com/office/drawing/2014/main" id="{D619FC33-16ED-4246-9596-BEFEB55E4CF6}"/>
-              </a:ext>
-              <a:ext uri="{C183D7F6-B498-43B3-948B-1728B52AA6E4}">
-                <adec:decorative xmlns:adec="http://schemas.microsoft.com/office/drawing/2017/decorative" val="1"/>
-              </a:ext>
-            </a:extLst>
-          </p:cNvPr>
-          <p:cNvGrpSpPr>
-            <a:grpSpLocks noGrp="1" noUngrp="1" noRot="1" noChangeAspect="1" noMove="1" noResize="1"/>
-          </p:cNvGrpSpPr>
-          <p:nvPr>
-            <p:extLst>
-              <p:ext uri="{386F3935-93C4-4BCD-93E2-E3B085C9AB24}">
-                <p16:designElem xmlns:p16="http://schemas.microsoft.com/office/powerpoint/2015/main" val="1"/>
-              </p:ext>
-            </p:extLst>
-          </p:nvPr>
-        </p:nvGrpSpPr>
-        <p:grpSpPr>
-          <a:xfrm>
-            <a:off x="438067" y="457200"/>
-            <a:ext cx="7507083" cy="5935132"/>
-            <a:chOff x="438067" y="457200"/>
-            <a:chExt cx="7507083" cy="5935132"/>
-          </a:xfrm>
-        </p:grpSpPr>
-        <p:sp>
-          <p:nvSpPr>
-            <p:cNvPr id="16" name="Rectangle 15">
-              <a:extLst>
-                <a:ext uri="{FF2B5EF4-FFF2-40B4-BE49-F238E27FC236}">
-                  <a16:creationId xmlns:a16="http://schemas.microsoft.com/office/drawing/2014/main" id="{2EEA80E1-F99F-4009-837F-2F72F8A5D580}"/>
-                </a:ext>
-                <a:ext uri="{C183D7F6-B498-43B3-948B-1728B52AA6E4}">
-                  <adec:decorative xmlns:adec="http://schemas.microsoft.com/office/drawing/2017/decorative" val="1"/>
-                </a:ext>
-              </a:extLst>
-            </p:cNvPr>
-            <p:cNvSpPr>
-              <a:spLocks/>
-            </p:cNvSpPr>
-            <p:nvPr>
-              <p:extLst>
-                <p:ext uri="{386F3935-93C4-4BCD-93E2-E3B085C9AB24}">
-                  <p16:designElem xmlns:p16="http://schemas.microsoft.com/office/powerpoint/2015/main" val="1"/>
-                </p:ext>
-              </p:extLst>
-            </p:nvPr>
-          </p:nvSpPr>
-          <p:spPr>
-            <a:xfrm>
-              <a:off x="438067" y="618067"/>
-              <a:ext cx="7503665" cy="5774265"/>
-            </a:xfrm>
-            <a:prstGeom prst="rect">
-              <a:avLst/>
-            </a:prstGeom>
-            <a:solidFill>
-              <a:schemeClr val="accent1">
-                <a:alpha val="97000"/>
-              </a:schemeClr>
-            </a:solidFill>
-            <a:ln w="6350" cmpd="sng">
-              <a:noFill/>
-            </a:ln>
-            <a:effectLst/>
-          </p:spPr>
-          <p:style>
-            <a:lnRef idx="1">
-              <a:schemeClr val="accent1"/>
-            </a:lnRef>
-            <a:fillRef idx="3">
-              <a:schemeClr val="accent1"/>
-            </a:fillRef>
-            <a:effectRef idx="2">
-              <a:schemeClr val="accent1"/>
-            </a:effectRef>
-            <a:fontRef idx="minor">
-              <a:schemeClr val="lt1"/>
-            </a:fontRef>
-          </p:style>
-        </p:sp>
-        <p:sp>
-          <p:nvSpPr>
-            <p:cNvPr id="17" name="Rectangle 16">
-              <a:extLst>
-                <a:ext uri="{FF2B5EF4-FFF2-40B4-BE49-F238E27FC236}">
-                  <a16:creationId xmlns:a16="http://schemas.microsoft.com/office/drawing/2014/main" id="{0230AF9A-4641-4BD8-9F95-9607CD304039}"/>
-                </a:ext>
-                <a:ext uri="{C183D7F6-B498-43B3-948B-1728B52AA6E4}">
-                  <adec:decorative xmlns:adec="http://schemas.microsoft.com/office/drawing/2017/decorative" val="1"/>
-                </a:ext>
-              </a:extLst>
-            </p:cNvPr>
-            <p:cNvSpPr>
-              <a:spLocks/>
-            </p:cNvSpPr>
-            <p:nvPr>
-              <p:extLst>
-                <p:ext uri="{386F3935-93C4-4BCD-93E2-E3B085C9AB24}">
-                  <p16:designElem xmlns:p16="http://schemas.microsoft.com/office/powerpoint/2015/main" val="1"/>
-                </p:ext>
-              </p:extLst>
-            </p:nvPr>
-          </p:nvSpPr>
-          <p:spPr>
-            <a:xfrm>
-              <a:off x="438068" y="457200"/>
-              <a:ext cx="3703320" cy="94997"/>
-            </a:xfrm>
-            <a:prstGeom prst="rect">
-              <a:avLst/>
-            </a:prstGeom>
-            <a:solidFill>
-              <a:schemeClr val="accent1"/>
-            </a:solidFill>
-            <a:ln>
-              <a:noFill/>
-            </a:ln>
-            <a:effectLst/>
-          </p:spPr>
-          <p:style>
-            <a:lnRef idx="1">
-              <a:schemeClr val="accent1"/>
-            </a:lnRef>
-            <a:fillRef idx="3">
-              <a:schemeClr val="accent1"/>
-            </a:fillRef>
-            <a:effectRef idx="2">
-              <a:schemeClr val="accent1"/>
-            </a:effectRef>
-            <a:fontRef idx="minor">
-              <a:schemeClr val="lt1"/>
-            </a:fontRef>
-          </p:style>
-        </p:sp>
-        <p:sp>
-          <p:nvSpPr>
-            <p:cNvPr id="18" name="Rectangle 17">
-              <a:extLst>
-                <a:ext uri="{FF2B5EF4-FFF2-40B4-BE49-F238E27FC236}">
-                  <a16:creationId xmlns:a16="http://schemas.microsoft.com/office/drawing/2014/main" id="{8703D4EC-9389-41B6-B88B-B6FDC8CD3330}"/>
-                </a:ext>
-                <a:ext uri="{C183D7F6-B498-43B3-948B-1728B52AA6E4}">
-                  <adec:decorative xmlns:adec="http://schemas.microsoft.com/office/drawing/2017/decorative" val="1"/>
-                </a:ext>
-              </a:extLst>
-            </p:cNvPr>
-            <p:cNvSpPr>
-              <a:spLocks/>
-            </p:cNvSpPr>
-            <p:nvPr>
-              <p:extLst>
-                <p:ext uri="{386F3935-93C4-4BCD-93E2-E3B085C9AB24}">
-                  <p16:designElem xmlns:p16="http://schemas.microsoft.com/office/powerpoint/2015/main" val="1"/>
-                </p:ext>
-              </p:extLst>
-            </p:nvPr>
-          </p:nvSpPr>
-          <p:spPr>
-            <a:xfrm>
-              <a:off x="4241830" y="457200"/>
-              <a:ext cx="3703320" cy="91440"/>
-            </a:xfrm>
-            <a:prstGeom prst="rect">
-              <a:avLst/>
-            </a:prstGeom>
-            <a:solidFill>
-              <a:schemeClr val="accent2"/>
-            </a:solidFill>
-            <a:ln>
-              <a:noFill/>
-            </a:ln>
-            <a:effectLst/>
-          </p:spPr>
-          <p:style>
-            <a:lnRef idx="1">
-              <a:schemeClr val="accent1"/>
-            </a:lnRef>
-            <a:fillRef idx="3">
-              <a:schemeClr val="accent1"/>
-            </a:fillRef>
-            <a:effectRef idx="2">
-              <a:schemeClr val="accent1"/>
-            </a:effectRef>
-            <a:fontRef idx="minor">
-              <a:schemeClr val="lt1"/>
-            </a:fontRef>
-          </p:style>
-        </p:sp>
-      </p:grpSp>
-      <p:sp>
-        <p:nvSpPr>
-          <p:cNvPr id="2" name="Titre 1">
-            <a:extLst>
-              <a:ext uri="{FF2B5EF4-FFF2-40B4-BE49-F238E27FC236}">
-                <a16:creationId xmlns:a16="http://schemas.microsoft.com/office/drawing/2014/main" id="{7F2616EE-270D-4F4C-BA1F-2708D387B800}"/>
-              </a:ext>
-            </a:extLst>
-          </p:cNvPr>
-          <p:cNvSpPr>
-            <a:spLocks noGrp="1"/>
-          </p:cNvSpPr>
-          <p:nvPr>
-            <p:ph type="title"/>
-          </p:nvPr>
-        </p:nvSpPr>
-        <p:spPr>
-          <a:xfrm>
-            <a:off x="584200" y="1006956"/>
-            <a:ext cx="7213600" cy="1121871"/>
-          </a:xfrm>
-        </p:spPr>
-        <p:txBody>
-          <a:bodyPr rtlCol="0" anchor="ctr">
-            <a:normAutofit/>
-          </a:bodyPr>
-          <a:lstStyle/>
-          <a:p>
-            <a:pPr algn="ctr" rtl="0"/>
-            <a:r>
-              <a:rPr lang="fr-FR" dirty="0"/>
-              <a:t>Communications numériques</a:t>
-            </a:r>
-          </a:p>
-        </p:txBody>
-      </p:sp>
-      <p:graphicFrame>
-        <p:nvGraphicFramePr>
-          <p:cNvPr id="6" name="Espace réservé du contenu 5" descr="Graphique SmartArt">
-            <a:extLst>
-              <a:ext uri="{FF2B5EF4-FFF2-40B4-BE49-F238E27FC236}">
-                <a16:creationId xmlns:a16="http://schemas.microsoft.com/office/drawing/2014/main" id="{BF629521-FFD2-45DA-9D1D-A5F09BD5A2D9}"/>
-              </a:ext>
-            </a:extLst>
-          </p:cNvPr>
-          <p:cNvGraphicFramePr>
-            <a:graphicFrameLocks noGrp="1"/>
-          </p:cNvGraphicFramePr>
-          <p:nvPr>
-            <p:ph idx="1"/>
-            <p:extLst>
-              <p:ext uri="{D42A27DB-BD31-4B8C-83A1-F6EECF244321}">
-                <p14:modId xmlns:p14="http://schemas.microsoft.com/office/powerpoint/2010/main" val="407969185"/>
-              </p:ext>
-            </p:extLst>
-          </p:nvPr>
-        </p:nvGraphicFramePr>
-        <p:xfrm>
-          <a:off x="719571" y="2198254"/>
-          <a:ext cx="6854248" cy="3563938"/>
-        </p:xfrm>
-        <a:graphic>
-          <a:graphicData uri="http://schemas.openxmlformats.org/drawingml/2006/diagram">
-            <dgm:relIds xmlns:dgm="http://schemas.openxmlformats.org/drawingml/2006/diagram" xmlns:r="http://schemas.openxmlformats.org/officeDocument/2006/relationships" r:dm="rId4" r:lo="rId5" r:qs="rId6" r:cs="rId7"/>
-          </a:graphicData>
-        </a:graphic>
-      </p:graphicFrame>
-    </p:spTree>
-    <p:extLst>
-      <p:ext uri="{BB962C8B-B14F-4D97-AF65-F5344CB8AC3E}">
-        <p14:creationId xmlns:p14="http://schemas.microsoft.com/office/powerpoint/2010/main" val="4209322005"/>
-      </p:ext>
-    </p:extLst>
-  </p:cSld>
-  <p:clrMapOvr>
-    <a:masterClrMapping/>
-  </p:clrMapOvr>
-</p:sld>
-</file>
-
-<file path=ppt/slides/slide7.xml><?xml version="1.0" encoding="utf-8"?>
-<p:sld xmlns:a="http://schemas.openxmlformats.org/drawingml/2006/main" xmlns:r="http://schemas.openxmlformats.org/officeDocument/2006/relationships" xmlns:p="http://schemas.openxmlformats.org/presentationml/2006/main">
-  <p:cSld>
-    <p:bg>
-      <p:bgPr>
-        <a:solidFill>
-          <a:schemeClr val="bg1"/>
-        </a:solidFill>
-        <a:effectLst/>
-      </p:bgPr>
-    </p:bg>
-    <p:spTree>
-      <p:nvGrpSpPr>
-        <p:cNvPr id="1" name=""/>
-        <p:cNvGrpSpPr/>
-        <p:nvPr/>
-      </p:nvGrpSpPr>
-      <p:grpSpPr>
-        <a:xfrm>
-          <a:off x="0" y="0"/>
-          <a:ext cx="0" cy="0"/>
-          <a:chOff x="0" y="0"/>
-          <a:chExt cx="0" cy="0"/>
-        </a:xfrm>
-      </p:grpSpPr>
-      <p:sp useBgFill="1">
-        <p:nvSpPr>
-          <p:cNvPr id="10" name="Rectangle 9">
-            <a:extLst>
-              <a:ext uri="{FF2B5EF4-FFF2-40B4-BE49-F238E27FC236}">
-                <a16:creationId xmlns:a16="http://schemas.microsoft.com/office/drawing/2014/main" id="{379F11E2-8BA5-4C5C-AE7C-361E5EA011FF}"/>
-              </a:ext>
-              <a:ext uri="{C183D7F6-B498-43B3-948B-1728B52AA6E4}">
-                <adec:decorative xmlns:adec="http://schemas.microsoft.com/office/drawing/2017/decorative" val="1"/>
-              </a:ext>
-            </a:extLst>
-          </p:cNvPr>
-          <p:cNvSpPr>
-            <a:spLocks noGrp="1" noRot="1" noChangeAspect="1" noMove="1" noResize="1" noEditPoints="1" noAdjustHandles="1" noChangeArrowheads="1" noChangeShapeType="1"/>
-          </p:cNvSpPr>
-          <p:nvPr>
-            <p:extLst>
-              <p:ext uri="{386F3935-93C4-4BCD-93E2-E3B085C9AB24}">
-                <p16:designElem xmlns:p16="http://schemas.microsoft.com/office/powerpoint/2015/main" val="1"/>
-              </p:ext>
-            </p:extLst>
-          </p:nvPr>
-        </p:nvSpPr>
-        <p:spPr>
-          <a:xfrm>
-            <a:off x="0" y="1"/>
-            <a:ext cx="12191999" cy="6858000"/>
-          </a:xfrm>
-          <a:prstGeom prst="rect">
-            <a:avLst/>
-          </a:prstGeom>
-          <a:ln>
-            <a:noFill/>
-          </a:ln>
-        </p:spPr>
-        <p:style>
-          <a:lnRef idx="2">
-            <a:schemeClr val="accent1">
-              <a:shade val="50000"/>
-            </a:schemeClr>
-          </a:lnRef>
-          <a:fillRef idx="1">
-            <a:schemeClr val="accent1"/>
-          </a:fillRef>
-          <a:effectRef idx="0">
-            <a:schemeClr val="accent1"/>
-          </a:effectRef>
-          <a:fontRef idx="minor">
-            <a:schemeClr val="lt1"/>
-          </a:fontRef>
-        </p:style>
-        <p:txBody>
-          <a:bodyPr rtlCol="0" anchor="ctr"/>
-          <a:lstStyle/>
-          <a:p>
-            <a:pPr algn="ctr" rtl="0"/>
-            <a:endParaRPr lang="fr-FR"/>
-          </a:p>
-        </p:txBody>
-      </p:sp>
-      <p:sp>
-        <p:nvSpPr>
-          <p:cNvPr id="12" name="Rectangle 11">
-            <a:extLst>
-              <a:ext uri="{FF2B5EF4-FFF2-40B4-BE49-F238E27FC236}">
-                <a16:creationId xmlns:a16="http://schemas.microsoft.com/office/drawing/2014/main" id="{7C00E1DA-EC7C-40FC-95E3-11FDCD2E4291}"/>
-              </a:ext>
-              <a:ext uri="{C183D7F6-B498-43B3-948B-1728B52AA6E4}">
-                <adec:decorative xmlns:adec="http://schemas.microsoft.com/office/drawing/2017/decorative" val="1"/>
-              </a:ext>
-            </a:extLst>
-          </p:cNvPr>
-          <p:cNvSpPr>
-            <a:spLocks noGrp="1" noRot="1" noChangeAspect="1" noMove="1" noResize="1" noEditPoints="1" noAdjustHandles="1" noChangeArrowheads="1" noChangeShapeType="1"/>
-          </p:cNvSpPr>
-          <p:nvPr>
-            <p:extLst>
-              <p:ext uri="{386F3935-93C4-4BCD-93E2-E3B085C9AB24}">
-                <p16:designElem xmlns:p16="http://schemas.microsoft.com/office/powerpoint/2015/main" val="1"/>
-              </p:ext>
-            </p:extLst>
-          </p:nvPr>
-        </p:nvSpPr>
-        <p:spPr>
-          <a:xfrm>
-            <a:off x="8042147" y="723899"/>
-            <a:ext cx="3703320" cy="5666666"/>
-          </a:xfrm>
-          <a:prstGeom prst="rect">
-            <a:avLst/>
-          </a:prstGeom>
-          <a:solidFill>
-            <a:schemeClr val="accent1"/>
-          </a:solidFill>
-          <a:ln>
-            <a:noFill/>
-          </a:ln>
-          <a:effectLst/>
-        </p:spPr>
-        <p:style>
-          <a:lnRef idx="1">
-            <a:schemeClr val="accent1"/>
-          </a:lnRef>
-          <a:fillRef idx="3">
-            <a:schemeClr val="accent1"/>
-          </a:fillRef>
-          <a:effectRef idx="2">
-            <a:schemeClr val="accent1"/>
-          </a:effectRef>
-          <a:fontRef idx="minor">
-            <a:schemeClr val="lt1"/>
-          </a:fontRef>
-        </p:style>
-      </p:sp>
-      <p:grpSp>
-        <p:nvGrpSpPr>
-          <p:cNvPr id="14" name="Groupe 13">
-            <a:extLst>
-              <a:ext uri="{FF2B5EF4-FFF2-40B4-BE49-F238E27FC236}">
-                <a16:creationId xmlns:a16="http://schemas.microsoft.com/office/drawing/2014/main" id="{9A421166-2996-41A7-B094-AE5316F347DD}"/>
-              </a:ext>
-              <a:ext uri="{C183D7F6-B498-43B3-948B-1728B52AA6E4}">
-                <adec:decorative xmlns:adec="http://schemas.microsoft.com/office/drawing/2017/decorative" val="1"/>
-              </a:ext>
-            </a:extLst>
-          </p:cNvPr>
-          <p:cNvGrpSpPr>
-            <a:grpSpLocks noGrp="1" noUngrp="1" noRot="1" noChangeAspect="1" noMove="1" noResize="1"/>
-          </p:cNvGrpSpPr>
-          <p:nvPr>
-            <p:extLst>
-              <p:ext uri="{386F3935-93C4-4BCD-93E2-E3B085C9AB24}">
-                <p16:designElem xmlns:p16="http://schemas.microsoft.com/office/powerpoint/2015/main" val="1"/>
-              </p:ext>
-            </p:extLst>
-          </p:nvPr>
-        </p:nvGrpSpPr>
-        <p:grpSpPr>
-          <a:xfrm>
-            <a:off x="446534" y="453643"/>
-            <a:ext cx="11298933" cy="98554"/>
-            <a:chOff x="446534" y="453643"/>
-            <a:chExt cx="11298933" cy="98554"/>
-          </a:xfrm>
-        </p:grpSpPr>
-        <p:sp>
-          <p:nvSpPr>
-            <p:cNvPr id="15" name="Rectangle 14">
-              <a:extLst>
-                <a:ext uri="{FF2B5EF4-FFF2-40B4-BE49-F238E27FC236}">
-                  <a16:creationId xmlns:a16="http://schemas.microsoft.com/office/drawing/2014/main" id="{FDBB1B92-A3EB-43E4-8FAB-D20E8ED14CEF}"/>
-                </a:ext>
-                <a:ext uri="{C183D7F6-B498-43B3-948B-1728B52AA6E4}">
-                  <adec:decorative xmlns:adec="http://schemas.microsoft.com/office/drawing/2017/decorative" val="1"/>
-                </a:ext>
-              </a:extLst>
-            </p:cNvPr>
-            <p:cNvSpPr>
-              <a:spLocks/>
-            </p:cNvSpPr>
-            <p:nvPr>
-              <p:extLst>
-                <p:ext uri="{386F3935-93C4-4BCD-93E2-E3B085C9AB24}">
-                  <p16:designElem xmlns:p16="http://schemas.microsoft.com/office/powerpoint/2015/main" val="1"/>
-                </p:ext>
-              </p:extLst>
-            </p:nvPr>
-          </p:nvSpPr>
-          <p:spPr>
-            <a:xfrm>
-              <a:off x="446534" y="457200"/>
-              <a:ext cx="3703320" cy="94997"/>
-            </a:xfrm>
-            <a:prstGeom prst="rect">
-              <a:avLst/>
-            </a:prstGeom>
-            <a:solidFill>
-              <a:schemeClr val="accent1"/>
-            </a:solidFill>
-            <a:ln>
-              <a:noFill/>
-            </a:ln>
-            <a:effectLst/>
-          </p:spPr>
-          <p:style>
-            <a:lnRef idx="1">
-              <a:schemeClr val="accent1"/>
-            </a:lnRef>
-            <a:fillRef idx="3">
-              <a:schemeClr val="accent1"/>
-            </a:fillRef>
-            <a:effectRef idx="2">
-              <a:schemeClr val="accent1"/>
-            </a:effectRef>
-            <a:fontRef idx="minor">
-              <a:schemeClr val="lt1"/>
-            </a:fontRef>
-          </p:style>
-        </p:sp>
-        <p:sp>
-          <p:nvSpPr>
-            <p:cNvPr id="16" name="Rectangle 15">
-              <a:extLst>
-                <a:ext uri="{FF2B5EF4-FFF2-40B4-BE49-F238E27FC236}">
-                  <a16:creationId xmlns:a16="http://schemas.microsoft.com/office/drawing/2014/main" id="{3F3972F4-FE7E-48EA-AAD8-9BE5750A6672}"/>
-                </a:ext>
-                <a:ext uri="{C183D7F6-B498-43B3-948B-1728B52AA6E4}">
-                  <adec:decorative xmlns:adec="http://schemas.microsoft.com/office/drawing/2017/decorative" val="1"/>
-                </a:ext>
-              </a:extLst>
-            </p:cNvPr>
-            <p:cNvSpPr>
-              <a:spLocks/>
-            </p:cNvSpPr>
-            <p:nvPr>
-              <p:extLst>
-                <p:ext uri="{386F3935-93C4-4BCD-93E2-E3B085C9AB24}">
-                  <p16:designElem xmlns:p16="http://schemas.microsoft.com/office/powerpoint/2015/main" val="1"/>
-                </p:ext>
-              </p:extLst>
-            </p:nvPr>
-          </p:nvSpPr>
-          <p:spPr>
-            <a:xfrm>
-              <a:off x="8042147" y="453643"/>
-              <a:ext cx="3703320" cy="98554"/>
-            </a:xfrm>
-            <a:prstGeom prst="rect">
-              <a:avLst/>
-            </a:prstGeom>
-            <a:solidFill>
-              <a:schemeClr val="accent4"/>
-            </a:solidFill>
-            <a:ln>
-              <a:noFill/>
-            </a:ln>
-            <a:effectLst/>
-          </p:spPr>
-          <p:style>
-            <a:lnRef idx="1">
-              <a:schemeClr val="accent1"/>
-            </a:lnRef>
-            <a:fillRef idx="3">
-              <a:schemeClr val="accent1"/>
-            </a:fillRef>
-            <a:effectRef idx="2">
-              <a:schemeClr val="accent1"/>
-            </a:effectRef>
-            <a:fontRef idx="minor">
-              <a:schemeClr val="lt1"/>
-            </a:fontRef>
-          </p:style>
-        </p:sp>
-        <p:sp>
-          <p:nvSpPr>
-            <p:cNvPr id="17" name="Rectangle 16">
-              <a:extLst>
-                <a:ext uri="{FF2B5EF4-FFF2-40B4-BE49-F238E27FC236}">
-                  <a16:creationId xmlns:a16="http://schemas.microsoft.com/office/drawing/2014/main" id="{221614E5-870B-4D5E-A43B-8FF7E5323484}"/>
-                </a:ext>
-                <a:ext uri="{C183D7F6-B498-43B3-948B-1728B52AA6E4}">
-                  <adec:decorative xmlns:adec="http://schemas.microsoft.com/office/drawing/2017/decorative" val="1"/>
-                </a:ext>
-              </a:extLst>
-            </p:cNvPr>
-            <p:cNvSpPr>
-              <a:spLocks/>
-            </p:cNvSpPr>
-            <p:nvPr>
-              <p:extLst>
-                <p:ext uri="{386F3935-93C4-4BCD-93E2-E3B085C9AB24}">
-                  <p16:designElem xmlns:p16="http://schemas.microsoft.com/office/powerpoint/2015/main" val="1"/>
-                </p:ext>
-              </p:extLst>
-            </p:nvPr>
-          </p:nvSpPr>
-          <p:spPr>
-            <a:xfrm>
-              <a:off x="4241830" y="457200"/>
-              <a:ext cx="3703320" cy="91440"/>
-            </a:xfrm>
-            <a:prstGeom prst="rect">
-              <a:avLst/>
-            </a:prstGeom>
-            <a:solidFill>
-              <a:schemeClr val="accent2"/>
-            </a:solidFill>
-            <a:ln>
-              <a:noFill/>
-            </a:ln>
-            <a:effectLst/>
-          </p:spPr>
-          <p:style>
-            <a:lnRef idx="1">
-              <a:schemeClr val="accent1"/>
-            </a:lnRef>
-            <a:fillRef idx="3">
-              <a:schemeClr val="accent1"/>
-            </a:fillRef>
-            <a:effectRef idx="2">
-              <a:schemeClr val="accent1"/>
-            </a:effectRef>
-            <a:fontRef idx="minor">
-              <a:schemeClr val="lt1"/>
-            </a:fontRef>
-          </p:style>
-        </p:sp>
-      </p:grpSp>
-      <p:sp>
-        <p:nvSpPr>
-          <p:cNvPr id="2" name="Titre 1">
-            <a:extLst>
-              <a:ext uri="{FF2B5EF4-FFF2-40B4-BE49-F238E27FC236}">
-                <a16:creationId xmlns:a16="http://schemas.microsoft.com/office/drawing/2014/main" id="{0F87E73C-2B1A-4602-BFBE-CFE1E55D9B38}"/>
-              </a:ext>
-            </a:extLst>
-          </p:cNvPr>
-          <p:cNvSpPr>
-            <a:spLocks noGrp="1"/>
-          </p:cNvSpPr>
-          <p:nvPr>
-            <p:ph type="ctrTitle"/>
-          </p:nvPr>
-        </p:nvSpPr>
-        <p:spPr>
-          <a:xfrm>
-            <a:off x="8296275" y="1419226"/>
-            <a:ext cx="3081576" cy="1746762"/>
-          </a:xfrm>
-        </p:spPr>
-        <p:txBody>
-          <a:bodyPr rtlCol="0">
-            <a:normAutofit/>
-          </a:bodyPr>
-          <a:lstStyle/>
-          <a:p>
-            <a:pPr rtl="0"/>
-            <a:r>
-              <a:rPr lang="fr-FR">
-                <a:solidFill>
-                  <a:srgbClr val="FFFFFF"/>
-                </a:solidFill>
-              </a:rPr>
-              <a:t>Merci</a:t>
-            </a:r>
-          </a:p>
-        </p:txBody>
-      </p:sp>
-      <p:sp>
-        <p:nvSpPr>
-          <p:cNvPr id="3" name="Sous-titre 2">
-            <a:extLst>
-              <a:ext uri="{FF2B5EF4-FFF2-40B4-BE49-F238E27FC236}">
-                <a16:creationId xmlns:a16="http://schemas.microsoft.com/office/drawing/2014/main" id="{A9CB511D-EA45-4336-847C-1252667143B5}"/>
-              </a:ext>
-            </a:extLst>
-          </p:cNvPr>
-          <p:cNvSpPr>
-            <a:spLocks noGrp="1"/>
-          </p:cNvSpPr>
-          <p:nvPr>
-            <p:ph type="subTitle" idx="1"/>
-          </p:nvPr>
-        </p:nvSpPr>
-        <p:spPr>
-          <a:xfrm>
-            <a:off x="8296275" y="3505095"/>
-            <a:ext cx="3081576" cy="2629006"/>
-          </a:xfrm>
-        </p:spPr>
-        <p:txBody>
-          <a:bodyPr rtlCol="0">
-            <a:normAutofit/>
-          </a:bodyPr>
-          <a:lstStyle/>
-          <a:p>
-            <a:pPr rtl="0"/>
-            <a:r>
-              <a:rPr lang="fr-FR">
-                <a:solidFill>
-                  <a:schemeClr val="bg2"/>
-                </a:solidFill>
-              </a:rPr>
-              <a:t>someone@example.com</a:t>
-            </a:r>
-          </a:p>
-          <a:p>
-            <a:pPr rtl="0"/>
-            <a:endParaRPr lang="fr-FR">
-              <a:solidFill>
-                <a:schemeClr val="bg2"/>
-              </a:solidFill>
-            </a:endParaRPr>
-          </a:p>
-          <a:p>
-            <a:pPr rtl="0"/>
-            <a:endParaRPr lang="fr-FR">
-              <a:solidFill>
-                <a:schemeClr val="bg2"/>
-              </a:solidFill>
-            </a:endParaRPr>
-          </a:p>
-        </p:txBody>
-      </p:sp>
-      <p:pic>
-        <p:nvPicPr>
-          <p:cNvPr id="5" name="Image 4" descr="Valeurs numériques">
-            <a:extLst>
-              <a:ext uri="{FF2B5EF4-FFF2-40B4-BE49-F238E27FC236}">
-                <a16:creationId xmlns:a16="http://schemas.microsoft.com/office/drawing/2014/main" id="{A21EA617-6D48-425F-97A8-7FEC82C8F401}"/>
-              </a:ext>
-            </a:extLst>
-          </p:cNvPr>
-          <p:cNvPicPr>
-            <a:picLocks noChangeAspect="1"/>
-          </p:cNvPicPr>
-          <p:nvPr/>
-        </p:nvPicPr>
-        <p:blipFill rotWithShape="1">
-          <a:blip r:embed="rId3" cstate="screen">
-            <a:extLst>
-              <a:ext uri="{28A0092B-C50C-407E-A947-70E740481C1C}">
-                <a14:useLocalDpi xmlns:a14="http://schemas.microsoft.com/office/drawing/2010/main"/>
-              </a:ext>
-            </a:extLst>
-          </a:blip>
-          <a:srcRect l="2189" r="9642" b="1"/>
-          <a:stretch/>
-        </p:blipFill>
-        <p:spPr>
-          <a:xfrm>
-            <a:off x="446534" y="723899"/>
-            <a:ext cx="7498616" cy="5676901"/>
-          </a:xfrm>
-          <a:prstGeom prst="rect">
-            <a:avLst/>
-          </a:prstGeom>
-        </p:spPr>
-      </p:pic>
-    </p:spTree>
-    <p:extLst>
-      <p:ext uri="{BB962C8B-B14F-4D97-AF65-F5344CB8AC3E}">
-        <p14:creationId xmlns:p14="http://schemas.microsoft.com/office/powerpoint/2010/main" val="3501347425"/>
       </p:ext>
     </p:extLst>
   </p:cSld>

</xml_diff>

<commit_message>
premiere exploration des données
</commit_message>
<xml_diff>
--- a/Presentation.pptx
+++ b/Presentation.pptx
@@ -5,10 +5,10 @@
     <p:sldMasterId id="2147483672" r:id="rId1"/>
   </p:sldMasterIdLst>
   <p:notesMasterIdLst>
-    <p:notesMasterId r:id="rId13"/>
+    <p:notesMasterId r:id="rId15"/>
   </p:notesMasterIdLst>
   <p:handoutMasterIdLst>
-    <p:handoutMasterId r:id="rId14"/>
+    <p:handoutMasterId r:id="rId16"/>
   </p:handoutMasterIdLst>
   <p:sldIdLst>
     <p:sldId id="256" r:id="rId2"/>
@@ -19,9 +19,11 @@
     <p:sldId id="266" r:id="rId7"/>
     <p:sldId id="267" r:id="rId8"/>
     <p:sldId id="261" r:id="rId9"/>
-    <p:sldId id="258" r:id="rId10"/>
-    <p:sldId id="259" r:id="rId11"/>
-    <p:sldId id="260" r:id="rId12"/>
+    <p:sldId id="269" r:id="rId10"/>
+    <p:sldId id="268" r:id="rId11"/>
+    <p:sldId id="258" r:id="rId12"/>
+    <p:sldId id="259" r:id="rId13"/>
+    <p:sldId id="260" r:id="rId14"/>
   </p:sldIdLst>
   <p:sldSz cx="12192000" cy="6858000"/>
   <p:notesSz cx="6858000" cy="9144000"/>
@@ -132,755 +134,6 @@
 </file>
 
 <file path=ppt/diagrams/colors1.xml><?xml version="1.0" encoding="utf-8"?>
-<dgm:colorsDef xmlns:dgm="http://schemas.openxmlformats.org/drawingml/2006/diagram" xmlns:a="http://schemas.openxmlformats.org/drawingml/2006/main" uniqueId="urn:microsoft.com/office/officeart/2018/5/colors/Iconchunking_neutralbg_accent2_2">
-  <dgm:title val=""/>
-  <dgm:desc val=""/>
-  <dgm:catLst>
-    <dgm:cat type="accent2" pri="11200"/>
-  </dgm:catLst>
-  <dgm:styleLbl name="node0">
-    <dgm:fillClrLst meth="repeat">
-      <a:schemeClr val="accent2"/>
-    </dgm:fillClrLst>
-    <dgm:linClrLst meth="repeat">
-      <a:schemeClr val="lt1"/>
-    </dgm:linClrLst>
-    <dgm:effectClrLst/>
-    <dgm:txLinClrLst/>
-    <dgm:txFillClrLst/>
-    <dgm:txEffectClrLst/>
-  </dgm:styleLbl>
-  <dgm:styleLbl name="node1">
-    <dgm:fillClrLst meth="repeat">
-      <a:schemeClr val="accent2"/>
-    </dgm:fillClrLst>
-    <dgm:linClrLst meth="repeat">
-      <a:schemeClr val="lt1">
-        <a:alpha val="0"/>
-      </a:schemeClr>
-    </dgm:linClrLst>
-    <dgm:effectClrLst/>
-    <dgm:txLinClrLst/>
-    <dgm:txFillClrLst/>
-    <dgm:txEffectClrLst/>
-  </dgm:styleLbl>
-  <dgm:styleLbl name="alignNode1">
-    <dgm:fillClrLst meth="repeat">
-      <a:schemeClr val="accent2"/>
-    </dgm:fillClrLst>
-    <dgm:linClrLst meth="repeat">
-      <a:schemeClr val="accent2"/>
-    </dgm:linClrLst>
-    <dgm:effectClrLst/>
-    <dgm:txLinClrLst/>
-    <dgm:txFillClrLst/>
-    <dgm:txEffectClrLst/>
-  </dgm:styleLbl>
-  <dgm:styleLbl name="lnNode1">
-    <dgm:fillClrLst meth="repeat">
-      <a:schemeClr val="accent2"/>
-    </dgm:fillClrLst>
-    <dgm:linClrLst meth="repeat">
-      <a:schemeClr val="lt1"/>
-    </dgm:linClrLst>
-    <dgm:effectClrLst/>
-    <dgm:txLinClrLst/>
-    <dgm:txFillClrLst/>
-    <dgm:txEffectClrLst/>
-  </dgm:styleLbl>
-  <dgm:styleLbl name="vennNode1">
-    <dgm:fillClrLst meth="repeat">
-      <a:schemeClr val="accent2">
-        <a:alpha val="50000"/>
-      </a:schemeClr>
-    </dgm:fillClrLst>
-    <dgm:linClrLst meth="repeat">
-      <a:schemeClr val="lt1"/>
-    </dgm:linClrLst>
-    <dgm:effectClrLst/>
-    <dgm:txLinClrLst/>
-    <dgm:txFillClrLst/>
-    <dgm:txEffectClrLst/>
-  </dgm:styleLbl>
-  <dgm:styleLbl name="node2">
-    <dgm:fillClrLst meth="repeat">
-      <a:schemeClr val="accent2"/>
-    </dgm:fillClrLst>
-    <dgm:linClrLst meth="repeat">
-      <a:schemeClr val="lt1"/>
-    </dgm:linClrLst>
-    <dgm:effectClrLst/>
-    <dgm:txLinClrLst/>
-    <dgm:txFillClrLst/>
-    <dgm:txEffectClrLst/>
-  </dgm:styleLbl>
-  <dgm:styleLbl name="node3">
-    <dgm:fillClrLst meth="repeat">
-      <a:schemeClr val="accent2"/>
-    </dgm:fillClrLst>
-    <dgm:linClrLst meth="repeat">
-      <a:schemeClr val="lt1"/>
-    </dgm:linClrLst>
-    <dgm:effectClrLst/>
-    <dgm:txLinClrLst/>
-    <dgm:txFillClrLst/>
-    <dgm:txEffectClrLst/>
-  </dgm:styleLbl>
-  <dgm:styleLbl name="node4">
-    <dgm:fillClrLst meth="repeat">
-      <a:schemeClr val="accent2"/>
-    </dgm:fillClrLst>
-    <dgm:linClrLst meth="repeat">
-      <a:schemeClr val="lt1"/>
-    </dgm:linClrLst>
-    <dgm:effectClrLst/>
-    <dgm:txLinClrLst/>
-    <dgm:txFillClrLst/>
-    <dgm:txEffectClrLst/>
-  </dgm:styleLbl>
-  <dgm:styleLbl name="fgImgPlace1">
-    <dgm:fillClrLst meth="repeat">
-      <a:schemeClr val="accent2">
-        <a:tint val="50000"/>
-      </a:schemeClr>
-    </dgm:fillClrLst>
-    <dgm:linClrLst meth="repeat">
-      <a:schemeClr val="lt1"/>
-    </dgm:linClrLst>
-    <dgm:effectClrLst/>
-    <dgm:txLinClrLst/>
-    <dgm:txFillClrLst meth="repeat">
-      <a:schemeClr val="lt1"/>
-    </dgm:txFillClrLst>
-    <dgm:txEffectClrLst/>
-  </dgm:styleLbl>
-  <dgm:styleLbl name="alignImgPlace1">
-    <dgm:fillClrLst meth="repeat">
-      <a:schemeClr val="accent2">
-        <a:tint val="50000"/>
-      </a:schemeClr>
-    </dgm:fillClrLst>
-    <dgm:linClrLst meth="repeat">
-      <a:schemeClr val="lt1"/>
-    </dgm:linClrLst>
-    <dgm:effectClrLst/>
-    <dgm:txLinClrLst/>
-    <dgm:txFillClrLst meth="repeat">
-      <a:schemeClr val="lt1"/>
-    </dgm:txFillClrLst>
-    <dgm:txEffectClrLst/>
-  </dgm:styleLbl>
-  <dgm:styleLbl name="bgImgPlace1">
-    <dgm:fillClrLst meth="repeat">
-      <a:schemeClr val="accent2">
-        <a:tint val="50000"/>
-      </a:schemeClr>
-    </dgm:fillClrLst>
-    <dgm:linClrLst meth="repeat">
-      <a:schemeClr val="lt1"/>
-    </dgm:linClrLst>
-    <dgm:effectClrLst/>
-    <dgm:txLinClrLst/>
-    <dgm:txFillClrLst meth="repeat">
-      <a:schemeClr val="lt1"/>
-    </dgm:txFillClrLst>
-    <dgm:txEffectClrLst/>
-  </dgm:styleLbl>
-  <dgm:styleLbl name="sibTrans2D1">
-    <dgm:fillClrLst meth="repeat">
-      <a:schemeClr val="accent2">
-        <a:tint val="60000"/>
-      </a:schemeClr>
-    </dgm:fillClrLst>
-    <dgm:linClrLst meth="repeat">
-      <a:schemeClr val="accent2">
-        <a:tint val="60000"/>
-      </a:schemeClr>
-    </dgm:linClrLst>
-    <dgm:effectClrLst/>
-    <dgm:txLinClrLst/>
-    <dgm:txFillClrLst/>
-    <dgm:txEffectClrLst/>
-  </dgm:styleLbl>
-  <dgm:styleLbl name="fgSibTrans2D1">
-    <dgm:fillClrLst meth="repeat">
-      <a:schemeClr val="accent2">
-        <a:tint val="60000"/>
-      </a:schemeClr>
-    </dgm:fillClrLst>
-    <dgm:linClrLst meth="repeat">
-      <a:schemeClr val="accent2">
-        <a:tint val="60000"/>
-      </a:schemeClr>
-    </dgm:linClrLst>
-    <dgm:effectClrLst/>
-    <dgm:txLinClrLst/>
-    <dgm:txFillClrLst/>
-    <dgm:txEffectClrLst/>
-  </dgm:styleLbl>
-  <dgm:styleLbl name="bgSibTrans2D1">
-    <dgm:fillClrLst meth="repeat">
-      <a:schemeClr val="accent2">
-        <a:tint val="60000"/>
-      </a:schemeClr>
-    </dgm:fillClrLst>
-    <dgm:linClrLst meth="repeat">
-      <a:schemeClr val="accent2">
-        <a:tint val="60000"/>
-      </a:schemeClr>
-    </dgm:linClrLst>
-    <dgm:effectClrLst/>
-    <dgm:txLinClrLst/>
-    <dgm:txFillClrLst/>
-    <dgm:txEffectClrLst/>
-  </dgm:styleLbl>
-  <dgm:styleLbl name="sibTrans1D1">
-    <dgm:fillClrLst meth="repeat">
-      <a:schemeClr val="accent2"/>
-    </dgm:fillClrLst>
-    <dgm:linClrLst meth="repeat">
-      <a:schemeClr val="accent2"/>
-    </dgm:linClrLst>
-    <dgm:effectClrLst/>
-    <dgm:txLinClrLst/>
-    <dgm:txFillClrLst meth="repeat">
-      <a:schemeClr val="tx1"/>
-    </dgm:txFillClrLst>
-    <dgm:txEffectClrLst/>
-  </dgm:styleLbl>
-  <dgm:styleLbl name="callout">
-    <dgm:fillClrLst meth="repeat">
-      <a:schemeClr val="accent2"/>
-    </dgm:fillClrLst>
-    <dgm:linClrLst meth="repeat">
-      <a:schemeClr val="accent2">
-        <a:tint val="50000"/>
-      </a:schemeClr>
-    </dgm:linClrLst>
-    <dgm:effectClrLst/>
-    <dgm:txLinClrLst/>
-    <dgm:txFillClrLst meth="repeat">
-      <a:schemeClr val="tx1"/>
-    </dgm:txFillClrLst>
-    <dgm:txEffectClrLst/>
-  </dgm:styleLbl>
-  <dgm:styleLbl name="asst0">
-    <dgm:fillClrLst meth="repeat">
-      <a:schemeClr val="accent2"/>
-    </dgm:fillClrLst>
-    <dgm:linClrLst meth="repeat">
-      <a:schemeClr val="lt1"/>
-    </dgm:linClrLst>
-    <dgm:effectClrLst/>
-    <dgm:txLinClrLst/>
-    <dgm:txFillClrLst/>
-    <dgm:txEffectClrLst/>
-  </dgm:styleLbl>
-  <dgm:styleLbl name="asst1">
-    <dgm:fillClrLst meth="repeat">
-      <a:schemeClr val="accent2"/>
-    </dgm:fillClrLst>
-    <dgm:linClrLst meth="repeat">
-      <a:schemeClr val="lt1"/>
-    </dgm:linClrLst>
-    <dgm:effectClrLst/>
-    <dgm:txLinClrLst/>
-    <dgm:txFillClrLst/>
-    <dgm:txEffectClrLst/>
-  </dgm:styleLbl>
-  <dgm:styleLbl name="asst2">
-    <dgm:fillClrLst meth="repeat">
-      <a:schemeClr val="accent2"/>
-    </dgm:fillClrLst>
-    <dgm:linClrLst meth="repeat">
-      <a:schemeClr val="lt1"/>
-    </dgm:linClrLst>
-    <dgm:effectClrLst/>
-    <dgm:txLinClrLst/>
-    <dgm:txFillClrLst/>
-    <dgm:txEffectClrLst/>
-  </dgm:styleLbl>
-  <dgm:styleLbl name="asst3">
-    <dgm:fillClrLst meth="repeat">
-      <a:schemeClr val="accent2"/>
-    </dgm:fillClrLst>
-    <dgm:linClrLst meth="repeat">
-      <a:schemeClr val="lt1"/>
-    </dgm:linClrLst>
-    <dgm:effectClrLst/>
-    <dgm:txLinClrLst/>
-    <dgm:txFillClrLst/>
-    <dgm:txEffectClrLst/>
-  </dgm:styleLbl>
-  <dgm:styleLbl name="asst4">
-    <dgm:fillClrLst meth="repeat">
-      <a:schemeClr val="accent2"/>
-    </dgm:fillClrLst>
-    <dgm:linClrLst meth="repeat">
-      <a:schemeClr val="lt1"/>
-    </dgm:linClrLst>
-    <dgm:effectClrLst/>
-    <dgm:txLinClrLst/>
-    <dgm:txFillClrLst/>
-    <dgm:txEffectClrLst/>
-  </dgm:styleLbl>
-  <dgm:styleLbl name="parChTrans2D1">
-    <dgm:fillClrLst meth="repeat">
-      <a:schemeClr val="accent2">
-        <a:tint val="60000"/>
-      </a:schemeClr>
-    </dgm:fillClrLst>
-    <dgm:linClrLst meth="repeat">
-      <a:schemeClr val="accent2">
-        <a:tint val="60000"/>
-      </a:schemeClr>
-    </dgm:linClrLst>
-    <dgm:effectClrLst/>
-    <dgm:txLinClrLst/>
-    <dgm:txFillClrLst meth="repeat">
-      <a:schemeClr val="lt1"/>
-    </dgm:txFillClrLst>
-    <dgm:txEffectClrLst/>
-  </dgm:styleLbl>
-  <dgm:styleLbl name="parChTrans2D2">
-    <dgm:fillClrLst meth="repeat">
-      <a:schemeClr val="accent2"/>
-    </dgm:fillClrLst>
-    <dgm:linClrLst meth="repeat">
-      <a:schemeClr val="accent2"/>
-    </dgm:linClrLst>
-    <dgm:effectClrLst/>
-    <dgm:txLinClrLst/>
-    <dgm:txFillClrLst meth="repeat">
-      <a:schemeClr val="lt1"/>
-    </dgm:txFillClrLst>
-    <dgm:txEffectClrLst/>
-  </dgm:styleLbl>
-  <dgm:styleLbl name="parChTrans2D3">
-    <dgm:fillClrLst meth="repeat">
-      <a:schemeClr val="accent2"/>
-    </dgm:fillClrLst>
-    <dgm:linClrLst meth="repeat">
-      <a:schemeClr val="accent2"/>
-    </dgm:linClrLst>
-    <dgm:effectClrLst/>
-    <dgm:txLinClrLst/>
-    <dgm:txFillClrLst meth="repeat">
-      <a:schemeClr val="lt1"/>
-    </dgm:txFillClrLst>
-    <dgm:txEffectClrLst/>
-  </dgm:styleLbl>
-  <dgm:styleLbl name="parChTrans2D4">
-    <dgm:fillClrLst meth="repeat">
-      <a:schemeClr val="accent2"/>
-    </dgm:fillClrLst>
-    <dgm:linClrLst meth="repeat">
-      <a:schemeClr val="accent2"/>
-    </dgm:linClrLst>
-    <dgm:effectClrLst/>
-    <dgm:txLinClrLst/>
-    <dgm:txFillClrLst meth="repeat">
-      <a:schemeClr val="lt1"/>
-    </dgm:txFillClrLst>
-    <dgm:txEffectClrLst/>
-  </dgm:styleLbl>
-  <dgm:styleLbl name="parChTrans1D1">
-    <dgm:fillClrLst meth="repeat">
-      <a:schemeClr val="accent2"/>
-    </dgm:fillClrLst>
-    <dgm:linClrLst meth="repeat">
-      <a:schemeClr val="accent2">
-        <a:shade val="60000"/>
-      </a:schemeClr>
-    </dgm:linClrLst>
-    <dgm:effectClrLst/>
-    <dgm:txLinClrLst/>
-    <dgm:txFillClrLst meth="repeat">
-      <a:schemeClr val="tx1"/>
-    </dgm:txFillClrLst>
-    <dgm:txEffectClrLst/>
-  </dgm:styleLbl>
-  <dgm:styleLbl name="parChTrans1D2">
-    <dgm:fillClrLst meth="repeat">
-      <a:schemeClr val="accent2"/>
-    </dgm:fillClrLst>
-    <dgm:linClrLst meth="repeat">
-      <a:schemeClr val="accent2">
-        <a:shade val="60000"/>
-      </a:schemeClr>
-    </dgm:linClrLst>
-    <dgm:effectClrLst/>
-    <dgm:txLinClrLst/>
-    <dgm:txFillClrLst meth="repeat">
-      <a:schemeClr val="tx1"/>
-    </dgm:txFillClrLst>
-    <dgm:txEffectClrLst/>
-  </dgm:styleLbl>
-  <dgm:styleLbl name="parChTrans1D3">
-    <dgm:fillClrLst meth="repeat">
-      <a:schemeClr val="accent2"/>
-    </dgm:fillClrLst>
-    <dgm:linClrLst meth="repeat">
-      <a:schemeClr val="accent2">
-        <a:shade val="80000"/>
-      </a:schemeClr>
-    </dgm:linClrLst>
-    <dgm:effectClrLst/>
-    <dgm:txLinClrLst/>
-    <dgm:txFillClrLst meth="repeat">
-      <a:schemeClr val="tx1"/>
-    </dgm:txFillClrLst>
-    <dgm:txEffectClrLst/>
-  </dgm:styleLbl>
-  <dgm:styleLbl name="parChTrans1D4">
-    <dgm:fillClrLst meth="repeat">
-      <a:schemeClr val="accent2"/>
-    </dgm:fillClrLst>
-    <dgm:linClrLst meth="repeat">
-      <a:schemeClr val="accent2">
-        <a:shade val="80000"/>
-      </a:schemeClr>
-    </dgm:linClrLst>
-    <dgm:effectClrLst/>
-    <dgm:txLinClrLst/>
-    <dgm:txFillClrLst meth="repeat">
-      <a:schemeClr val="tx1"/>
-    </dgm:txFillClrLst>
-    <dgm:txEffectClrLst/>
-  </dgm:styleLbl>
-  <dgm:styleLbl name="fgAcc1">
-    <dgm:fillClrLst meth="repeat">
-      <a:schemeClr val="lt1">
-        <a:alpha val="90000"/>
-      </a:schemeClr>
-    </dgm:fillClrLst>
-    <dgm:linClrLst meth="repeat">
-      <a:schemeClr val="accent2"/>
-    </dgm:linClrLst>
-    <dgm:effectClrLst/>
-    <dgm:txLinClrLst/>
-    <dgm:txFillClrLst meth="repeat">
-      <a:schemeClr val="dk1"/>
-    </dgm:txFillClrLst>
-    <dgm:txEffectClrLst/>
-  </dgm:styleLbl>
-  <dgm:styleLbl name="conFgAcc1">
-    <dgm:fillClrLst meth="repeat">
-      <a:schemeClr val="lt1">
-        <a:alpha val="90000"/>
-      </a:schemeClr>
-    </dgm:fillClrLst>
-    <dgm:linClrLst meth="repeat">
-      <a:schemeClr val="accent2"/>
-    </dgm:linClrLst>
-    <dgm:effectClrLst/>
-    <dgm:txLinClrLst/>
-    <dgm:txFillClrLst meth="repeat">
-      <a:schemeClr val="dk1"/>
-    </dgm:txFillClrLst>
-    <dgm:txEffectClrLst/>
-  </dgm:styleLbl>
-  <dgm:styleLbl name="alignAcc1">
-    <dgm:fillClrLst meth="repeat">
-      <a:schemeClr val="lt1">
-        <a:alpha val="90000"/>
-      </a:schemeClr>
-    </dgm:fillClrLst>
-    <dgm:linClrLst meth="repeat">
-      <a:schemeClr val="accent2"/>
-    </dgm:linClrLst>
-    <dgm:effectClrLst/>
-    <dgm:txLinClrLst/>
-    <dgm:txFillClrLst meth="repeat">
-      <a:schemeClr val="dk1"/>
-    </dgm:txFillClrLst>
-    <dgm:txEffectClrLst/>
-  </dgm:styleLbl>
-  <dgm:styleLbl name="trAlignAcc1">
-    <dgm:fillClrLst meth="repeat">
-      <a:schemeClr val="lt1">
-        <a:alpha val="40000"/>
-      </a:schemeClr>
-    </dgm:fillClrLst>
-    <dgm:linClrLst meth="repeat">
-      <a:schemeClr val="accent2"/>
-    </dgm:linClrLst>
-    <dgm:effectClrLst/>
-    <dgm:txLinClrLst/>
-    <dgm:txFillClrLst meth="repeat">
-      <a:schemeClr val="dk1"/>
-    </dgm:txFillClrLst>
-    <dgm:txEffectClrLst/>
-  </dgm:styleLbl>
-  <dgm:styleLbl name="bgAcc1">
-    <dgm:fillClrLst meth="repeat">
-      <a:schemeClr val="lt1">
-        <a:alpha val="90000"/>
-      </a:schemeClr>
-    </dgm:fillClrLst>
-    <dgm:linClrLst meth="repeat">
-      <a:schemeClr val="accent2"/>
-    </dgm:linClrLst>
-    <dgm:effectClrLst/>
-    <dgm:txLinClrLst/>
-    <dgm:txFillClrLst meth="repeat">
-      <a:schemeClr val="dk1"/>
-    </dgm:txFillClrLst>
-    <dgm:txEffectClrLst/>
-  </dgm:styleLbl>
-  <dgm:styleLbl name="solidFgAcc1">
-    <dgm:fillClrLst meth="repeat">
-      <a:schemeClr val="lt1"/>
-    </dgm:fillClrLst>
-    <dgm:linClrLst meth="repeat">
-      <a:schemeClr val="accent2"/>
-    </dgm:linClrLst>
-    <dgm:effectClrLst/>
-    <dgm:txLinClrLst/>
-    <dgm:txFillClrLst meth="repeat">
-      <a:schemeClr val="dk1"/>
-    </dgm:txFillClrLst>
-    <dgm:txEffectClrLst/>
-  </dgm:styleLbl>
-  <dgm:styleLbl name="solidAlignAcc1">
-    <dgm:fillClrLst meth="repeat">
-      <a:schemeClr val="lt1"/>
-    </dgm:fillClrLst>
-    <dgm:linClrLst meth="repeat">
-      <a:schemeClr val="accent2"/>
-    </dgm:linClrLst>
-    <dgm:effectClrLst/>
-    <dgm:txLinClrLst/>
-    <dgm:txFillClrLst meth="repeat">
-      <a:schemeClr val="dk1"/>
-    </dgm:txFillClrLst>
-    <dgm:txEffectClrLst/>
-  </dgm:styleLbl>
-  <dgm:styleLbl name="solidBgAcc1">
-    <dgm:fillClrLst meth="repeat">
-      <a:schemeClr val="lt1"/>
-    </dgm:fillClrLst>
-    <dgm:linClrLst meth="repeat">
-      <a:schemeClr val="accent2"/>
-    </dgm:linClrLst>
-    <dgm:effectClrLst/>
-    <dgm:txLinClrLst/>
-    <dgm:txFillClrLst meth="repeat">
-      <a:schemeClr val="dk1"/>
-    </dgm:txFillClrLst>
-    <dgm:txEffectClrLst/>
-  </dgm:styleLbl>
-  <dgm:styleLbl name="fgAccFollowNode1">
-    <dgm:fillClrLst meth="repeat">
-      <a:schemeClr val="accent2">
-        <a:alpha val="90000"/>
-        <a:tint val="40000"/>
-      </a:schemeClr>
-    </dgm:fillClrLst>
-    <dgm:linClrLst meth="repeat">
-      <a:schemeClr val="accent2">
-        <a:alpha val="90000"/>
-        <a:tint val="40000"/>
-      </a:schemeClr>
-    </dgm:linClrLst>
-    <dgm:effectClrLst/>
-    <dgm:txLinClrLst/>
-    <dgm:txFillClrLst meth="repeat">
-      <a:schemeClr val="dk1"/>
-    </dgm:txFillClrLst>
-    <dgm:txEffectClrLst/>
-  </dgm:styleLbl>
-  <dgm:styleLbl name="alignAccFollowNode1">
-    <dgm:fillClrLst meth="repeat">
-      <a:schemeClr val="accent2">
-        <a:alpha val="90000"/>
-        <a:tint val="40000"/>
-      </a:schemeClr>
-    </dgm:fillClrLst>
-    <dgm:linClrLst meth="repeat">
-      <a:schemeClr val="accent2">
-        <a:alpha val="90000"/>
-        <a:tint val="40000"/>
-      </a:schemeClr>
-    </dgm:linClrLst>
-    <dgm:effectClrLst/>
-    <dgm:txLinClrLst/>
-    <dgm:txFillClrLst meth="repeat">
-      <a:schemeClr val="dk1"/>
-    </dgm:txFillClrLst>
-    <dgm:txEffectClrLst/>
-  </dgm:styleLbl>
-  <dgm:styleLbl name="bgAccFollowNode1">
-    <dgm:fillClrLst meth="repeat">
-      <a:schemeClr val="accent2">
-        <a:alpha val="90000"/>
-        <a:tint val="40000"/>
-      </a:schemeClr>
-    </dgm:fillClrLst>
-    <dgm:linClrLst meth="repeat">
-      <a:schemeClr val="accent2">
-        <a:alpha val="90000"/>
-        <a:tint val="40000"/>
-      </a:schemeClr>
-    </dgm:linClrLst>
-    <dgm:effectClrLst/>
-    <dgm:txLinClrLst/>
-    <dgm:txFillClrLst meth="repeat">
-      <a:schemeClr val="dk1"/>
-    </dgm:txFillClrLst>
-    <dgm:txEffectClrLst/>
-  </dgm:styleLbl>
-  <dgm:styleLbl name="fgAcc0">
-    <dgm:fillClrLst meth="repeat">
-      <a:schemeClr val="lt1">
-        <a:alpha val="90000"/>
-      </a:schemeClr>
-    </dgm:fillClrLst>
-    <dgm:linClrLst meth="repeat">
-      <a:schemeClr val="accent2"/>
-    </dgm:linClrLst>
-    <dgm:effectClrLst/>
-    <dgm:txLinClrLst/>
-    <dgm:txFillClrLst meth="repeat">
-      <a:schemeClr val="dk1"/>
-    </dgm:txFillClrLst>
-    <dgm:txEffectClrLst/>
-  </dgm:styleLbl>
-  <dgm:styleLbl name="fgAcc2">
-    <dgm:fillClrLst meth="repeat">
-      <a:schemeClr val="lt1">
-        <a:alpha val="90000"/>
-      </a:schemeClr>
-    </dgm:fillClrLst>
-    <dgm:linClrLst meth="repeat">
-      <a:schemeClr val="accent2"/>
-    </dgm:linClrLst>
-    <dgm:effectClrLst/>
-    <dgm:txLinClrLst/>
-    <dgm:txFillClrLst meth="repeat">
-      <a:schemeClr val="dk1"/>
-    </dgm:txFillClrLst>
-    <dgm:txEffectClrLst/>
-  </dgm:styleLbl>
-  <dgm:styleLbl name="fgAcc3">
-    <dgm:fillClrLst meth="repeat">
-      <a:schemeClr val="lt1">
-        <a:alpha val="90000"/>
-      </a:schemeClr>
-    </dgm:fillClrLst>
-    <dgm:linClrLst meth="repeat">
-      <a:schemeClr val="accent2"/>
-    </dgm:linClrLst>
-    <dgm:effectClrLst/>
-    <dgm:txLinClrLst/>
-    <dgm:txFillClrLst meth="repeat">
-      <a:schemeClr val="dk1"/>
-    </dgm:txFillClrLst>
-    <dgm:txEffectClrLst/>
-  </dgm:styleLbl>
-  <dgm:styleLbl name="fgAcc4">
-    <dgm:fillClrLst meth="repeat">
-      <a:schemeClr val="lt1">
-        <a:alpha val="90000"/>
-      </a:schemeClr>
-    </dgm:fillClrLst>
-    <dgm:linClrLst meth="repeat">
-      <a:schemeClr val="accent2"/>
-    </dgm:linClrLst>
-    <dgm:effectClrLst/>
-    <dgm:txLinClrLst/>
-    <dgm:txFillClrLst meth="repeat">
-      <a:schemeClr val="dk1"/>
-    </dgm:txFillClrLst>
-    <dgm:txEffectClrLst/>
-  </dgm:styleLbl>
-  <dgm:styleLbl name="bgShp">
-    <dgm:fillClrLst meth="repeat">
-      <a:schemeClr val="bg1">
-        <a:lumMod val="95000"/>
-      </a:schemeClr>
-    </dgm:fillClrLst>
-    <dgm:linClrLst meth="repeat">
-      <a:schemeClr val="accent2"/>
-    </dgm:linClrLst>
-    <dgm:effectClrLst/>
-    <dgm:txLinClrLst/>
-    <dgm:txFillClrLst meth="repeat">
-      <a:schemeClr val="dk1"/>
-    </dgm:txFillClrLst>
-    <dgm:txEffectClrLst/>
-  </dgm:styleLbl>
-  <dgm:styleLbl name="dkBgShp">
-    <dgm:fillClrLst meth="repeat">
-      <a:schemeClr val="accent2">
-        <a:shade val="80000"/>
-      </a:schemeClr>
-    </dgm:fillClrLst>
-    <dgm:linClrLst meth="repeat">
-      <a:schemeClr val="accent2"/>
-    </dgm:linClrLst>
-    <dgm:effectClrLst/>
-    <dgm:txLinClrLst/>
-    <dgm:txFillClrLst meth="repeat">
-      <a:schemeClr val="lt1"/>
-    </dgm:txFillClrLst>
-    <dgm:txEffectClrLst/>
-  </dgm:styleLbl>
-  <dgm:styleLbl name="trBgShp">
-    <dgm:fillClrLst meth="repeat">
-      <a:schemeClr val="accent2">
-        <a:tint val="50000"/>
-        <a:alpha val="40000"/>
-      </a:schemeClr>
-    </dgm:fillClrLst>
-    <dgm:linClrLst meth="repeat">
-      <a:schemeClr val="accent2"/>
-    </dgm:linClrLst>
-    <dgm:effectClrLst/>
-    <dgm:txLinClrLst/>
-    <dgm:txFillClrLst meth="repeat">
-      <a:schemeClr val="lt1"/>
-    </dgm:txFillClrLst>
-    <dgm:txEffectClrLst/>
-  </dgm:styleLbl>
-  <dgm:styleLbl name="fgShp">
-    <dgm:fillClrLst meth="repeat">
-      <a:schemeClr val="accent2">
-        <a:tint val="60000"/>
-      </a:schemeClr>
-    </dgm:fillClrLst>
-    <dgm:linClrLst meth="repeat">
-      <a:schemeClr val="lt1"/>
-    </dgm:linClrLst>
-    <dgm:effectClrLst/>
-    <dgm:txLinClrLst/>
-    <dgm:txFillClrLst meth="repeat">
-      <a:schemeClr val="dk1"/>
-    </dgm:txFillClrLst>
-    <dgm:txEffectClrLst/>
-  </dgm:styleLbl>
-  <dgm:styleLbl name="revTx">
-    <dgm:fillClrLst meth="repeat">
-      <a:schemeClr val="lt1">
-        <a:alpha val="0"/>
-      </a:schemeClr>
-    </dgm:fillClrLst>
-    <dgm:linClrLst meth="repeat">
-      <a:schemeClr val="dk1">
-        <a:alpha val="0"/>
-      </a:schemeClr>
-    </dgm:linClrLst>
-    <dgm:effectClrLst/>
-    <dgm:txLinClrLst/>
-    <dgm:txFillClrLst meth="repeat">
-      <a:schemeClr val="tx1"/>
-    </dgm:txFillClrLst>
-    <dgm:txEffectClrLst/>
-  </dgm:styleLbl>
-</dgm:colorsDef>
-</file>
-
-<file path=ppt/diagrams/colors2.xml><?xml version="1.0" encoding="utf-8"?>
 <dgm:colorsDef xmlns:dgm="http://schemas.openxmlformats.org/drawingml/2006/diagram" xmlns:a="http://schemas.openxmlformats.org/drawingml/2006/main" uniqueId="urn:microsoft.com/office/officeart/2005/8/colors/accent2_2">
   <dgm:title val=""/>
   <dgm:desc val=""/>
@@ -1630,318 +883,6 @@
 <file path=ppt/diagrams/data1.xml><?xml version="1.0" encoding="utf-8"?>
 <dgm:dataModel xmlns:dgm="http://schemas.openxmlformats.org/drawingml/2006/diagram" xmlns:a="http://schemas.openxmlformats.org/drawingml/2006/main">
   <dgm:ptLst>
-    <dgm:pt modelId="{7D9C16A6-8C48-4165-8DAF-8C957C12A8FA}" type="doc">
-      <dgm:prSet loTypeId="urn:microsoft.com/office/officeart/2018/2/layout/IconLabelList" loCatId="icon" qsTypeId="urn:microsoft.com/office/officeart/2005/8/quickstyle/simple1" qsCatId="simple" csTypeId="urn:microsoft.com/office/officeart/2018/5/colors/Iconchunking_neutralbg_accent2_2" csCatId="accent2" phldr="1"/>
-      <dgm:spPr/>
-    </dgm:pt>
-    <dgm:pt modelId="{701D68F5-42F8-47BC-8FED-84C50F595DF0}">
-      <dgm:prSet phldrT="[Text]"/>
-      <dgm:spPr/>
-      <dgm:t>
-        <a:bodyPr rtlCol="0"/>
-        <a:lstStyle/>
-        <a:p>
-          <a:pPr rtl="0"/>
-          <a:r>
-            <a:rPr lang="fr-FR" noProof="0" dirty="0"/>
-            <a:t>Réseau</a:t>
-          </a:r>
-        </a:p>
-      </dgm:t>
-    </dgm:pt>
-    <dgm:pt modelId="{9617668C-C38C-4017-8DDF-37855B15D110}" type="parTrans" cxnId="{C4BA385D-31ED-40EF-A5D6-98DFBA64E71A}">
-      <dgm:prSet/>
-      <dgm:spPr/>
-      <dgm:t>
-        <a:bodyPr rtlCol="0"/>
-        <a:lstStyle/>
-        <a:p>
-          <a:pPr rtl="0"/>
-          <a:endParaRPr lang="fr-FR" noProof="0" dirty="0"/>
-        </a:p>
-      </dgm:t>
-    </dgm:pt>
-    <dgm:pt modelId="{0C95B389-AC0C-4055-9AA3-38815EFC8B0A}" type="sibTrans" cxnId="{C4BA385D-31ED-40EF-A5D6-98DFBA64E71A}">
-      <dgm:prSet/>
-      <dgm:spPr/>
-      <dgm:t>
-        <a:bodyPr rtlCol="0"/>
-        <a:lstStyle/>
-        <a:p>
-          <a:pPr rtl="0"/>
-          <a:endParaRPr lang="fr-FR" noProof="0" dirty="0"/>
-        </a:p>
-      </dgm:t>
-    </dgm:pt>
-    <dgm:pt modelId="{91A66877-AC1C-46D9-BF2C-6024B638DEA9}">
-      <dgm:prSet phldrT="[Text]"/>
-      <dgm:spPr/>
-      <dgm:t>
-        <a:bodyPr rtlCol="0"/>
-        <a:lstStyle/>
-        <a:p>
-          <a:pPr rtl="0"/>
-          <a:r>
-            <a:rPr lang="fr-FR" noProof="0" dirty="0"/>
-            <a:t>Satellite</a:t>
-          </a:r>
-        </a:p>
-      </dgm:t>
-    </dgm:pt>
-    <dgm:pt modelId="{913FED05-DF41-48A7-B1F8-81937A468EF9}" type="parTrans" cxnId="{7F0DAB6F-9257-4F2D-B31A-3418F73F6952}">
-      <dgm:prSet/>
-      <dgm:spPr/>
-      <dgm:t>
-        <a:bodyPr rtlCol="0"/>
-        <a:lstStyle/>
-        <a:p>
-          <a:pPr rtl="0"/>
-          <a:endParaRPr lang="fr-FR" noProof="0" dirty="0"/>
-        </a:p>
-      </dgm:t>
-    </dgm:pt>
-    <dgm:pt modelId="{BFCE4A28-C381-46FF-935A-B11534EF7D87}" type="sibTrans" cxnId="{7F0DAB6F-9257-4F2D-B31A-3418F73F6952}">
-      <dgm:prSet/>
-      <dgm:spPr/>
-      <dgm:t>
-        <a:bodyPr rtlCol="0"/>
-        <a:lstStyle/>
-        <a:p>
-          <a:pPr rtl="0"/>
-          <a:endParaRPr lang="fr-FR" noProof="0" dirty="0"/>
-        </a:p>
-      </dgm:t>
-    </dgm:pt>
-    <dgm:pt modelId="{76CC3289-2662-43F0-A3C6-BA04A135F08C}">
-      <dgm:prSet phldrT="[Text]"/>
-      <dgm:spPr/>
-      <dgm:t>
-        <a:bodyPr rtlCol="0"/>
-        <a:lstStyle/>
-        <a:p>
-          <a:pPr rtl="0"/>
-          <a:r>
-            <a:rPr lang="fr-FR" noProof="0" dirty="0"/>
-            <a:t>Liaison</a:t>
-          </a:r>
-        </a:p>
-      </dgm:t>
-    </dgm:pt>
-    <dgm:pt modelId="{D46DB4DA-1442-4ECE-89FE-BBB1E3489E3D}" type="parTrans" cxnId="{0400886E-8A1A-44C2-95A7-DB0EF4911494}">
-      <dgm:prSet/>
-      <dgm:spPr/>
-      <dgm:t>
-        <a:bodyPr rtlCol="0"/>
-        <a:lstStyle/>
-        <a:p>
-          <a:pPr rtl="0"/>
-          <a:endParaRPr lang="fr-FR" noProof="0" dirty="0"/>
-        </a:p>
-      </dgm:t>
-    </dgm:pt>
-    <dgm:pt modelId="{FA28C9D6-476E-43CD-BA23-D6D990FD78D0}" type="sibTrans" cxnId="{0400886E-8A1A-44C2-95A7-DB0EF4911494}">
-      <dgm:prSet/>
-      <dgm:spPr/>
-      <dgm:t>
-        <a:bodyPr rtlCol="0"/>
-        <a:lstStyle/>
-        <a:p>
-          <a:pPr rtl="0"/>
-          <a:endParaRPr lang="fr-FR" noProof="0" dirty="0"/>
-        </a:p>
-      </dgm:t>
-    </dgm:pt>
-    <dgm:pt modelId="{8994D886-A75F-411A-A9D7-D31991FF12BD}" type="pres">
-      <dgm:prSet presAssocID="{7D9C16A6-8C48-4165-8DAF-8C957C12A8FA}" presName="root" presStyleCnt="0">
-        <dgm:presLayoutVars>
-          <dgm:dir/>
-          <dgm:resizeHandles val="exact"/>
-        </dgm:presLayoutVars>
-      </dgm:prSet>
-      <dgm:spPr/>
-    </dgm:pt>
-    <dgm:pt modelId="{E1DBA6D5-BD14-4CD2-A0CC-80F867FEFA81}" type="pres">
-      <dgm:prSet presAssocID="{701D68F5-42F8-47BC-8FED-84C50F595DF0}" presName="compNode" presStyleCnt="0"/>
-      <dgm:spPr/>
-    </dgm:pt>
-    <dgm:pt modelId="{19A8DC21-3E65-409D-AD53-DA51BB9198A0}" type="pres">
-      <dgm:prSet presAssocID="{701D68F5-42F8-47BC-8FED-84C50F595DF0}" presName="iconRect" presStyleLbl="node1" presStyleIdx="0" presStyleCnt="3" custScaleX="157625" custScaleY="157625"/>
-      <dgm:spPr>
-        <a:blipFill>
-          <a:blip xmlns:r="http://schemas.openxmlformats.org/officeDocument/2006/relationships" r:embed="rId1">
-            <a:extLst>
-              <a:ext uri="{96DAC541-7B7A-43D3-8B79-37D633B846F1}">
-                <asvg:svgBlip xmlns:asvg="http://schemas.microsoft.com/office/drawing/2016/SVG/main" r:embed="rId2"/>
-              </a:ext>
-            </a:extLst>
-          </a:blip>
-          <a:srcRect/>
-          <a:stretch>
-            <a:fillRect/>
-          </a:stretch>
-        </a:blipFill>
-        <a:ln>
-          <a:noFill/>
-        </a:ln>
-      </dgm:spPr>
-      <dgm:extLst>
-        <a:ext uri="{E40237B7-FDA0-4F09-8148-C483321AD2D9}">
-          <dgm14:cNvPr xmlns:dgm14="http://schemas.microsoft.com/office/drawing/2010/diagram" id="0" name="" descr="Network"/>
-        </a:ext>
-      </dgm:extLst>
-    </dgm:pt>
-    <dgm:pt modelId="{B9F90A48-FF94-4C94-A587-0190406F6FD3}" type="pres">
-      <dgm:prSet presAssocID="{701D68F5-42F8-47BC-8FED-84C50F595DF0}" presName="spaceRect" presStyleCnt="0"/>
-      <dgm:spPr/>
-    </dgm:pt>
-    <dgm:pt modelId="{A99B5DD6-89E9-4537-B415-4205CEB9323A}" type="pres">
-      <dgm:prSet presAssocID="{701D68F5-42F8-47BC-8FED-84C50F595DF0}" presName="textRect" presStyleLbl="revTx" presStyleIdx="0" presStyleCnt="3">
-        <dgm:presLayoutVars>
-          <dgm:chMax val="1"/>
-          <dgm:chPref val="1"/>
-        </dgm:presLayoutVars>
-      </dgm:prSet>
-      <dgm:spPr/>
-    </dgm:pt>
-    <dgm:pt modelId="{8B391436-B9B0-45BD-A57F-792D6376D868}" type="pres">
-      <dgm:prSet presAssocID="{0C95B389-AC0C-4055-9AA3-38815EFC8B0A}" presName="sibTrans" presStyleCnt="0"/>
-      <dgm:spPr/>
-    </dgm:pt>
-    <dgm:pt modelId="{95872155-C45D-46D3-874C-D838089A06F8}" type="pres">
-      <dgm:prSet presAssocID="{91A66877-AC1C-46D9-BF2C-6024B638DEA9}" presName="compNode" presStyleCnt="0"/>
-      <dgm:spPr/>
-    </dgm:pt>
-    <dgm:pt modelId="{CE9DF0E8-B0DE-4E1E-9FF4-6006AD8428DB}" type="pres">
-      <dgm:prSet presAssocID="{91A66877-AC1C-46D9-BF2C-6024B638DEA9}" presName="iconRect" presStyleLbl="node1" presStyleIdx="1" presStyleCnt="3" custScaleX="157625" custScaleY="157625"/>
-      <dgm:spPr>
-        <a:blipFill>
-          <a:blip xmlns:r="http://schemas.openxmlformats.org/officeDocument/2006/relationships" r:embed="rId3">
-            <a:extLst>
-              <a:ext uri="{28A0092B-C50C-407E-A947-70E740481C1C}">
-                <a14:useLocalDpi xmlns:a14="http://schemas.microsoft.com/office/drawing/2010/main" val="0"/>
-              </a:ext>
-              <a:ext uri="{96DAC541-7B7A-43D3-8B79-37D633B846F1}">
-                <asvg:svgBlip xmlns:asvg="http://schemas.microsoft.com/office/drawing/2016/SVG/main" r:embed="rId4"/>
-              </a:ext>
-            </a:extLst>
-          </a:blip>
-          <a:stretch>
-            <a:fillRect/>
-          </a:stretch>
-        </a:blipFill>
-        <a:ln>
-          <a:noFill/>
-        </a:ln>
-      </dgm:spPr>
-      <dgm:extLst>
-        <a:ext uri="{E40237B7-FDA0-4F09-8148-C483321AD2D9}">
-          <dgm14:cNvPr xmlns:dgm14="http://schemas.microsoft.com/office/drawing/2010/diagram" id="0" name="" descr="Satellite"/>
-        </a:ext>
-      </dgm:extLst>
-    </dgm:pt>
-    <dgm:pt modelId="{AA0423A1-55B2-45E9-BFE7-3FBE5BDA65ED}" type="pres">
-      <dgm:prSet presAssocID="{91A66877-AC1C-46D9-BF2C-6024B638DEA9}" presName="spaceRect" presStyleCnt="0"/>
-      <dgm:spPr/>
-    </dgm:pt>
-    <dgm:pt modelId="{55120873-6F5C-4053-8EAD-6287A7F1097E}" type="pres">
-      <dgm:prSet presAssocID="{91A66877-AC1C-46D9-BF2C-6024B638DEA9}" presName="textRect" presStyleLbl="revTx" presStyleIdx="1" presStyleCnt="3">
-        <dgm:presLayoutVars>
-          <dgm:chMax val="1"/>
-          <dgm:chPref val="1"/>
-        </dgm:presLayoutVars>
-      </dgm:prSet>
-      <dgm:spPr/>
-    </dgm:pt>
-    <dgm:pt modelId="{F679C986-30E4-4F0A-A3A6-CAE528BFED76}" type="pres">
-      <dgm:prSet presAssocID="{BFCE4A28-C381-46FF-935A-B11534EF7D87}" presName="sibTrans" presStyleCnt="0"/>
-      <dgm:spPr/>
-    </dgm:pt>
-    <dgm:pt modelId="{2EC2FDE3-8908-45C7-A3FD-EB370213FE69}" type="pres">
-      <dgm:prSet presAssocID="{76CC3289-2662-43F0-A3C6-BA04A135F08C}" presName="compNode" presStyleCnt="0"/>
-      <dgm:spPr/>
-    </dgm:pt>
-    <dgm:pt modelId="{6DB1FE51-13D0-4A38-AD6E-48D4371A1AF3}" type="pres">
-      <dgm:prSet presAssocID="{76CC3289-2662-43F0-A3C6-BA04A135F08C}" presName="iconRect" presStyleLbl="node1" presStyleIdx="2" presStyleCnt="3" custScaleX="157625" custScaleY="157625"/>
-      <dgm:spPr>
-        <a:blipFill>
-          <a:blip xmlns:r="http://schemas.openxmlformats.org/officeDocument/2006/relationships" r:embed="rId5">
-            <a:extLst>
-              <a:ext uri="{28A0092B-C50C-407E-A947-70E740481C1C}">
-                <a14:useLocalDpi xmlns:a14="http://schemas.microsoft.com/office/drawing/2010/main" val="0"/>
-              </a:ext>
-              <a:ext uri="{96DAC541-7B7A-43D3-8B79-37D633B846F1}">
-                <asvg:svgBlip xmlns:asvg="http://schemas.microsoft.com/office/drawing/2016/SVG/main" r:embed="rId6"/>
-              </a:ext>
-            </a:extLst>
-          </a:blip>
-          <a:srcRect/>
-          <a:stretch>
-            <a:fillRect/>
-          </a:stretch>
-        </a:blipFill>
-        <a:ln>
-          <a:noFill/>
-        </a:ln>
-      </dgm:spPr>
-      <dgm:extLst>
-        <a:ext uri="{E40237B7-FDA0-4F09-8148-C483321AD2D9}">
-          <dgm14:cNvPr xmlns:dgm14="http://schemas.microsoft.com/office/drawing/2010/diagram" id="0" name="" descr="Link"/>
-        </a:ext>
-      </dgm:extLst>
-    </dgm:pt>
-    <dgm:pt modelId="{0928538A-05CC-4A79-BD5D-92F985D1EEE5}" type="pres">
-      <dgm:prSet presAssocID="{76CC3289-2662-43F0-A3C6-BA04A135F08C}" presName="spaceRect" presStyleCnt="0"/>
-      <dgm:spPr/>
-    </dgm:pt>
-    <dgm:pt modelId="{133097FC-B1F8-4953-B0AB-E8E73D968D1C}" type="pres">
-      <dgm:prSet presAssocID="{76CC3289-2662-43F0-A3C6-BA04A135F08C}" presName="textRect" presStyleLbl="revTx" presStyleIdx="2" presStyleCnt="3">
-        <dgm:presLayoutVars>
-          <dgm:chMax val="1"/>
-          <dgm:chPref val="1"/>
-        </dgm:presLayoutVars>
-      </dgm:prSet>
-      <dgm:spPr/>
-    </dgm:pt>
-  </dgm:ptLst>
-  <dgm:cxnLst>
-    <dgm:cxn modelId="{1B8CB22C-9648-419B-97E9-4AA6C3555723}" type="presOf" srcId="{701D68F5-42F8-47BC-8FED-84C50F595DF0}" destId="{A99B5DD6-89E9-4537-B415-4205CEB9323A}" srcOrd="0" destOrd="0" presId="urn:microsoft.com/office/officeart/2018/2/layout/IconLabelList"/>
-    <dgm:cxn modelId="{C4BA385D-31ED-40EF-A5D6-98DFBA64E71A}" srcId="{7D9C16A6-8C48-4165-8DAF-8C957C12A8FA}" destId="{701D68F5-42F8-47BC-8FED-84C50F595DF0}" srcOrd="0" destOrd="0" parTransId="{9617668C-C38C-4017-8DDF-37855B15D110}" sibTransId="{0C95B389-AC0C-4055-9AA3-38815EFC8B0A}"/>
-    <dgm:cxn modelId="{5574CC64-4BF2-43BE-BABC-6DF1E58A4C74}" type="presOf" srcId="{7D9C16A6-8C48-4165-8DAF-8C957C12A8FA}" destId="{8994D886-A75F-411A-A9D7-D31991FF12BD}" srcOrd="0" destOrd="0" presId="urn:microsoft.com/office/officeart/2018/2/layout/IconLabelList"/>
-    <dgm:cxn modelId="{0400886E-8A1A-44C2-95A7-DB0EF4911494}" srcId="{7D9C16A6-8C48-4165-8DAF-8C957C12A8FA}" destId="{76CC3289-2662-43F0-A3C6-BA04A135F08C}" srcOrd="2" destOrd="0" parTransId="{D46DB4DA-1442-4ECE-89FE-BBB1E3489E3D}" sibTransId="{FA28C9D6-476E-43CD-BA23-D6D990FD78D0}"/>
-    <dgm:cxn modelId="{7F0DAB6F-9257-4F2D-B31A-3418F73F6952}" srcId="{7D9C16A6-8C48-4165-8DAF-8C957C12A8FA}" destId="{91A66877-AC1C-46D9-BF2C-6024B638DEA9}" srcOrd="1" destOrd="0" parTransId="{913FED05-DF41-48A7-B1F8-81937A468EF9}" sibTransId="{BFCE4A28-C381-46FF-935A-B11534EF7D87}"/>
-    <dgm:cxn modelId="{EC5C6E85-C523-4B60-976B-342F12E3A6CB}" type="presOf" srcId="{91A66877-AC1C-46D9-BF2C-6024B638DEA9}" destId="{55120873-6F5C-4053-8EAD-6287A7F1097E}" srcOrd="0" destOrd="0" presId="urn:microsoft.com/office/officeart/2018/2/layout/IconLabelList"/>
-    <dgm:cxn modelId="{6E31C6AB-C9E6-448F-A8CC-566A63619D4D}" type="presOf" srcId="{76CC3289-2662-43F0-A3C6-BA04A135F08C}" destId="{133097FC-B1F8-4953-B0AB-E8E73D968D1C}" srcOrd="0" destOrd="0" presId="urn:microsoft.com/office/officeart/2018/2/layout/IconLabelList"/>
-    <dgm:cxn modelId="{2AD6E781-3ED2-484E-B438-73386D2C583D}" type="presParOf" srcId="{8994D886-A75F-411A-A9D7-D31991FF12BD}" destId="{E1DBA6D5-BD14-4CD2-A0CC-80F867FEFA81}" srcOrd="0" destOrd="0" presId="urn:microsoft.com/office/officeart/2018/2/layout/IconLabelList"/>
-    <dgm:cxn modelId="{10B2B212-528C-471D-ABD0-D66ED992B833}" type="presParOf" srcId="{E1DBA6D5-BD14-4CD2-A0CC-80F867FEFA81}" destId="{19A8DC21-3E65-409D-AD53-DA51BB9198A0}" srcOrd="0" destOrd="0" presId="urn:microsoft.com/office/officeart/2018/2/layout/IconLabelList"/>
-    <dgm:cxn modelId="{2A8FB3D0-F98B-4F5A-BACA-4315E38776FB}" type="presParOf" srcId="{E1DBA6D5-BD14-4CD2-A0CC-80F867FEFA81}" destId="{B9F90A48-FF94-4C94-A587-0190406F6FD3}" srcOrd="1" destOrd="0" presId="urn:microsoft.com/office/officeart/2018/2/layout/IconLabelList"/>
-    <dgm:cxn modelId="{95FEF629-9884-451C-89B4-41B897ABE3D6}" type="presParOf" srcId="{E1DBA6D5-BD14-4CD2-A0CC-80F867FEFA81}" destId="{A99B5DD6-89E9-4537-B415-4205CEB9323A}" srcOrd="2" destOrd="0" presId="urn:microsoft.com/office/officeart/2018/2/layout/IconLabelList"/>
-    <dgm:cxn modelId="{0FE6827F-DE80-4F8A-8E9D-7F88C0F7EF29}" type="presParOf" srcId="{8994D886-A75F-411A-A9D7-D31991FF12BD}" destId="{8B391436-B9B0-45BD-A57F-792D6376D868}" srcOrd="1" destOrd="0" presId="urn:microsoft.com/office/officeart/2018/2/layout/IconLabelList"/>
-    <dgm:cxn modelId="{4857BE3A-D518-473D-AC79-7B9BF18B9824}" type="presParOf" srcId="{8994D886-A75F-411A-A9D7-D31991FF12BD}" destId="{95872155-C45D-46D3-874C-D838089A06F8}" srcOrd="2" destOrd="0" presId="urn:microsoft.com/office/officeart/2018/2/layout/IconLabelList"/>
-    <dgm:cxn modelId="{B4B325C4-81F2-4B3E-8CBF-4532B0BFA343}" type="presParOf" srcId="{95872155-C45D-46D3-874C-D838089A06F8}" destId="{CE9DF0E8-B0DE-4E1E-9FF4-6006AD8428DB}" srcOrd="0" destOrd="0" presId="urn:microsoft.com/office/officeart/2018/2/layout/IconLabelList"/>
-    <dgm:cxn modelId="{0AE6D335-6E55-47E1-BAD8-0368620AB8F6}" type="presParOf" srcId="{95872155-C45D-46D3-874C-D838089A06F8}" destId="{AA0423A1-55B2-45E9-BFE7-3FBE5BDA65ED}" srcOrd="1" destOrd="0" presId="urn:microsoft.com/office/officeart/2018/2/layout/IconLabelList"/>
-    <dgm:cxn modelId="{AFEE8CCD-97FE-4EFA-A584-DF6AFDAD2B20}" type="presParOf" srcId="{95872155-C45D-46D3-874C-D838089A06F8}" destId="{55120873-6F5C-4053-8EAD-6287A7F1097E}" srcOrd="2" destOrd="0" presId="urn:microsoft.com/office/officeart/2018/2/layout/IconLabelList"/>
-    <dgm:cxn modelId="{26649F18-C204-4047-8300-905486AB3755}" type="presParOf" srcId="{8994D886-A75F-411A-A9D7-D31991FF12BD}" destId="{F679C986-30E4-4F0A-A3A6-CAE528BFED76}" srcOrd="3" destOrd="0" presId="urn:microsoft.com/office/officeart/2018/2/layout/IconLabelList"/>
-    <dgm:cxn modelId="{898D629F-DA37-435F-A0B2-0617605D711A}" type="presParOf" srcId="{8994D886-A75F-411A-A9D7-D31991FF12BD}" destId="{2EC2FDE3-8908-45C7-A3FD-EB370213FE69}" srcOrd="4" destOrd="0" presId="urn:microsoft.com/office/officeart/2018/2/layout/IconLabelList"/>
-    <dgm:cxn modelId="{2BDADB1C-15B1-4763-9B35-3792147F8F87}" type="presParOf" srcId="{2EC2FDE3-8908-45C7-A3FD-EB370213FE69}" destId="{6DB1FE51-13D0-4A38-AD6E-48D4371A1AF3}" srcOrd="0" destOrd="0" presId="urn:microsoft.com/office/officeart/2018/2/layout/IconLabelList"/>
-    <dgm:cxn modelId="{F692F1E6-C6EC-4391-8432-EB6C34194240}" type="presParOf" srcId="{2EC2FDE3-8908-45C7-A3FD-EB370213FE69}" destId="{0928538A-05CC-4A79-BD5D-92F985D1EEE5}" srcOrd="1" destOrd="0" presId="urn:microsoft.com/office/officeart/2018/2/layout/IconLabelList"/>
-    <dgm:cxn modelId="{0E6AF6C4-A4E5-4234-9E16-F9F2334264CD}" type="presParOf" srcId="{2EC2FDE3-8908-45C7-A3FD-EB370213FE69}" destId="{133097FC-B1F8-4953-B0AB-E8E73D968D1C}" srcOrd="2" destOrd="0" presId="urn:microsoft.com/office/officeart/2018/2/layout/IconLabelList"/>
-  </dgm:cxnLst>
-  <dgm:bg/>
-  <dgm:whole/>
-  <dgm:extLst>
-    <a:ext uri="http://schemas.microsoft.com/office/drawing/2008/diagram">
-      <dsp:dataModelExt xmlns:dsp="http://schemas.microsoft.com/office/drawing/2008/diagram" relId="rId7" minVer="http://schemas.openxmlformats.org/drawingml/2006/diagram"/>
-    </a:ext>
-    <a:ext uri="{C62137D5-CB1D-491B-B009-E17868A290BF}">
-      <dgm14:recolorImg xmlns:dgm14="http://schemas.microsoft.com/office/drawing/2010/diagram" val="1"/>
-    </a:ext>
-  </dgm:extLst>
-</dgm:dataModel>
-</file>
-
-<file path=ppt/diagrams/data2.xml><?xml version="1.0" encoding="utf-8"?>
-<dgm:dataModel xmlns:dgm="http://schemas.openxmlformats.org/drawingml/2006/diagram" xmlns:a="http://schemas.openxmlformats.org/drawingml/2006/main">
-  <dgm:ptLst>
     <dgm:pt modelId="{7E5AA53B-3EEE-4DE4-BB81-9044890C2946}" type="doc">
       <dgm:prSet loTypeId="urn:microsoft.com/office/officeart/2008/layout/VerticalCurvedList" loCatId="list" qsTypeId="urn:microsoft.com/office/officeart/2005/8/quickstyle/simple4" qsCatId="simple" csTypeId="urn:microsoft.com/office/officeart/2005/8/colors/accent2_2" csCatId="accent2" phldr="1"/>
       <dgm:spPr/>
@@ -2202,344 +1143,6 @@
 </file>
 
 <file path=ppt/diagrams/drawing1.xml><?xml version="1.0" encoding="utf-8"?>
-<dsp:drawing xmlns:dgm="http://schemas.openxmlformats.org/drawingml/2006/diagram" xmlns:dsp="http://schemas.microsoft.com/office/drawing/2008/diagram" xmlns:a="http://schemas.openxmlformats.org/drawingml/2006/main">
-  <dsp:spTree>
-    <dsp:nvGrpSpPr>
-      <dsp:cNvPr id="0" name=""/>
-      <dsp:cNvGrpSpPr/>
-    </dsp:nvGrpSpPr>
-    <dsp:grpSpPr/>
-    <dsp:sp modelId="{19A8DC21-3E65-409D-AD53-DA51BB9198A0}">
-      <dsp:nvSpPr>
-        <dsp:cNvPr id="0" name=""/>
-        <dsp:cNvSpPr/>
-      </dsp:nvSpPr>
-      <dsp:spPr>
-        <a:xfrm>
-          <a:off x="523237" y="494935"/>
-          <a:ext cx="2285995" cy="2285995"/>
-        </a:xfrm>
-        <a:prstGeom prst="rect">
-          <a:avLst/>
-        </a:prstGeom>
-        <a:blipFill>
-          <a:blip xmlns:r="http://schemas.openxmlformats.org/officeDocument/2006/relationships" r:embed="rId1">
-            <a:extLst>
-              <a:ext uri="{96DAC541-7B7A-43D3-8B79-37D633B846F1}">
-                <asvg:svgBlip xmlns:asvg="http://schemas.microsoft.com/office/drawing/2016/SVG/main" r:embed="rId2"/>
-              </a:ext>
-            </a:extLst>
-          </a:blip>
-          <a:srcRect/>
-          <a:stretch>
-            <a:fillRect/>
-          </a:stretch>
-        </a:blipFill>
-        <a:ln w="22225" cap="rnd" cmpd="sng" algn="ctr">
-          <a:noFill/>
-          <a:prstDash val="solid"/>
-        </a:ln>
-        <a:effectLst/>
-      </dsp:spPr>
-      <dsp:style>
-        <a:lnRef idx="2">
-          <a:scrgbClr r="0" g="0" b="0"/>
-        </a:lnRef>
-        <a:fillRef idx="1">
-          <a:scrgbClr r="0" g="0" b="0"/>
-        </a:fillRef>
-        <a:effectRef idx="0">
-          <a:scrgbClr r="0" g="0" b="0"/>
-        </a:effectRef>
-        <a:fontRef idx="minor">
-          <a:schemeClr val="lt1"/>
-        </a:fontRef>
-      </dsp:style>
-    </dsp:sp>
-    <dsp:sp modelId="{A99B5DD6-89E9-4537-B415-4205CEB9323A}">
-      <dsp:nvSpPr>
-        <dsp:cNvPr id="0" name=""/>
-        <dsp:cNvSpPr/>
-      </dsp:nvSpPr>
-      <dsp:spPr>
-        <a:xfrm>
-          <a:off x="54818" y="2746269"/>
-          <a:ext cx="3222832" cy="720000"/>
-        </a:xfrm>
-        <a:prstGeom prst="rect">
-          <a:avLst/>
-        </a:prstGeom>
-        <a:noFill/>
-        <a:ln>
-          <a:noFill/>
-        </a:ln>
-        <a:effectLst/>
-      </dsp:spPr>
-      <dsp:style>
-        <a:lnRef idx="0">
-          <a:scrgbClr r="0" g="0" b="0"/>
-        </a:lnRef>
-        <a:fillRef idx="0">
-          <a:scrgbClr r="0" g="0" b="0"/>
-        </a:fillRef>
-        <a:effectRef idx="0">
-          <a:scrgbClr r="0" g="0" b="0"/>
-        </a:effectRef>
-        <a:fontRef idx="minor"/>
-      </dsp:style>
-      <dsp:txBody>
-        <a:bodyPr spcFirstLastPara="0" vert="horz" wrap="square" lIns="0" tIns="0" rIns="0" bIns="0" numCol="1" spcCol="1270" rtlCol="0" anchor="t" anchorCtr="0">
-          <a:noAutofit/>
-        </a:bodyPr>
-        <a:lstStyle/>
-        <a:p>
-          <a:pPr marL="0" lvl="0" indent="0" algn="ctr" defTabSz="1600200" rtl="0">
-            <a:lnSpc>
-              <a:spcPct val="90000"/>
-            </a:lnSpc>
-            <a:spcBef>
-              <a:spcPct val="0"/>
-            </a:spcBef>
-            <a:spcAft>
-              <a:spcPct val="35000"/>
-            </a:spcAft>
-            <a:buNone/>
-          </a:pPr>
-          <a:r>
-            <a:rPr lang="fr-FR" sz="3600" kern="1200" noProof="0" dirty="0"/>
-            <a:t>Réseau</a:t>
-          </a:r>
-        </a:p>
-      </dsp:txBody>
-      <dsp:txXfrm>
-        <a:off x="54818" y="2746269"/>
-        <a:ext cx="3222832" cy="720000"/>
-      </dsp:txXfrm>
-    </dsp:sp>
-    <dsp:sp modelId="{CE9DF0E8-B0DE-4E1E-9FF4-6006AD8428DB}">
-      <dsp:nvSpPr>
-        <dsp:cNvPr id="0" name=""/>
-        <dsp:cNvSpPr/>
-      </dsp:nvSpPr>
-      <dsp:spPr>
-        <a:xfrm>
-          <a:off x="4310064" y="494935"/>
-          <a:ext cx="2285995" cy="2285995"/>
-        </a:xfrm>
-        <a:prstGeom prst="rect">
-          <a:avLst/>
-        </a:prstGeom>
-        <a:blipFill>
-          <a:blip xmlns:r="http://schemas.openxmlformats.org/officeDocument/2006/relationships" r:embed="rId3">
-            <a:extLst>
-              <a:ext uri="{28A0092B-C50C-407E-A947-70E740481C1C}">
-                <a14:useLocalDpi xmlns:a14="http://schemas.microsoft.com/office/drawing/2010/main" val="0"/>
-              </a:ext>
-              <a:ext uri="{96DAC541-7B7A-43D3-8B79-37D633B846F1}">
-                <asvg:svgBlip xmlns:asvg="http://schemas.microsoft.com/office/drawing/2016/SVG/main" r:embed="rId4"/>
-              </a:ext>
-            </a:extLst>
-          </a:blip>
-          <a:stretch>
-            <a:fillRect/>
-          </a:stretch>
-        </a:blipFill>
-        <a:ln w="22225" cap="rnd" cmpd="sng" algn="ctr">
-          <a:noFill/>
-          <a:prstDash val="solid"/>
-        </a:ln>
-        <a:effectLst/>
-      </dsp:spPr>
-      <dsp:style>
-        <a:lnRef idx="2">
-          <a:scrgbClr r="0" g="0" b="0"/>
-        </a:lnRef>
-        <a:fillRef idx="1">
-          <a:scrgbClr r="0" g="0" b="0"/>
-        </a:fillRef>
-        <a:effectRef idx="0">
-          <a:scrgbClr r="0" g="0" b="0"/>
-        </a:effectRef>
-        <a:fontRef idx="minor">
-          <a:schemeClr val="lt1"/>
-        </a:fontRef>
-      </dsp:style>
-    </dsp:sp>
-    <dsp:sp modelId="{55120873-6F5C-4053-8EAD-6287A7F1097E}">
-      <dsp:nvSpPr>
-        <dsp:cNvPr id="0" name=""/>
-        <dsp:cNvSpPr/>
-      </dsp:nvSpPr>
-      <dsp:spPr>
-        <a:xfrm>
-          <a:off x="3841646" y="2746269"/>
-          <a:ext cx="3222832" cy="720000"/>
-        </a:xfrm>
-        <a:prstGeom prst="rect">
-          <a:avLst/>
-        </a:prstGeom>
-        <a:noFill/>
-        <a:ln>
-          <a:noFill/>
-        </a:ln>
-        <a:effectLst/>
-      </dsp:spPr>
-      <dsp:style>
-        <a:lnRef idx="0">
-          <a:scrgbClr r="0" g="0" b="0"/>
-        </a:lnRef>
-        <a:fillRef idx="0">
-          <a:scrgbClr r="0" g="0" b="0"/>
-        </a:fillRef>
-        <a:effectRef idx="0">
-          <a:scrgbClr r="0" g="0" b="0"/>
-        </a:effectRef>
-        <a:fontRef idx="minor"/>
-      </dsp:style>
-      <dsp:txBody>
-        <a:bodyPr spcFirstLastPara="0" vert="horz" wrap="square" lIns="0" tIns="0" rIns="0" bIns="0" numCol="1" spcCol="1270" rtlCol="0" anchor="t" anchorCtr="0">
-          <a:noAutofit/>
-        </a:bodyPr>
-        <a:lstStyle/>
-        <a:p>
-          <a:pPr marL="0" lvl="0" indent="0" algn="ctr" defTabSz="1600200" rtl="0">
-            <a:lnSpc>
-              <a:spcPct val="90000"/>
-            </a:lnSpc>
-            <a:spcBef>
-              <a:spcPct val="0"/>
-            </a:spcBef>
-            <a:spcAft>
-              <a:spcPct val="35000"/>
-            </a:spcAft>
-            <a:buNone/>
-          </a:pPr>
-          <a:r>
-            <a:rPr lang="fr-FR" sz="3600" kern="1200" noProof="0" dirty="0"/>
-            <a:t>Satellite</a:t>
-          </a:r>
-        </a:p>
-      </dsp:txBody>
-      <dsp:txXfrm>
-        <a:off x="3841646" y="2746269"/>
-        <a:ext cx="3222832" cy="720000"/>
-      </dsp:txXfrm>
-    </dsp:sp>
-    <dsp:sp modelId="{6DB1FE51-13D0-4A38-AD6E-48D4371A1AF3}">
-      <dsp:nvSpPr>
-        <dsp:cNvPr id="0" name=""/>
-        <dsp:cNvSpPr/>
-      </dsp:nvSpPr>
-      <dsp:spPr>
-        <a:xfrm>
-          <a:off x="8096892" y="494935"/>
-          <a:ext cx="2285995" cy="2285995"/>
-        </a:xfrm>
-        <a:prstGeom prst="rect">
-          <a:avLst/>
-        </a:prstGeom>
-        <a:blipFill>
-          <a:blip xmlns:r="http://schemas.openxmlformats.org/officeDocument/2006/relationships" r:embed="rId5">
-            <a:extLst>
-              <a:ext uri="{28A0092B-C50C-407E-A947-70E740481C1C}">
-                <a14:useLocalDpi xmlns:a14="http://schemas.microsoft.com/office/drawing/2010/main" val="0"/>
-              </a:ext>
-              <a:ext uri="{96DAC541-7B7A-43D3-8B79-37D633B846F1}">
-                <asvg:svgBlip xmlns:asvg="http://schemas.microsoft.com/office/drawing/2016/SVG/main" r:embed="rId6"/>
-              </a:ext>
-            </a:extLst>
-          </a:blip>
-          <a:srcRect/>
-          <a:stretch>
-            <a:fillRect/>
-          </a:stretch>
-        </a:blipFill>
-        <a:ln w="22225" cap="rnd" cmpd="sng" algn="ctr">
-          <a:noFill/>
-          <a:prstDash val="solid"/>
-        </a:ln>
-        <a:effectLst/>
-      </dsp:spPr>
-      <dsp:style>
-        <a:lnRef idx="2">
-          <a:scrgbClr r="0" g="0" b="0"/>
-        </a:lnRef>
-        <a:fillRef idx="1">
-          <a:scrgbClr r="0" g="0" b="0"/>
-        </a:fillRef>
-        <a:effectRef idx="0">
-          <a:scrgbClr r="0" g="0" b="0"/>
-        </a:effectRef>
-        <a:fontRef idx="minor">
-          <a:schemeClr val="lt1"/>
-        </a:fontRef>
-      </dsp:style>
-    </dsp:sp>
-    <dsp:sp modelId="{133097FC-B1F8-4953-B0AB-E8E73D968D1C}">
-      <dsp:nvSpPr>
-        <dsp:cNvPr id="0" name=""/>
-        <dsp:cNvSpPr/>
-      </dsp:nvSpPr>
-      <dsp:spPr>
-        <a:xfrm>
-          <a:off x="7628474" y="2746269"/>
-          <a:ext cx="3222832" cy="720000"/>
-        </a:xfrm>
-        <a:prstGeom prst="rect">
-          <a:avLst/>
-        </a:prstGeom>
-        <a:noFill/>
-        <a:ln>
-          <a:noFill/>
-        </a:ln>
-        <a:effectLst/>
-      </dsp:spPr>
-      <dsp:style>
-        <a:lnRef idx="0">
-          <a:scrgbClr r="0" g="0" b="0"/>
-        </a:lnRef>
-        <a:fillRef idx="0">
-          <a:scrgbClr r="0" g="0" b="0"/>
-        </a:fillRef>
-        <a:effectRef idx="0">
-          <a:scrgbClr r="0" g="0" b="0"/>
-        </a:effectRef>
-        <a:fontRef idx="minor"/>
-      </dsp:style>
-      <dsp:txBody>
-        <a:bodyPr spcFirstLastPara="0" vert="horz" wrap="square" lIns="0" tIns="0" rIns="0" bIns="0" numCol="1" spcCol="1270" rtlCol="0" anchor="t" anchorCtr="0">
-          <a:noAutofit/>
-        </a:bodyPr>
-        <a:lstStyle/>
-        <a:p>
-          <a:pPr marL="0" lvl="0" indent="0" algn="ctr" defTabSz="1600200" rtl="0">
-            <a:lnSpc>
-              <a:spcPct val="90000"/>
-            </a:lnSpc>
-            <a:spcBef>
-              <a:spcPct val="0"/>
-            </a:spcBef>
-            <a:spcAft>
-              <a:spcPct val="35000"/>
-            </a:spcAft>
-            <a:buNone/>
-          </a:pPr>
-          <a:r>
-            <a:rPr lang="fr-FR" sz="3600" kern="1200" noProof="0" dirty="0"/>
-            <a:t>Liaison</a:t>
-          </a:r>
-        </a:p>
-      </dsp:txBody>
-      <dsp:txXfrm>
-        <a:off x="7628474" y="2746269"/>
-        <a:ext cx="3222832" cy="720000"/>
-      </dsp:txXfrm>
-    </dsp:sp>
-  </dsp:spTree>
-</dsp:drawing>
-</file>
-
-<file path=ppt/diagrams/drawing2.xml><?xml version="1.0" encoding="utf-8"?>
 <dsp:drawing xmlns:dgm="http://schemas.openxmlformats.org/drawingml/2006/diagram" xmlns:dsp="http://schemas.microsoft.com/office/drawing/2008/diagram" xmlns:a="http://schemas.openxmlformats.org/drawingml/2006/main">
   <dsp:spTree>
     <dsp:nvGrpSpPr>
@@ -3014,196 +1617,6 @@
 </file>
 
 <file path=ppt/diagrams/layout1.xml><?xml version="1.0" encoding="utf-8"?>
-<dgm:layoutDef xmlns:dgm="http://schemas.openxmlformats.org/drawingml/2006/diagram" xmlns:a="http://schemas.openxmlformats.org/drawingml/2006/main" uniqueId="urn:microsoft.com/office/officeart/2018/2/layout/IconLabelList">
-  <dgm:title val="Liste d’étiquettes d’icônes"/>
-  <dgm:desc val="Permet de représenter des blocs d’informations non séquentiels ou groupés accompagnés d’éléments visuels associés. Fonctionne de manière optimale avec des icônes ou de petites images avec de courtes légendes de texte."/>
-  <dgm:catLst>
-    <dgm:cat type="icon" pri="500"/>
-  </dgm:catLst>
-  <dgm:sampData useDef="1">
-    <dgm:dataModel>
-      <dgm:ptLst/>
-      <dgm:bg/>
-      <dgm:whole/>
-    </dgm:dataModel>
-  </dgm:sampData>
-  <dgm:styleData useDef="1">
-    <dgm:dataModel>
-      <dgm:ptLst/>
-      <dgm:bg/>
-      <dgm:whole/>
-    </dgm:dataModel>
-  </dgm:styleData>
-  <dgm:clrData useDef="1">
-    <dgm:dataModel>
-      <dgm:ptLst/>
-      <dgm:bg/>
-      <dgm:whole/>
-    </dgm:dataModel>
-  </dgm:clrData>
-  <dgm:layoutNode name="root">
-    <dgm:varLst>
-      <dgm:dir/>
-      <dgm:resizeHandles val="exact"/>
-    </dgm:varLst>
-    <dgm:choose name="Name0">
-      <dgm:if name="Name1" axis="self" func="var" arg="dir" op="equ" val="norm">
-        <dgm:alg type="snake">
-          <dgm:param type="grDir" val="tL"/>
-          <dgm:param type="flowDir" val="row"/>
-          <dgm:param type="contDir" val="sameDir"/>
-          <dgm:param type="off" val="ctr"/>
-          <dgm:param type="vertAlign" val="mid"/>
-          <dgm:param type="horzAlign" val="ctr"/>
-        </dgm:alg>
-      </dgm:if>
-      <dgm:else name="Name2">
-        <dgm:alg type="snake">
-          <dgm:param type="grDir" val="tR"/>
-          <dgm:param type="flowDir" val="row"/>
-          <dgm:param type="contDir" val="sameDir"/>
-          <dgm:param type="off" val="ctr"/>
-          <dgm:param type="vertAlign" val="mid"/>
-          <dgm:param type="horzAlign" val="ctr"/>
-        </dgm:alg>
-      </dgm:else>
-    </dgm:choose>
-    <dgm:shape xmlns:r="http://schemas.openxmlformats.org/officeDocument/2006/relationships" r:blip="">
-      <dgm:adjLst/>
-    </dgm:shape>
-    <dgm:presOf/>
-    <dgm:choose name="Name3">
-      <dgm:if name="Name4" axis="ch" ptType="node" func="cnt" op="lte" val="2">
-        <dgm:constrLst>
-          <dgm:constr type="h" for="ch" forName="compNode" refType="h" fact="0.4"/>
-          <dgm:constr type="w" for="ch" forName="compNode" val="120"/>
-          <dgm:constr type="w" for="ch" forName="sibTrans" refType="w" refFor="ch" refForName="compNode" fact="0.175"/>
-          <dgm:constr type="sp" refType="w" refFor="ch" refForName="compNode" op="equ" fact="0.25"/>
-          <dgm:constr type="primFontSz" for="des" ptType="node" op="equ" val="50"/>
-          <dgm:constr type="h" for="des" forName="compNode" op="equ"/>
-          <dgm:constr type="h" for="des" forName="textRect" op="equ"/>
-        </dgm:constrLst>
-      </dgm:if>
-      <dgm:if name="Name5" axis="ch" ptType="node" func="cnt" op="lte" val="4">
-        <dgm:constrLst>
-          <dgm:constr type="h" for="ch" forName="compNode" refType="h" fact="0.4"/>
-          <dgm:constr type="w" for="ch" forName="compNode" refType="w"/>
-          <dgm:constr type="w" for="ch" forName="sibTrans" refType="w" refFor="ch" refForName="compNode" fact="0.175"/>
-          <dgm:constr type="sp" refType="w" refFor="ch" refForName="compNode" op="equ" fact="0.25"/>
-          <dgm:constr type="primFontSz" for="des" ptType="node" op="equ" val="36"/>
-          <dgm:constr type="h" for="des" forName="compNode" op="equ"/>
-          <dgm:constr type="h" for="des" forName="textRect" op="equ"/>
-        </dgm:constrLst>
-      </dgm:if>
-      <dgm:else name="Name6">
-        <dgm:constrLst>
-          <dgm:constr type="h" for="ch" forName="compNode" refType="h" fact="0.4"/>
-          <dgm:constr type="w" for="ch" forName="compNode" refType="w"/>
-          <dgm:constr type="w" for="ch" forName="sibTrans" refType="w" refFor="ch" refForName="compNode" fact="0.175"/>
-          <dgm:constr type="sp" refType="w" refFor="ch" refForName="compNode" op="equ" fact="0.25"/>
-          <dgm:constr type="primFontSz" for="des" ptType="node" op="equ" val="24"/>
-          <dgm:constr type="h" for="des" forName="compNode" op="equ"/>
-          <dgm:constr type="h" for="des" forName="textRect" op="equ"/>
-        </dgm:constrLst>
-      </dgm:else>
-    </dgm:choose>
-    <dgm:ruleLst>
-      <dgm:rule type="w" for="ch" forName="compNode" val="50" fact="NaN" max="NaN"/>
-    </dgm:ruleLst>
-    <dgm:forEach name="Name7" axis="ch" ptType="node">
-      <dgm:layoutNode name="compNode">
-        <dgm:alg type="composite"/>
-        <dgm:shape xmlns:r="http://schemas.openxmlformats.org/officeDocument/2006/relationships" r:blip="">
-          <dgm:adjLst/>
-        </dgm:shape>
-        <dgm:presOf axis="self"/>
-        <dgm:constrLst>
-          <dgm:constr type="w" for="ch" forName="iconRect" refType="w" fact="0.45"/>
-          <dgm:constr type="h" for="ch" forName="iconRect" refType="w" refFor="ch" refForName="iconRect"/>
-          <dgm:constr type="ctrX" for="ch" forName="iconRect" refType="w" fact="0.5"/>
-          <dgm:constr type="t" for="ch" forName="iconRect"/>
-          <dgm:constr type="h" for="ch" forName="spaceRect" refType="h" fact="0.15"/>
-          <dgm:constr type="w" for="ch" forName="spaceRect" refType="w"/>
-          <dgm:constr type="l" for="ch" forName="spaceRect"/>
-          <dgm:constr type="t" for="ch" forName="spaceRect" refType="b" refFor="ch" refForName="iconRect"/>
-          <dgm:constr type="h" for="ch" forName="textRect" val="20"/>
-          <dgm:constr type="w" for="ch" forName="textRect" refType="w"/>
-          <dgm:constr type="l" for="ch" forName="textRect"/>
-          <dgm:constr type="t" for="ch" forName="textRect" refType="b" refFor="ch" refForName="spaceRect"/>
-        </dgm:constrLst>
-        <dgm:ruleLst>
-          <dgm:rule type="h" val="INF" fact="NaN" max="NaN"/>
-        </dgm:ruleLst>
-        <dgm:layoutNode name="iconRect" styleLbl="node1">
-          <dgm:alg type="sp"/>
-          <dgm:shape xmlns:r="http://schemas.openxmlformats.org/officeDocument/2006/relationships" type="rect" r:blip="" blipPhldr="1">
-            <dgm:adjLst/>
-          </dgm:shape>
-          <dgm:presOf/>
-          <dgm:constrLst/>
-          <dgm:ruleLst/>
-        </dgm:layoutNode>
-        <dgm:layoutNode name="spaceRect">
-          <dgm:alg type="sp"/>
-          <dgm:shape xmlns:r="http://schemas.openxmlformats.org/officeDocument/2006/relationships" r:blip="">
-            <dgm:adjLst/>
-          </dgm:shape>
-          <dgm:presOf/>
-          <dgm:constrLst/>
-          <dgm:ruleLst/>
-        </dgm:layoutNode>
-        <dgm:layoutNode name="textRect" styleLbl="revTx">
-          <dgm:varLst>
-            <dgm:chMax val="1"/>
-            <dgm:chPref val="1"/>
-          </dgm:varLst>
-          <dgm:alg type="tx">
-            <dgm:param type="txAnchorVert" val="t"/>
-          </dgm:alg>
-          <dgm:shape xmlns:r="http://schemas.openxmlformats.org/officeDocument/2006/relationships" type="rect" r:blip="">
-            <dgm:adjLst/>
-          </dgm:shape>
-          <dgm:presOf axis="self" ptType="node"/>
-          <dgm:constrLst>
-            <dgm:constr type="lMarg"/>
-            <dgm:constr type="rMarg"/>
-            <dgm:constr type="tMarg"/>
-            <dgm:constr type="bMarg"/>
-          </dgm:constrLst>
-          <dgm:ruleLst>
-            <dgm:rule type="primFontSz" val="11" fact="NaN" max="NaN"/>
-            <dgm:rule type="h" val="INF" fact="NaN" max="NaN"/>
-          </dgm:ruleLst>
-        </dgm:layoutNode>
-      </dgm:layoutNode>
-      <dgm:forEach name="Name8" axis="followSib" ptType="sibTrans" cnt="1">
-        <dgm:layoutNode name="sibTrans">
-          <dgm:alg type="sp"/>
-          <dgm:shape xmlns:r="http://schemas.openxmlformats.org/officeDocument/2006/relationships" r:blip="">
-            <dgm:adjLst/>
-          </dgm:shape>
-          <dgm:presOf axis="self"/>
-          <dgm:constrLst/>
-          <dgm:ruleLst/>
-        </dgm:layoutNode>
-      </dgm:forEach>
-    </dgm:forEach>
-  </dgm:layoutNode>
-  <dgm:extLst>
-    <a:ext uri="{68A01E43-0DF5-4B5B-8FA6-DAF915123BFB}">
-      <dgm1612:lstStyle xmlns:dgm1612="http://schemas.microsoft.com/office/drawing/2016/12/diagram">
-        <a:lvl1pPr>
-          <a:lnSpc>
-            <a:spcPct val="100000"/>
-          </a:lnSpc>
-        </a:lvl1pPr>
-      </dgm1612:lstStyle>
-    </a:ext>
-  </dgm:extLst>
-</dgm:layoutDef>
-</file>
-
-<file path=ppt/diagrams/layout2.xml><?xml version="1.0" encoding="utf-8"?>
 <dgm:layoutDef xmlns:dgm="http://schemas.openxmlformats.org/drawingml/2006/diagram" xmlns:a="http://schemas.openxmlformats.org/drawingml/2006/main" uniqueId="urn:microsoft.com/office/officeart/2008/layout/VerticalCurvedList">
   <dgm:title val=""/>
   <dgm:desc val=""/>
@@ -4482,1040 +2895,6 @@
 </file>
 
 <file path=ppt/diagrams/quickStyle1.xml><?xml version="1.0" encoding="utf-8"?>
-<dgm:styleDef xmlns:dgm="http://schemas.openxmlformats.org/drawingml/2006/diagram" xmlns:a="http://schemas.openxmlformats.org/drawingml/2006/main" uniqueId="urn:microsoft.com/office/officeart/2005/8/quickstyle/simple1">
-  <dgm:title val=""/>
-  <dgm:desc val=""/>
-  <dgm:catLst>
-    <dgm:cat type="simple" pri="10100"/>
-  </dgm:catLst>
-  <dgm:scene3d>
-    <a:camera prst="orthographicFront"/>
-    <a:lightRig rig="threePt" dir="t"/>
-  </dgm:scene3d>
-  <dgm:styleLbl name="node0">
-    <dgm:scene3d>
-      <a:camera prst="orthographicFront"/>
-      <a:lightRig rig="threePt" dir="t"/>
-    </dgm:scene3d>
-    <dgm:sp3d/>
-    <dgm:txPr/>
-    <dgm:style>
-      <a:lnRef idx="2">
-        <a:scrgbClr r="0" g="0" b="0"/>
-      </a:lnRef>
-      <a:fillRef idx="1">
-        <a:scrgbClr r="0" g="0" b="0"/>
-      </a:fillRef>
-      <a:effectRef idx="0">
-        <a:scrgbClr r="0" g="0" b="0"/>
-      </a:effectRef>
-      <a:fontRef idx="minor">
-        <a:schemeClr val="lt1"/>
-      </a:fontRef>
-    </dgm:style>
-  </dgm:styleLbl>
-  <dgm:styleLbl name="lnNode1">
-    <dgm:scene3d>
-      <a:camera prst="orthographicFront"/>
-      <a:lightRig rig="threePt" dir="t"/>
-    </dgm:scene3d>
-    <dgm:sp3d/>
-    <dgm:txPr/>
-    <dgm:style>
-      <a:lnRef idx="2">
-        <a:scrgbClr r="0" g="0" b="0"/>
-      </a:lnRef>
-      <a:fillRef idx="1">
-        <a:scrgbClr r="0" g="0" b="0"/>
-      </a:fillRef>
-      <a:effectRef idx="0">
-        <a:scrgbClr r="0" g="0" b="0"/>
-      </a:effectRef>
-      <a:fontRef idx="minor">
-        <a:schemeClr val="lt1"/>
-      </a:fontRef>
-    </dgm:style>
-  </dgm:styleLbl>
-  <dgm:styleLbl name="vennNode1">
-    <dgm:scene3d>
-      <a:camera prst="orthographicFront"/>
-      <a:lightRig rig="threePt" dir="t"/>
-    </dgm:scene3d>
-    <dgm:sp3d/>
-    <dgm:txPr/>
-    <dgm:style>
-      <a:lnRef idx="2">
-        <a:scrgbClr r="0" g="0" b="0"/>
-      </a:lnRef>
-      <a:fillRef idx="1">
-        <a:scrgbClr r="0" g="0" b="0"/>
-      </a:fillRef>
-      <a:effectRef idx="0">
-        <a:scrgbClr r="0" g="0" b="0"/>
-      </a:effectRef>
-      <a:fontRef idx="minor">
-        <a:schemeClr val="tx1"/>
-      </a:fontRef>
-    </dgm:style>
-  </dgm:styleLbl>
-  <dgm:styleLbl name="alignNode1">
-    <dgm:scene3d>
-      <a:camera prst="orthographicFront"/>
-      <a:lightRig rig="threePt" dir="t"/>
-    </dgm:scene3d>
-    <dgm:sp3d/>
-    <dgm:txPr/>
-    <dgm:style>
-      <a:lnRef idx="2">
-        <a:scrgbClr r="0" g="0" b="0"/>
-      </a:lnRef>
-      <a:fillRef idx="1">
-        <a:scrgbClr r="0" g="0" b="0"/>
-      </a:fillRef>
-      <a:effectRef idx="0">
-        <a:scrgbClr r="0" g="0" b="0"/>
-      </a:effectRef>
-      <a:fontRef idx="minor">
-        <a:schemeClr val="lt1"/>
-      </a:fontRef>
-    </dgm:style>
-  </dgm:styleLbl>
-  <dgm:styleLbl name="node1">
-    <dgm:scene3d>
-      <a:camera prst="orthographicFront"/>
-      <a:lightRig rig="threePt" dir="t"/>
-    </dgm:scene3d>
-    <dgm:sp3d/>
-    <dgm:txPr/>
-    <dgm:style>
-      <a:lnRef idx="2">
-        <a:scrgbClr r="0" g="0" b="0"/>
-      </a:lnRef>
-      <a:fillRef idx="1">
-        <a:scrgbClr r="0" g="0" b="0"/>
-      </a:fillRef>
-      <a:effectRef idx="0">
-        <a:scrgbClr r="0" g="0" b="0"/>
-      </a:effectRef>
-      <a:fontRef idx="minor">
-        <a:schemeClr val="lt1"/>
-      </a:fontRef>
-    </dgm:style>
-  </dgm:styleLbl>
-  <dgm:styleLbl name="node2">
-    <dgm:scene3d>
-      <a:camera prst="orthographicFront"/>
-      <a:lightRig rig="threePt" dir="t"/>
-    </dgm:scene3d>
-    <dgm:sp3d/>
-    <dgm:txPr/>
-    <dgm:style>
-      <a:lnRef idx="2">
-        <a:scrgbClr r="0" g="0" b="0"/>
-      </a:lnRef>
-      <a:fillRef idx="1">
-        <a:scrgbClr r="0" g="0" b="0"/>
-      </a:fillRef>
-      <a:effectRef idx="0">
-        <a:scrgbClr r="0" g="0" b="0"/>
-      </a:effectRef>
-      <a:fontRef idx="minor">
-        <a:schemeClr val="lt1"/>
-      </a:fontRef>
-    </dgm:style>
-  </dgm:styleLbl>
-  <dgm:styleLbl name="node3">
-    <dgm:scene3d>
-      <a:camera prst="orthographicFront"/>
-      <a:lightRig rig="threePt" dir="t"/>
-    </dgm:scene3d>
-    <dgm:sp3d/>
-    <dgm:txPr/>
-    <dgm:style>
-      <a:lnRef idx="2">
-        <a:scrgbClr r="0" g="0" b="0"/>
-      </a:lnRef>
-      <a:fillRef idx="1">
-        <a:scrgbClr r="0" g="0" b="0"/>
-      </a:fillRef>
-      <a:effectRef idx="0">
-        <a:scrgbClr r="0" g="0" b="0"/>
-      </a:effectRef>
-      <a:fontRef idx="minor">
-        <a:schemeClr val="lt1"/>
-      </a:fontRef>
-    </dgm:style>
-  </dgm:styleLbl>
-  <dgm:styleLbl name="node4">
-    <dgm:scene3d>
-      <a:camera prst="orthographicFront"/>
-      <a:lightRig rig="threePt" dir="t"/>
-    </dgm:scene3d>
-    <dgm:sp3d/>
-    <dgm:txPr/>
-    <dgm:style>
-      <a:lnRef idx="2">
-        <a:scrgbClr r="0" g="0" b="0"/>
-      </a:lnRef>
-      <a:fillRef idx="1">
-        <a:scrgbClr r="0" g="0" b="0"/>
-      </a:fillRef>
-      <a:effectRef idx="0">
-        <a:scrgbClr r="0" g="0" b="0"/>
-      </a:effectRef>
-      <a:fontRef idx="minor">
-        <a:schemeClr val="lt1"/>
-      </a:fontRef>
-    </dgm:style>
-  </dgm:styleLbl>
-  <dgm:styleLbl name="fgImgPlace1">
-    <dgm:scene3d>
-      <a:camera prst="orthographicFront"/>
-      <a:lightRig rig="threePt" dir="t"/>
-    </dgm:scene3d>
-    <dgm:sp3d/>
-    <dgm:txPr/>
-    <dgm:style>
-      <a:lnRef idx="2">
-        <a:scrgbClr r="0" g="0" b="0"/>
-      </a:lnRef>
-      <a:fillRef idx="1">
-        <a:scrgbClr r="0" g="0" b="0"/>
-      </a:fillRef>
-      <a:effectRef idx="0">
-        <a:scrgbClr r="0" g="0" b="0"/>
-      </a:effectRef>
-      <a:fontRef idx="minor"/>
-    </dgm:style>
-  </dgm:styleLbl>
-  <dgm:styleLbl name="alignImgPlace1">
-    <dgm:scene3d>
-      <a:camera prst="orthographicFront"/>
-      <a:lightRig rig="threePt" dir="t"/>
-    </dgm:scene3d>
-    <dgm:sp3d/>
-    <dgm:txPr/>
-    <dgm:style>
-      <a:lnRef idx="2">
-        <a:scrgbClr r="0" g="0" b="0"/>
-      </a:lnRef>
-      <a:fillRef idx="1">
-        <a:scrgbClr r="0" g="0" b="0"/>
-      </a:fillRef>
-      <a:effectRef idx="0">
-        <a:scrgbClr r="0" g="0" b="0"/>
-      </a:effectRef>
-      <a:fontRef idx="minor"/>
-    </dgm:style>
-  </dgm:styleLbl>
-  <dgm:styleLbl name="bgImgPlace1">
-    <dgm:scene3d>
-      <a:camera prst="orthographicFront"/>
-      <a:lightRig rig="threePt" dir="t"/>
-    </dgm:scene3d>
-    <dgm:sp3d/>
-    <dgm:txPr/>
-    <dgm:style>
-      <a:lnRef idx="2">
-        <a:scrgbClr r="0" g="0" b="0"/>
-      </a:lnRef>
-      <a:fillRef idx="1">
-        <a:scrgbClr r="0" g="0" b="0"/>
-      </a:fillRef>
-      <a:effectRef idx="0">
-        <a:scrgbClr r="0" g="0" b="0"/>
-      </a:effectRef>
-      <a:fontRef idx="minor"/>
-    </dgm:style>
-  </dgm:styleLbl>
-  <dgm:styleLbl name="sibTrans2D1">
-    <dgm:scene3d>
-      <a:camera prst="orthographicFront"/>
-      <a:lightRig rig="threePt" dir="t"/>
-    </dgm:scene3d>
-    <dgm:sp3d/>
-    <dgm:txPr/>
-    <dgm:style>
-      <a:lnRef idx="0">
-        <a:scrgbClr r="0" g="0" b="0"/>
-      </a:lnRef>
-      <a:fillRef idx="1">
-        <a:scrgbClr r="0" g="0" b="0"/>
-      </a:fillRef>
-      <a:effectRef idx="0">
-        <a:scrgbClr r="0" g="0" b="0"/>
-      </a:effectRef>
-      <a:fontRef idx="minor">
-        <a:schemeClr val="lt1"/>
-      </a:fontRef>
-    </dgm:style>
-  </dgm:styleLbl>
-  <dgm:styleLbl name="fgSibTrans2D1">
-    <dgm:scene3d>
-      <a:camera prst="orthographicFront"/>
-      <a:lightRig rig="threePt" dir="t"/>
-    </dgm:scene3d>
-    <dgm:sp3d/>
-    <dgm:txPr/>
-    <dgm:style>
-      <a:lnRef idx="0">
-        <a:scrgbClr r="0" g="0" b="0"/>
-      </a:lnRef>
-      <a:fillRef idx="1">
-        <a:scrgbClr r="0" g="0" b="0"/>
-      </a:fillRef>
-      <a:effectRef idx="0">
-        <a:scrgbClr r="0" g="0" b="0"/>
-      </a:effectRef>
-      <a:fontRef idx="minor">
-        <a:schemeClr val="lt1"/>
-      </a:fontRef>
-    </dgm:style>
-  </dgm:styleLbl>
-  <dgm:styleLbl name="bgSibTrans2D1">
-    <dgm:scene3d>
-      <a:camera prst="orthographicFront"/>
-      <a:lightRig rig="threePt" dir="t"/>
-    </dgm:scene3d>
-    <dgm:sp3d/>
-    <dgm:txPr/>
-    <dgm:style>
-      <a:lnRef idx="0">
-        <a:scrgbClr r="0" g="0" b="0"/>
-      </a:lnRef>
-      <a:fillRef idx="1">
-        <a:scrgbClr r="0" g="0" b="0"/>
-      </a:fillRef>
-      <a:effectRef idx="0">
-        <a:scrgbClr r="0" g="0" b="0"/>
-      </a:effectRef>
-      <a:fontRef idx="minor">
-        <a:schemeClr val="lt1"/>
-      </a:fontRef>
-    </dgm:style>
-  </dgm:styleLbl>
-  <dgm:styleLbl name="sibTrans1D1">
-    <dgm:scene3d>
-      <a:camera prst="orthographicFront"/>
-      <a:lightRig rig="threePt" dir="t"/>
-    </dgm:scene3d>
-    <dgm:sp3d/>
-    <dgm:txPr/>
-    <dgm:style>
-      <a:lnRef idx="1">
-        <a:scrgbClr r="0" g="0" b="0"/>
-      </a:lnRef>
-      <a:fillRef idx="0">
-        <a:scrgbClr r="0" g="0" b="0"/>
-      </a:fillRef>
-      <a:effectRef idx="0">
-        <a:scrgbClr r="0" g="0" b="0"/>
-      </a:effectRef>
-      <a:fontRef idx="minor"/>
-    </dgm:style>
-  </dgm:styleLbl>
-  <dgm:styleLbl name="callout">
-    <dgm:scene3d>
-      <a:camera prst="orthographicFront"/>
-      <a:lightRig rig="threePt" dir="t"/>
-    </dgm:scene3d>
-    <dgm:sp3d/>
-    <dgm:txPr/>
-    <dgm:style>
-      <a:lnRef idx="2">
-        <a:scrgbClr r="0" g="0" b="0"/>
-      </a:lnRef>
-      <a:fillRef idx="1">
-        <a:scrgbClr r="0" g="0" b="0"/>
-      </a:fillRef>
-      <a:effectRef idx="0">
-        <a:scrgbClr r="0" g="0" b="0"/>
-      </a:effectRef>
-      <a:fontRef idx="minor"/>
-    </dgm:style>
-  </dgm:styleLbl>
-  <dgm:styleLbl name="asst0">
-    <dgm:scene3d>
-      <a:camera prst="orthographicFront"/>
-      <a:lightRig rig="threePt" dir="t"/>
-    </dgm:scene3d>
-    <dgm:sp3d/>
-    <dgm:txPr/>
-    <dgm:style>
-      <a:lnRef idx="2">
-        <a:scrgbClr r="0" g="0" b="0"/>
-      </a:lnRef>
-      <a:fillRef idx="1">
-        <a:scrgbClr r="0" g="0" b="0"/>
-      </a:fillRef>
-      <a:effectRef idx="0">
-        <a:scrgbClr r="0" g="0" b="0"/>
-      </a:effectRef>
-      <a:fontRef idx="minor">
-        <a:schemeClr val="lt1"/>
-      </a:fontRef>
-    </dgm:style>
-  </dgm:styleLbl>
-  <dgm:styleLbl name="asst1">
-    <dgm:scene3d>
-      <a:camera prst="orthographicFront"/>
-      <a:lightRig rig="threePt" dir="t"/>
-    </dgm:scene3d>
-    <dgm:sp3d/>
-    <dgm:txPr/>
-    <dgm:style>
-      <a:lnRef idx="2">
-        <a:scrgbClr r="0" g="0" b="0"/>
-      </a:lnRef>
-      <a:fillRef idx="1">
-        <a:scrgbClr r="0" g="0" b="0"/>
-      </a:fillRef>
-      <a:effectRef idx="0">
-        <a:scrgbClr r="0" g="0" b="0"/>
-      </a:effectRef>
-      <a:fontRef idx="minor">
-        <a:schemeClr val="lt1"/>
-      </a:fontRef>
-    </dgm:style>
-  </dgm:styleLbl>
-  <dgm:styleLbl name="asst2">
-    <dgm:scene3d>
-      <a:camera prst="orthographicFront"/>
-      <a:lightRig rig="threePt" dir="t"/>
-    </dgm:scene3d>
-    <dgm:sp3d/>
-    <dgm:txPr/>
-    <dgm:style>
-      <a:lnRef idx="2">
-        <a:scrgbClr r="0" g="0" b="0"/>
-      </a:lnRef>
-      <a:fillRef idx="1">
-        <a:scrgbClr r="0" g="0" b="0"/>
-      </a:fillRef>
-      <a:effectRef idx="0">
-        <a:scrgbClr r="0" g="0" b="0"/>
-      </a:effectRef>
-      <a:fontRef idx="minor">
-        <a:schemeClr val="lt1"/>
-      </a:fontRef>
-    </dgm:style>
-  </dgm:styleLbl>
-  <dgm:styleLbl name="asst3">
-    <dgm:scene3d>
-      <a:camera prst="orthographicFront"/>
-      <a:lightRig rig="threePt" dir="t"/>
-    </dgm:scene3d>
-    <dgm:sp3d/>
-    <dgm:txPr/>
-    <dgm:style>
-      <a:lnRef idx="2">
-        <a:scrgbClr r="0" g="0" b="0"/>
-      </a:lnRef>
-      <a:fillRef idx="1">
-        <a:scrgbClr r="0" g="0" b="0"/>
-      </a:fillRef>
-      <a:effectRef idx="0">
-        <a:scrgbClr r="0" g="0" b="0"/>
-      </a:effectRef>
-      <a:fontRef idx="minor">
-        <a:schemeClr val="lt1"/>
-      </a:fontRef>
-    </dgm:style>
-  </dgm:styleLbl>
-  <dgm:styleLbl name="asst4">
-    <dgm:scene3d>
-      <a:camera prst="orthographicFront"/>
-      <a:lightRig rig="threePt" dir="t"/>
-    </dgm:scene3d>
-    <dgm:sp3d/>
-    <dgm:txPr/>
-    <dgm:style>
-      <a:lnRef idx="2">
-        <a:scrgbClr r="0" g="0" b="0"/>
-      </a:lnRef>
-      <a:fillRef idx="1">
-        <a:scrgbClr r="0" g="0" b="0"/>
-      </a:fillRef>
-      <a:effectRef idx="0">
-        <a:scrgbClr r="0" g="0" b="0"/>
-      </a:effectRef>
-      <a:fontRef idx="minor">
-        <a:schemeClr val="lt1"/>
-      </a:fontRef>
-    </dgm:style>
-  </dgm:styleLbl>
-  <dgm:styleLbl name="parChTrans2D1">
-    <dgm:scene3d>
-      <a:camera prst="orthographicFront"/>
-      <a:lightRig rig="threePt" dir="t"/>
-    </dgm:scene3d>
-    <dgm:sp3d/>
-    <dgm:txPr/>
-    <dgm:style>
-      <a:lnRef idx="2">
-        <a:scrgbClr r="0" g="0" b="0"/>
-      </a:lnRef>
-      <a:fillRef idx="1">
-        <a:scrgbClr r="0" g="0" b="0"/>
-      </a:fillRef>
-      <a:effectRef idx="0">
-        <a:scrgbClr r="0" g="0" b="0"/>
-      </a:effectRef>
-      <a:fontRef idx="minor">
-        <a:schemeClr val="lt1"/>
-      </a:fontRef>
-    </dgm:style>
-  </dgm:styleLbl>
-  <dgm:styleLbl name="parChTrans2D2">
-    <dgm:scene3d>
-      <a:camera prst="orthographicFront"/>
-      <a:lightRig rig="threePt" dir="t"/>
-    </dgm:scene3d>
-    <dgm:sp3d/>
-    <dgm:txPr/>
-    <dgm:style>
-      <a:lnRef idx="2">
-        <a:scrgbClr r="0" g="0" b="0"/>
-      </a:lnRef>
-      <a:fillRef idx="1">
-        <a:scrgbClr r="0" g="0" b="0"/>
-      </a:fillRef>
-      <a:effectRef idx="0">
-        <a:scrgbClr r="0" g="0" b="0"/>
-      </a:effectRef>
-      <a:fontRef idx="minor">
-        <a:schemeClr val="lt1"/>
-      </a:fontRef>
-    </dgm:style>
-  </dgm:styleLbl>
-  <dgm:styleLbl name="parChTrans2D3">
-    <dgm:scene3d>
-      <a:camera prst="orthographicFront"/>
-      <a:lightRig rig="threePt" dir="t"/>
-    </dgm:scene3d>
-    <dgm:sp3d/>
-    <dgm:txPr/>
-    <dgm:style>
-      <a:lnRef idx="2">
-        <a:scrgbClr r="0" g="0" b="0"/>
-      </a:lnRef>
-      <a:fillRef idx="1">
-        <a:scrgbClr r="0" g="0" b="0"/>
-      </a:fillRef>
-      <a:effectRef idx="0">
-        <a:scrgbClr r="0" g="0" b="0"/>
-      </a:effectRef>
-      <a:fontRef idx="minor">
-        <a:schemeClr val="lt1"/>
-      </a:fontRef>
-    </dgm:style>
-  </dgm:styleLbl>
-  <dgm:styleLbl name="parChTrans2D4">
-    <dgm:scene3d>
-      <a:camera prst="orthographicFront"/>
-      <a:lightRig rig="threePt" dir="t"/>
-    </dgm:scene3d>
-    <dgm:sp3d/>
-    <dgm:txPr/>
-    <dgm:style>
-      <a:lnRef idx="2">
-        <a:scrgbClr r="0" g="0" b="0"/>
-      </a:lnRef>
-      <a:fillRef idx="1">
-        <a:scrgbClr r="0" g="0" b="0"/>
-      </a:fillRef>
-      <a:effectRef idx="0">
-        <a:scrgbClr r="0" g="0" b="0"/>
-      </a:effectRef>
-      <a:fontRef idx="minor">
-        <a:schemeClr val="lt1"/>
-      </a:fontRef>
-    </dgm:style>
-  </dgm:styleLbl>
-  <dgm:styleLbl name="parChTrans1D1">
-    <dgm:scene3d>
-      <a:camera prst="orthographicFront"/>
-      <a:lightRig rig="threePt" dir="t"/>
-    </dgm:scene3d>
-    <dgm:sp3d/>
-    <dgm:txPr/>
-    <dgm:style>
-      <a:lnRef idx="2">
-        <a:scrgbClr r="0" g="0" b="0"/>
-      </a:lnRef>
-      <a:fillRef idx="0">
-        <a:scrgbClr r="0" g="0" b="0"/>
-      </a:fillRef>
-      <a:effectRef idx="0">
-        <a:scrgbClr r="0" g="0" b="0"/>
-      </a:effectRef>
-      <a:fontRef idx="minor"/>
-    </dgm:style>
-  </dgm:styleLbl>
-  <dgm:styleLbl name="parChTrans1D2">
-    <dgm:scene3d>
-      <a:camera prst="orthographicFront"/>
-      <a:lightRig rig="threePt" dir="t"/>
-    </dgm:scene3d>
-    <dgm:sp3d/>
-    <dgm:txPr/>
-    <dgm:style>
-      <a:lnRef idx="2">
-        <a:scrgbClr r="0" g="0" b="0"/>
-      </a:lnRef>
-      <a:fillRef idx="0">
-        <a:scrgbClr r="0" g="0" b="0"/>
-      </a:fillRef>
-      <a:effectRef idx="0">
-        <a:scrgbClr r="0" g="0" b="0"/>
-      </a:effectRef>
-      <a:fontRef idx="minor"/>
-    </dgm:style>
-  </dgm:styleLbl>
-  <dgm:styleLbl name="parChTrans1D3">
-    <dgm:scene3d>
-      <a:camera prst="orthographicFront"/>
-      <a:lightRig rig="threePt" dir="t"/>
-    </dgm:scene3d>
-    <dgm:sp3d/>
-    <dgm:txPr/>
-    <dgm:style>
-      <a:lnRef idx="2">
-        <a:scrgbClr r="0" g="0" b="0"/>
-      </a:lnRef>
-      <a:fillRef idx="0">
-        <a:scrgbClr r="0" g="0" b="0"/>
-      </a:fillRef>
-      <a:effectRef idx="0">
-        <a:scrgbClr r="0" g="0" b="0"/>
-      </a:effectRef>
-      <a:fontRef idx="minor"/>
-    </dgm:style>
-  </dgm:styleLbl>
-  <dgm:styleLbl name="parChTrans1D4">
-    <dgm:scene3d>
-      <a:camera prst="orthographicFront"/>
-      <a:lightRig rig="threePt" dir="t"/>
-    </dgm:scene3d>
-    <dgm:sp3d/>
-    <dgm:txPr/>
-    <dgm:style>
-      <a:lnRef idx="2">
-        <a:scrgbClr r="0" g="0" b="0"/>
-      </a:lnRef>
-      <a:fillRef idx="0">
-        <a:scrgbClr r="0" g="0" b="0"/>
-      </a:fillRef>
-      <a:effectRef idx="0">
-        <a:scrgbClr r="0" g="0" b="0"/>
-      </a:effectRef>
-      <a:fontRef idx="minor"/>
-    </dgm:style>
-  </dgm:styleLbl>
-  <dgm:styleLbl name="fgAcc1">
-    <dgm:scene3d>
-      <a:camera prst="orthographicFront"/>
-      <a:lightRig rig="threePt" dir="t"/>
-    </dgm:scene3d>
-    <dgm:sp3d/>
-    <dgm:txPr/>
-    <dgm:style>
-      <a:lnRef idx="2">
-        <a:scrgbClr r="0" g="0" b="0"/>
-      </a:lnRef>
-      <a:fillRef idx="1">
-        <a:scrgbClr r="0" g="0" b="0"/>
-      </a:fillRef>
-      <a:effectRef idx="0">
-        <a:scrgbClr r="0" g="0" b="0"/>
-      </a:effectRef>
-      <a:fontRef idx="minor"/>
-    </dgm:style>
-  </dgm:styleLbl>
-  <dgm:styleLbl name="conFgAcc1">
-    <dgm:scene3d>
-      <a:camera prst="orthographicFront"/>
-      <a:lightRig rig="threePt" dir="t"/>
-    </dgm:scene3d>
-    <dgm:sp3d/>
-    <dgm:txPr/>
-    <dgm:style>
-      <a:lnRef idx="2">
-        <a:scrgbClr r="0" g="0" b="0"/>
-      </a:lnRef>
-      <a:fillRef idx="1">
-        <a:scrgbClr r="0" g="0" b="0"/>
-      </a:fillRef>
-      <a:effectRef idx="0">
-        <a:scrgbClr r="0" g="0" b="0"/>
-      </a:effectRef>
-      <a:fontRef idx="minor"/>
-    </dgm:style>
-  </dgm:styleLbl>
-  <dgm:styleLbl name="alignAcc1">
-    <dgm:scene3d>
-      <a:camera prst="orthographicFront"/>
-      <a:lightRig rig="threePt" dir="t"/>
-    </dgm:scene3d>
-    <dgm:sp3d/>
-    <dgm:txPr/>
-    <dgm:style>
-      <a:lnRef idx="2">
-        <a:scrgbClr r="0" g="0" b="0"/>
-      </a:lnRef>
-      <a:fillRef idx="1">
-        <a:scrgbClr r="0" g="0" b="0"/>
-      </a:fillRef>
-      <a:effectRef idx="0">
-        <a:scrgbClr r="0" g="0" b="0"/>
-      </a:effectRef>
-      <a:fontRef idx="minor"/>
-    </dgm:style>
-  </dgm:styleLbl>
-  <dgm:styleLbl name="trAlignAcc1">
-    <dgm:scene3d>
-      <a:camera prst="orthographicFront"/>
-      <a:lightRig rig="threePt" dir="t"/>
-    </dgm:scene3d>
-    <dgm:sp3d/>
-    <dgm:txPr/>
-    <dgm:style>
-      <a:lnRef idx="1">
-        <a:scrgbClr r="0" g="0" b="0"/>
-      </a:lnRef>
-      <a:fillRef idx="1">
-        <a:scrgbClr r="0" g="0" b="0"/>
-      </a:fillRef>
-      <a:effectRef idx="0">
-        <a:scrgbClr r="0" g="0" b="0"/>
-      </a:effectRef>
-      <a:fontRef idx="minor"/>
-    </dgm:style>
-  </dgm:styleLbl>
-  <dgm:styleLbl name="bgAcc1">
-    <dgm:scene3d>
-      <a:camera prst="orthographicFront"/>
-      <a:lightRig rig="threePt" dir="t"/>
-    </dgm:scene3d>
-    <dgm:sp3d/>
-    <dgm:txPr/>
-    <dgm:style>
-      <a:lnRef idx="2">
-        <a:scrgbClr r="0" g="0" b="0"/>
-      </a:lnRef>
-      <a:fillRef idx="1">
-        <a:scrgbClr r="0" g="0" b="0"/>
-      </a:fillRef>
-      <a:effectRef idx="0">
-        <a:scrgbClr r="0" g="0" b="0"/>
-      </a:effectRef>
-      <a:fontRef idx="minor"/>
-    </dgm:style>
-  </dgm:styleLbl>
-  <dgm:styleLbl name="solidFgAcc1">
-    <dgm:scene3d>
-      <a:camera prst="orthographicFront"/>
-      <a:lightRig rig="threePt" dir="t"/>
-    </dgm:scene3d>
-    <dgm:sp3d/>
-    <dgm:txPr/>
-    <dgm:style>
-      <a:lnRef idx="2">
-        <a:scrgbClr r="0" g="0" b="0"/>
-      </a:lnRef>
-      <a:fillRef idx="1">
-        <a:scrgbClr r="0" g="0" b="0"/>
-      </a:fillRef>
-      <a:effectRef idx="0">
-        <a:scrgbClr r="0" g="0" b="0"/>
-      </a:effectRef>
-      <a:fontRef idx="minor"/>
-    </dgm:style>
-  </dgm:styleLbl>
-  <dgm:styleLbl name="solidAlignAcc1">
-    <dgm:scene3d>
-      <a:camera prst="orthographicFront"/>
-      <a:lightRig rig="threePt" dir="t"/>
-    </dgm:scene3d>
-    <dgm:sp3d/>
-    <dgm:txPr/>
-    <dgm:style>
-      <a:lnRef idx="2">
-        <a:scrgbClr r="0" g="0" b="0"/>
-      </a:lnRef>
-      <a:fillRef idx="1">
-        <a:scrgbClr r="0" g="0" b="0"/>
-      </a:fillRef>
-      <a:effectRef idx="0">
-        <a:scrgbClr r="0" g="0" b="0"/>
-      </a:effectRef>
-      <a:fontRef idx="minor"/>
-    </dgm:style>
-  </dgm:styleLbl>
-  <dgm:styleLbl name="solidBgAcc1">
-    <dgm:scene3d>
-      <a:camera prst="orthographicFront"/>
-      <a:lightRig rig="threePt" dir="t"/>
-    </dgm:scene3d>
-    <dgm:sp3d/>
-    <dgm:txPr/>
-    <dgm:style>
-      <a:lnRef idx="2">
-        <a:scrgbClr r="0" g="0" b="0"/>
-      </a:lnRef>
-      <a:fillRef idx="1">
-        <a:scrgbClr r="0" g="0" b="0"/>
-      </a:fillRef>
-      <a:effectRef idx="0">
-        <a:scrgbClr r="0" g="0" b="0"/>
-      </a:effectRef>
-      <a:fontRef idx="minor"/>
-    </dgm:style>
-  </dgm:styleLbl>
-  <dgm:styleLbl name="fgAccFollowNode1">
-    <dgm:scene3d>
-      <a:camera prst="orthographicFront"/>
-      <a:lightRig rig="threePt" dir="t"/>
-    </dgm:scene3d>
-    <dgm:sp3d/>
-    <dgm:txPr/>
-    <dgm:style>
-      <a:lnRef idx="2">
-        <a:scrgbClr r="0" g="0" b="0"/>
-      </a:lnRef>
-      <a:fillRef idx="1">
-        <a:scrgbClr r="0" g="0" b="0"/>
-      </a:fillRef>
-      <a:effectRef idx="0">
-        <a:scrgbClr r="0" g="0" b="0"/>
-      </a:effectRef>
-      <a:fontRef idx="minor"/>
-    </dgm:style>
-  </dgm:styleLbl>
-  <dgm:styleLbl name="alignAccFollowNode1">
-    <dgm:scene3d>
-      <a:camera prst="orthographicFront"/>
-      <a:lightRig rig="threePt" dir="t"/>
-    </dgm:scene3d>
-    <dgm:sp3d/>
-    <dgm:txPr/>
-    <dgm:style>
-      <a:lnRef idx="2">
-        <a:scrgbClr r="0" g="0" b="0"/>
-      </a:lnRef>
-      <a:fillRef idx="1">
-        <a:scrgbClr r="0" g="0" b="0"/>
-      </a:fillRef>
-      <a:effectRef idx="0">
-        <a:scrgbClr r="0" g="0" b="0"/>
-      </a:effectRef>
-      <a:fontRef idx="minor"/>
-    </dgm:style>
-  </dgm:styleLbl>
-  <dgm:styleLbl name="bgAccFollowNode1">
-    <dgm:scene3d>
-      <a:camera prst="orthographicFront"/>
-      <a:lightRig rig="threePt" dir="t"/>
-    </dgm:scene3d>
-    <dgm:sp3d/>
-    <dgm:txPr/>
-    <dgm:style>
-      <a:lnRef idx="2">
-        <a:scrgbClr r="0" g="0" b="0"/>
-      </a:lnRef>
-      <a:fillRef idx="1">
-        <a:scrgbClr r="0" g="0" b="0"/>
-      </a:fillRef>
-      <a:effectRef idx="0">
-        <a:scrgbClr r="0" g="0" b="0"/>
-      </a:effectRef>
-      <a:fontRef idx="minor"/>
-    </dgm:style>
-  </dgm:styleLbl>
-  <dgm:styleLbl name="fgAcc0">
-    <dgm:scene3d>
-      <a:camera prst="orthographicFront"/>
-      <a:lightRig rig="threePt" dir="t"/>
-    </dgm:scene3d>
-    <dgm:sp3d/>
-    <dgm:txPr/>
-    <dgm:style>
-      <a:lnRef idx="2">
-        <a:scrgbClr r="0" g="0" b="0"/>
-      </a:lnRef>
-      <a:fillRef idx="1">
-        <a:scrgbClr r="0" g="0" b="0"/>
-      </a:fillRef>
-      <a:effectRef idx="0">
-        <a:scrgbClr r="0" g="0" b="0"/>
-      </a:effectRef>
-      <a:fontRef idx="minor"/>
-    </dgm:style>
-  </dgm:styleLbl>
-  <dgm:styleLbl name="fgAcc2">
-    <dgm:scene3d>
-      <a:camera prst="orthographicFront"/>
-      <a:lightRig rig="threePt" dir="t"/>
-    </dgm:scene3d>
-    <dgm:sp3d/>
-    <dgm:txPr/>
-    <dgm:style>
-      <a:lnRef idx="2">
-        <a:scrgbClr r="0" g="0" b="0"/>
-      </a:lnRef>
-      <a:fillRef idx="1">
-        <a:scrgbClr r="0" g="0" b="0"/>
-      </a:fillRef>
-      <a:effectRef idx="0">
-        <a:scrgbClr r="0" g="0" b="0"/>
-      </a:effectRef>
-      <a:fontRef idx="minor"/>
-    </dgm:style>
-  </dgm:styleLbl>
-  <dgm:styleLbl name="fgAcc3">
-    <dgm:scene3d>
-      <a:camera prst="orthographicFront"/>
-      <a:lightRig rig="threePt" dir="t"/>
-    </dgm:scene3d>
-    <dgm:sp3d/>
-    <dgm:txPr/>
-    <dgm:style>
-      <a:lnRef idx="2">
-        <a:scrgbClr r="0" g="0" b="0"/>
-      </a:lnRef>
-      <a:fillRef idx="1">
-        <a:scrgbClr r="0" g="0" b="0"/>
-      </a:fillRef>
-      <a:effectRef idx="0">
-        <a:scrgbClr r="0" g="0" b="0"/>
-      </a:effectRef>
-      <a:fontRef idx="minor"/>
-    </dgm:style>
-  </dgm:styleLbl>
-  <dgm:styleLbl name="fgAcc4">
-    <dgm:scene3d>
-      <a:camera prst="orthographicFront"/>
-      <a:lightRig rig="threePt" dir="t"/>
-    </dgm:scene3d>
-    <dgm:sp3d/>
-    <dgm:txPr/>
-    <dgm:style>
-      <a:lnRef idx="2">
-        <a:scrgbClr r="0" g="0" b="0"/>
-      </a:lnRef>
-      <a:fillRef idx="1">
-        <a:scrgbClr r="0" g="0" b="0"/>
-      </a:fillRef>
-      <a:effectRef idx="0">
-        <a:scrgbClr r="0" g="0" b="0"/>
-      </a:effectRef>
-      <a:fontRef idx="minor"/>
-    </dgm:style>
-  </dgm:styleLbl>
-  <dgm:styleLbl name="bgShp">
-    <dgm:scene3d>
-      <a:camera prst="orthographicFront"/>
-      <a:lightRig rig="threePt" dir="t"/>
-    </dgm:scene3d>
-    <dgm:sp3d/>
-    <dgm:txPr/>
-    <dgm:style>
-      <a:lnRef idx="0">
-        <a:scrgbClr r="0" g="0" b="0"/>
-      </a:lnRef>
-      <a:fillRef idx="1">
-        <a:scrgbClr r="0" g="0" b="0"/>
-      </a:fillRef>
-      <a:effectRef idx="0">
-        <a:scrgbClr r="0" g="0" b="0"/>
-      </a:effectRef>
-      <a:fontRef idx="minor"/>
-    </dgm:style>
-  </dgm:styleLbl>
-  <dgm:styleLbl name="dkBgShp">
-    <dgm:scene3d>
-      <a:camera prst="orthographicFront"/>
-      <a:lightRig rig="threePt" dir="t"/>
-    </dgm:scene3d>
-    <dgm:sp3d/>
-    <dgm:txPr/>
-    <dgm:style>
-      <a:lnRef idx="0">
-        <a:scrgbClr r="0" g="0" b="0"/>
-      </a:lnRef>
-      <a:fillRef idx="1">
-        <a:scrgbClr r="0" g="0" b="0"/>
-      </a:fillRef>
-      <a:effectRef idx="0">
-        <a:scrgbClr r="0" g="0" b="0"/>
-      </a:effectRef>
-      <a:fontRef idx="minor"/>
-    </dgm:style>
-  </dgm:styleLbl>
-  <dgm:styleLbl name="trBgShp">
-    <dgm:scene3d>
-      <a:camera prst="orthographicFront"/>
-      <a:lightRig rig="threePt" dir="t"/>
-    </dgm:scene3d>
-    <dgm:sp3d/>
-    <dgm:txPr/>
-    <dgm:style>
-      <a:lnRef idx="0">
-        <a:scrgbClr r="0" g="0" b="0"/>
-      </a:lnRef>
-      <a:fillRef idx="1">
-        <a:scrgbClr r="0" g="0" b="0"/>
-      </a:fillRef>
-      <a:effectRef idx="0">
-        <a:scrgbClr r="0" g="0" b="0"/>
-      </a:effectRef>
-      <a:fontRef idx="minor"/>
-    </dgm:style>
-  </dgm:styleLbl>
-  <dgm:styleLbl name="fgShp">
-    <dgm:scene3d>
-      <a:camera prst="orthographicFront"/>
-      <a:lightRig rig="threePt" dir="t"/>
-    </dgm:scene3d>
-    <dgm:sp3d/>
-    <dgm:txPr/>
-    <dgm:style>
-      <a:lnRef idx="2">
-        <a:scrgbClr r="0" g="0" b="0"/>
-      </a:lnRef>
-      <a:fillRef idx="1">
-        <a:scrgbClr r="0" g="0" b="0"/>
-      </a:fillRef>
-      <a:effectRef idx="0">
-        <a:scrgbClr r="0" g="0" b="0"/>
-      </a:effectRef>
-      <a:fontRef idx="minor"/>
-    </dgm:style>
-  </dgm:styleLbl>
-  <dgm:styleLbl name="revTx">
-    <dgm:scene3d>
-      <a:camera prst="orthographicFront"/>
-      <a:lightRig rig="threePt" dir="t"/>
-    </dgm:scene3d>
-    <dgm:sp3d/>
-    <dgm:txPr/>
-    <dgm:style>
-      <a:lnRef idx="0">
-        <a:scrgbClr r="0" g="0" b="0"/>
-      </a:lnRef>
-      <a:fillRef idx="0">
-        <a:scrgbClr r="0" g="0" b="0"/>
-      </a:fillRef>
-      <a:effectRef idx="0">
-        <a:scrgbClr r="0" g="0" b="0"/>
-      </a:effectRef>
-      <a:fontRef idx="minor"/>
-    </dgm:style>
-  </dgm:styleLbl>
-</dgm:styleDef>
-</file>
-
-<file path=ppt/diagrams/quickStyle2.xml><?xml version="1.0" encoding="utf-8"?>
 <dgm:styleDef xmlns:dgm="http://schemas.openxmlformats.org/drawingml/2006/diagram" xmlns:a="http://schemas.openxmlformats.org/drawingml/2006/main" uniqueId="urn:microsoft.com/office/officeart/2005/8/quickstyle/simple4">
   <dgm:title val=""/>
   <dgm:desc val=""/>
@@ -7289,7 +4668,13 @@
   <p:cSld>
     <p:spTree>
       <p:nvGrpSpPr>
-        <p:cNvPr id="1" name=""/>
+        <p:cNvPr id="1" name="">
+          <a:extLst>
+            <a:ext uri="{FF2B5EF4-FFF2-40B4-BE49-F238E27FC236}">
+              <a16:creationId xmlns:a16="http://schemas.microsoft.com/office/drawing/2014/main" id="{1BA47DDF-1565-460D-7632-8DB4205BF129}"/>
+            </a:ext>
+          </a:extLst>
+        </p:cNvPr>
         <p:cNvGrpSpPr/>
         <p:nvPr/>
       </p:nvGrpSpPr>
@@ -7303,7 +4688,13 @@
       </p:grpSpPr>
       <p:sp>
         <p:nvSpPr>
-          <p:cNvPr id="2" name="Espace réservé de l'image des diapositives 1"/>
+          <p:cNvPr id="2" name="Espace réservé de l’image des diapositives 1">
+            <a:extLst>
+              <a:ext uri="{FF2B5EF4-FFF2-40B4-BE49-F238E27FC236}">
+                <a16:creationId xmlns:a16="http://schemas.microsoft.com/office/drawing/2014/main" id="{4937EF3A-67B8-3982-9B6C-5AFF4168C634}"/>
+              </a:ext>
+            </a:extLst>
+          </p:cNvPr>
           <p:cNvSpPr>
             <a:spLocks noGrp="1" noRot="1" noChangeAspect="1"/>
           </p:cNvSpPr>
@@ -7322,7 +4713,13 @@
       </p:sp>
       <p:sp>
         <p:nvSpPr>
-          <p:cNvPr id="3" name="Espace réservé des notes 2"/>
+          <p:cNvPr id="3" name="Espace réservé des commentaires 2">
+            <a:extLst>
+              <a:ext uri="{FF2B5EF4-FFF2-40B4-BE49-F238E27FC236}">
+                <a16:creationId xmlns:a16="http://schemas.microsoft.com/office/drawing/2014/main" id="{C6179351-D1B0-8933-365D-1A8449B4557B}"/>
+              </a:ext>
+            </a:extLst>
+          </p:cNvPr>
           <p:cNvSpPr>
             <a:spLocks noGrp="1"/>
           </p:cNvSpPr>
@@ -7332,16 +4729,23 @@
         </p:nvSpPr>
         <p:spPr/>
         <p:txBody>
-          <a:bodyPr/>
+          <a:bodyPr rtlCol="0"/>
           <a:lstStyle/>
           <a:p>
+            <a:pPr rtl="0"/>
             <a:endParaRPr lang="fr-FR"/>
           </a:p>
         </p:txBody>
       </p:sp>
       <p:sp>
         <p:nvSpPr>
-          <p:cNvPr id="4" name="Espace réservé du numéro de diapositive 3"/>
+          <p:cNvPr id="4" name="Espace réservé du numéro de diapositive 3">
+            <a:extLst>
+              <a:ext uri="{FF2B5EF4-FFF2-40B4-BE49-F238E27FC236}">
+                <a16:creationId xmlns:a16="http://schemas.microsoft.com/office/drawing/2014/main" id="{AFB64E2C-F309-26A1-29C7-D147CB8322B7}"/>
+              </a:ext>
+            </a:extLst>
+          </p:cNvPr>
           <p:cNvSpPr>
             <a:spLocks noGrp="1"/>
           </p:cNvSpPr>
@@ -7351,7 +4755,7 @@
         </p:nvSpPr>
         <p:spPr/>
         <p:txBody>
-          <a:bodyPr/>
+          <a:bodyPr rtlCol="0"/>
           <a:lstStyle/>
           <a:p>
             <a:pPr rtl="0"/>
@@ -7366,7 +4770,7 @@
     </p:spTree>
     <p:extLst>
       <p:ext uri="{BB962C8B-B14F-4D97-AF65-F5344CB8AC3E}">
-        <p14:creationId xmlns:p14="http://schemas.microsoft.com/office/powerpoint/2010/main" val="2289636734"/>
+        <p14:creationId xmlns:p14="http://schemas.microsoft.com/office/powerpoint/2010/main" val="350088730"/>
       </p:ext>
     </p:extLst>
   </p:cSld>
@@ -7381,7 +4785,13 @@
   <p:cSld>
     <p:spTree>
       <p:nvGrpSpPr>
-        <p:cNvPr id="1" name=""/>
+        <p:cNvPr id="1" name="">
+          <a:extLst>
+            <a:ext uri="{FF2B5EF4-FFF2-40B4-BE49-F238E27FC236}">
+              <a16:creationId xmlns:a16="http://schemas.microsoft.com/office/drawing/2014/main" id="{87DCEE5D-BBD3-A2EC-1F05-E46CF48A1196}"/>
+            </a:ext>
+          </a:extLst>
+        </p:cNvPr>
         <p:cNvGrpSpPr/>
         <p:nvPr/>
       </p:nvGrpSpPr>
@@ -7395,7 +4805,13 @@
       </p:grpSpPr>
       <p:sp>
         <p:nvSpPr>
-          <p:cNvPr id="2" name="Espace réservé de l’image des diapositives 1"/>
+          <p:cNvPr id="2" name="Espace réservé de l’image des diapositives 1">
+            <a:extLst>
+              <a:ext uri="{FF2B5EF4-FFF2-40B4-BE49-F238E27FC236}">
+                <a16:creationId xmlns:a16="http://schemas.microsoft.com/office/drawing/2014/main" id="{6D9FE61C-76CE-1BB9-1395-173342861534}"/>
+              </a:ext>
+            </a:extLst>
+          </p:cNvPr>
           <p:cNvSpPr>
             <a:spLocks noGrp="1" noRot="1" noChangeAspect="1"/>
           </p:cNvSpPr>
@@ -7414,7 +4830,13 @@
       </p:sp>
       <p:sp>
         <p:nvSpPr>
-          <p:cNvPr id="3" name="Espace réservé des commentaires 2"/>
+          <p:cNvPr id="3" name="Espace réservé des commentaires 2">
+            <a:extLst>
+              <a:ext uri="{FF2B5EF4-FFF2-40B4-BE49-F238E27FC236}">
+                <a16:creationId xmlns:a16="http://schemas.microsoft.com/office/drawing/2014/main" id="{EC764E2B-A845-3539-9858-36364E24920E}"/>
+              </a:ext>
+            </a:extLst>
+          </p:cNvPr>
           <p:cNvSpPr>
             <a:spLocks noGrp="1"/>
           </p:cNvSpPr>
@@ -7434,7 +4856,13 @@
       </p:sp>
       <p:sp>
         <p:nvSpPr>
-          <p:cNvPr id="4" name="Espace réservé du numéro de diapositive 3"/>
+          <p:cNvPr id="4" name="Espace réservé du numéro de diapositive 3">
+            <a:extLst>
+              <a:ext uri="{FF2B5EF4-FFF2-40B4-BE49-F238E27FC236}">
+                <a16:creationId xmlns:a16="http://schemas.microsoft.com/office/drawing/2014/main" id="{E7399622-8265-25D5-383D-A84B233D5AED}"/>
+              </a:ext>
+            </a:extLst>
+          </p:cNvPr>
           <p:cNvSpPr>
             <a:spLocks noGrp="1"/>
           </p:cNvSpPr>
@@ -7459,7 +4887,7 @@
     </p:spTree>
     <p:extLst>
       <p:ext uri="{BB962C8B-B14F-4D97-AF65-F5344CB8AC3E}">
-        <p14:creationId xmlns:p14="http://schemas.microsoft.com/office/powerpoint/2010/main" val="3505115597"/>
+        <p14:creationId xmlns:p14="http://schemas.microsoft.com/office/powerpoint/2010/main" val="1129451749"/>
       </p:ext>
     </p:extLst>
   </p:cSld>
@@ -7488,6 +4916,98 @@
       </p:grpSpPr>
       <p:sp>
         <p:nvSpPr>
+          <p:cNvPr id="2" name="Espace réservé de l'image des diapositives 1"/>
+          <p:cNvSpPr>
+            <a:spLocks noGrp="1" noRot="1" noChangeAspect="1"/>
+          </p:cNvSpPr>
+          <p:nvPr>
+            <p:ph type="sldImg"/>
+          </p:nvPr>
+        </p:nvSpPr>
+        <p:spPr/>
+        <p:txBody>
+          <a:bodyPr/>
+          <a:lstStyle/>
+          <a:p>
+            <a:endParaRPr lang="fr-FR"/>
+          </a:p>
+        </p:txBody>
+      </p:sp>
+      <p:sp>
+        <p:nvSpPr>
+          <p:cNvPr id="3" name="Espace réservé des notes 2"/>
+          <p:cNvSpPr>
+            <a:spLocks noGrp="1"/>
+          </p:cNvSpPr>
+          <p:nvPr>
+            <p:ph type="body" idx="1"/>
+          </p:nvPr>
+        </p:nvSpPr>
+        <p:spPr/>
+        <p:txBody>
+          <a:bodyPr/>
+          <a:lstStyle/>
+          <a:p>
+            <a:endParaRPr lang="fr-FR"/>
+          </a:p>
+        </p:txBody>
+      </p:sp>
+      <p:sp>
+        <p:nvSpPr>
+          <p:cNvPr id="4" name="Espace réservé du numéro de diapositive 3"/>
+          <p:cNvSpPr>
+            <a:spLocks noGrp="1"/>
+          </p:cNvSpPr>
+          <p:nvPr>
+            <p:ph type="sldNum" sz="quarter" idx="5"/>
+          </p:nvPr>
+        </p:nvSpPr>
+        <p:spPr/>
+        <p:txBody>
+          <a:bodyPr/>
+          <a:lstStyle/>
+          <a:p>
+            <a:pPr rtl="0"/>
+            <a:fld id="{C6B3AB32-59DF-41F1-9618-EDFBF5049629}" type="slidenum">
+              <a:rPr lang="fr-FR" smtClean="0"/>
+              <a:t>11</a:t>
+            </a:fld>
+            <a:endParaRPr lang="fr-FR"/>
+          </a:p>
+        </p:txBody>
+      </p:sp>
+    </p:spTree>
+    <p:extLst>
+      <p:ext uri="{BB962C8B-B14F-4D97-AF65-F5344CB8AC3E}">
+        <p14:creationId xmlns:p14="http://schemas.microsoft.com/office/powerpoint/2010/main" val="2289636734"/>
+      </p:ext>
+    </p:extLst>
+  </p:cSld>
+  <p:clrMapOvr>
+    <a:masterClrMapping/>
+  </p:clrMapOvr>
+</p:notes>
+</file>
+
+<file path=ppt/notesSlides/notesSlide6.xml><?xml version="1.0" encoding="utf-8"?>
+<p:notes xmlns:a="http://schemas.openxmlformats.org/drawingml/2006/main" xmlns:r="http://schemas.openxmlformats.org/officeDocument/2006/relationships" xmlns:p="http://schemas.openxmlformats.org/presentationml/2006/main">
+  <p:cSld>
+    <p:spTree>
+      <p:nvGrpSpPr>
+        <p:cNvPr id="1" name=""/>
+        <p:cNvGrpSpPr/>
+        <p:nvPr/>
+      </p:nvGrpSpPr>
+      <p:grpSpPr>
+        <a:xfrm>
+          <a:off x="0" y="0"/>
+          <a:ext cx="0" cy="0"/>
+          <a:chOff x="0" y="0"/>
+          <a:chExt cx="0" cy="0"/>
+        </a:xfrm>
+      </p:grpSpPr>
+      <p:sp>
+        <p:nvSpPr>
           <p:cNvPr id="2" name="Espace réservé de l’image des diapositives 1"/>
           <p:cNvSpPr>
             <a:spLocks noGrp="1" noRot="1" noChangeAspect="1"/>
@@ -7543,7 +5063,100 @@
             <a:pPr rtl="0"/>
             <a:fld id="{C6B3AB32-59DF-41F1-9618-EDFBF5049629}" type="slidenum">
               <a:rPr lang="fr-FR" smtClean="0"/>
-              <a:t>11</a:t>
+              <a:t>12</a:t>
+            </a:fld>
+            <a:endParaRPr lang="fr-FR"/>
+          </a:p>
+        </p:txBody>
+      </p:sp>
+    </p:spTree>
+    <p:extLst>
+      <p:ext uri="{BB962C8B-B14F-4D97-AF65-F5344CB8AC3E}">
+        <p14:creationId xmlns:p14="http://schemas.microsoft.com/office/powerpoint/2010/main" val="3505115597"/>
+      </p:ext>
+    </p:extLst>
+  </p:cSld>
+  <p:clrMapOvr>
+    <a:masterClrMapping/>
+  </p:clrMapOvr>
+</p:notes>
+</file>
+
+<file path=ppt/notesSlides/notesSlide7.xml><?xml version="1.0" encoding="utf-8"?>
+<p:notes xmlns:a="http://schemas.openxmlformats.org/drawingml/2006/main" xmlns:r="http://schemas.openxmlformats.org/officeDocument/2006/relationships" xmlns:p="http://schemas.openxmlformats.org/presentationml/2006/main">
+  <p:cSld>
+    <p:spTree>
+      <p:nvGrpSpPr>
+        <p:cNvPr id="1" name=""/>
+        <p:cNvGrpSpPr/>
+        <p:nvPr/>
+      </p:nvGrpSpPr>
+      <p:grpSpPr>
+        <a:xfrm>
+          <a:off x="0" y="0"/>
+          <a:ext cx="0" cy="0"/>
+          <a:chOff x="0" y="0"/>
+          <a:chExt cx="0" cy="0"/>
+        </a:xfrm>
+      </p:grpSpPr>
+      <p:sp>
+        <p:nvSpPr>
+          <p:cNvPr id="2" name="Espace réservé de l’image des diapositives 1"/>
+          <p:cNvSpPr>
+            <a:spLocks noGrp="1" noRot="1" noChangeAspect="1"/>
+          </p:cNvSpPr>
+          <p:nvPr>
+            <p:ph type="sldImg"/>
+          </p:nvPr>
+        </p:nvSpPr>
+        <p:spPr/>
+        <p:txBody>
+          <a:bodyPr/>
+          <a:lstStyle/>
+          <a:p>
+            <a:endParaRPr lang="fr-FR"/>
+          </a:p>
+        </p:txBody>
+      </p:sp>
+      <p:sp>
+        <p:nvSpPr>
+          <p:cNvPr id="3" name="Espace réservé des commentaires 2"/>
+          <p:cNvSpPr>
+            <a:spLocks noGrp="1"/>
+          </p:cNvSpPr>
+          <p:nvPr>
+            <p:ph type="body" idx="1"/>
+          </p:nvPr>
+        </p:nvSpPr>
+        <p:spPr/>
+        <p:txBody>
+          <a:bodyPr rtlCol="0"/>
+          <a:lstStyle/>
+          <a:p>
+            <a:pPr rtl="0"/>
+            <a:endParaRPr lang="fr-FR"/>
+          </a:p>
+        </p:txBody>
+      </p:sp>
+      <p:sp>
+        <p:nvSpPr>
+          <p:cNvPr id="4" name="Espace réservé du numéro de diapositive 3"/>
+          <p:cNvSpPr>
+            <a:spLocks noGrp="1"/>
+          </p:cNvSpPr>
+          <p:nvPr>
+            <p:ph type="sldNum" sz="quarter" idx="5"/>
+          </p:nvPr>
+        </p:nvSpPr>
+        <p:spPr/>
+        <p:txBody>
+          <a:bodyPr rtlCol="0"/>
+          <a:lstStyle/>
+          <a:p>
+            <a:pPr rtl="0"/>
+            <a:fld id="{C6B3AB32-59DF-41F1-9618-EDFBF5049629}" type="slidenum">
+              <a:rPr lang="fr-FR" smtClean="0"/>
+              <a:t>13</a:t>
             </a:fld>
             <a:endParaRPr lang="fr-FR"/>
           </a:p>
@@ -11930,6 +9543,370 @@
     </p:bg>
     <p:spTree>
       <p:nvGrpSpPr>
+        <p:cNvPr id="1" name="">
+          <a:extLst>
+            <a:ext uri="{FF2B5EF4-FFF2-40B4-BE49-F238E27FC236}">
+              <a16:creationId xmlns:a16="http://schemas.microsoft.com/office/drawing/2014/main" id="{4B18B833-405A-98C1-A288-499D9175B89E}"/>
+            </a:ext>
+          </a:extLst>
+        </p:cNvPr>
+        <p:cNvGrpSpPr/>
+        <p:nvPr/>
+      </p:nvGrpSpPr>
+      <p:grpSpPr>
+        <a:xfrm>
+          <a:off x="0" y="0"/>
+          <a:ext cx="0" cy="0"/>
+          <a:chOff x="0" y="0"/>
+          <a:chExt cx="0" cy="0"/>
+        </a:xfrm>
+      </p:grpSpPr>
+      <p:sp useBgFill="1">
+        <p:nvSpPr>
+          <p:cNvPr id="29" name="Rectangle 28">
+            <a:extLst>
+              <a:ext uri="{FF2B5EF4-FFF2-40B4-BE49-F238E27FC236}">
+                <a16:creationId xmlns:a16="http://schemas.microsoft.com/office/drawing/2014/main" id="{093C1BDC-2C05-BF86-B68A-94D066C59223}"/>
+              </a:ext>
+              <a:ext uri="{C183D7F6-B498-43B3-948B-1728B52AA6E4}">
+                <adec:decorative xmlns:adec="http://schemas.microsoft.com/office/drawing/2017/decorative" val="1"/>
+              </a:ext>
+            </a:extLst>
+          </p:cNvPr>
+          <p:cNvSpPr>
+            <a:spLocks noGrp="1" noRot="1" noChangeAspect="1" noMove="1" noResize="1" noEditPoints="1" noAdjustHandles="1" noChangeArrowheads="1" noChangeShapeType="1"/>
+          </p:cNvSpPr>
+          <p:nvPr>
+            <p:extLst>
+              <p:ext uri="{386F3935-93C4-4BCD-93E2-E3B085C9AB24}">
+                <p16:designElem xmlns:p16="http://schemas.microsoft.com/office/powerpoint/2015/main" val="1"/>
+              </p:ext>
+            </p:extLst>
+          </p:nvPr>
+        </p:nvSpPr>
+        <p:spPr>
+          <a:xfrm>
+            <a:off x="0" y="536712"/>
+            <a:ext cx="12192000" cy="6321287"/>
+          </a:xfrm>
+          <a:prstGeom prst="rect">
+            <a:avLst/>
+          </a:prstGeom>
+          <a:ln>
+            <a:noFill/>
+          </a:ln>
+        </p:spPr>
+        <p:style>
+          <a:lnRef idx="2">
+            <a:schemeClr val="accent1">
+              <a:shade val="50000"/>
+            </a:schemeClr>
+          </a:lnRef>
+          <a:fillRef idx="1">
+            <a:schemeClr val="accent1"/>
+          </a:fillRef>
+          <a:effectRef idx="0">
+            <a:schemeClr val="accent1"/>
+          </a:effectRef>
+          <a:fontRef idx="minor">
+            <a:schemeClr val="lt1"/>
+          </a:fontRef>
+        </p:style>
+        <p:txBody>
+          <a:bodyPr rtlCol="0" anchor="ctr"/>
+          <a:lstStyle/>
+          <a:p>
+            <a:pPr algn="ctr" rtl="0"/>
+            <a:endParaRPr lang="fr-FR" dirty="0"/>
+          </a:p>
+        </p:txBody>
+      </p:sp>
+      <p:sp>
+        <p:nvSpPr>
+          <p:cNvPr id="31" name="Rectangle 30">
+            <a:extLst>
+              <a:ext uri="{FF2B5EF4-FFF2-40B4-BE49-F238E27FC236}">
+                <a16:creationId xmlns:a16="http://schemas.microsoft.com/office/drawing/2014/main" id="{29571379-3E20-69F7-9628-23ADBCDE3623}"/>
+              </a:ext>
+              <a:ext uri="{C183D7F6-B498-43B3-948B-1728B52AA6E4}">
+                <adec:decorative xmlns:adec="http://schemas.microsoft.com/office/drawing/2017/decorative" val="1"/>
+              </a:ext>
+            </a:extLst>
+          </p:cNvPr>
+          <p:cNvSpPr>
+            <a:spLocks noGrp="1" noRot="1" noChangeAspect="1" noMove="1" noResize="1" noEditPoints="1" noAdjustHandles="1" noChangeArrowheads="1" noChangeShapeType="1"/>
+          </p:cNvSpPr>
+          <p:nvPr>
+            <p:extLst>
+              <p:ext uri="{386F3935-93C4-4BCD-93E2-E3B085C9AB24}">
+                <p16:designElem xmlns:p16="http://schemas.microsoft.com/office/powerpoint/2015/main" val="1"/>
+              </p:ext>
+            </p:extLst>
+          </p:nvPr>
+        </p:nvSpPr>
+        <p:spPr>
+          <a:xfrm>
+            <a:off x="447817" y="5141974"/>
+            <a:ext cx="11290860" cy="1258827"/>
+          </a:xfrm>
+          <a:prstGeom prst="rect">
+            <a:avLst/>
+          </a:prstGeom>
+          <a:solidFill>
+            <a:schemeClr val="accent1"/>
+          </a:solidFill>
+          <a:ln>
+            <a:noFill/>
+          </a:ln>
+          <a:effectLst/>
+        </p:spPr>
+        <p:style>
+          <a:lnRef idx="1">
+            <a:schemeClr val="accent1"/>
+          </a:lnRef>
+          <a:fillRef idx="3">
+            <a:schemeClr val="accent1"/>
+          </a:fillRef>
+          <a:effectRef idx="2">
+            <a:schemeClr val="accent1"/>
+          </a:effectRef>
+          <a:fontRef idx="minor">
+            <a:schemeClr val="lt1"/>
+          </a:fontRef>
+        </p:style>
+        <p:txBody>
+          <a:bodyPr/>
+          <a:lstStyle/>
+          <a:p>
+            <a:endParaRPr lang="fr-FR"/>
+          </a:p>
+        </p:txBody>
+      </p:sp>
+      <p:sp>
+        <p:nvSpPr>
+          <p:cNvPr id="2" name="Titre 1">
+            <a:extLst>
+              <a:ext uri="{FF2B5EF4-FFF2-40B4-BE49-F238E27FC236}">
+                <a16:creationId xmlns:a16="http://schemas.microsoft.com/office/drawing/2014/main" id="{5141CCC8-361F-2DEE-6A82-B39F954F7C3F}"/>
+              </a:ext>
+            </a:extLst>
+          </p:cNvPr>
+          <p:cNvSpPr>
+            <a:spLocks noGrp="1"/>
+          </p:cNvSpPr>
+          <p:nvPr>
+            <p:ph type="title"/>
+          </p:nvPr>
+        </p:nvSpPr>
+        <p:spPr>
+          <a:xfrm>
+            <a:off x="581192" y="5264487"/>
+            <a:ext cx="11029616" cy="718870"/>
+          </a:xfrm>
+        </p:spPr>
+        <p:txBody>
+          <a:bodyPr rtlCol="0">
+            <a:normAutofit/>
+          </a:bodyPr>
+          <a:lstStyle/>
+          <a:p>
+            <a:pPr rtl="0"/>
+            <a:r>
+              <a:rPr lang="fr-FR" dirty="0">
+                <a:solidFill>
+                  <a:srgbClr val="FFFEFF"/>
+                </a:solidFill>
+              </a:rPr>
+              <a:t>Ce qu’il faut changer pour réduire les démissions</a:t>
+            </a:r>
+          </a:p>
+        </p:txBody>
+      </p:sp>
+      <p:sp>
+        <p:nvSpPr>
+          <p:cNvPr id="9" name="ZoneTexte 8">
+            <a:extLst>
+              <a:ext uri="{FF2B5EF4-FFF2-40B4-BE49-F238E27FC236}">
+                <a16:creationId xmlns:a16="http://schemas.microsoft.com/office/drawing/2014/main" id="{269AD7A6-C290-ACEC-8A86-EABD7A5787B8}"/>
+              </a:ext>
+            </a:extLst>
+          </p:cNvPr>
+          <p:cNvSpPr txBox="1"/>
+          <p:nvPr/>
+        </p:nvSpPr>
+        <p:spPr>
+          <a:xfrm>
+            <a:off x="2561035" y="1716026"/>
+            <a:ext cx="6093618" cy="769441"/>
+          </a:xfrm>
+          <a:prstGeom prst="rect">
+            <a:avLst/>
+          </a:prstGeom>
+          <a:noFill/>
+        </p:spPr>
+        <p:txBody>
+          <a:bodyPr wrap="square">
+            <a:spAutoFit/>
+          </a:bodyPr>
+          <a:lstStyle/>
+          <a:p>
+            <a:r>
+              <a:rPr lang="fr-FR" sz="4400" dirty="0" err="1"/>
+              <a:t>Counterfactuals</a:t>
+            </a:r>
+            <a:endParaRPr lang="fr-FR" sz="4400" dirty="0"/>
+          </a:p>
+        </p:txBody>
+      </p:sp>
+    </p:spTree>
+    <p:extLst>
+      <p:ext uri="{BB962C8B-B14F-4D97-AF65-F5344CB8AC3E}">
+        <p14:creationId xmlns:p14="http://schemas.microsoft.com/office/powerpoint/2010/main" val="4112041680"/>
+      </p:ext>
+    </p:extLst>
+  </p:cSld>
+  <p:clrMapOvr>
+    <a:masterClrMapping/>
+  </p:clrMapOvr>
+</p:sld>
+</file>
+
+<file path=ppt/slides/slide11.xml><?xml version="1.0" encoding="utf-8"?>
+<p:sld xmlns:a="http://schemas.openxmlformats.org/drawingml/2006/main" xmlns:r="http://schemas.openxmlformats.org/officeDocument/2006/relationships" xmlns:p="http://schemas.openxmlformats.org/presentationml/2006/main">
+  <p:cSld>
+    <p:spTree>
+      <p:nvGrpSpPr>
+        <p:cNvPr id="1" name=""/>
+        <p:cNvGrpSpPr/>
+        <p:nvPr/>
+      </p:nvGrpSpPr>
+      <p:grpSpPr>
+        <a:xfrm>
+          <a:off x="0" y="0"/>
+          <a:ext cx="0" cy="0"/>
+          <a:chOff x="0" y="0"/>
+          <a:chExt cx="0" cy="0"/>
+        </a:xfrm>
+      </p:grpSpPr>
+      <p:sp>
+        <p:nvSpPr>
+          <p:cNvPr id="2" name="Titre 1">
+            <a:extLst>
+              <a:ext uri="{FF2B5EF4-FFF2-40B4-BE49-F238E27FC236}">
+                <a16:creationId xmlns:a16="http://schemas.microsoft.com/office/drawing/2014/main" id="{921633EB-7DCB-4DDC-80AF-C885A3EE1245}"/>
+              </a:ext>
+            </a:extLst>
+          </p:cNvPr>
+          <p:cNvSpPr>
+            <a:spLocks noGrp="1"/>
+          </p:cNvSpPr>
+          <p:nvPr>
+            <p:ph type="title"/>
+          </p:nvPr>
+        </p:nvSpPr>
+        <p:spPr/>
+        <p:txBody>
+          <a:bodyPr rtlCol="0"/>
+          <a:lstStyle/>
+          <a:p>
+            <a:pPr rtl="0"/>
+            <a:r>
+              <a:rPr lang="fr-FR"/>
+              <a:t>Contexte concurrentiel</a:t>
+            </a:r>
+          </a:p>
+        </p:txBody>
+      </p:sp>
+      <p:pic>
+        <p:nvPicPr>
+          <p:cNvPr id="11" name="Espace réservé du contenu 4" descr="Graphiques">
+            <a:extLst>
+              <a:ext uri="{FF2B5EF4-FFF2-40B4-BE49-F238E27FC236}">
+                <a16:creationId xmlns:a16="http://schemas.microsoft.com/office/drawing/2014/main" id="{47D9BE16-119C-43B2-9AE6-18C4A150C0EF}"/>
+              </a:ext>
+            </a:extLst>
+          </p:cNvPr>
+          <p:cNvPicPr>
+            <a:picLocks noGrp="1" noChangeAspect="1"/>
+          </p:cNvPicPr>
+          <p:nvPr>
+            <p:ph sz="half" idx="1"/>
+          </p:nvPr>
+        </p:nvPicPr>
+        <p:blipFill rotWithShape="1">
+          <a:blip r:embed="rId3" cstate="screen">
+            <a:extLst>
+              <a:ext uri="{28A0092B-C50C-407E-A947-70E740481C1C}">
+                <a14:useLocalDpi xmlns:a14="http://schemas.microsoft.com/office/drawing/2010/main"/>
+              </a:ext>
+            </a:extLst>
+          </a:blip>
+          <a:stretch/>
+        </p:blipFill>
+        <p:spPr>
+          <a:xfrm>
+            <a:off x="581025" y="2231480"/>
+            <a:ext cx="5422900" cy="3625353"/>
+          </a:xfrm>
+        </p:spPr>
+      </p:pic>
+      <p:pic>
+        <p:nvPicPr>
+          <p:cNvPr id="18" name="Espace réservé du contenu 17" descr="Espace réservé au graphique">
+            <a:extLst>
+              <a:ext uri="{FF2B5EF4-FFF2-40B4-BE49-F238E27FC236}">
+                <a16:creationId xmlns:a16="http://schemas.microsoft.com/office/drawing/2014/main" id="{BFEA8EC1-23A4-4843-A9C3-AE771D73392A}"/>
+              </a:ext>
+            </a:extLst>
+          </p:cNvPr>
+          <p:cNvPicPr>
+            <a:picLocks noGrp="1" noChangeAspect="1"/>
+          </p:cNvPicPr>
+          <p:nvPr>
+            <p:ph sz="half" idx="2"/>
+          </p:nvPr>
+        </p:nvPicPr>
+        <p:blipFill>
+          <a:blip r:embed="rId4"/>
+          <a:srcRect/>
+          <a:stretch/>
+        </p:blipFill>
+        <p:spPr>
+          <a:xfrm>
+            <a:off x="6201812" y="2571845"/>
+            <a:ext cx="5395426" cy="2944623"/>
+          </a:xfrm>
+          <a:prstGeom prst="rect">
+            <a:avLst/>
+          </a:prstGeom>
+        </p:spPr>
+      </p:pic>
+    </p:spTree>
+    <p:extLst>
+      <p:ext uri="{BB962C8B-B14F-4D97-AF65-F5344CB8AC3E}">
+        <p14:creationId xmlns:p14="http://schemas.microsoft.com/office/powerpoint/2010/main" val="497607547"/>
+      </p:ext>
+    </p:extLst>
+  </p:cSld>
+  <p:clrMapOvr>
+    <a:masterClrMapping/>
+  </p:clrMapOvr>
+</p:sld>
+</file>
+
+<file path=ppt/slides/slide12.xml><?xml version="1.0" encoding="utf-8"?>
+<p:sld xmlns:a="http://schemas.openxmlformats.org/drawingml/2006/main" xmlns:r="http://schemas.openxmlformats.org/officeDocument/2006/relationships" xmlns:p="http://schemas.openxmlformats.org/presentationml/2006/main">
+  <p:cSld>
+    <p:bg>
+      <p:bgPr>
+        <a:solidFill>
+          <a:schemeClr val="bg1"/>
+        </a:solidFill>
+        <a:effectLst/>
+      </p:bgPr>
+    </p:bg>
+    <p:spTree>
+      <p:nvGrpSpPr>
         <p:cNvPr id="1" name=""/>
         <p:cNvGrpSpPr/>
         <p:nvPr/>
@@ -12334,7 +10311,7 @@
 </p:sld>
 </file>
 
-<file path=ppt/slides/slide11.xml><?xml version="1.0" encoding="utf-8"?>
+<file path=ppt/slides/slide13.xml><?xml version="1.0" encoding="utf-8"?>
 <p:sld xmlns:a="http://schemas.openxmlformats.org/drawingml/2006/main" xmlns:r="http://schemas.openxmlformats.org/officeDocument/2006/relationships" xmlns:p="http://schemas.openxmlformats.org/presentationml/2006/main">
   <p:cSld>
     <p:bg>
@@ -14975,75 +12952,196 @@
       </p:sp>
       <p:sp>
         <p:nvSpPr>
-          <p:cNvPr id="2" name="Titre 1">
+          <p:cNvPr id="16" name="Titre 1">
             <a:extLst>
               <a:ext uri="{FF2B5EF4-FFF2-40B4-BE49-F238E27FC236}">
                 <a16:creationId xmlns:a16="http://schemas.microsoft.com/office/drawing/2014/main" id="{5B040558-A365-4CCE-92FA-5A48CD98F9C9}"/>
               </a:ext>
             </a:extLst>
           </p:cNvPr>
-          <p:cNvSpPr>
-            <a:spLocks noGrp="1"/>
+          <p:cNvSpPr txBox="1">
+            <a:spLocks/>
           </p:cNvSpPr>
-          <p:nvPr>
-            <p:ph type="title"/>
-          </p:nvPr>
+          <p:nvPr/>
         </p:nvSpPr>
         <p:spPr>
           <a:xfrm>
-            <a:off x="581192" y="5264487"/>
-            <a:ext cx="11029616" cy="718870"/>
+            <a:off x="5645059" y="1716026"/>
+            <a:ext cx="5184866" cy="1427224"/>
           </a:xfrm>
+          <a:prstGeom prst="rect">
+            <a:avLst/>
+          </a:prstGeom>
         </p:spPr>
         <p:txBody>
-          <a:bodyPr rtlCol="0">
+          <a:bodyPr vert="horz" lIns="91440" tIns="45720" rIns="91440" bIns="45720" rtlCol="0" anchor="b">
             <a:normAutofit/>
           </a:bodyPr>
-          <a:lstStyle/>
-          <a:p>
-            <a:pPr rtl="0"/>
-            <a:r>
-              <a:rPr lang="fr-FR" dirty="0">
+          <a:lstStyle>
+            <a:lvl1pPr algn="l" defTabSz="457200" rtl="0" eaLnBrk="1" latinLnBrk="0" hangingPunct="1">
+              <a:spcBef>
+                <a:spcPct val="0"/>
+              </a:spcBef>
+              <a:buNone/>
+              <a:defRPr sz="2800" b="0" kern="1200" cap="all">
                 <a:solidFill>
-                  <a:srgbClr val="FFFEFF"/>
+                  <a:schemeClr val="bg1"/>
+                </a:solidFill>
+                <a:latin typeface="+mj-lt"/>
+                <a:ea typeface="+mj-ea"/>
+                <a:cs typeface="+mj-cs"/>
+              </a:defRPr>
+            </a:lvl1pPr>
+            <a:lvl2pPr eaLnBrk="1" hangingPunct="1">
+              <a:defRPr>
+                <a:solidFill>
+                  <a:schemeClr val="tx2"/>
+                </a:solidFill>
+              </a:defRPr>
+            </a:lvl2pPr>
+            <a:lvl3pPr eaLnBrk="1" hangingPunct="1">
+              <a:defRPr>
+                <a:solidFill>
+                  <a:schemeClr val="tx2"/>
+                </a:solidFill>
+              </a:defRPr>
+            </a:lvl3pPr>
+            <a:lvl4pPr eaLnBrk="1" hangingPunct="1">
+              <a:defRPr>
+                <a:solidFill>
+                  <a:schemeClr val="tx2"/>
+                </a:solidFill>
+              </a:defRPr>
+            </a:lvl4pPr>
+            <a:lvl5pPr eaLnBrk="1" hangingPunct="1">
+              <a:defRPr>
+                <a:solidFill>
+                  <a:schemeClr val="tx2"/>
+                </a:solidFill>
+              </a:defRPr>
+            </a:lvl5pPr>
+            <a:lvl6pPr eaLnBrk="1" hangingPunct="1">
+              <a:defRPr>
+                <a:solidFill>
+                  <a:schemeClr val="tx2"/>
+                </a:solidFill>
+              </a:defRPr>
+            </a:lvl6pPr>
+            <a:lvl7pPr eaLnBrk="1" hangingPunct="1">
+              <a:defRPr>
+                <a:solidFill>
+                  <a:schemeClr val="tx2"/>
+                </a:solidFill>
+              </a:defRPr>
+            </a:lvl7pPr>
+            <a:lvl8pPr eaLnBrk="1" hangingPunct="1">
+              <a:defRPr>
+                <a:solidFill>
+                  <a:schemeClr val="tx2"/>
+                </a:solidFill>
+              </a:defRPr>
+            </a:lvl8pPr>
+            <a:lvl9pPr eaLnBrk="1" hangingPunct="1">
+              <a:defRPr>
+                <a:solidFill>
+                  <a:schemeClr val="tx2"/>
+                </a:solidFill>
+              </a:defRPr>
+            </a:lvl9pPr>
+          </a:lstStyle>
+          <a:p>
+            <a:r>
+              <a:rPr lang="fr-FR" sz="4800" cap="none" dirty="0">
+                <a:solidFill>
+                  <a:srgbClr val="FF0000"/>
                 </a:solidFill>
               </a:rPr>
-              <a:t>Exigences technologiques</a:t>
-            </a:r>
-          </a:p>
-        </p:txBody>
-      </p:sp>
-      <p:graphicFrame>
-        <p:nvGraphicFramePr>
-          <p:cNvPr id="4" name="Espace réservé du contenu 3" descr="Graphique icône SmartArt">
+              <a:t>40%</a:t>
+            </a:r>
+            <a:r>
+              <a:rPr lang="fr-FR" cap="none" dirty="0">
+                <a:solidFill>
+                  <a:srgbClr val="FF0000"/>
+                </a:solidFill>
+              </a:rPr>
+              <a:t> des démissions chez les </a:t>
+            </a:r>
+            <a:r>
+              <a:rPr lang="fr-FR" u="sng" cap="none" dirty="0">
+                <a:solidFill>
+                  <a:srgbClr val="FF0000"/>
+                </a:solidFill>
+              </a:rPr>
+              <a:t>Représentants Commerciaux</a:t>
+            </a:r>
+          </a:p>
+        </p:txBody>
+      </p:sp>
+      <p:sp>
+        <p:nvSpPr>
+          <p:cNvPr id="18" name="ZoneTexte 17">
             <a:extLst>
               <a:ext uri="{FF2B5EF4-FFF2-40B4-BE49-F238E27FC236}">
-                <a16:creationId xmlns:a16="http://schemas.microsoft.com/office/drawing/2014/main" id="{81E592E1-99DF-4294-A2E9-EF46299BD3F4}"/>
+                <a16:creationId xmlns:a16="http://schemas.microsoft.com/office/drawing/2014/main" id="{B0BD638C-6081-6B05-3B36-010A31D628CB}"/>
               </a:ext>
             </a:extLst>
           </p:cNvPr>
-          <p:cNvGraphicFramePr>
-            <a:graphicFrameLocks noGrp="1"/>
-          </p:cNvGraphicFramePr>
-          <p:nvPr>
-            <p:ph idx="1"/>
-            <p:extLst>
-              <p:ext uri="{D42A27DB-BD31-4B8C-83A1-F6EECF244321}">
-                <p14:modId xmlns:p14="http://schemas.microsoft.com/office/powerpoint/2010/main" val="4223713530"/>
-              </p:ext>
-            </p:extLst>
-          </p:nvPr>
-        </p:nvGraphicFramePr>
-        <p:xfrm>
-          <a:off x="642938" y="858445"/>
-          <a:ext cx="10906125" cy="3961205"/>
-        </p:xfrm>
-        <a:graphic>
-          <a:graphicData uri="http://schemas.openxmlformats.org/drawingml/2006/diagram">
-            <dgm:relIds xmlns:dgm="http://schemas.openxmlformats.org/drawingml/2006/diagram" xmlns:r="http://schemas.openxmlformats.org/officeDocument/2006/relationships" r:dm="rId3" r:lo="rId4" r:qs="rId5" r:cs="rId6"/>
-          </a:graphicData>
-        </a:graphic>
-      </p:graphicFrame>
+          <p:cNvSpPr txBox="1"/>
+          <p:nvPr/>
+        </p:nvSpPr>
+        <p:spPr>
+          <a:xfrm>
+            <a:off x="5645059" y="832348"/>
+            <a:ext cx="5336120" cy="461665"/>
+          </a:xfrm>
+          <a:prstGeom prst="rect">
+            <a:avLst/>
+          </a:prstGeom>
+          <a:noFill/>
+        </p:spPr>
+        <p:txBody>
+          <a:bodyPr wrap="square">
+            <a:spAutoFit/>
+          </a:bodyPr>
+          <a:lstStyle/>
+          <a:p>
+            <a:r>
+              <a:rPr lang="fr-FR" sz="2400" cap="none" dirty="0"/>
+              <a:t>Exploration : Corrélations </a:t>
+            </a:r>
+          </a:p>
+        </p:txBody>
+      </p:sp>
+      <p:pic>
+        <p:nvPicPr>
+          <p:cNvPr id="20" name="Image 19">
+            <a:extLst>
+              <a:ext uri="{FF2B5EF4-FFF2-40B4-BE49-F238E27FC236}">
+                <a16:creationId xmlns:a16="http://schemas.microsoft.com/office/drawing/2014/main" id="{B3D15DF8-3B97-F7DD-058E-E925DC0347EA}"/>
+              </a:ext>
+            </a:extLst>
+          </p:cNvPr>
+          <p:cNvPicPr>
+            <a:picLocks noChangeAspect="1"/>
+          </p:cNvPicPr>
+          <p:nvPr/>
+        </p:nvPicPr>
+        <p:blipFill>
+          <a:blip r:embed="rId3"/>
+          <a:stretch>
+            <a:fillRect/>
+          </a:stretch>
+        </p:blipFill>
+        <p:spPr>
+          <a:xfrm>
+            <a:off x="447817" y="665951"/>
+            <a:ext cx="4981433" cy="5317061"/>
+          </a:xfrm>
+          <a:prstGeom prst="rect">
+            <a:avLst/>
+          </a:prstGeom>
+        </p:spPr>
+      </p:pic>
     </p:spTree>
     <p:extLst>
       <p:ext uri="{BB962C8B-B14F-4D97-AF65-F5344CB8AC3E}">
@@ -15060,9 +13158,23 @@
 <file path=ppt/slides/slide9.xml><?xml version="1.0" encoding="utf-8"?>
 <p:sld xmlns:a="http://schemas.openxmlformats.org/drawingml/2006/main" xmlns:r="http://schemas.openxmlformats.org/officeDocument/2006/relationships" xmlns:p="http://schemas.openxmlformats.org/presentationml/2006/main">
   <p:cSld>
+    <p:bg>
+      <p:bgPr>
+        <a:solidFill>
+          <a:schemeClr val="bg1"/>
+        </a:solidFill>
+        <a:effectLst/>
+      </p:bgPr>
+    </p:bg>
     <p:spTree>
       <p:nvGrpSpPr>
-        <p:cNvPr id="1" name=""/>
+        <p:cNvPr id="1" name="">
+          <a:extLst>
+            <a:ext uri="{FF2B5EF4-FFF2-40B4-BE49-F238E27FC236}">
+              <a16:creationId xmlns:a16="http://schemas.microsoft.com/office/drawing/2014/main" id="{637D91BC-2A87-779E-5258-A9E8BD4A10BF}"/>
+            </a:ext>
+          </a:extLst>
+        </p:cNvPr>
         <p:cNvGrpSpPr/>
         <p:nvPr/>
       </p:nvGrpSpPr>
@@ -15074,93 +13186,302 @@
           <a:chExt cx="0" cy="0"/>
         </a:xfrm>
       </p:grpSpPr>
-      <p:sp>
-        <p:nvSpPr>
-          <p:cNvPr id="2" name="Titre 1">
+      <p:sp useBgFill="1">
+        <p:nvSpPr>
+          <p:cNvPr id="29" name="Rectangle 28">
             <a:extLst>
               <a:ext uri="{FF2B5EF4-FFF2-40B4-BE49-F238E27FC236}">
-                <a16:creationId xmlns:a16="http://schemas.microsoft.com/office/drawing/2014/main" id="{921633EB-7DCB-4DDC-80AF-C885A3EE1245}"/>
+                <a16:creationId xmlns:a16="http://schemas.microsoft.com/office/drawing/2014/main" id="{EA4F88AF-2AF3-7515-EBBA-ACD303DCAD75}"/>
+              </a:ext>
+              <a:ext uri="{C183D7F6-B498-43B3-948B-1728B52AA6E4}">
+                <adec:decorative xmlns:adec="http://schemas.microsoft.com/office/drawing/2017/decorative" val="1"/>
               </a:ext>
             </a:extLst>
           </p:cNvPr>
           <p:cNvSpPr>
-            <a:spLocks noGrp="1"/>
+            <a:spLocks noGrp="1" noRot="1" noChangeAspect="1" noMove="1" noResize="1" noEditPoints="1" noAdjustHandles="1" noChangeArrowheads="1" noChangeShapeType="1"/>
           </p:cNvSpPr>
           <p:nvPr>
-            <p:ph type="title"/>
+            <p:extLst>
+              <p:ext uri="{386F3935-93C4-4BCD-93E2-E3B085C9AB24}">
+                <p16:designElem xmlns:p16="http://schemas.microsoft.com/office/powerpoint/2015/main" val="1"/>
+              </p:ext>
+            </p:extLst>
           </p:nvPr>
         </p:nvSpPr>
-        <p:spPr/>
-        <p:txBody>
-          <a:bodyPr rtlCol="0"/>
+        <p:spPr>
+          <a:xfrm>
+            <a:off x="0" y="536712"/>
+            <a:ext cx="12192000" cy="6321287"/>
+          </a:xfrm>
+          <a:prstGeom prst="rect">
+            <a:avLst/>
+          </a:prstGeom>
+          <a:ln>
+            <a:noFill/>
+          </a:ln>
+        </p:spPr>
+        <p:style>
+          <a:lnRef idx="2">
+            <a:schemeClr val="accent1">
+              <a:shade val="50000"/>
+            </a:schemeClr>
+          </a:lnRef>
+          <a:fillRef idx="1">
+            <a:schemeClr val="accent1"/>
+          </a:fillRef>
+          <a:effectRef idx="0">
+            <a:schemeClr val="accent1"/>
+          </a:effectRef>
+          <a:fontRef idx="minor">
+            <a:schemeClr val="lt1"/>
+          </a:fontRef>
+        </p:style>
+        <p:txBody>
+          <a:bodyPr rtlCol="0" anchor="ctr"/>
           <a:lstStyle/>
           <a:p>
-            <a:pPr rtl="0"/>
-            <a:r>
-              <a:rPr lang="fr-FR"/>
-              <a:t>Contexte concurrentiel</a:t>
+            <a:pPr algn="ctr" rtl="0"/>
+            <a:endParaRPr lang="fr-FR" dirty="0"/>
+          </a:p>
+        </p:txBody>
+      </p:sp>
+      <p:sp>
+        <p:nvSpPr>
+          <p:cNvPr id="31" name="Rectangle 30">
+            <a:extLst>
+              <a:ext uri="{FF2B5EF4-FFF2-40B4-BE49-F238E27FC236}">
+                <a16:creationId xmlns:a16="http://schemas.microsoft.com/office/drawing/2014/main" id="{EB30508F-D7DF-F9AD-6E2B-B67CD4D31CDA}"/>
+              </a:ext>
+              <a:ext uri="{C183D7F6-B498-43B3-948B-1728B52AA6E4}">
+                <adec:decorative xmlns:adec="http://schemas.microsoft.com/office/drawing/2017/decorative" val="1"/>
+              </a:ext>
+            </a:extLst>
+          </p:cNvPr>
+          <p:cNvSpPr>
+            <a:spLocks noGrp="1" noRot="1" noChangeAspect="1" noMove="1" noResize="1" noEditPoints="1" noAdjustHandles="1" noChangeArrowheads="1" noChangeShapeType="1"/>
+          </p:cNvSpPr>
+          <p:nvPr>
+            <p:extLst>
+              <p:ext uri="{386F3935-93C4-4BCD-93E2-E3B085C9AB24}">
+                <p16:designElem xmlns:p16="http://schemas.microsoft.com/office/powerpoint/2015/main" val="1"/>
+              </p:ext>
+            </p:extLst>
+          </p:nvPr>
+        </p:nvSpPr>
+        <p:spPr>
+          <a:xfrm>
+            <a:off x="447817" y="5141974"/>
+            <a:ext cx="11290860" cy="1258827"/>
+          </a:xfrm>
+          <a:prstGeom prst="rect">
+            <a:avLst/>
+          </a:prstGeom>
+          <a:solidFill>
+            <a:schemeClr val="accent1"/>
+          </a:solidFill>
+          <a:ln>
+            <a:noFill/>
+          </a:ln>
+          <a:effectLst/>
+        </p:spPr>
+        <p:style>
+          <a:lnRef idx="1">
+            <a:schemeClr val="accent1"/>
+          </a:lnRef>
+          <a:fillRef idx="3">
+            <a:schemeClr val="accent1"/>
+          </a:fillRef>
+          <a:effectRef idx="2">
+            <a:schemeClr val="accent1"/>
+          </a:effectRef>
+          <a:fontRef idx="minor">
+            <a:schemeClr val="lt1"/>
+          </a:fontRef>
+        </p:style>
+        <p:txBody>
+          <a:bodyPr/>
+          <a:lstStyle/>
+          <a:p>
+            <a:endParaRPr lang="fr-FR"/>
+          </a:p>
+        </p:txBody>
+      </p:sp>
+      <p:sp>
+        <p:nvSpPr>
+          <p:cNvPr id="16" name="Titre 1">
+            <a:extLst>
+              <a:ext uri="{FF2B5EF4-FFF2-40B4-BE49-F238E27FC236}">
+                <a16:creationId xmlns:a16="http://schemas.microsoft.com/office/drawing/2014/main" id="{61FF514C-3589-53E0-58F5-7F90B18B28D6}"/>
+              </a:ext>
+            </a:extLst>
+          </p:cNvPr>
+          <p:cNvSpPr txBox="1">
+            <a:spLocks/>
+          </p:cNvSpPr>
+          <p:nvPr/>
+        </p:nvSpPr>
+        <p:spPr>
+          <a:xfrm>
+            <a:off x="5645059" y="1790769"/>
+            <a:ext cx="5184866" cy="1427224"/>
+          </a:xfrm>
+          <a:prstGeom prst="rect">
+            <a:avLst/>
+          </a:prstGeom>
+        </p:spPr>
+        <p:txBody>
+          <a:bodyPr vert="horz" lIns="91440" tIns="45720" rIns="91440" bIns="45720" rtlCol="0" anchor="b">
+            <a:normAutofit fontScale="92500" lnSpcReduction="10000"/>
+          </a:bodyPr>
+          <a:lstStyle>
+            <a:lvl1pPr algn="l" defTabSz="457200" rtl="0" eaLnBrk="1" latinLnBrk="0" hangingPunct="1">
+              <a:spcBef>
+                <a:spcPct val="0"/>
+              </a:spcBef>
+              <a:buNone/>
+              <a:defRPr sz="2800" b="0" kern="1200" cap="all">
+                <a:solidFill>
+                  <a:schemeClr val="bg1"/>
+                </a:solidFill>
+                <a:latin typeface="+mj-lt"/>
+                <a:ea typeface="+mj-ea"/>
+                <a:cs typeface="+mj-cs"/>
+              </a:defRPr>
+            </a:lvl1pPr>
+            <a:lvl2pPr eaLnBrk="1" hangingPunct="1">
+              <a:defRPr>
+                <a:solidFill>
+                  <a:schemeClr val="tx2"/>
+                </a:solidFill>
+              </a:defRPr>
+            </a:lvl2pPr>
+            <a:lvl3pPr eaLnBrk="1" hangingPunct="1">
+              <a:defRPr>
+                <a:solidFill>
+                  <a:schemeClr val="tx2"/>
+                </a:solidFill>
+              </a:defRPr>
+            </a:lvl3pPr>
+            <a:lvl4pPr eaLnBrk="1" hangingPunct="1">
+              <a:defRPr>
+                <a:solidFill>
+                  <a:schemeClr val="tx2"/>
+                </a:solidFill>
+              </a:defRPr>
+            </a:lvl4pPr>
+            <a:lvl5pPr eaLnBrk="1" hangingPunct="1">
+              <a:defRPr>
+                <a:solidFill>
+                  <a:schemeClr val="tx2"/>
+                </a:solidFill>
+              </a:defRPr>
+            </a:lvl5pPr>
+            <a:lvl6pPr eaLnBrk="1" hangingPunct="1">
+              <a:defRPr>
+                <a:solidFill>
+                  <a:schemeClr val="tx2"/>
+                </a:solidFill>
+              </a:defRPr>
+            </a:lvl6pPr>
+            <a:lvl7pPr eaLnBrk="1" hangingPunct="1">
+              <a:defRPr>
+                <a:solidFill>
+                  <a:schemeClr val="tx2"/>
+                </a:solidFill>
+              </a:defRPr>
+            </a:lvl7pPr>
+            <a:lvl8pPr eaLnBrk="1" hangingPunct="1">
+              <a:defRPr>
+                <a:solidFill>
+                  <a:schemeClr val="tx2"/>
+                </a:solidFill>
+              </a:defRPr>
+            </a:lvl8pPr>
+            <a:lvl9pPr eaLnBrk="1" hangingPunct="1">
+              <a:defRPr>
+                <a:solidFill>
+                  <a:schemeClr val="tx2"/>
+                </a:solidFill>
+              </a:defRPr>
+            </a:lvl9pPr>
+          </a:lstStyle>
+          <a:p>
+            <a:r>
+              <a:rPr lang="fr-FR" sz="4800" cap="none" dirty="0">
+                <a:solidFill>
+                  <a:srgbClr val="FF0000"/>
+                </a:solidFill>
+              </a:rPr>
+              <a:t>Les postes les plus concernés</a:t>
+            </a:r>
+            <a:endParaRPr lang="fr-FR" u="sng" cap="none" dirty="0">
+              <a:solidFill>
+                <a:srgbClr val="FF0000"/>
+              </a:solidFill>
+            </a:endParaRPr>
+          </a:p>
+        </p:txBody>
+      </p:sp>
+      <p:sp>
+        <p:nvSpPr>
+          <p:cNvPr id="18" name="ZoneTexte 17">
+            <a:extLst>
+              <a:ext uri="{FF2B5EF4-FFF2-40B4-BE49-F238E27FC236}">
+                <a16:creationId xmlns:a16="http://schemas.microsoft.com/office/drawing/2014/main" id="{5AC1AEB7-D60E-5E65-96CE-B822593C1567}"/>
+              </a:ext>
+            </a:extLst>
+          </p:cNvPr>
+          <p:cNvSpPr txBox="1"/>
+          <p:nvPr/>
+        </p:nvSpPr>
+        <p:spPr>
+          <a:xfrm>
+            <a:off x="5645059" y="832348"/>
+            <a:ext cx="5336120" cy="461665"/>
+          </a:xfrm>
+          <a:prstGeom prst="rect">
+            <a:avLst/>
+          </a:prstGeom>
+          <a:noFill/>
+        </p:spPr>
+        <p:txBody>
+          <a:bodyPr wrap="square">
+            <a:spAutoFit/>
+          </a:bodyPr>
+          <a:lstStyle/>
+          <a:p>
+            <a:r>
+              <a:rPr lang="fr-FR" sz="2400" cap="none" dirty="0"/>
+              <a:t>Exploration : Corrélations </a:t>
             </a:r>
           </a:p>
         </p:txBody>
       </p:sp>
       <p:pic>
         <p:nvPicPr>
-          <p:cNvPr id="11" name="Espace réservé du contenu 4" descr="Graphiques">
+          <p:cNvPr id="9" name="Image 8">
             <a:extLst>
               <a:ext uri="{FF2B5EF4-FFF2-40B4-BE49-F238E27FC236}">
-                <a16:creationId xmlns:a16="http://schemas.microsoft.com/office/drawing/2014/main" id="{47D9BE16-119C-43B2-9AE6-18C4A150C0EF}"/>
+                <a16:creationId xmlns:a16="http://schemas.microsoft.com/office/drawing/2014/main" id="{3FC2BB6D-6F45-8FDB-F8B4-D3F38F116A03}"/>
               </a:ext>
             </a:extLst>
           </p:cNvPr>
           <p:cNvPicPr>
-            <a:picLocks noGrp="1" noChangeAspect="1"/>
+            <a:picLocks noChangeAspect="1"/>
           </p:cNvPicPr>
-          <p:nvPr>
-            <p:ph sz="half" idx="1"/>
-          </p:nvPr>
+          <p:nvPr/>
         </p:nvPicPr>
-        <p:blipFill rotWithShape="1">
-          <a:blip r:embed="rId3" cstate="screen">
-            <a:extLst>
-              <a:ext uri="{28A0092B-C50C-407E-A947-70E740481C1C}">
-                <a14:useLocalDpi xmlns:a14="http://schemas.microsoft.com/office/drawing/2010/main"/>
-              </a:ext>
-            </a:extLst>
-          </a:blip>
-          <a:stretch/>
+        <p:blipFill>
+          <a:blip r:embed="rId3"/>
+          <a:stretch>
+            <a:fillRect/>
+          </a:stretch>
         </p:blipFill>
         <p:spPr>
           <a:xfrm>
-            <a:off x="581025" y="2231480"/>
-            <a:ext cx="5422900" cy="3625353"/>
-          </a:xfrm>
-        </p:spPr>
-      </p:pic>
-      <p:pic>
-        <p:nvPicPr>
-          <p:cNvPr id="18" name="Espace réservé du contenu 17" descr="Espace réservé au graphique">
-            <a:extLst>
-              <a:ext uri="{FF2B5EF4-FFF2-40B4-BE49-F238E27FC236}">
-                <a16:creationId xmlns:a16="http://schemas.microsoft.com/office/drawing/2014/main" id="{BFEA8EC1-23A4-4843-A9C3-AE771D73392A}"/>
-              </a:ext>
-            </a:extLst>
-          </p:cNvPr>
-          <p:cNvPicPr>
-            <a:picLocks noGrp="1" noChangeAspect="1"/>
-          </p:cNvPicPr>
-          <p:nvPr>
-            <p:ph sz="half" idx="2"/>
-          </p:nvPr>
-        </p:nvPicPr>
-        <p:blipFill>
-          <a:blip r:embed="rId4"/>
-          <a:srcRect/>
-          <a:stretch/>
-        </p:blipFill>
-        <p:spPr>
-          <a:xfrm>
-            <a:off x="6201812" y="2571845"/>
-            <a:ext cx="5395426" cy="2944623"/>
+            <a:off x="691819" y="832348"/>
+            <a:ext cx="4721048" cy="5054102"/>
           </a:xfrm>
           <a:prstGeom prst="rect">
             <a:avLst/>
@@ -15170,7 +13491,7 @@
     </p:spTree>
     <p:extLst>
       <p:ext uri="{BB962C8B-B14F-4D97-AF65-F5344CB8AC3E}">
-        <p14:creationId xmlns:p14="http://schemas.microsoft.com/office/powerpoint/2010/main" val="497607547"/>
+        <p14:creationId xmlns:p14="http://schemas.microsoft.com/office/powerpoint/2010/main" val="3872737980"/>
       </p:ext>
     </p:extLst>
   </p:cSld>

</xml_diff>

<commit_message>
Corrections basées sur les remarques de l'évaluation
</commit_message>
<xml_diff>
--- a/Presentation.pptx
+++ b/Presentation.pptx
@@ -5,10 +5,10 @@
     <p:sldMasterId id="2147483672" r:id="rId1"/>
   </p:sldMasterIdLst>
   <p:notesMasterIdLst>
-    <p:notesMasterId r:id="rId45"/>
+    <p:notesMasterId r:id="rId48"/>
   </p:notesMasterIdLst>
   <p:handoutMasterIdLst>
-    <p:handoutMasterId r:id="rId46"/>
+    <p:handoutMasterId r:id="rId49"/>
   </p:handoutMasterIdLst>
   <p:sldIdLst>
     <p:sldId id="256" r:id="rId2"/>
@@ -50,10 +50,13 @@
     <p:sldId id="290" r:id="rId38"/>
     <p:sldId id="289" r:id="rId39"/>
     <p:sldId id="304" r:id="rId40"/>
-    <p:sldId id="291" r:id="rId41"/>
-    <p:sldId id="293" r:id="rId42"/>
+    <p:sldId id="314" r:id="rId41"/>
+    <p:sldId id="291" r:id="rId42"/>
     <p:sldId id="268" r:id="rId43"/>
-    <p:sldId id="260" r:id="rId44"/>
+    <p:sldId id="313" r:id="rId44"/>
+    <p:sldId id="315" r:id="rId45"/>
+    <p:sldId id="316" r:id="rId46"/>
+    <p:sldId id="260" r:id="rId47"/>
   </p:sldIdLst>
   <p:sldSz cx="12192000" cy="6858000"/>
   <p:notesSz cx="6858000" cy="9144000"/>
@@ -259,7 +262,7 @@
             <a:pPr rtl="0"/>
             <a:fld id="{43367168-A7C3-4A51-ACFE-4D76B720982F}" type="datetime1">
               <a:rPr lang="fr-FR" smtClean="0"/>
-              <a:t>19/06/2026</a:t>
+              <a:t>20/06/2026</a:t>
             </a:fld>
             <a:endParaRPr lang="fr-FR"/>
           </a:p>
@@ -441,7 +444,7 @@
             <a:pPr rtl="0"/>
             <a:fld id="{CB4F1169-1988-463B-A52C-EF5C9A50040C}" type="datetime1">
               <a:rPr lang="fr-FR" noProof="0" smtClean="0"/>
-              <a:t>19/06/2026</a:t>
+              <a:t>20/06/2026</a:t>
             </a:fld>
             <a:endParaRPr lang="fr-FR" noProof="0"/>
           </a:p>
@@ -3595,7 +3598,7 @@
             </a:r>
             <a:r>
               <a:rPr lang="fr-FR" dirty="0"/>
-              <a:t>=&gt; les réussites et les loupés</a:t>
+              <a:t>=&gt; les vrais et fausses prédictions</a:t>
             </a:r>
           </a:p>
           <a:p>
@@ -4530,32 +4533,7 @@
           <a:p>
             <a:r>
               <a:rPr lang="fr-FR" dirty="0"/>
-              <a:t>Pour ne pas louper de faux-positifs</a:t>
-            </a:r>
-          </a:p>
-          <a:p>
-            <a:endParaRPr lang="fr-FR" dirty="0"/>
-          </a:p>
-          <a:p>
-            <a:r>
-              <a:rPr lang="fr-FR" dirty="0"/>
-              <a:t>objectif semble être de </a:t>
-            </a:r>
-            <a:r>
-              <a:rPr lang="fr-FR" b="1" dirty="0"/>
-              <a:t>ne pas manquer les employés susceptibles de partir</a:t>
-            </a:r>
-            <a:r>
-              <a:rPr lang="fr-FR" dirty="0"/>
-              <a:t>, il serait intéressant de rechercher un seuil qui maximise le </a:t>
-            </a:r>
-            <a:r>
-              <a:rPr lang="fr-FR" dirty="0" err="1"/>
-              <a:t>recall</a:t>
-            </a:r>
-            <a:r>
-              <a:rPr lang="fr-FR" dirty="0"/>
-              <a:t> tout en gardant un nombre raisonnable de faux positifs.</a:t>
+              <a:t>Pour minimiser les faux-négatifs idéal dans un cas de démissions RH</a:t>
             </a:r>
           </a:p>
         </p:txBody>
@@ -4660,31 +4638,7 @@
             </a:pPr>
             <a:r>
               <a:rPr lang="fr-FR" dirty="0"/>
-              <a:t>le meilleur modèle est la </a:t>
-            </a:r>
-            <a:r>
-              <a:rPr lang="fr-FR" dirty="0" err="1"/>
-              <a:t>LogisticRegression</a:t>
-            </a:r>
-            <a:r>
-              <a:rPr lang="fr-FR" dirty="0"/>
-              <a:t> qui affiche un meilleur taux de </a:t>
-            </a:r>
-            <a:r>
-              <a:rPr lang="fr-FR" dirty="0" err="1"/>
-              <a:t>recall</a:t>
-            </a:r>
-            <a:r>
-              <a:rPr lang="fr-FR" dirty="0"/>
-              <a:t> (Idéal dans notre </a:t>
-            </a:r>
-            <a:r>
-              <a:rPr lang="fr-FR" dirty="0" err="1"/>
-              <a:t>problèmatique</a:t>
-            </a:r>
-            <a:r>
-              <a:rPr lang="fr-FR" dirty="0"/>
-              <a:t> métier)</a:t>
+              <a:t>Les deux modèles supervisés apportent une réelle amélioration par rapport au modèle de référence</a:t>
             </a:r>
           </a:p>
           <a:p>
@@ -4693,26 +4647,40 @@
               <a:buChar char="•"/>
             </a:pPr>
             <a:r>
+              <a:rPr lang="fr-FR" dirty="0"/>
+              <a:t>La régression logistique obtient les meilleures performances globales avec une AUC de 0,87 et un meilleur compromis entre précision et rappel</a:t>
+            </a:r>
+          </a:p>
+          <a:p>
+            <a:pPr marL="171450" indent="-171450">
+              <a:buFont typeface="Arial" panose="020B0604020202020204" pitchFamily="34" charset="0"/>
+              <a:buChar char="•"/>
+            </a:pPr>
+            <a:r>
               <a:rPr lang="fr-FR" dirty="0" err="1"/>
               <a:t>XGBoost</a:t>
             </a:r>
             <a:r>
               <a:rPr lang="fr-FR" dirty="0"/>
-              <a:t> affiche des résultats similaires mais inversement proportionnel </a:t>
-            </a:r>
-            <a:r>
-              <a:rPr lang="fr-FR" dirty="0" err="1"/>
-              <a:t>precision</a:t>
-            </a:r>
+              <a:t> présente cependant un rappel supérieur, ce qui lui permet d’identifier davantage de départs potentiels, au prix d’un nombre plus important de faux positifs.</a:t>
+            </a:r>
+          </a:p>
+          <a:p>
+            <a:pPr marL="171450" indent="-171450">
+              <a:buFont typeface="Arial" panose="020B0604020202020204" pitchFamily="34" charset="0"/>
+              <a:buChar char="•"/>
+            </a:pPr>
+            <a:endParaRPr lang="fr-FR" dirty="0"/>
+          </a:p>
+          <a:p>
+            <a:pPr marL="0" indent="0">
+              <a:buFont typeface="Arial" panose="020B0604020202020204" pitchFamily="34" charset="0"/>
+              <a:buNone/>
+            </a:pPr>
             <a:r>
               <a:rPr lang="fr-FR" dirty="0"/>
-              <a:t>/</a:t>
-            </a:r>
-            <a:r>
-              <a:rPr lang="fr-FR" dirty="0" err="1"/>
-              <a:t>recall</a:t>
-            </a:r>
-            <a:endParaRPr lang="fr-FR" dirty="0"/>
+              <a:t>Le choix final dépend de la stratégie métier : privilégier la fiabilité des alertes ou maximiser la détection des situations à risque.</a:t>
+            </a:r>
           </a:p>
         </p:txBody>
       </p:sp>
@@ -4806,138 +4774,55 @@
           <a:p>
             <a:r>
               <a:rPr lang="fr-FR" dirty="0"/>
-              <a:t>Le modèle le tranche pas idéalement entre 0 ou 1 mais hésite dans la distribution des probabilités.</a:t>
+              <a:t>il est utile de compléter l’analyse précédente par la </a:t>
+            </a:r>
+            <a:r>
+              <a:rPr lang="fr-FR" b="1" dirty="0"/>
+              <a:t>matrice de confusion de chaque modèle</a:t>
+            </a:r>
+          </a:p>
+          <a:p>
+            <a:r>
+              <a:rPr lang="fr-FR" b="0" dirty="0"/>
+              <a:t>l</a:t>
+            </a:r>
+            <a:r>
+              <a:rPr lang="fr-FR" dirty="0"/>
+              <a:t>es valeurs des faux positifs et faux négatifs permettent de voir combien ils représentent concrètement.</a:t>
             </a:r>
           </a:p>
           <a:p>
             <a:endParaRPr lang="fr-FR" dirty="0"/>
           </a:p>
           <a:p>
+            <a:endParaRPr lang="fr-FR" dirty="0"/>
+          </a:p>
+          <a:p>
+            <a:pPr marL="171450" indent="-171450">
+              <a:buFont typeface="Arial" panose="020B0604020202020204" pitchFamily="34" charset="0"/>
+              <a:buChar char="•"/>
+            </a:pPr>
+            <a:r>
+              <a:rPr lang="fr-FR" dirty="0" err="1"/>
+              <a:t>LogisticRegression</a:t>
+            </a:r>
             <a:r>
               <a:rPr lang="fr-FR" dirty="0"/>
-              <a:t>Le modèle est </a:t>
-            </a:r>
-            <a:r>
-              <a:rPr lang="fr-FR" b="1" dirty="0"/>
-              <a:t>bon pour détecter les départs</a:t>
+              <a:t> génère peu de fausses alertes, ce qui signifie que les salariés identifiés comme à risque présentent une probabilité élevée d’être réellement concernés. En revanche, le modèle ne détecte pas tous les départs potentiels.</a:t>
+            </a:r>
+          </a:p>
+          <a:p>
+            <a:pPr marL="171450" indent="-171450">
+              <a:buFont typeface="Arial" panose="020B0604020202020204" pitchFamily="34" charset="0"/>
+              <a:buChar char="•"/>
+            </a:pPr>
+            <a:r>
+              <a:rPr lang="fr-FR" dirty="0" err="1"/>
+              <a:t>XGBoost</a:t>
             </a:r>
             <a:r>
               <a:rPr lang="fr-FR" dirty="0"/>
-              <a:t> : seulement 9 départs manqués sur 39. (</a:t>
-            </a:r>
-            <a:r>
-              <a:rPr lang="fr-FR" dirty="0" err="1"/>
-              <a:t>Recall</a:t>
-            </a:r>
-            <a:r>
-              <a:rPr lang="fr-FR" dirty="0"/>
-              <a:t> proche de 77 %.)</a:t>
-            </a:r>
-          </a:p>
-          <a:p>
-            <a:r>
-              <a:rPr lang="fr-FR" dirty="0"/>
-              <a:t>Le modèle est </a:t>
-            </a:r>
-            <a:r>
-              <a:rPr lang="fr-FR" b="1" dirty="0"/>
-              <a:t>moins bon pour cibler précisément les personnes à risque</a:t>
-            </a:r>
-            <a:r>
-              <a:rPr lang="fr-FR" dirty="0"/>
-              <a:t> : 52 alertes sur 82 sont des faux positifs.</a:t>
-            </a:r>
-          </a:p>
-          <a:p>
-            <a:endParaRPr lang="fr-FR" dirty="0"/>
-          </a:p>
-          <a:p>
-            <a:endParaRPr lang="fr-FR" dirty="0"/>
-          </a:p>
-          <a:p>
-            <a:r>
-              <a:rPr lang="fr-FR" dirty="0"/>
-              <a:t>TP = 28  , les employés qui ont réellement quitté l'entreprise et que le modèle a correctement identifiés.</a:t>
-            </a:r>
-          </a:p>
-          <a:p>
-            <a:endParaRPr lang="fr-FR" dirty="0"/>
-          </a:p>
-          <a:p>
-            <a:r>
-              <a:rPr lang="fr-FR" dirty="0"/>
-              <a:t>FN = 11 , les employés qui ont quitté l'entreprise mais que le modèle avait classés comme restant.</a:t>
-            </a:r>
-          </a:p>
-          <a:p>
-            <a:endParaRPr lang="fr-FR" dirty="0"/>
-          </a:p>
-          <a:p>
-            <a:r>
-              <a:rPr lang="fr-FR" dirty="0"/>
-              <a:t>FP = 26  , les employés prédits comme partants alors qu'ils sont finalement restés.</a:t>
-            </a:r>
-          </a:p>
-          <a:p>
-            <a:endParaRPr lang="fr-FR" dirty="0"/>
-          </a:p>
-          <a:p>
-            <a:r>
-              <a:rPr lang="fr-FR" dirty="0"/>
-              <a:t>TN = 153 , les employés restés dans l'entreprise et correctement identifiés.</a:t>
-            </a:r>
-          </a:p>
-          <a:p>
-            <a:endParaRPr lang="fr-FR" dirty="0"/>
-          </a:p>
-          <a:p>
-            <a:endParaRPr lang="fr-FR" dirty="0"/>
-          </a:p>
-          <a:p>
-            <a:endParaRPr lang="fr-FR" dirty="0"/>
-          </a:p>
-          <a:p>
-            <a:r>
-              <a:rPr lang="fr-FR" dirty="0"/>
-              <a:t>Cette courbe ROC permet d'évaluer la capacité de ton modèle à </a:t>
-            </a:r>
-            <a:r>
-              <a:rPr lang="fr-FR" b="1" dirty="0"/>
-              <a:t>séparer les employés qui quittent l'entreprise (</a:t>
-            </a:r>
-            <a:r>
-              <a:rPr lang="fr-FR" sz="1200" b="1" kern="1200" dirty="0">
-                <a:solidFill>
-                  <a:schemeClr val="tx1"/>
-                </a:solidFill>
-                <a:latin typeface="+mn-lt"/>
-                <a:ea typeface="+mn-ea"/>
-                <a:cs typeface="+mn-cs"/>
-              </a:rPr>
-              <a:t>1</a:t>
-            </a:r>
-            <a:r>
-              <a:rPr lang="fr-FR" b="1" dirty="0"/>
-              <a:t>) de ceux qui restent (</a:t>
-            </a:r>
-            <a:r>
-              <a:rPr lang="fr-FR" sz="1200" b="1" kern="1200" dirty="0">
-                <a:solidFill>
-                  <a:schemeClr val="tx1"/>
-                </a:solidFill>
-                <a:latin typeface="+mn-lt"/>
-                <a:ea typeface="+mn-ea"/>
-                <a:cs typeface="+mn-cs"/>
-              </a:rPr>
-              <a:t>0</a:t>
-            </a:r>
-            <a:r>
-              <a:rPr lang="fr-FR" b="1" dirty="0"/>
-              <a:t>)</a:t>
-            </a:r>
-            <a:r>
-              <a:rPr lang="fr-FR" dirty="0"/>
-              <a:t>, indépendamment du seuil de décision choisi.</a:t>
+              <a:t> maximise la détection des départs potentiels avec un rappel très élevé. En contrepartie, il identifie davantage de salariés comme à risque alors qu’ils ne quitteront finalement pas l’entreprise.</a:t>
             </a:r>
           </a:p>
         </p:txBody>
@@ -4984,7 +4869,13 @@
   <p:cSld>
     <p:spTree>
       <p:nvGrpSpPr>
-        <p:cNvPr id="1" name=""/>
+        <p:cNvPr id="1" name="">
+          <a:extLst>
+            <a:ext uri="{FF2B5EF4-FFF2-40B4-BE49-F238E27FC236}">
+              <a16:creationId xmlns:a16="http://schemas.microsoft.com/office/drawing/2014/main" id="{87D15C25-228B-8785-1328-76CF45DD24E1}"/>
+            </a:ext>
+          </a:extLst>
+        </p:cNvPr>
         <p:cNvGrpSpPr/>
         <p:nvPr/>
       </p:nvGrpSpPr>
@@ -4998,7 +4889,13 @@
       </p:grpSpPr>
       <p:sp>
         <p:nvSpPr>
-          <p:cNvPr id="2" name="Espace réservé de l'image des diapositives 1"/>
+          <p:cNvPr id="2" name="Espace réservé de l'image des diapositives 1">
+            <a:extLst>
+              <a:ext uri="{FF2B5EF4-FFF2-40B4-BE49-F238E27FC236}">
+                <a16:creationId xmlns:a16="http://schemas.microsoft.com/office/drawing/2014/main" id="{FF23AE19-236C-F250-6248-0A646DE85D62}"/>
+              </a:ext>
+            </a:extLst>
+          </p:cNvPr>
           <p:cNvSpPr>
             <a:spLocks noGrp="1" noRot="1" noChangeAspect="1"/>
           </p:cNvSpPr>
@@ -5017,7 +4914,13 @@
       </p:sp>
       <p:sp>
         <p:nvSpPr>
-          <p:cNvPr id="3" name="Espace réservé des notes 2"/>
+          <p:cNvPr id="3" name="Espace réservé des notes 2">
+            <a:extLst>
+              <a:ext uri="{FF2B5EF4-FFF2-40B4-BE49-F238E27FC236}">
+                <a16:creationId xmlns:a16="http://schemas.microsoft.com/office/drawing/2014/main" id="{643F74D9-E560-68F8-5F16-7D7DA451E5F6}"/>
+              </a:ext>
+            </a:extLst>
+          </p:cNvPr>
           <p:cNvSpPr>
             <a:spLocks noGrp="1"/>
           </p:cNvSpPr>
@@ -5030,37 +4933,33 @@
           <a:bodyPr/>
           <a:lstStyle/>
           <a:p>
+            <a:endParaRPr lang="fr-FR" dirty="0"/>
+          </a:p>
+          <a:p>
             <a:r>
               <a:rPr lang="fr-FR" dirty="0"/>
-              <a:t>Les heures supplémentaire marquent très nettement les départs liés, 100% des départs réalisés des heures sup.</a:t>
-            </a:r>
-          </a:p>
-          <a:p>
+              <a:t>Pour un usage RH de prévention des départs, </a:t>
+            </a:r>
+            <a:r>
+              <a:rPr lang="fr-FR" dirty="0" err="1"/>
+              <a:t>XGBoost</a:t>
+            </a:r>
             <a:r>
               <a:rPr lang="fr-FR" dirty="0"/>
-              <a:t>Les revenus mensuels sont plus contrastés mais joue un rôle important</a:t>
-            </a:r>
-          </a:p>
-          <a:p>
-            <a:endParaRPr lang="fr-FR" dirty="0"/>
-          </a:p>
-          <a:p>
-            <a:r>
-              <a:rPr lang="fr-FR" dirty="0"/>
-              <a:t>Bleu = valeur basse</a:t>
-            </a:r>
-          </a:p>
-          <a:p>
-            <a:r>
-              <a:rPr lang="fr-FR" dirty="0"/>
-              <a:t>Rouge = valeur haute</a:t>
-            </a:r>
-          </a:p>
-        </p:txBody>
-      </p:sp>
-      <p:sp>
-        <p:nvSpPr>
-          <p:cNvPr id="4" name="Espace réservé du numéro de diapositive 3"/>
+              <a:t> semble généralement plus intéressant car un faux négatif (ne pas accompagner un salarié réellement en risque de départ) peut être plus coûteux </a:t>
+            </a:r>
+          </a:p>
+        </p:txBody>
+      </p:sp>
+      <p:sp>
+        <p:nvSpPr>
+          <p:cNvPr id="4" name="Espace réservé du numéro de diapositive 3">
+            <a:extLst>
+              <a:ext uri="{FF2B5EF4-FFF2-40B4-BE49-F238E27FC236}">
+                <a16:creationId xmlns:a16="http://schemas.microsoft.com/office/drawing/2014/main" id="{64BD9169-65B7-90B3-713F-AC77BAFF48B5}"/>
+              </a:ext>
+            </a:extLst>
+          </p:cNvPr>
           <p:cNvSpPr>
             <a:spLocks noGrp="1"/>
           </p:cNvSpPr>
@@ -5085,7 +4984,7 @@
     </p:spTree>
     <p:extLst>
       <p:ext uri="{BB962C8B-B14F-4D97-AF65-F5344CB8AC3E}">
-        <p14:creationId xmlns:p14="http://schemas.microsoft.com/office/powerpoint/2010/main" val="2968093594"/>
+        <p14:creationId xmlns:p14="http://schemas.microsoft.com/office/powerpoint/2010/main" val="2321014910"/>
       </p:ext>
     </p:extLst>
   </p:cSld>
@@ -5100,13 +4999,7 @@
   <p:cSld>
     <p:spTree>
       <p:nvGrpSpPr>
-        <p:cNvPr id="1" name="">
-          <a:extLst>
-            <a:ext uri="{FF2B5EF4-FFF2-40B4-BE49-F238E27FC236}">
-              <a16:creationId xmlns:a16="http://schemas.microsoft.com/office/drawing/2014/main" id="{02165B04-F66D-DCED-B6D2-4CA699C3DABF}"/>
-            </a:ext>
-          </a:extLst>
-        </p:cNvPr>
+        <p:cNvPr id="1" name=""/>
         <p:cNvGrpSpPr/>
         <p:nvPr/>
       </p:nvGrpSpPr>
@@ -5120,13 +5013,7 @@
       </p:grpSpPr>
       <p:sp>
         <p:nvSpPr>
-          <p:cNvPr id="2" name="Espace réservé de l'image des diapositives 1">
-            <a:extLst>
-              <a:ext uri="{FF2B5EF4-FFF2-40B4-BE49-F238E27FC236}">
-                <a16:creationId xmlns:a16="http://schemas.microsoft.com/office/drawing/2014/main" id="{E43D558A-C96B-1EDB-3468-AE294F5A0DB0}"/>
-              </a:ext>
-            </a:extLst>
-          </p:cNvPr>
+          <p:cNvPr id="2" name="Espace réservé de l'image des diapositives 1"/>
           <p:cNvSpPr>
             <a:spLocks noGrp="1" noRot="1" noChangeAspect="1"/>
           </p:cNvSpPr>
@@ -5145,13 +5032,7 @@
       </p:sp>
       <p:sp>
         <p:nvSpPr>
-          <p:cNvPr id="3" name="Espace réservé des notes 2">
-            <a:extLst>
-              <a:ext uri="{FF2B5EF4-FFF2-40B4-BE49-F238E27FC236}">
-                <a16:creationId xmlns:a16="http://schemas.microsoft.com/office/drawing/2014/main" id="{8FA87FC6-1571-34A5-CA93-2BB7AC0E32A8}"/>
-              </a:ext>
-            </a:extLst>
-          </p:cNvPr>
+          <p:cNvPr id="3" name="Espace réservé des notes 2"/>
           <p:cNvSpPr>
             <a:spLocks noGrp="1"/>
           </p:cNvSpPr>
@@ -5166,26 +5047,39 @@
           <a:p>
             <a:r>
               <a:rPr lang="fr-FR" dirty="0"/>
-              <a:t>Les heures supplémentaire marquent très nettement les départs liés, 100% des départs réalisés des heures sup.</a:t>
-            </a:r>
+              <a:t>Selon notre modèle, l’importance global des variables qui influe le plus sur les prédictions sont: </a:t>
+            </a:r>
+            <a:r>
+              <a:rPr lang="fr-FR" b="1" dirty="0"/>
+              <a:t>participations, heures sup, pression et revenus</a:t>
+            </a:r>
+          </a:p>
+          <a:p>
+            <a:endParaRPr lang="fr-FR" dirty="0"/>
+          </a:p>
+          <a:p>
+            <a:endParaRPr lang="fr-FR" dirty="0"/>
+          </a:p>
+          <a:p>
+            <a:endParaRPr lang="fr-FR" dirty="0"/>
           </a:p>
           <a:p>
             <a:r>
               <a:rPr lang="fr-FR" dirty="0"/>
-              <a:t>Les revenus mensuels sont plus contrastés mais joue un rôle important</a:t>
-            </a:r>
-          </a:p>
-        </p:txBody>
-      </p:sp>
-      <p:sp>
-        <p:nvSpPr>
-          <p:cNvPr id="4" name="Espace réservé du numéro de diapositive 3">
-            <a:extLst>
-              <a:ext uri="{FF2B5EF4-FFF2-40B4-BE49-F238E27FC236}">
-                <a16:creationId xmlns:a16="http://schemas.microsoft.com/office/drawing/2014/main" id="{D12FF07F-D2E4-57F1-EEB2-0E9BD461BAFB}"/>
-              </a:ext>
-            </a:extLst>
-          </p:cNvPr>
+              <a:t>Bleu = valeur basse</a:t>
+            </a:r>
+          </a:p>
+          <a:p>
+            <a:r>
+              <a:rPr lang="fr-FR" dirty="0"/>
+              <a:t>Rouge = valeur haute</a:t>
+            </a:r>
+          </a:p>
+        </p:txBody>
+      </p:sp>
+      <p:sp>
+        <p:nvSpPr>
+          <p:cNvPr id="4" name="Espace réservé du numéro de diapositive 3"/>
           <p:cNvSpPr>
             <a:spLocks noGrp="1"/>
           </p:cNvSpPr>
@@ -5210,7 +5104,7 @@
     </p:spTree>
     <p:extLst>
       <p:ext uri="{BB962C8B-B14F-4D97-AF65-F5344CB8AC3E}">
-        <p14:creationId xmlns:p14="http://schemas.microsoft.com/office/powerpoint/2010/main" val="932827959"/>
+        <p14:creationId xmlns:p14="http://schemas.microsoft.com/office/powerpoint/2010/main" val="2968093594"/>
       </p:ext>
     </p:extLst>
   </p:cSld>
@@ -5367,6 +5261,91 @@
       </p:grpSpPr>
       <p:sp>
         <p:nvSpPr>
+          <p:cNvPr id="2" name="Espace réservé de l'image des diapositives 1"/>
+          <p:cNvSpPr>
+            <a:spLocks noGrp="1" noRot="1" noChangeAspect="1"/>
+          </p:cNvSpPr>
+          <p:nvPr>
+            <p:ph type="sldImg"/>
+          </p:nvPr>
+        </p:nvSpPr>
+        <p:spPr/>
+      </p:sp>
+      <p:sp>
+        <p:nvSpPr>
+          <p:cNvPr id="3" name="Espace réservé des notes 2"/>
+          <p:cNvSpPr>
+            <a:spLocks noGrp="1"/>
+          </p:cNvSpPr>
+          <p:nvPr>
+            <p:ph type="body" idx="1"/>
+          </p:nvPr>
+        </p:nvSpPr>
+        <p:spPr/>
+        <p:txBody>
+          <a:bodyPr/>
+          <a:lstStyle/>
+          <a:p>
+            <a:endParaRPr lang="fr-FR" dirty="0"/>
+          </a:p>
+        </p:txBody>
+      </p:sp>
+      <p:sp>
+        <p:nvSpPr>
+          <p:cNvPr id="4" name="Espace réservé du numéro de diapositive 3"/>
+          <p:cNvSpPr>
+            <a:spLocks noGrp="1"/>
+          </p:cNvSpPr>
+          <p:nvPr>
+            <p:ph type="sldNum" sz="quarter" idx="5"/>
+          </p:nvPr>
+        </p:nvSpPr>
+        <p:spPr/>
+        <p:txBody>
+          <a:bodyPr/>
+          <a:lstStyle/>
+          <a:p>
+            <a:pPr rtl="0"/>
+            <a:fld id="{C6B3AB32-59DF-41F1-9618-EDFBF5049629}" type="slidenum">
+              <a:rPr lang="fr-FR" noProof="0" smtClean="0"/>
+              <a:t>44</a:t>
+            </a:fld>
+            <a:endParaRPr lang="fr-FR" noProof="0"/>
+          </a:p>
+        </p:txBody>
+      </p:sp>
+    </p:spTree>
+    <p:extLst>
+      <p:ext uri="{BB962C8B-B14F-4D97-AF65-F5344CB8AC3E}">
+        <p14:creationId xmlns:p14="http://schemas.microsoft.com/office/powerpoint/2010/main" val="1602127881"/>
+      </p:ext>
+    </p:extLst>
+  </p:cSld>
+  <p:clrMapOvr>
+    <a:masterClrMapping/>
+  </p:clrMapOvr>
+</p:notes>
+</file>
+
+<file path=ppt/notesSlides/notesSlide38.xml><?xml version="1.0" encoding="utf-8"?>
+<p:notes xmlns:a="http://schemas.openxmlformats.org/drawingml/2006/main" xmlns:r="http://schemas.openxmlformats.org/officeDocument/2006/relationships" xmlns:p="http://schemas.openxmlformats.org/presentationml/2006/main">
+  <p:cSld>
+    <p:spTree>
+      <p:nvGrpSpPr>
+        <p:cNvPr id="1" name=""/>
+        <p:cNvGrpSpPr/>
+        <p:nvPr/>
+      </p:nvGrpSpPr>
+      <p:grpSpPr>
+        <a:xfrm>
+          <a:off x="0" y="0"/>
+          <a:ext cx="0" cy="0"/>
+          <a:chOff x="0" y="0"/>
+          <a:chExt cx="0" cy="0"/>
+        </a:xfrm>
+      </p:grpSpPr>
+      <p:sp>
+        <p:nvSpPr>
           <p:cNvPr id="2" name="Espace réservé de l’image des diapositives 1"/>
           <p:cNvSpPr>
             <a:spLocks noGrp="1" noRot="1" noChangeAspect="1"/>
@@ -5422,7 +5401,7 @@
             <a:pPr rtl="0"/>
             <a:fld id="{C6B3AB32-59DF-41F1-9618-EDFBF5049629}" type="slidenum">
               <a:rPr lang="fr-FR" smtClean="0"/>
-              <a:t>43</a:t>
+              <a:t>46</a:t>
             </a:fld>
             <a:endParaRPr lang="fr-FR"/>
           </a:p>
@@ -6255,7 +6234,7 @@
             <a:pPr rtl="0"/>
             <a:fld id="{3F3B20A7-A3FE-46B9-84EA-B4257BA7E60C}" type="datetime1">
               <a:rPr lang="fr-FR" noProof="0" smtClean="0"/>
-              <a:t>19/06/2026</a:t>
+              <a:t>20/06/2026</a:t>
             </a:fld>
             <a:endParaRPr lang="fr-FR" noProof="0"/>
           </a:p>
@@ -6527,7 +6506,7 @@
             <a:pPr rtl="0"/>
             <a:fld id="{7E5E3FBB-57D2-4FB3-B51E-0FDE8CEE6791}" type="datetime1">
               <a:rPr lang="fr-FR" noProof="0" smtClean="0"/>
-              <a:t>19/06/2026</a:t>
+              <a:t>20/06/2026</a:t>
             </a:fld>
             <a:endParaRPr lang="fr-FR" noProof="0"/>
           </a:p>
@@ -6772,7 +6751,7 @@
             <a:pPr rtl="0"/>
             <a:fld id="{BE9F9435-70D7-42BA-8564-5EC34B97B69E}" type="datetime1">
               <a:rPr lang="fr-FR" noProof="0" smtClean="0"/>
-              <a:t>19/06/2026</a:t>
+              <a:t>20/06/2026</a:t>
             </a:fld>
             <a:endParaRPr lang="fr-FR" noProof="0"/>
           </a:p>
@@ -7022,7 +7001,7 @@
             <a:pPr rtl="0"/>
             <a:fld id="{29B34D2F-0B02-482E-ABD2-95D8C2FF2A58}" type="datetime1">
               <a:rPr lang="fr-FR" noProof="0" smtClean="0"/>
-              <a:t>19/06/2026</a:t>
+              <a:t>20/06/2026</a:t>
             </a:fld>
             <a:endParaRPr lang="fr-FR" noProof="0"/>
           </a:p>
@@ -7340,7 +7319,7 @@
             <a:pPr rtl="0"/>
             <a:fld id="{126ECFBB-4871-428F-B4AE-1EF357E63674}" type="datetime1">
               <a:rPr lang="fr-FR" noProof="0" smtClean="0"/>
-              <a:t>19/06/2026</a:t>
+              <a:t>20/06/2026</a:t>
             </a:fld>
             <a:endParaRPr lang="fr-FR" noProof="0"/>
           </a:p>
@@ -7651,7 +7630,7 @@
             <a:pPr rtl="0"/>
             <a:fld id="{75517F14-0D9C-452E-A596-36902551AE9C}" type="datetime1">
               <a:rPr lang="fr-FR" noProof="0" smtClean="0"/>
-              <a:t>19/06/2026</a:t>
+              <a:t>20/06/2026</a:t>
             </a:fld>
             <a:endParaRPr lang="fr-FR" noProof="0"/>
           </a:p>
@@ -8082,7 +8061,7 @@
             <a:pPr rtl="0"/>
             <a:fld id="{FA9BF800-A62B-4735-B9A7-5450007C0A78}" type="datetime1">
               <a:rPr lang="fr-FR" noProof="0" smtClean="0"/>
-              <a:t>19/06/2026</a:t>
+              <a:t>20/06/2026</a:t>
             </a:fld>
             <a:endParaRPr lang="fr-FR" noProof="0"/>
           </a:p>
@@ -8181,7 +8160,7 @@
             <a:pPr rtl="0"/>
             <a:fld id="{F47267E0-A979-4430-94B4-54611641D8EE}" type="datetime1">
               <a:rPr lang="fr-FR" noProof="0" smtClean="0"/>
-              <a:t>19/06/2026</a:t>
+              <a:t>20/06/2026</a:t>
             </a:fld>
             <a:endParaRPr lang="fr-FR" noProof="0"/>
           </a:p>
@@ -8354,7 +8333,7 @@
             <a:pPr rtl="0"/>
             <a:fld id="{C58A73B6-B077-488D-82CF-3056D5BAC73E}" type="datetime1">
               <a:rPr lang="fr-FR" noProof="0" smtClean="0"/>
-              <a:t>19/06/2026</a:t>
+              <a:t>20/06/2026</a:t>
             </a:fld>
             <a:endParaRPr lang="fr-FR" noProof="0"/>
           </a:p>
@@ -8742,7 +8721,7 @@
             <a:pPr rtl="0"/>
             <a:fld id="{98F108A3-3495-404B-9869-1BA62DF0E465}" type="datetime1">
               <a:rPr lang="fr-FR" noProof="0" smtClean="0"/>
-              <a:t>19/06/2026</a:t>
+              <a:t>20/06/2026</a:t>
             </a:fld>
             <a:endParaRPr lang="fr-FR" noProof="0"/>
           </a:p>
@@ -9035,7 +9014,7 @@
             <a:pPr rtl="0"/>
             <a:fld id="{94B550F6-4238-41AE-B6F4-4D375745C983}" type="datetime1">
               <a:rPr lang="fr-FR" noProof="0" smtClean="0"/>
-              <a:t>19/06/2026</a:t>
+              <a:t>20/06/2026</a:t>
             </a:fld>
             <a:endParaRPr lang="fr-FR" noProof="0"/>
           </a:p>
@@ -9249,7 +9228,7 @@
             <a:pPr rtl="0"/>
             <a:fld id="{BBB97F02-5EDD-4BF6-BE41-AB41D1FEABF8}" type="datetime1">
               <a:rPr lang="fr-FR" noProof="0" smtClean="0"/>
-              <a:t>19/06/2026</a:t>
+              <a:t>20/06/2026</a:t>
             </a:fld>
             <a:endParaRPr lang="fr-FR" noProof="0"/>
           </a:p>
@@ -19334,10 +19313,10 @@
       </p:sp>
       <p:pic>
         <p:nvPicPr>
-          <p:cNvPr id="6" name="Image 5">
-            <a:extLst>
-              <a:ext uri="{FF2B5EF4-FFF2-40B4-BE49-F238E27FC236}">
-                <a16:creationId xmlns:a16="http://schemas.microsoft.com/office/drawing/2014/main" id="{0FD5DA50-FE06-C4AC-01D3-5DF6FB1BF328}"/>
+          <p:cNvPr id="3" name="Image 2">
+            <a:extLst>
+              <a:ext uri="{FF2B5EF4-FFF2-40B4-BE49-F238E27FC236}">
+                <a16:creationId xmlns:a16="http://schemas.microsoft.com/office/drawing/2014/main" id="{C7B48085-0847-54A7-6CD5-FE50F6F56FA9}"/>
               </a:ext>
             </a:extLst>
           </p:cNvPr>
@@ -19354,8 +19333,8 @@
         </p:blipFill>
         <p:spPr>
           <a:xfrm>
-            <a:off x="2004687" y="1970111"/>
-            <a:ext cx="8182626" cy="4887889"/>
+            <a:off x="2004687" y="1715956"/>
+            <a:ext cx="8182626" cy="4904571"/>
           </a:xfrm>
           <a:prstGeom prst="rect">
             <a:avLst/>
@@ -19432,10 +19411,10 @@
       </p:sp>
       <p:pic>
         <p:nvPicPr>
-          <p:cNvPr id="5" name="Image 4">
-            <a:extLst>
-              <a:ext uri="{FF2B5EF4-FFF2-40B4-BE49-F238E27FC236}">
-                <a16:creationId xmlns:a16="http://schemas.microsoft.com/office/drawing/2014/main" id="{09082FCE-0D47-E676-68D4-3769E0594345}"/>
+          <p:cNvPr id="3" name="Image 2">
+            <a:extLst>
+              <a:ext uri="{FF2B5EF4-FFF2-40B4-BE49-F238E27FC236}">
+                <a16:creationId xmlns:a16="http://schemas.microsoft.com/office/drawing/2014/main" id="{353B3B5F-0586-DE5E-383F-89891D5AAC7B}"/>
               </a:ext>
             </a:extLst>
           </p:cNvPr>
@@ -19452,8 +19431,8 @@
         </p:blipFill>
         <p:spPr>
           <a:xfrm>
-            <a:off x="2009450" y="1871019"/>
-            <a:ext cx="8173100" cy="4858779"/>
+            <a:off x="1986915" y="1835834"/>
+            <a:ext cx="8218170" cy="4912396"/>
           </a:xfrm>
           <a:prstGeom prst="rect">
             <a:avLst/>
@@ -19572,6 +19551,36 @@
           <a:chExt cx="0" cy="0"/>
         </a:xfrm>
       </p:grpSpPr>
+      <p:pic>
+        <p:nvPicPr>
+          <p:cNvPr id="3" name="Image 2">
+            <a:extLst>
+              <a:ext uri="{FF2B5EF4-FFF2-40B4-BE49-F238E27FC236}">
+                <a16:creationId xmlns:a16="http://schemas.microsoft.com/office/drawing/2014/main" id="{E2395F56-D98B-8CE2-513D-C5544C802316}"/>
+              </a:ext>
+            </a:extLst>
+          </p:cNvPr>
+          <p:cNvPicPr>
+            <a:picLocks noChangeAspect="1"/>
+          </p:cNvPicPr>
+          <p:nvPr/>
+        </p:nvPicPr>
+        <p:blipFill>
+          <a:blip r:embed="rId3"/>
+          <a:stretch>
+            <a:fillRect/>
+          </a:stretch>
+        </p:blipFill>
+        <p:spPr>
+          <a:xfrm>
+            <a:off x="1753448" y="2622704"/>
+            <a:ext cx="8273577" cy="2054992"/>
+          </a:xfrm>
+          <a:prstGeom prst="rect">
+            <a:avLst/>
+          </a:prstGeom>
+        </p:spPr>
+      </p:pic>
       <p:sp>
         <p:nvSpPr>
           <p:cNvPr id="4" name="Titre 3">
@@ -19669,103 +19678,21 @@
           </a:p>
         </p:txBody>
       </p:sp>
-      <p:pic>
-        <p:nvPicPr>
-          <p:cNvPr id="6" name="Image 5">
-            <a:extLst>
-              <a:ext uri="{FF2B5EF4-FFF2-40B4-BE49-F238E27FC236}">
-                <a16:creationId xmlns:a16="http://schemas.microsoft.com/office/drawing/2014/main" id="{CE22F050-3B23-2B96-FF61-CF3C6C7AB784}"/>
-              </a:ext>
-            </a:extLst>
-          </p:cNvPr>
-          <p:cNvPicPr>
-            <a:picLocks noChangeAspect="1"/>
-          </p:cNvPicPr>
+      <p:sp>
+        <p:nvSpPr>
+          <p:cNvPr id="8" name="Rectangle 7">
+            <a:extLst>
+              <a:ext uri="{FF2B5EF4-FFF2-40B4-BE49-F238E27FC236}">
+                <a16:creationId xmlns:a16="http://schemas.microsoft.com/office/drawing/2014/main" id="{A3525A5F-63BC-3C7A-E69E-33CB93D6419A}"/>
+              </a:ext>
+            </a:extLst>
+          </p:cNvPr>
+          <p:cNvSpPr/>
           <p:nvPr/>
-        </p:nvPicPr>
-        <p:blipFill>
-          <a:blip r:embed="rId3"/>
-          <a:stretch>
-            <a:fillRect/>
-          </a:stretch>
-        </p:blipFill>
+        </p:nvSpPr>
         <p:spPr>
           <a:xfrm>
-            <a:off x="1836925" y="2521057"/>
-            <a:ext cx="8124585" cy="2250967"/>
-          </a:xfrm>
-          <a:prstGeom prst="rect">
-            <a:avLst/>
-          </a:prstGeom>
-        </p:spPr>
-      </p:pic>
-      <p:sp>
-        <p:nvSpPr>
-          <p:cNvPr id="7" name="Rectangle 6">
-            <a:extLst>
-              <a:ext uri="{FF2B5EF4-FFF2-40B4-BE49-F238E27FC236}">
-                <a16:creationId xmlns:a16="http://schemas.microsoft.com/office/drawing/2014/main" id="{0A9ED9EE-78D9-AD38-5898-1B7207948B27}"/>
-              </a:ext>
-            </a:extLst>
-          </p:cNvPr>
-          <p:cNvSpPr/>
-          <p:nvPr/>
-        </p:nvSpPr>
-        <p:spPr>
-          <a:xfrm>
-            <a:off x="2343150" y="3643313"/>
-            <a:ext cx="2286000" cy="426556"/>
-          </a:xfrm>
-          <a:prstGeom prst="rect">
-            <a:avLst/>
-          </a:prstGeom>
-          <a:noFill/>
-          <a:ln w="76200">
-            <a:solidFill>
-              <a:srgbClr val="FFC000"/>
-            </a:solidFill>
-          </a:ln>
-        </p:spPr>
-        <p:style>
-          <a:lnRef idx="2">
-            <a:schemeClr val="accent1">
-              <a:shade val="15000"/>
-            </a:schemeClr>
-          </a:lnRef>
-          <a:fillRef idx="1">
-            <a:schemeClr val="accent1"/>
-          </a:fillRef>
-          <a:effectRef idx="0">
-            <a:schemeClr val="accent1"/>
-          </a:effectRef>
-          <a:fontRef idx="minor">
-            <a:schemeClr val="lt1"/>
-          </a:fontRef>
-        </p:style>
-        <p:txBody>
-          <a:bodyPr rtlCol="0" anchor="ctr"/>
-          <a:lstStyle/>
-          <a:p>
-            <a:pPr algn="ctr"/>
-            <a:endParaRPr lang="fr-FR"/>
-          </a:p>
-        </p:txBody>
-      </p:sp>
-      <p:sp>
-        <p:nvSpPr>
-          <p:cNvPr id="8" name="Rectangle 7">
-            <a:extLst>
-              <a:ext uri="{FF2B5EF4-FFF2-40B4-BE49-F238E27FC236}">
-                <a16:creationId xmlns:a16="http://schemas.microsoft.com/office/drawing/2014/main" id="{A3525A5F-63BC-3C7A-E69E-33CB93D6419A}"/>
-              </a:ext>
-            </a:extLst>
-          </p:cNvPr>
-          <p:cNvSpPr/>
-          <p:nvPr/>
-        </p:nvSpPr>
-        <p:spPr>
-          <a:xfrm>
-            <a:off x="7267575" y="3636482"/>
+            <a:off x="6508937" y="3674638"/>
             <a:ext cx="819150" cy="426556"/>
           </a:xfrm>
           <a:prstGeom prst="rect">
@@ -19817,7 +19744,111 @@
         </p:nvSpPr>
         <p:spPr>
           <a:xfrm>
-            <a:off x="9006210" y="3636482"/>
+            <a:off x="7409372" y="4176167"/>
+            <a:ext cx="819150" cy="426556"/>
+          </a:xfrm>
+          <a:prstGeom prst="rect">
+            <a:avLst/>
+          </a:prstGeom>
+          <a:noFill/>
+          <a:ln w="76200">
+            <a:solidFill>
+              <a:srgbClr val="FFC000"/>
+            </a:solidFill>
+          </a:ln>
+        </p:spPr>
+        <p:style>
+          <a:lnRef idx="2">
+            <a:schemeClr val="accent1">
+              <a:shade val="15000"/>
+            </a:schemeClr>
+          </a:lnRef>
+          <a:fillRef idx="1">
+            <a:schemeClr val="accent1"/>
+          </a:fillRef>
+          <a:effectRef idx="0">
+            <a:schemeClr val="accent1"/>
+          </a:effectRef>
+          <a:fontRef idx="minor">
+            <a:schemeClr val="lt1"/>
+          </a:fontRef>
+        </p:style>
+        <p:txBody>
+          <a:bodyPr rtlCol="0" anchor="ctr"/>
+          <a:lstStyle/>
+          <a:p>
+            <a:pPr algn="ctr"/>
+            <a:endParaRPr lang="fr-FR"/>
+          </a:p>
+        </p:txBody>
+      </p:sp>
+      <p:sp>
+        <p:nvSpPr>
+          <p:cNvPr id="14" name="Rectangle 13">
+            <a:extLst>
+              <a:ext uri="{FF2B5EF4-FFF2-40B4-BE49-F238E27FC236}">
+                <a16:creationId xmlns:a16="http://schemas.microsoft.com/office/drawing/2014/main" id="{7F41AC11-7867-3C4A-8B9F-98CB3B462A00}"/>
+              </a:ext>
+            </a:extLst>
+          </p:cNvPr>
+          <p:cNvSpPr/>
+          <p:nvPr/>
+        </p:nvSpPr>
+        <p:spPr>
+          <a:xfrm>
+            <a:off x="8267981" y="3674638"/>
+            <a:ext cx="819150" cy="426556"/>
+          </a:xfrm>
+          <a:prstGeom prst="rect">
+            <a:avLst/>
+          </a:prstGeom>
+          <a:noFill/>
+          <a:ln w="76200">
+            <a:solidFill>
+              <a:srgbClr val="FFC000"/>
+            </a:solidFill>
+          </a:ln>
+        </p:spPr>
+        <p:style>
+          <a:lnRef idx="2">
+            <a:schemeClr val="accent1">
+              <a:shade val="15000"/>
+            </a:schemeClr>
+          </a:lnRef>
+          <a:fillRef idx="1">
+            <a:schemeClr val="accent1"/>
+          </a:fillRef>
+          <a:effectRef idx="0">
+            <a:schemeClr val="accent1"/>
+          </a:effectRef>
+          <a:fontRef idx="minor">
+            <a:schemeClr val="lt1"/>
+          </a:fontRef>
+        </p:style>
+        <p:txBody>
+          <a:bodyPr rtlCol="0" anchor="ctr"/>
+          <a:lstStyle/>
+          <a:p>
+            <a:pPr algn="ctr"/>
+            <a:endParaRPr lang="fr-FR"/>
+          </a:p>
+        </p:txBody>
+      </p:sp>
+      <p:sp>
+        <p:nvSpPr>
+          <p:cNvPr id="15" name="Rectangle 14">
+            <a:extLst>
+              <a:ext uri="{FF2B5EF4-FFF2-40B4-BE49-F238E27FC236}">
+                <a16:creationId xmlns:a16="http://schemas.microsoft.com/office/drawing/2014/main" id="{B6613796-E50F-5997-C361-1920D5BABCDE}"/>
+              </a:ext>
+            </a:extLst>
+          </p:cNvPr>
+          <p:cNvSpPr/>
+          <p:nvPr/>
+        </p:nvSpPr>
+        <p:spPr>
+          <a:xfrm>
+            <a:off x="9173137" y="3674638"/>
             <a:ext cx="819150" cy="426556"/>
           </a:xfrm>
           <a:prstGeom prst="rect">
@@ -19885,12 +19916,49 @@
           <a:chExt cx="0" cy="0"/>
         </a:xfrm>
       </p:grpSpPr>
+      <p:sp>
+        <p:nvSpPr>
+          <p:cNvPr id="8" name="Titre 3">
+            <a:extLst>
+              <a:ext uri="{FF2B5EF4-FFF2-40B4-BE49-F238E27FC236}">
+                <a16:creationId xmlns:a16="http://schemas.microsoft.com/office/drawing/2014/main" id="{18EB53AB-FFA5-379A-BD6D-C07E347591D2}"/>
+              </a:ext>
+            </a:extLst>
+          </p:cNvPr>
+          <p:cNvSpPr>
+            <a:spLocks noGrp="1"/>
+          </p:cNvSpPr>
+          <p:nvPr>
+            <p:ph type="title"/>
+          </p:nvPr>
+        </p:nvSpPr>
+        <p:spPr>
+          <a:xfrm>
+            <a:off x="581192" y="702156"/>
+            <a:ext cx="11029616" cy="1013800"/>
+          </a:xfrm>
+        </p:spPr>
+        <p:txBody>
+          <a:bodyPr/>
+          <a:lstStyle/>
+          <a:p>
+            <a:r>
+              <a:rPr lang="fr-FR" b="1" dirty="0"/>
+              <a:t>EVALUATION Finale</a:t>
+            </a:r>
+            <a:br>
+              <a:rPr lang="fr-FR" dirty="0"/>
+            </a:br>
+            <a:endParaRPr lang="fr-FR" dirty="0"/>
+          </a:p>
+        </p:txBody>
+      </p:sp>
       <p:pic>
         <p:nvPicPr>
-          <p:cNvPr id="13" name="Image 12">
-            <a:extLst>
-              <a:ext uri="{FF2B5EF4-FFF2-40B4-BE49-F238E27FC236}">
-                <a16:creationId xmlns:a16="http://schemas.microsoft.com/office/drawing/2014/main" id="{DF79E957-64BC-68E8-4D7E-E470CC7A0091}"/>
+          <p:cNvPr id="6" name="Image 5">
+            <a:extLst>
+              <a:ext uri="{FF2B5EF4-FFF2-40B4-BE49-F238E27FC236}">
+                <a16:creationId xmlns:a16="http://schemas.microsoft.com/office/drawing/2014/main" id="{ED4197C8-18EB-36A0-1979-75CCBB1D112A}"/>
               </a:ext>
             </a:extLst>
           </p:cNvPr>
@@ -19907,176 +19975,20 @@
         </p:blipFill>
         <p:spPr>
           <a:xfrm>
-            <a:off x="6781571" y="1813480"/>
-            <a:ext cx="4679944" cy="3689695"/>
+            <a:off x="890392" y="3199532"/>
+            <a:ext cx="4063371" cy="2648818"/>
           </a:xfrm>
           <a:prstGeom prst="rect">
             <a:avLst/>
           </a:prstGeom>
         </p:spPr>
       </p:pic>
-      <p:sp>
-        <p:nvSpPr>
-          <p:cNvPr id="8" name="Titre 3">
-            <a:extLst>
-              <a:ext uri="{FF2B5EF4-FFF2-40B4-BE49-F238E27FC236}">
-                <a16:creationId xmlns:a16="http://schemas.microsoft.com/office/drawing/2014/main" id="{18EB53AB-FFA5-379A-BD6D-C07E347591D2}"/>
-              </a:ext>
-            </a:extLst>
-          </p:cNvPr>
-          <p:cNvSpPr>
-            <a:spLocks noGrp="1"/>
-          </p:cNvSpPr>
-          <p:nvPr>
-            <p:ph type="title"/>
-          </p:nvPr>
-        </p:nvSpPr>
-        <p:spPr>
-          <a:xfrm>
-            <a:off x="581192" y="702156"/>
-            <a:ext cx="11029616" cy="1013800"/>
-          </a:xfrm>
-        </p:spPr>
-        <p:txBody>
-          <a:bodyPr/>
-          <a:lstStyle/>
-          <a:p>
-            <a:r>
-              <a:rPr lang="fr-FR" b="1" dirty="0"/>
-              <a:t>EVALUATION Finale</a:t>
-            </a:r>
-            <a:br>
-              <a:rPr lang="fr-FR" dirty="0"/>
-            </a:br>
-            <a:endParaRPr lang="fr-FR" dirty="0"/>
-          </a:p>
-        </p:txBody>
-      </p:sp>
-      <p:sp>
-        <p:nvSpPr>
-          <p:cNvPr id="4" name="ZoneTexte 3">
-            <a:extLst>
-              <a:ext uri="{FF2B5EF4-FFF2-40B4-BE49-F238E27FC236}">
-                <a16:creationId xmlns:a16="http://schemas.microsoft.com/office/drawing/2014/main" id="{7B23442C-8924-96D4-D2CA-ED1037924F10}"/>
-              </a:ext>
-            </a:extLst>
-          </p:cNvPr>
-          <p:cNvSpPr txBox="1"/>
-          <p:nvPr/>
-        </p:nvSpPr>
-        <p:spPr>
-          <a:xfrm>
-            <a:off x="7854733" y="5600700"/>
-            <a:ext cx="2023865" cy="646331"/>
-          </a:xfrm>
-          <a:prstGeom prst="rect">
-            <a:avLst/>
-          </a:prstGeom>
-          <a:noFill/>
-        </p:spPr>
-        <p:txBody>
-          <a:bodyPr wrap="square">
-            <a:spAutoFit/>
-          </a:bodyPr>
-          <a:lstStyle/>
-          <a:p>
-            <a:pPr algn="ctr"/>
-            <a:r>
-              <a:rPr lang="fr-FR" dirty="0"/>
-              <a:t>0 = Négatif = Reste </a:t>
-            </a:r>
-          </a:p>
-          <a:p>
-            <a:pPr algn="ctr"/>
-            <a:r>
-              <a:rPr lang="fr-FR" dirty="0"/>
-              <a:t>1 = Positif = Quitte</a:t>
-            </a:r>
-          </a:p>
-        </p:txBody>
-      </p:sp>
-      <p:sp>
-        <p:nvSpPr>
-          <p:cNvPr id="7" name="ZoneTexte 6">
-            <a:extLst>
-              <a:ext uri="{FF2B5EF4-FFF2-40B4-BE49-F238E27FC236}">
-                <a16:creationId xmlns:a16="http://schemas.microsoft.com/office/drawing/2014/main" id="{2BD9D254-866B-4EED-77BA-236DFA7035F1}"/>
-              </a:ext>
-            </a:extLst>
-          </p:cNvPr>
-          <p:cNvSpPr txBox="1"/>
-          <p:nvPr/>
-        </p:nvSpPr>
-        <p:spPr>
-          <a:xfrm>
-            <a:off x="7854732" y="5148958"/>
-            <a:ext cx="2023865" cy="369332"/>
-          </a:xfrm>
-          <a:prstGeom prst="rect">
-            <a:avLst/>
-          </a:prstGeom>
-          <a:solidFill>
-            <a:schemeClr val="bg1"/>
-          </a:solidFill>
-        </p:spPr>
-        <p:txBody>
-          <a:bodyPr wrap="square">
-            <a:spAutoFit/>
-          </a:bodyPr>
-          <a:lstStyle/>
-          <a:p>
-            <a:pPr algn="ctr"/>
-            <a:r>
-              <a:rPr lang="fr-FR" dirty="0"/>
-              <a:t>Val. Prédit</a:t>
-            </a:r>
-          </a:p>
-        </p:txBody>
-      </p:sp>
-      <p:sp>
-        <p:nvSpPr>
-          <p:cNvPr id="9" name="ZoneTexte 8">
-            <a:extLst>
-              <a:ext uri="{FF2B5EF4-FFF2-40B4-BE49-F238E27FC236}">
-                <a16:creationId xmlns:a16="http://schemas.microsoft.com/office/drawing/2014/main" id="{C8D4581A-AF1C-A722-0BC1-54730DFD4D46}"/>
-              </a:ext>
-            </a:extLst>
-          </p:cNvPr>
-          <p:cNvSpPr txBox="1"/>
-          <p:nvPr/>
-        </p:nvSpPr>
-        <p:spPr>
-          <a:xfrm rot="16200000">
-            <a:off x="6219992" y="3574812"/>
-            <a:ext cx="2023865" cy="369332"/>
-          </a:xfrm>
-          <a:prstGeom prst="rect">
-            <a:avLst/>
-          </a:prstGeom>
-          <a:solidFill>
-            <a:schemeClr val="bg1"/>
-          </a:solidFill>
-        </p:spPr>
-        <p:txBody>
-          <a:bodyPr wrap="square">
-            <a:spAutoFit/>
-          </a:bodyPr>
-          <a:lstStyle/>
-          <a:p>
-            <a:pPr algn="ctr"/>
-            <a:r>
-              <a:rPr lang="fr-FR" dirty="0"/>
-              <a:t>Val. Réelle</a:t>
-            </a:r>
-          </a:p>
-        </p:txBody>
-      </p:sp>
       <p:pic>
         <p:nvPicPr>
-          <p:cNvPr id="11" name="Image 10">
-            <a:extLst>
-              <a:ext uri="{FF2B5EF4-FFF2-40B4-BE49-F238E27FC236}">
-                <a16:creationId xmlns:a16="http://schemas.microsoft.com/office/drawing/2014/main" id="{127E5663-589D-6D7D-D4E3-266B49667036}"/>
+          <p:cNvPr id="12" name="Image 11">
+            <a:extLst>
+              <a:ext uri="{FF2B5EF4-FFF2-40B4-BE49-F238E27FC236}">
+                <a16:creationId xmlns:a16="http://schemas.microsoft.com/office/drawing/2014/main" id="{8F241D61-152B-5C28-509D-831F67B81315}"/>
               </a:ext>
             </a:extLst>
           </p:cNvPr>
@@ -20093,14 +20005,276 @@
         </p:blipFill>
         <p:spPr>
           <a:xfrm>
-            <a:off x="581192" y="2290603"/>
-            <a:ext cx="5822990" cy="3038635"/>
+            <a:off x="6986413" y="3199532"/>
+            <a:ext cx="3600737" cy="2648818"/>
           </a:xfrm>
           <a:prstGeom prst="rect">
             <a:avLst/>
           </a:prstGeom>
         </p:spPr>
       </p:pic>
+      <p:sp>
+        <p:nvSpPr>
+          <p:cNvPr id="14" name="Titre 1">
+            <a:extLst>
+              <a:ext uri="{FF2B5EF4-FFF2-40B4-BE49-F238E27FC236}">
+                <a16:creationId xmlns:a16="http://schemas.microsoft.com/office/drawing/2014/main" id="{66567174-AFA7-31E1-C647-D70B2B83F4FB}"/>
+              </a:ext>
+            </a:extLst>
+          </p:cNvPr>
+          <p:cNvSpPr txBox="1">
+            <a:spLocks/>
+          </p:cNvSpPr>
+          <p:nvPr/>
+        </p:nvSpPr>
+        <p:spPr>
+          <a:xfrm>
+            <a:off x="735791" y="2185162"/>
+            <a:ext cx="4372571" cy="1013800"/>
+          </a:xfrm>
+          <a:prstGeom prst="rect">
+            <a:avLst/>
+          </a:prstGeom>
+        </p:spPr>
+        <p:txBody>
+          <a:bodyPr vert="horz" lIns="91440" tIns="45720" rIns="91440" bIns="45720" rtlCol="0" anchor="b">
+            <a:normAutofit fontScale="85000" lnSpcReduction="20000"/>
+          </a:bodyPr>
+          <a:lstStyle>
+            <a:lvl1pPr algn="l" defTabSz="457200" rtl="0" eaLnBrk="1" latinLnBrk="0" hangingPunct="1">
+              <a:spcBef>
+                <a:spcPct val="0"/>
+              </a:spcBef>
+              <a:buNone/>
+              <a:defRPr sz="2800" b="0" kern="1200" cap="all">
+                <a:solidFill>
+                  <a:schemeClr val="bg1"/>
+                </a:solidFill>
+                <a:latin typeface="+mj-lt"/>
+                <a:ea typeface="+mj-ea"/>
+                <a:cs typeface="+mj-cs"/>
+              </a:defRPr>
+            </a:lvl1pPr>
+            <a:lvl2pPr eaLnBrk="1" hangingPunct="1">
+              <a:defRPr>
+                <a:solidFill>
+                  <a:schemeClr val="tx2"/>
+                </a:solidFill>
+              </a:defRPr>
+            </a:lvl2pPr>
+            <a:lvl3pPr eaLnBrk="1" hangingPunct="1">
+              <a:defRPr>
+                <a:solidFill>
+                  <a:schemeClr val="tx2"/>
+                </a:solidFill>
+              </a:defRPr>
+            </a:lvl3pPr>
+            <a:lvl4pPr eaLnBrk="1" hangingPunct="1">
+              <a:defRPr>
+                <a:solidFill>
+                  <a:schemeClr val="tx2"/>
+                </a:solidFill>
+              </a:defRPr>
+            </a:lvl4pPr>
+            <a:lvl5pPr eaLnBrk="1" hangingPunct="1">
+              <a:defRPr>
+                <a:solidFill>
+                  <a:schemeClr val="tx2"/>
+                </a:solidFill>
+              </a:defRPr>
+            </a:lvl5pPr>
+            <a:lvl6pPr eaLnBrk="1" hangingPunct="1">
+              <a:defRPr>
+                <a:solidFill>
+                  <a:schemeClr val="tx2"/>
+                </a:solidFill>
+              </a:defRPr>
+            </a:lvl6pPr>
+            <a:lvl7pPr eaLnBrk="1" hangingPunct="1">
+              <a:defRPr>
+                <a:solidFill>
+                  <a:schemeClr val="tx2"/>
+                </a:solidFill>
+              </a:defRPr>
+            </a:lvl7pPr>
+            <a:lvl8pPr eaLnBrk="1" hangingPunct="1">
+              <a:defRPr>
+                <a:solidFill>
+                  <a:schemeClr val="tx2"/>
+                </a:solidFill>
+              </a:defRPr>
+            </a:lvl8pPr>
+            <a:lvl9pPr eaLnBrk="1" hangingPunct="1">
+              <a:defRPr>
+                <a:solidFill>
+                  <a:schemeClr val="tx2"/>
+                </a:solidFill>
+              </a:defRPr>
+            </a:lvl9pPr>
+          </a:lstStyle>
+          <a:p>
+            <a:pPr algn="ctr"/>
+            <a:r>
+              <a:rPr lang="fr-FR" sz="4400" dirty="0" err="1">
+                <a:solidFill>
+                  <a:schemeClr val="tx1"/>
+                </a:solidFill>
+                <a:latin typeface="Arial" panose="020B0604020202020204" pitchFamily="34" charset="0"/>
+                <a:cs typeface="Arial" panose="020B0604020202020204" pitchFamily="34" charset="0"/>
+              </a:rPr>
+              <a:t>Logistic</a:t>
+            </a:r>
+            <a:r>
+              <a:rPr lang="fr-FR" sz="4400" dirty="0">
+                <a:solidFill>
+                  <a:schemeClr val="tx1"/>
+                </a:solidFill>
+                <a:latin typeface="Arial" panose="020B0604020202020204" pitchFamily="34" charset="0"/>
+                <a:cs typeface="Arial" panose="020B0604020202020204" pitchFamily="34" charset="0"/>
+              </a:rPr>
+              <a:t> </a:t>
+            </a:r>
+            <a:r>
+              <a:rPr lang="fr-FR" sz="4400" dirty="0" err="1">
+                <a:solidFill>
+                  <a:schemeClr val="tx1"/>
+                </a:solidFill>
+                <a:latin typeface="Arial" panose="020B0604020202020204" pitchFamily="34" charset="0"/>
+                <a:cs typeface="Arial" panose="020B0604020202020204" pitchFamily="34" charset="0"/>
+              </a:rPr>
+              <a:t>Regression</a:t>
+            </a:r>
+            <a:endParaRPr lang="fr-FR" sz="4400" dirty="0">
+              <a:solidFill>
+                <a:schemeClr val="tx1"/>
+              </a:solidFill>
+              <a:latin typeface="Arial" panose="020B0604020202020204" pitchFamily="34" charset="0"/>
+              <a:cs typeface="Arial" panose="020B0604020202020204" pitchFamily="34" charset="0"/>
+            </a:endParaRPr>
+          </a:p>
+        </p:txBody>
+      </p:sp>
+      <p:sp>
+        <p:nvSpPr>
+          <p:cNvPr id="15" name="Titre 1">
+            <a:extLst>
+              <a:ext uri="{FF2B5EF4-FFF2-40B4-BE49-F238E27FC236}">
+                <a16:creationId xmlns:a16="http://schemas.microsoft.com/office/drawing/2014/main" id="{9D2CC7D2-791E-99BB-47DD-2FAD4DDEE663}"/>
+              </a:ext>
+            </a:extLst>
+          </p:cNvPr>
+          <p:cNvSpPr txBox="1">
+            <a:spLocks/>
+          </p:cNvSpPr>
+          <p:nvPr/>
+        </p:nvSpPr>
+        <p:spPr>
+          <a:xfrm>
+            <a:off x="6600495" y="2185162"/>
+            <a:ext cx="4372571" cy="1013800"/>
+          </a:xfrm>
+          <a:prstGeom prst="rect">
+            <a:avLst/>
+          </a:prstGeom>
+        </p:spPr>
+        <p:txBody>
+          <a:bodyPr vert="horz" lIns="91440" tIns="45720" rIns="91440" bIns="45720" rtlCol="0" anchor="b">
+            <a:normAutofit/>
+          </a:bodyPr>
+          <a:lstStyle>
+            <a:lvl1pPr algn="l" defTabSz="457200" rtl="0" eaLnBrk="1" latinLnBrk="0" hangingPunct="1">
+              <a:spcBef>
+                <a:spcPct val="0"/>
+              </a:spcBef>
+              <a:buNone/>
+              <a:defRPr sz="2800" b="0" kern="1200" cap="all">
+                <a:solidFill>
+                  <a:schemeClr val="bg1"/>
+                </a:solidFill>
+                <a:latin typeface="+mj-lt"/>
+                <a:ea typeface="+mj-ea"/>
+                <a:cs typeface="+mj-cs"/>
+              </a:defRPr>
+            </a:lvl1pPr>
+            <a:lvl2pPr eaLnBrk="1" hangingPunct="1">
+              <a:defRPr>
+                <a:solidFill>
+                  <a:schemeClr val="tx2"/>
+                </a:solidFill>
+              </a:defRPr>
+            </a:lvl2pPr>
+            <a:lvl3pPr eaLnBrk="1" hangingPunct="1">
+              <a:defRPr>
+                <a:solidFill>
+                  <a:schemeClr val="tx2"/>
+                </a:solidFill>
+              </a:defRPr>
+            </a:lvl3pPr>
+            <a:lvl4pPr eaLnBrk="1" hangingPunct="1">
+              <a:defRPr>
+                <a:solidFill>
+                  <a:schemeClr val="tx2"/>
+                </a:solidFill>
+              </a:defRPr>
+            </a:lvl4pPr>
+            <a:lvl5pPr eaLnBrk="1" hangingPunct="1">
+              <a:defRPr>
+                <a:solidFill>
+                  <a:schemeClr val="tx2"/>
+                </a:solidFill>
+              </a:defRPr>
+            </a:lvl5pPr>
+            <a:lvl6pPr eaLnBrk="1" hangingPunct="1">
+              <a:defRPr>
+                <a:solidFill>
+                  <a:schemeClr val="tx2"/>
+                </a:solidFill>
+              </a:defRPr>
+            </a:lvl6pPr>
+            <a:lvl7pPr eaLnBrk="1" hangingPunct="1">
+              <a:defRPr>
+                <a:solidFill>
+                  <a:schemeClr val="tx2"/>
+                </a:solidFill>
+              </a:defRPr>
+            </a:lvl7pPr>
+            <a:lvl8pPr eaLnBrk="1" hangingPunct="1">
+              <a:defRPr>
+                <a:solidFill>
+                  <a:schemeClr val="tx2"/>
+                </a:solidFill>
+              </a:defRPr>
+            </a:lvl8pPr>
+            <a:lvl9pPr eaLnBrk="1" hangingPunct="1">
+              <a:defRPr>
+                <a:solidFill>
+                  <a:schemeClr val="tx2"/>
+                </a:solidFill>
+              </a:defRPr>
+            </a:lvl9pPr>
+          </a:lstStyle>
+          <a:p>
+            <a:pPr algn="ctr"/>
+            <a:r>
+              <a:rPr lang="fr-FR" sz="4400" dirty="0" err="1">
+                <a:solidFill>
+                  <a:schemeClr val="tx1"/>
+                </a:solidFill>
+                <a:latin typeface="Arial" panose="020B0604020202020204" pitchFamily="34" charset="0"/>
+                <a:cs typeface="Arial" panose="020B0604020202020204" pitchFamily="34" charset="0"/>
+              </a:rPr>
+              <a:t>XGBoost</a:t>
+            </a:r>
+            <a:endParaRPr lang="fr-FR" sz="4400" dirty="0">
+              <a:solidFill>
+                <a:schemeClr val="tx1"/>
+              </a:solidFill>
+              <a:latin typeface="Arial" panose="020B0604020202020204" pitchFamily="34" charset="0"/>
+              <a:cs typeface="Arial" panose="020B0604020202020204" pitchFamily="34" charset="0"/>
+            </a:endParaRPr>
+          </a:p>
+        </p:txBody>
+      </p:sp>
     </p:spTree>
     <p:extLst>
       <p:ext uri="{BB962C8B-B14F-4D97-AF65-F5344CB8AC3E}">
@@ -20249,6 +20423,332 @@
         <p:cNvPr id="1" name="">
           <a:extLst>
             <a:ext uri="{FF2B5EF4-FFF2-40B4-BE49-F238E27FC236}">
+              <a16:creationId xmlns:a16="http://schemas.microsoft.com/office/drawing/2014/main" id="{E431A2C4-25E2-3728-296E-F6373F7C6360}"/>
+            </a:ext>
+          </a:extLst>
+        </p:cNvPr>
+        <p:cNvGrpSpPr/>
+        <p:nvPr/>
+      </p:nvGrpSpPr>
+      <p:grpSpPr>
+        <a:xfrm>
+          <a:off x="0" y="0"/>
+          <a:ext cx="0" cy="0"/>
+          <a:chOff x="0" y="0"/>
+          <a:chExt cx="0" cy="0"/>
+        </a:xfrm>
+      </p:grpSpPr>
+      <p:sp>
+        <p:nvSpPr>
+          <p:cNvPr id="8" name="Titre 3">
+            <a:extLst>
+              <a:ext uri="{FF2B5EF4-FFF2-40B4-BE49-F238E27FC236}">
+                <a16:creationId xmlns:a16="http://schemas.microsoft.com/office/drawing/2014/main" id="{E7555151-0FB2-904B-9902-258325CCDE9D}"/>
+              </a:ext>
+            </a:extLst>
+          </p:cNvPr>
+          <p:cNvSpPr>
+            <a:spLocks noGrp="1"/>
+          </p:cNvSpPr>
+          <p:nvPr>
+            <p:ph type="title"/>
+          </p:nvPr>
+        </p:nvSpPr>
+        <p:spPr>
+          <a:xfrm>
+            <a:off x="581192" y="702156"/>
+            <a:ext cx="11029616" cy="1013800"/>
+          </a:xfrm>
+        </p:spPr>
+        <p:txBody>
+          <a:bodyPr/>
+          <a:lstStyle/>
+          <a:p>
+            <a:r>
+              <a:rPr lang="fr-FR" b="1" dirty="0"/>
+              <a:t>EVALUATION Finale</a:t>
+            </a:r>
+            <a:br>
+              <a:rPr lang="fr-FR" dirty="0"/>
+            </a:br>
+            <a:endParaRPr lang="fr-FR" dirty="0"/>
+          </a:p>
+        </p:txBody>
+      </p:sp>
+      <p:pic>
+        <p:nvPicPr>
+          <p:cNvPr id="12" name="Image 11">
+            <a:extLst>
+              <a:ext uri="{FF2B5EF4-FFF2-40B4-BE49-F238E27FC236}">
+                <a16:creationId xmlns:a16="http://schemas.microsoft.com/office/drawing/2014/main" id="{7350548B-853C-AAEC-0435-0203CCAD4D8A}"/>
+              </a:ext>
+            </a:extLst>
+          </p:cNvPr>
+          <p:cNvPicPr>
+            <a:picLocks noChangeAspect="1"/>
+          </p:cNvPicPr>
+          <p:nvPr/>
+        </p:nvPicPr>
+        <p:blipFill>
+          <a:blip r:embed="rId3"/>
+          <a:stretch>
+            <a:fillRect/>
+          </a:stretch>
+        </p:blipFill>
+        <p:spPr>
+          <a:xfrm>
+            <a:off x="865013" y="3199532"/>
+            <a:ext cx="3600737" cy="2648818"/>
+          </a:xfrm>
+          <a:prstGeom prst="rect">
+            <a:avLst/>
+          </a:prstGeom>
+        </p:spPr>
+      </p:pic>
+      <p:sp>
+        <p:nvSpPr>
+          <p:cNvPr id="15" name="Titre 1">
+            <a:extLst>
+              <a:ext uri="{FF2B5EF4-FFF2-40B4-BE49-F238E27FC236}">
+                <a16:creationId xmlns:a16="http://schemas.microsoft.com/office/drawing/2014/main" id="{2C0E204B-583C-A6F5-BFD5-DC91225801B8}"/>
+              </a:ext>
+            </a:extLst>
+          </p:cNvPr>
+          <p:cNvSpPr txBox="1">
+            <a:spLocks/>
+          </p:cNvSpPr>
+          <p:nvPr/>
+        </p:nvSpPr>
+        <p:spPr>
+          <a:xfrm>
+            <a:off x="479095" y="2185162"/>
+            <a:ext cx="4372571" cy="1013800"/>
+          </a:xfrm>
+          <a:prstGeom prst="rect">
+            <a:avLst/>
+          </a:prstGeom>
+        </p:spPr>
+        <p:txBody>
+          <a:bodyPr vert="horz" lIns="91440" tIns="45720" rIns="91440" bIns="45720" rtlCol="0" anchor="b">
+            <a:normAutofit/>
+          </a:bodyPr>
+          <a:lstStyle>
+            <a:lvl1pPr algn="l" defTabSz="457200" rtl="0" eaLnBrk="1" latinLnBrk="0" hangingPunct="1">
+              <a:spcBef>
+                <a:spcPct val="0"/>
+              </a:spcBef>
+              <a:buNone/>
+              <a:defRPr sz="2800" b="0" kern="1200" cap="all">
+                <a:solidFill>
+                  <a:schemeClr val="bg1"/>
+                </a:solidFill>
+                <a:latin typeface="+mj-lt"/>
+                <a:ea typeface="+mj-ea"/>
+                <a:cs typeface="+mj-cs"/>
+              </a:defRPr>
+            </a:lvl1pPr>
+            <a:lvl2pPr eaLnBrk="1" hangingPunct="1">
+              <a:defRPr>
+                <a:solidFill>
+                  <a:schemeClr val="tx2"/>
+                </a:solidFill>
+              </a:defRPr>
+            </a:lvl2pPr>
+            <a:lvl3pPr eaLnBrk="1" hangingPunct="1">
+              <a:defRPr>
+                <a:solidFill>
+                  <a:schemeClr val="tx2"/>
+                </a:solidFill>
+              </a:defRPr>
+            </a:lvl3pPr>
+            <a:lvl4pPr eaLnBrk="1" hangingPunct="1">
+              <a:defRPr>
+                <a:solidFill>
+                  <a:schemeClr val="tx2"/>
+                </a:solidFill>
+              </a:defRPr>
+            </a:lvl4pPr>
+            <a:lvl5pPr eaLnBrk="1" hangingPunct="1">
+              <a:defRPr>
+                <a:solidFill>
+                  <a:schemeClr val="tx2"/>
+                </a:solidFill>
+              </a:defRPr>
+            </a:lvl5pPr>
+            <a:lvl6pPr eaLnBrk="1" hangingPunct="1">
+              <a:defRPr>
+                <a:solidFill>
+                  <a:schemeClr val="tx2"/>
+                </a:solidFill>
+              </a:defRPr>
+            </a:lvl6pPr>
+            <a:lvl7pPr eaLnBrk="1" hangingPunct="1">
+              <a:defRPr>
+                <a:solidFill>
+                  <a:schemeClr val="tx2"/>
+                </a:solidFill>
+              </a:defRPr>
+            </a:lvl7pPr>
+            <a:lvl8pPr eaLnBrk="1" hangingPunct="1">
+              <a:defRPr>
+                <a:solidFill>
+                  <a:schemeClr val="tx2"/>
+                </a:solidFill>
+              </a:defRPr>
+            </a:lvl8pPr>
+            <a:lvl9pPr eaLnBrk="1" hangingPunct="1">
+              <a:defRPr>
+                <a:solidFill>
+                  <a:schemeClr val="tx2"/>
+                </a:solidFill>
+              </a:defRPr>
+            </a:lvl9pPr>
+          </a:lstStyle>
+          <a:p>
+            <a:pPr algn="ctr"/>
+            <a:r>
+              <a:rPr lang="fr-FR" sz="4400" dirty="0" err="1">
+                <a:solidFill>
+                  <a:schemeClr val="tx1"/>
+                </a:solidFill>
+                <a:latin typeface="Arial" panose="020B0604020202020204" pitchFamily="34" charset="0"/>
+                <a:cs typeface="Arial" panose="020B0604020202020204" pitchFamily="34" charset="0"/>
+              </a:rPr>
+              <a:t>XGBoost</a:t>
+            </a:r>
+            <a:endParaRPr lang="fr-FR" sz="4400" dirty="0">
+              <a:solidFill>
+                <a:schemeClr val="tx1"/>
+              </a:solidFill>
+              <a:latin typeface="Arial" panose="020B0604020202020204" pitchFamily="34" charset="0"/>
+              <a:cs typeface="Arial" panose="020B0604020202020204" pitchFamily="34" charset="0"/>
+            </a:endParaRPr>
+          </a:p>
+        </p:txBody>
+      </p:sp>
+      <p:sp>
+        <p:nvSpPr>
+          <p:cNvPr id="3" name="ZoneTexte 2">
+            <a:extLst>
+              <a:ext uri="{FF2B5EF4-FFF2-40B4-BE49-F238E27FC236}">
+                <a16:creationId xmlns:a16="http://schemas.microsoft.com/office/drawing/2014/main" id="{36D085EB-17E2-1495-7DD1-F070CEF791A5}"/>
+              </a:ext>
+            </a:extLst>
+          </p:cNvPr>
+          <p:cNvSpPr txBox="1"/>
+          <p:nvPr/>
+        </p:nvSpPr>
+        <p:spPr>
+          <a:xfrm>
+            <a:off x="5575300" y="3886200"/>
+            <a:ext cx="5562600" cy="1200329"/>
+          </a:xfrm>
+          <a:prstGeom prst="rect">
+            <a:avLst/>
+          </a:prstGeom>
+          <a:noFill/>
+        </p:spPr>
+        <p:txBody>
+          <a:bodyPr wrap="square" rtlCol="0">
+            <a:spAutoFit/>
+          </a:bodyPr>
+          <a:lstStyle/>
+          <a:p>
+            <a:pPr marL="285750" indent="-285750">
+              <a:buFont typeface="Arial" panose="020B0604020202020204" pitchFamily="34" charset="0"/>
+              <a:buChar char="•"/>
+            </a:pPr>
+            <a:r>
+              <a:rPr lang="fr-FR" sz="2400" dirty="0"/>
+              <a:t>152 départs correctement détectés</a:t>
+            </a:r>
+          </a:p>
+          <a:p>
+            <a:pPr marL="285750" indent="-285750">
+              <a:buFont typeface="Arial" panose="020B0604020202020204" pitchFamily="34" charset="0"/>
+              <a:buChar char="•"/>
+            </a:pPr>
+            <a:r>
+              <a:rPr lang="fr-FR" sz="2400" dirty="0"/>
+              <a:t>Seulement 6 départs manqués</a:t>
+            </a:r>
+          </a:p>
+          <a:p>
+            <a:pPr marL="285750" indent="-285750">
+              <a:buFont typeface="Arial" panose="020B0604020202020204" pitchFamily="34" charset="0"/>
+              <a:buChar char="•"/>
+            </a:pPr>
+            <a:r>
+              <a:rPr lang="fr-FR" sz="2400" dirty="0"/>
+              <a:t>46 fausses alertes</a:t>
+            </a:r>
+          </a:p>
+        </p:txBody>
+      </p:sp>
+      <p:sp>
+        <p:nvSpPr>
+          <p:cNvPr id="7" name="ZoneTexte 6">
+            <a:extLst>
+              <a:ext uri="{FF2B5EF4-FFF2-40B4-BE49-F238E27FC236}">
+                <a16:creationId xmlns:a16="http://schemas.microsoft.com/office/drawing/2014/main" id="{B56CD812-31E7-8C42-76BA-54AF6835C414}"/>
+              </a:ext>
+            </a:extLst>
+          </p:cNvPr>
+          <p:cNvSpPr txBox="1"/>
+          <p:nvPr/>
+        </p:nvSpPr>
+        <p:spPr>
+          <a:xfrm>
+            <a:off x="5575299" y="2494746"/>
+            <a:ext cx="5751687" cy="954107"/>
+          </a:xfrm>
+          <a:prstGeom prst="rect">
+            <a:avLst/>
+          </a:prstGeom>
+          <a:noFill/>
+        </p:spPr>
+        <p:txBody>
+          <a:bodyPr wrap="square" rtlCol="0">
+            <a:spAutoFit/>
+          </a:bodyPr>
+          <a:lstStyle/>
+          <a:p>
+            <a:r>
+              <a:rPr lang="fr-FR" sz="2800" dirty="0"/>
+              <a:t>Plus adapté à notre </a:t>
+            </a:r>
+            <a:r>
+              <a:rPr lang="fr-FR" sz="2800" dirty="0" err="1"/>
+              <a:t>problèmatique</a:t>
+            </a:r>
+            <a:r>
+              <a:rPr lang="fr-FR" sz="2800" dirty="0"/>
+              <a:t> métier RH</a:t>
+            </a:r>
+          </a:p>
+        </p:txBody>
+      </p:sp>
+    </p:spTree>
+    <p:extLst>
+      <p:ext uri="{BB962C8B-B14F-4D97-AF65-F5344CB8AC3E}">
+        <p14:creationId xmlns:p14="http://schemas.microsoft.com/office/powerpoint/2010/main" val="1375298666"/>
+      </p:ext>
+    </p:extLst>
+  </p:cSld>
+  <p:clrMapOvr>
+    <a:masterClrMapping/>
+  </p:clrMapOvr>
+</p:sld>
+</file>
+
+<file path=ppt/slides/slide41.xml><?xml version="1.0" encoding="utf-8"?>
+<p:sld xmlns:a="http://schemas.openxmlformats.org/drawingml/2006/main" xmlns:r="http://schemas.openxmlformats.org/officeDocument/2006/relationships" xmlns:p="http://schemas.openxmlformats.org/presentationml/2006/main">
+  <p:cSld>
+    <p:spTree>
+      <p:nvGrpSpPr>
+        <p:cNvPr id="1" name="">
+          <a:extLst>
+            <a:ext uri="{FF2B5EF4-FFF2-40B4-BE49-F238E27FC236}">
               <a16:creationId xmlns:a16="http://schemas.microsoft.com/office/drawing/2014/main" id="{3775402F-471B-553A-AB43-A1D1DD523F2D}"/>
             </a:ext>
           </a:extLst>
@@ -20311,7 +20811,7 @@
         <p:spPr>
           <a:xfrm>
             <a:off x="6982788" y="3429000"/>
-            <a:ext cx="4812176" cy="657936"/>
+            <a:ext cx="4812176" cy="1536700"/>
           </a:xfrm>
           <a:prstGeom prst="rect">
             <a:avLst/>
@@ -20363,14 +20863,41 @@
               <a:t> Importances</a:t>
             </a:r>
           </a:p>
+          <a:p>
+            <a:pPr marL="0" lvl="0" indent="0" algn="ctr" defTabSz="1600200" rtl="0">
+              <a:lnSpc>
+                <a:spcPct val="90000"/>
+              </a:lnSpc>
+              <a:spcBef>
+                <a:spcPct val="0"/>
+              </a:spcBef>
+              <a:spcAft>
+                <a:spcPct val="35000"/>
+              </a:spcAft>
+              <a:buNone/>
+            </a:pPr>
+            <a:r>
+              <a:rPr lang="fr-FR" sz="3600" dirty="0"/>
+              <a:t>Méthode </a:t>
+            </a:r>
+            <a:r>
+              <a:rPr lang="fr-FR" sz="3600" dirty="0" err="1"/>
+              <a:t>Beeswarm</a:t>
+            </a:r>
+            <a:r>
+              <a:rPr lang="fr-FR" sz="3600" dirty="0"/>
+              <a:t> SHAP</a:t>
+            </a:r>
+            <a:endParaRPr lang="fr-FR" sz="3600" kern="1200" noProof="0" dirty="0"/>
+          </a:p>
         </p:txBody>
       </p:sp>
       <p:pic>
         <p:nvPicPr>
-          <p:cNvPr id="3" name="Image 2">
-            <a:extLst>
-              <a:ext uri="{FF2B5EF4-FFF2-40B4-BE49-F238E27FC236}">
-                <a16:creationId xmlns:a16="http://schemas.microsoft.com/office/drawing/2014/main" id="{AA601D0E-E615-D908-58AF-46253D7D8E4E}"/>
+          <p:cNvPr id="5" name="Image 4">
+            <a:extLst>
+              <a:ext uri="{FF2B5EF4-FFF2-40B4-BE49-F238E27FC236}">
+                <a16:creationId xmlns:a16="http://schemas.microsoft.com/office/drawing/2014/main" id="{D3D3DB8E-4CDC-113F-E1B0-3DF42201CF7B}"/>
               </a:ext>
             </a:extLst>
           </p:cNvPr>
@@ -20387,244 +20914,246 @@
         </p:blipFill>
         <p:spPr>
           <a:xfrm>
-            <a:off x="928688" y="1527968"/>
-            <a:ext cx="5937160" cy="4789922"/>
+            <a:off x="449844" y="2116006"/>
+            <a:ext cx="6563424" cy="4340064"/>
           </a:xfrm>
           <a:prstGeom prst="rect">
             <a:avLst/>
           </a:prstGeom>
         </p:spPr>
       </p:pic>
+      <p:sp>
+        <p:nvSpPr>
+          <p:cNvPr id="6" name="Titre 1">
+            <a:extLst>
+              <a:ext uri="{FF2B5EF4-FFF2-40B4-BE49-F238E27FC236}">
+                <a16:creationId xmlns:a16="http://schemas.microsoft.com/office/drawing/2014/main" id="{425CCF26-E480-46FC-4D55-DF1FE7710E31}"/>
+              </a:ext>
+            </a:extLst>
+          </p:cNvPr>
+          <p:cNvSpPr txBox="1">
+            <a:spLocks/>
+          </p:cNvSpPr>
+          <p:nvPr/>
+        </p:nvSpPr>
+        <p:spPr>
+          <a:xfrm>
+            <a:off x="3865869" y="1915312"/>
+            <a:ext cx="1109992" cy="401388"/>
+          </a:xfrm>
+          <a:prstGeom prst="rect">
+            <a:avLst/>
+          </a:prstGeom>
+        </p:spPr>
+        <p:txBody>
+          <a:bodyPr vert="horz" lIns="91440" tIns="45720" rIns="91440" bIns="45720" rtlCol="0" anchor="b">
+            <a:normAutofit/>
+          </a:bodyPr>
+          <a:lstStyle>
+            <a:lvl1pPr algn="l" defTabSz="457200" rtl="0" eaLnBrk="1" latinLnBrk="0" hangingPunct="1">
+              <a:spcBef>
+                <a:spcPct val="0"/>
+              </a:spcBef>
+              <a:buNone/>
+              <a:defRPr sz="2800" b="0" kern="1200" cap="all">
+                <a:solidFill>
+                  <a:schemeClr val="bg1"/>
+                </a:solidFill>
+                <a:latin typeface="+mj-lt"/>
+                <a:ea typeface="+mj-ea"/>
+                <a:cs typeface="+mj-cs"/>
+              </a:defRPr>
+            </a:lvl1pPr>
+            <a:lvl2pPr eaLnBrk="1" hangingPunct="1">
+              <a:defRPr>
+                <a:solidFill>
+                  <a:schemeClr val="tx2"/>
+                </a:solidFill>
+              </a:defRPr>
+            </a:lvl2pPr>
+            <a:lvl3pPr eaLnBrk="1" hangingPunct="1">
+              <a:defRPr>
+                <a:solidFill>
+                  <a:schemeClr val="tx2"/>
+                </a:solidFill>
+              </a:defRPr>
+            </a:lvl3pPr>
+            <a:lvl4pPr eaLnBrk="1" hangingPunct="1">
+              <a:defRPr>
+                <a:solidFill>
+                  <a:schemeClr val="tx2"/>
+                </a:solidFill>
+              </a:defRPr>
+            </a:lvl4pPr>
+            <a:lvl5pPr eaLnBrk="1" hangingPunct="1">
+              <a:defRPr>
+                <a:solidFill>
+                  <a:schemeClr val="tx2"/>
+                </a:solidFill>
+              </a:defRPr>
+            </a:lvl5pPr>
+            <a:lvl6pPr eaLnBrk="1" hangingPunct="1">
+              <a:defRPr>
+                <a:solidFill>
+                  <a:schemeClr val="tx2"/>
+                </a:solidFill>
+              </a:defRPr>
+            </a:lvl6pPr>
+            <a:lvl7pPr eaLnBrk="1" hangingPunct="1">
+              <a:defRPr>
+                <a:solidFill>
+                  <a:schemeClr val="tx2"/>
+                </a:solidFill>
+              </a:defRPr>
+            </a:lvl7pPr>
+            <a:lvl8pPr eaLnBrk="1" hangingPunct="1">
+              <a:defRPr>
+                <a:solidFill>
+                  <a:schemeClr val="tx2"/>
+                </a:solidFill>
+              </a:defRPr>
+            </a:lvl8pPr>
+            <a:lvl9pPr eaLnBrk="1" hangingPunct="1">
+              <a:defRPr>
+                <a:solidFill>
+                  <a:schemeClr val="tx2"/>
+                </a:solidFill>
+              </a:defRPr>
+            </a:lvl9pPr>
+          </a:lstStyle>
+          <a:p>
+            <a:pPr algn="ctr"/>
+            <a:r>
+              <a:rPr lang="fr-FR" sz="1400" dirty="0">
+                <a:solidFill>
+                  <a:schemeClr val="tx1"/>
+                </a:solidFill>
+                <a:latin typeface="Arial" panose="020B0604020202020204" pitchFamily="34" charset="0"/>
+                <a:cs typeface="Arial" panose="020B0604020202020204" pitchFamily="34" charset="0"/>
+              </a:rPr>
+              <a:t>Reste</a:t>
+            </a:r>
+          </a:p>
+        </p:txBody>
+      </p:sp>
+      <p:sp>
+        <p:nvSpPr>
+          <p:cNvPr id="8" name="Titre 1">
+            <a:extLst>
+              <a:ext uri="{FF2B5EF4-FFF2-40B4-BE49-F238E27FC236}">
+                <a16:creationId xmlns:a16="http://schemas.microsoft.com/office/drawing/2014/main" id="{89C55D6A-F499-C008-B751-EC603C25B471}"/>
+              </a:ext>
+            </a:extLst>
+          </p:cNvPr>
+          <p:cNvSpPr txBox="1">
+            <a:spLocks/>
+          </p:cNvSpPr>
+          <p:nvPr/>
+        </p:nvSpPr>
+        <p:spPr>
+          <a:xfrm>
+            <a:off x="5189208" y="1915312"/>
+            <a:ext cx="1109992" cy="401388"/>
+          </a:xfrm>
+          <a:prstGeom prst="rect">
+            <a:avLst/>
+          </a:prstGeom>
+        </p:spPr>
+        <p:txBody>
+          <a:bodyPr vert="horz" lIns="91440" tIns="45720" rIns="91440" bIns="45720" rtlCol="0" anchor="b">
+            <a:normAutofit/>
+          </a:bodyPr>
+          <a:lstStyle>
+            <a:lvl1pPr algn="l" defTabSz="457200" rtl="0" eaLnBrk="1" latinLnBrk="0" hangingPunct="1">
+              <a:spcBef>
+                <a:spcPct val="0"/>
+              </a:spcBef>
+              <a:buNone/>
+              <a:defRPr sz="2800" b="0" kern="1200" cap="all">
+                <a:solidFill>
+                  <a:schemeClr val="bg1"/>
+                </a:solidFill>
+                <a:latin typeface="+mj-lt"/>
+                <a:ea typeface="+mj-ea"/>
+                <a:cs typeface="+mj-cs"/>
+              </a:defRPr>
+            </a:lvl1pPr>
+            <a:lvl2pPr eaLnBrk="1" hangingPunct="1">
+              <a:defRPr>
+                <a:solidFill>
+                  <a:schemeClr val="tx2"/>
+                </a:solidFill>
+              </a:defRPr>
+            </a:lvl2pPr>
+            <a:lvl3pPr eaLnBrk="1" hangingPunct="1">
+              <a:defRPr>
+                <a:solidFill>
+                  <a:schemeClr val="tx2"/>
+                </a:solidFill>
+              </a:defRPr>
+            </a:lvl3pPr>
+            <a:lvl4pPr eaLnBrk="1" hangingPunct="1">
+              <a:defRPr>
+                <a:solidFill>
+                  <a:schemeClr val="tx2"/>
+                </a:solidFill>
+              </a:defRPr>
+            </a:lvl4pPr>
+            <a:lvl5pPr eaLnBrk="1" hangingPunct="1">
+              <a:defRPr>
+                <a:solidFill>
+                  <a:schemeClr val="tx2"/>
+                </a:solidFill>
+              </a:defRPr>
+            </a:lvl5pPr>
+            <a:lvl6pPr eaLnBrk="1" hangingPunct="1">
+              <a:defRPr>
+                <a:solidFill>
+                  <a:schemeClr val="tx2"/>
+                </a:solidFill>
+              </a:defRPr>
+            </a:lvl6pPr>
+            <a:lvl7pPr eaLnBrk="1" hangingPunct="1">
+              <a:defRPr>
+                <a:solidFill>
+                  <a:schemeClr val="tx2"/>
+                </a:solidFill>
+              </a:defRPr>
+            </a:lvl7pPr>
+            <a:lvl8pPr eaLnBrk="1" hangingPunct="1">
+              <a:defRPr>
+                <a:solidFill>
+                  <a:schemeClr val="tx2"/>
+                </a:solidFill>
+              </a:defRPr>
+            </a:lvl8pPr>
+            <a:lvl9pPr eaLnBrk="1" hangingPunct="1">
+              <a:defRPr>
+                <a:solidFill>
+                  <a:schemeClr val="tx2"/>
+                </a:solidFill>
+              </a:defRPr>
+            </a:lvl9pPr>
+          </a:lstStyle>
+          <a:p>
+            <a:pPr algn="ctr"/>
+            <a:r>
+              <a:rPr lang="fr-FR" sz="1400" dirty="0">
+                <a:solidFill>
+                  <a:schemeClr val="tx1"/>
+                </a:solidFill>
+                <a:latin typeface="Arial" panose="020B0604020202020204" pitchFamily="34" charset="0"/>
+                <a:cs typeface="Arial" panose="020B0604020202020204" pitchFamily="34" charset="0"/>
+              </a:rPr>
+              <a:t>PART</a:t>
+            </a:r>
+          </a:p>
+        </p:txBody>
+      </p:sp>
     </p:spTree>
     <p:extLst>
       <p:ext uri="{BB962C8B-B14F-4D97-AF65-F5344CB8AC3E}">
         <p14:creationId xmlns:p14="http://schemas.microsoft.com/office/powerpoint/2010/main" val="1214922190"/>
-      </p:ext>
-    </p:extLst>
-  </p:cSld>
-  <p:clrMapOvr>
-    <a:masterClrMapping/>
-  </p:clrMapOvr>
-</p:sld>
-</file>
-
-<file path=ppt/slides/slide41.xml><?xml version="1.0" encoding="utf-8"?>
-<p:sld xmlns:a="http://schemas.openxmlformats.org/drawingml/2006/main" xmlns:r="http://schemas.openxmlformats.org/officeDocument/2006/relationships" xmlns:p="http://schemas.openxmlformats.org/presentationml/2006/main">
-  <p:cSld>
-    <p:spTree>
-      <p:nvGrpSpPr>
-        <p:cNvPr id="1" name="">
-          <a:extLst>
-            <a:ext uri="{FF2B5EF4-FFF2-40B4-BE49-F238E27FC236}">
-              <a16:creationId xmlns:a16="http://schemas.microsoft.com/office/drawing/2014/main" id="{F30BBB5A-7956-3D8B-A575-8040EE35CB8F}"/>
-            </a:ext>
-          </a:extLst>
-        </p:cNvPr>
-        <p:cNvGrpSpPr/>
-        <p:nvPr/>
-      </p:nvGrpSpPr>
-      <p:grpSpPr>
-        <a:xfrm>
-          <a:off x="0" y="0"/>
-          <a:ext cx="0" cy="0"/>
-          <a:chOff x="0" y="0"/>
-          <a:chExt cx="0" cy="0"/>
-        </a:xfrm>
-      </p:grpSpPr>
-      <p:sp>
-        <p:nvSpPr>
-          <p:cNvPr id="4" name="Titre 3">
-            <a:extLst>
-              <a:ext uri="{FF2B5EF4-FFF2-40B4-BE49-F238E27FC236}">
-                <a16:creationId xmlns:a16="http://schemas.microsoft.com/office/drawing/2014/main" id="{8777ED1F-0C09-3194-C9FC-0D653287A8DF}"/>
-              </a:ext>
-            </a:extLst>
-          </p:cNvPr>
-          <p:cNvSpPr>
-            <a:spLocks noGrp="1"/>
-          </p:cNvSpPr>
-          <p:nvPr>
-            <p:ph type="title"/>
-          </p:nvPr>
-        </p:nvSpPr>
-        <p:spPr/>
-        <p:txBody>
-          <a:bodyPr/>
-          <a:lstStyle/>
-          <a:p>
-            <a:r>
-              <a:rPr lang="fr-FR" b="1" dirty="0"/>
-              <a:t>EVALUATION Finale</a:t>
-            </a:r>
-            <a:br>
-              <a:rPr lang="fr-FR" dirty="0"/>
-            </a:br>
-            <a:endParaRPr lang="fr-FR" dirty="0"/>
-          </a:p>
-        </p:txBody>
-      </p:sp>
-      <p:sp>
-        <p:nvSpPr>
-          <p:cNvPr id="3" name="ZoneTexte 2">
-            <a:extLst>
-              <a:ext uri="{FF2B5EF4-FFF2-40B4-BE49-F238E27FC236}">
-                <a16:creationId xmlns:a16="http://schemas.microsoft.com/office/drawing/2014/main" id="{52297735-EBFF-BFB5-3925-434E790ED85A}"/>
-              </a:ext>
-            </a:extLst>
-          </p:cNvPr>
-          <p:cNvSpPr txBox="1"/>
-          <p:nvPr/>
-        </p:nvSpPr>
-        <p:spPr>
-          <a:xfrm>
-            <a:off x="299495" y="2000731"/>
-            <a:ext cx="11593010" cy="4247317"/>
-          </a:xfrm>
-          <a:prstGeom prst="rect">
-            <a:avLst/>
-          </a:prstGeom>
-          <a:noFill/>
-        </p:spPr>
-        <p:txBody>
-          <a:bodyPr wrap="square">
-            <a:spAutoFit/>
-          </a:bodyPr>
-          <a:lstStyle/>
-          <a:p>
-            <a:pPr algn="ctr"/>
-            <a:endParaRPr lang="fr-FR" dirty="0"/>
-          </a:p>
-          <a:p>
-            <a:pPr algn="ctr"/>
-            <a:r>
-              <a:rPr lang="fr-FR" b="1" dirty="0"/>
-              <a:t>La combinaison :</a:t>
-            </a:r>
-          </a:p>
-          <a:p>
-            <a:pPr algn="ctr"/>
-            <a:r>
-              <a:rPr lang="fr-FR" dirty="0"/>
-              <a:t>salaire bas + heures supplémentaires + distance domicile travail + nombre de participations PEE</a:t>
-            </a:r>
-          </a:p>
-          <a:p>
-            <a:pPr algn="ctr"/>
-            <a:r>
-              <a:rPr lang="fr-FR" dirty="0"/>
-              <a:t>joue un rôle de pression au travail qui n’est pas récompensé par le salaire</a:t>
-            </a:r>
-          </a:p>
-          <a:p>
-            <a:pPr algn="ctr"/>
-            <a:endParaRPr lang="fr-FR" dirty="0"/>
-          </a:p>
-          <a:p>
-            <a:pPr algn="ctr"/>
-            <a:endParaRPr lang="fr-FR" dirty="0"/>
-          </a:p>
-          <a:p>
-            <a:pPr algn="ctr"/>
-            <a:r>
-              <a:rPr lang="fr-FR" b="1" dirty="0"/>
-              <a:t>Les postes les plus touchés sont : </a:t>
-            </a:r>
-          </a:p>
-          <a:p>
-            <a:pPr marL="171450" indent="-171450" algn="ctr">
-              <a:buFont typeface="Arial" panose="020B0604020202020204" pitchFamily="34" charset="0"/>
-              <a:buChar char="•"/>
-            </a:pPr>
-            <a:r>
-              <a:rPr lang="fr-FR" sz="1800" b="0" i="0" kern="1200" dirty="0">
-                <a:solidFill>
-                  <a:schemeClr val="tx1"/>
-                </a:solidFill>
-                <a:effectLst/>
-                <a:latin typeface="+mn-lt"/>
-                <a:ea typeface="+mn-ea"/>
-                <a:cs typeface="+mn-cs"/>
-              </a:rPr>
-              <a:t>Représentant Commercial</a:t>
-            </a:r>
-          </a:p>
-          <a:p>
-            <a:pPr marL="171450" indent="-171450" algn="ctr">
-              <a:buFont typeface="Arial" panose="020B0604020202020204" pitchFamily="34" charset="0"/>
-              <a:buChar char="•"/>
-            </a:pPr>
-            <a:r>
-              <a:rPr lang="fr-FR" sz="1800" b="0" i="0" kern="1200" dirty="0">
-                <a:solidFill>
-                  <a:schemeClr val="tx1"/>
-                </a:solidFill>
-                <a:effectLst/>
-                <a:latin typeface="+mn-lt"/>
-                <a:ea typeface="+mn-ea"/>
-                <a:cs typeface="+mn-cs"/>
-              </a:rPr>
-              <a:t>Consultant</a:t>
-            </a:r>
-          </a:p>
-          <a:p>
-            <a:pPr marL="171450" indent="-171450" algn="ctr">
-              <a:buFont typeface="Arial" panose="020B0604020202020204" pitchFamily="34" charset="0"/>
-              <a:buChar char="•"/>
-            </a:pPr>
-            <a:r>
-              <a:rPr lang="fr-FR" sz="1800" b="0" i="0" kern="1200" dirty="0">
-                <a:solidFill>
-                  <a:schemeClr val="tx1"/>
-                </a:solidFill>
-                <a:effectLst/>
-                <a:latin typeface="+mn-lt"/>
-                <a:ea typeface="+mn-ea"/>
-                <a:cs typeface="+mn-cs"/>
-              </a:rPr>
-              <a:t>Ressources Humaines</a:t>
-            </a:r>
-          </a:p>
-          <a:p>
-            <a:pPr marL="171450" indent="-171450" algn="ctr">
-              <a:buFont typeface="Arial" panose="020B0604020202020204" pitchFamily="34" charset="0"/>
-              <a:buChar char="•"/>
-            </a:pPr>
-            <a:endParaRPr lang="fr-FR" dirty="0"/>
-          </a:p>
-          <a:p>
-            <a:pPr marL="171450" indent="-171450" algn="ctr">
-              <a:buFont typeface="Arial" panose="020B0604020202020204" pitchFamily="34" charset="0"/>
-              <a:buChar char="•"/>
-            </a:pPr>
-            <a:endParaRPr lang="fr-FR" dirty="0"/>
-          </a:p>
-          <a:p>
-            <a:pPr algn="ctr"/>
-            <a:r>
-              <a:rPr lang="fr-FR" dirty="0"/>
-              <a:t>Le modèle est cohérent avec l’analyse préliminaire des données</a:t>
-            </a:r>
-          </a:p>
-          <a:p>
-            <a:pPr algn="ctr"/>
-            <a:r>
-              <a:rPr lang="fr-FR" dirty="0"/>
-              <a:t>Cependant, le modèle est loin d’être parfait avec beaucoup de prédictions incorrectes</a:t>
-            </a:r>
-          </a:p>
-          <a:p>
-            <a:pPr algn="ctr"/>
-            <a:r>
-              <a:rPr lang="fr-FR" dirty="0"/>
-              <a:t>Les données n’expliquent pas tout mais donne une tendance localisée</a:t>
-            </a:r>
-          </a:p>
-        </p:txBody>
-      </p:sp>
-    </p:spTree>
-    <p:extLst>
-      <p:ext uri="{BB962C8B-B14F-4D97-AF65-F5344CB8AC3E}">
-        <p14:creationId xmlns:p14="http://schemas.microsoft.com/office/powerpoint/2010/main" val="2147500627"/>
       </p:ext>
     </p:extLst>
   </p:cSld>
@@ -20864,10 +21393,10 @@
       </p:sp>
       <p:pic>
         <p:nvPicPr>
-          <p:cNvPr id="4" name="Image 3">
-            <a:extLst>
-              <a:ext uri="{FF2B5EF4-FFF2-40B4-BE49-F238E27FC236}">
-                <a16:creationId xmlns:a16="http://schemas.microsoft.com/office/drawing/2014/main" id="{8524568F-AD33-3E82-601D-70507A946E1F}"/>
+          <p:cNvPr id="5" name="Image 4">
+            <a:extLst>
+              <a:ext uri="{FF2B5EF4-FFF2-40B4-BE49-F238E27FC236}">
+                <a16:creationId xmlns:a16="http://schemas.microsoft.com/office/drawing/2014/main" id="{CED3A3B5-FB71-2C16-AE87-011F126522B0}"/>
               </a:ext>
             </a:extLst>
           </p:cNvPr>
@@ -20884,8 +21413,8 @@
         </p:blipFill>
         <p:spPr>
           <a:xfrm>
-            <a:off x="1814512" y="788128"/>
-            <a:ext cx="9422651" cy="4626835"/>
+            <a:off x="1596062" y="650136"/>
+            <a:ext cx="9422651" cy="4614351"/>
           </a:xfrm>
           <a:prstGeom prst="rect">
             <a:avLst/>
@@ -20906,6 +21435,855 @@
 </file>
 
 <file path=ppt/slides/slide43.xml><?xml version="1.0" encoding="utf-8"?>
+<p:sld xmlns:a="http://schemas.openxmlformats.org/drawingml/2006/main" xmlns:r="http://schemas.openxmlformats.org/officeDocument/2006/relationships" xmlns:p="http://schemas.openxmlformats.org/presentationml/2006/main">
+  <p:cSld>
+    <p:spTree>
+      <p:nvGrpSpPr>
+        <p:cNvPr id="1" name=""/>
+        <p:cNvGrpSpPr/>
+        <p:nvPr/>
+      </p:nvGrpSpPr>
+      <p:grpSpPr>
+        <a:xfrm>
+          <a:off x="0" y="0"/>
+          <a:ext cx="0" cy="0"/>
+          <a:chOff x="0" y="0"/>
+          <a:chExt cx="0" cy="0"/>
+        </a:xfrm>
+      </p:grpSpPr>
+      <p:sp>
+        <p:nvSpPr>
+          <p:cNvPr id="2" name="Titre 1">
+            <a:extLst>
+              <a:ext uri="{FF2B5EF4-FFF2-40B4-BE49-F238E27FC236}">
+                <a16:creationId xmlns:a16="http://schemas.microsoft.com/office/drawing/2014/main" id="{59934296-83DA-CEAD-A449-078039C09F3C}"/>
+              </a:ext>
+            </a:extLst>
+          </p:cNvPr>
+          <p:cNvSpPr>
+            <a:spLocks noGrp="1"/>
+          </p:cNvSpPr>
+          <p:nvPr>
+            <p:ph type="title"/>
+          </p:nvPr>
+        </p:nvSpPr>
+        <p:spPr/>
+        <p:txBody>
+          <a:bodyPr/>
+          <a:lstStyle/>
+          <a:p>
+            <a:r>
+              <a:rPr lang="fr-FR" dirty="0"/>
+              <a:t>Analyse des résultats</a:t>
+            </a:r>
+          </a:p>
+        </p:txBody>
+      </p:sp>
+      <p:sp>
+        <p:nvSpPr>
+          <p:cNvPr id="6" name="ZoneTexte 5">
+            <a:extLst>
+              <a:ext uri="{FF2B5EF4-FFF2-40B4-BE49-F238E27FC236}">
+                <a16:creationId xmlns:a16="http://schemas.microsoft.com/office/drawing/2014/main" id="{ED86BB06-FCE9-520A-8158-7E97B6EF4988}"/>
+              </a:ext>
+            </a:extLst>
+          </p:cNvPr>
+          <p:cNvSpPr txBox="1"/>
+          <p:nvPr/>
+        </p:nvSpPr>
+        <p:spPr>
+          <a:xfrm>
+            <a:off x="581192" y="2144236"/>
+            <a:ext cx="6096000" cy="2031325"/>
+          </a:xfrm>
+          <a:prstGeom prst="rect">
+            <a:avLst/>
+          </a:prstGeom>
+          <a:noFill/>
+        </p:spPr>
+        <p:txBody>
+          <a:bodyPr wrap="square">
+            <a:spAutoFit/>
+          </a:bodyPr>
+          <a:lstStyle/>
+          <a:p>
+            <a:pPr marL="285750" indent="-285750">
+              <a:buFont typeface="Arial" panose="020B0604020202020204" pitchFamily="34" charset="0"/>
+              <a:buChar char="•"/>
+            </a:pPr>
+            <a:r>
+              <a:rPr lang="fr-FR" dirty="0">
+                <a:latin typeface="Arial" panose="020B0604020202020204" pitchFamily="34" charset="0"/>
+                <a:cs typeface="Arial" panose="020B0604020202020204" pitchFamily="34" charset="0"/>
+              </a:rPr>
+              <a:t>L'analyse SHAP montre que la </a:t>
+            </a:r>
+            <a:r>
+              <a:rPr lang="fr-FR" b="1" dirty="0">
+                <a:latin typeface="Arial" panose="020B0604020202020204" pitchFamily="34" charset="0"/>
+                <a:cs typeface="Arial" panose="020B0604020202020204" pitchFamily="34" charset="0"/>
+              </a:rPr>
+              <a:t>participation PEE est la variable la plus influente</a:t>
+            </a:r>
+            <a:r>
+              <a:rPr lang="fr-FR" dirty="0">
+                <a:latin typeface="Arial" panose="020B0604020202020204" pitchFamily="34" charset="0"/>
+                <a:cs typeface="Arial" panose="020B0604020202020204" pitchFamily="34" charset="0"/>
+              </a:rPr>
+              <a:t> dans la prédiction du départ des employés. Les </a:t>
+            </a:r>
+            <a:r>
+              <a:rPr lang="fr-FR" b="1" dirty="0">
+                <a:latin typeface="Arial" panose="020B0604020202020204" pitchFamily="34" charset="0"/>
+                <a:cs typeface="Arial" panose="020B0604020202020204" pitchFamily="34" charset="0"/>
+              </a:rPr>
+              <a:t>valeurs élevées d’heures supplémentaires et de pression au travail </a:t>
+            </a:r>
+            <a:r>
+              <a:rPr lang="fr-FR" dirty="0">
+                <a:latin typeface="Arial" panose="020B0604020202020204" pitchFamily="34" charset="0"/>
+                <a:cs typeface="Arial" panose="020B0604020202020204" pitchFamily="34" charset="0"/>
+              </a:rPr>
+              <a:t>sont principalement associées à des valeurs SHAP positives, indiquant </a:t>
+            </a:r>
+            <a:r>
+              <a:rPr lang="fr-FR" b="1" dirty="0">
+                <a:latin typeface="Arial" panose="020B0604020202020204" pitchFamily="34" charset="0"/>
+                <a:cs typeface="Arial" panose="020B0604020202020204" pitchFamily="34" charset="0"/>
+              </a:rPr>
+              <a:t>qu'elles augmentent le risque prédit de départ</a:t>
+            </a:r>
+            <a:r>
+              <a:rPr lang="fr-FR" dirty="0">
+                <a:latin typeface="Arial" panose="020B0604020202020204" pitchFamily="34" charset="0"/>
+                <a:cs typeface="Arial" panose="020B0604020202020204" pitchFamily="34" charset="0"/>
+              </a:rPr>
+              <a:t>.</a:t>
+            </a:r>
+          </a:p>
+        </p:txBody>
+      </p:sp>
+      <p:sp>
+        <p:nvSpPr>
+          <p:cNvPr id="7" name="ZoneTexte 6">
+            <a:extLst>
+              <a:ext uri="{FF2B5EF4-FFF2-40B4-BE49-F238E27FC236}">
+                <a16:creationId xmlns:a16="http://schemas.microsoft.com/office/drawing/2014/main" id="{F4A1394F-8772-5380-C766-1BD6C3FA6249}"/>
+              </a:ext>
+            </a:extLst>
+          </p:cNvPr>
+          <p:cNvSpPr txBox="1"/>
+          <p:nvPr/>
+        </p:nvSpPr>
+        <p:spPr>
+          <a:xfrm>
+            <a:off x="581192" y="4603841"/>
+            <a:ext cx="6096000" cy="1200329"/>
+          </a:xfrm>
+          <a:prstGeom prst="rect">
+            <a:avLst/>
+          </a:prstGeom>
+          <a:noFill/>
+        </p:spPr>
+        <p:txBody>
+          <a:bodyPr wrap="square">
+            <a:spAutoFit/>
+          </a:bodyPr>
+          <a:lstStyle>
+            <a:defPPr rtl="0">
+              <a:defRPr lang="fr-FR"/>
+            </a:defPPr>
+            <a:lvl1pPr marL="285750" indent="-285750">
+              <a:buFont typeface="Arial" panose="020B0604020202020204" pitchFamily="34" charset="0"/>
+              <a:buChar char="•"/>
+              <a:defRPr>
+                <a:latin typeface="Arial" panose="020B0604020202020204" pitchFamily="34" charset="0"/>
+                <a:cs typeface="Arial" panose="020B0604020202020204" pitchFamily="34" charset="0"/>
+              </a:defRPr>
+            </a:lvl1pPr>
+          </a:lstStyle>
+          <a:p>
+            <a:r>
+              <a:rPr lang="fr-FR" dirty="0"/>
+              <a:t>Les résultats du modèle doivent être </a:t>
+            </a:r>
+            <a:r>
+              <a:rPr lang="fr-FR" b="1" dirty="0"/>
+              <a:t>interprétés avec prudence</a:t>
+            </a:r>
+            <a:r>
+              <a:rPr lang="fr-FR" dirty="0"/>
+              <a:t> en raison d’un </a:t>
+            </a:r>
+            <a:r>
+              <a:rPr lang="fr-FR" b="1" dirty="0"/>
+              <a:t>risque potentiel de data </a:t>
+            </a:r>
+            <a:r>
+              <a:rPr lang="fr-FR" b="1" dirty="0" err="1"/>
+              <a:t>leakage</a:t>
+            </a:r>
+            <a:r>
+              <a:rPr lang="fr-FR" dirty="0"/>
+              <a:t> associé aux variables issues du sondage collaborateur. </a:t>
+            </a:r>
+          </a:p>
+        </p:txBody>
+      </p:sp>
+      <p:sp>
+        <p:nvSpPr>
+          <p:cNvPr id="8" name="ZoneTexte 7">
+            <a:extLst>
+              <a:ext uri="{FF2B5EF4-FFF2-40B4-BE49-F238E27FC236}">
+                <a16:creationId xmlns:a16="http://schemas.microsoft.com/office/drawing/2014/main" id="{D463666C-40C0-8C75-24EE-995D61180735}"/>
+              </a:ext>
+            </a:extLst>
+          </p:cNvPr>
+          <p:cNvSpPr txBox="1"/>
+          <p:nvPr/>
+        </p:nvSpPr>
+        <p:spPr>
+          <a:xfrm>
+            <a:off x="6934200" y="4603840"/>
+            <a:ext cx="4676608" cy="1200329"/>
+          </a:xfrm>
+          <a:prstGeom prst="rect">
+            <a:avLst/>
+          </a:prstGeom>
+          <a:noFill/>
+        </p:spPr>
+        <p:txBody>
+          <a:bodyPr wrap="square">
+            <a:spAutoFit/>
+          </a:bodyPr>
+          <a:lstStyle>
+            <a:defPPr rtl="0">
+              <a:defRPr lang="fr-FR"/>
+            </a:defPPr>
+            <a:lvl1pPr marL="285750" indent="-285750">
+              <a:buFont typeface="Arial" panose="020B0604020202020204" pitchFamily="34" charset="0"/>
+              <a:buChar char="•"/>
+              <a:defRPr>
+                <a:latin typeface="Arial" panose="020B0604020202020204" pitchFamily="34" charset="0"/>
+                <a:cs typeface="Arial" panose="020B0604020202020204" pitchFamily="34" charset="0"/>
+              </a:defRPr>
+            </a:lvl1pPr>
+          </a:lstStyle>
+          <a:p>
+            <a:pPr marL="0" indent="0">
+              <a:buNone/>
+            </a:pPr>
+            <a:r>
+              <a:rPr lang="fr-FR" b="1" dirty="0"/>
+              <a:t>Les postes les plus touchés sont : </a:t>
+            </a:r>
+          </a:p>
+          <a:p>
+            <a:r>
+              <a:rPr lang="fr-FR" dirty="0"/>
+              <a:t>Représentant Commercial</a:t>
+            </a:r>
+          </a:p>
+          <a:p>
+            <a:r>
+              <a:rPr lang="fr-FR" dirty="0"/>
+              <a:t>Consultant</a:t>
+            </a:r>
+          </a:p>
+          <a:p>
+            <a:r>
+              <a:rPr lang="fr-FR" dirty="0"/>
+              <a:t>Ressources Humaines</a:t>
+            </a:r>
+          </a:p>
+        </p:txBody>
+      </p:sp>
+      <p:sp>
+        <p:nvSpPr>
+          <p:cNvPr id="10" name="ZoneTexte 9">
+            <a:extLst>
+              <a:ext uri="{FF2B5EF4-FFF2-40B4-BE49-F238E27FC236}">
+                <a16:creationId xmlns:a16="http://schemas.microsoft.com/office/drawing/2014/main" id="{ADCE9426-E859-6887-E12D-99F1362F0F2C}"/>
+              </a:ext>
+            </a:extLst>
+          </p:cNvPr>
+          <p:cNvSpPr txBox="1"/>
+          <p:nvPr/>
+        </p:nvSpPr>
+        <p:spPr>
+          <a:xfrm>
+            <a:off x="6934200" y="2144236"/>
+            <a:ext cx="4829175" cy="1477328"/>
+          </a:xfrm>
+          <a:prstGeom prst="rect">
+            <a:avLst/>
+          </a:prstGeom>
+          <a:noFill/>
+        </p:spPr>
+        <p:txBody>
+          <a:bodyPr wrap="square">
+            <a:spAutoFit/>
+          </a:bodyPr>
+          <a:lstStyle/>
+          <a:p>
+            <a:pPr marL="285750" indent="-285750">
+              <a:buFont typeface="Arial" panose="020B0604020202020204" pitchFamily="34" charset="0"/>
+              <a:buChar char="•"/>
+            </a:pPr>
+            <a:r>
+              <a:rPr lang="fr-FR" dirty="0">
+                <a:latin typeface="Arial" panose="020B0604020202020204" pitchFamily="34" charset="0"/>
+                <a:cs typeface="Arial" panose="020B0604020202020204" pitchFamily="34" charset="0"/>
+              </a:rPr>
+              <a:t>L'analyse des prédictions montre un modèle capable de prédire les départs avec peu d’erreurs dans les faux négatifs, Le modèle peut donc accompagner la recherche d’éventuels départs</a:t>
+            </a:r>
+          </a:p>
+        </p:txBody>
+      </p:sp>
+    </p:spTree>
+    <p:extLst>
+      <p:ext uri="{BB962C8B-B14F-4D97-AF65-F5344CB8AC3E}">
+        <p14:creationId xmlns:p14="http://schemas.microsoft.com/office/powerpoint/2010/main" val="1603750557"/>
+      </p:ext>
+    </p:extLst>
+  </p:cSld>
+  <p:clrMapOvr>
+    <a:masterClrMapping/>
+  </p:clrMapOvr>
+</p:sld>
+</file>
+
+<file path=ppt/slides/slide44.xml><?xml version="1.0" encoding="utf-8"?>
+<p:sld xmlns:a="http://schemas.openxmlformats.org/drawingml/2006/main" xmlns:r="http://schemas.openxmlformats.org/officeDocument/2006/relationships" xmlns:p="http://schemas.openxmlformats.org/presentationml/2006/main">
+  <p:cSld>
+    <p:spTree>
+      <p:nvGrpSpPr>
+        <p:cNvPr id="1" name=""/>
+        <p:cNvGrpSpPr/>
+        <p:nvPr/>
+      </p:nvGrpSpPr>
+      <p:grpSpPr>
+        <a:xfrm>
+          <a:off x="0" y="0"/>
+          <a:ext cx="0" cy="0"/>
+          <a:chOff x="0" y="0"/>
+          <a:chExt cx="0" cy="0"/>
+        </a:xfrm>
+      </p:grpSpPr>
+      <p:sp>
+        <p:nvSpPr>
+          <p:cNvPr id="2" name="Titre 1">
+            <a:extLst>
+              <a:ext uri="{FF2B5EF4-FFF2-40B4-BE49-F238E27FC236}">
+                <a16:creationId xmlns:a16="http://schemas.microsoft.com/office/drawing/2014/main" id="{D760A667-1637-0FB5-5FFF-5B96BDD5C5B0}"/>
+              </a:ext>
+            </a:extLst>
+          </p:cNvPr>
+          <p:cNvSpPr>
+            <a:spLocks noGrp="1"/>
+          </p:cNvSpPr>
+          <p:nvPr>
+            <p:ph type="title"/>
+          </p:nvPr>
+        </p:nvSpPr>
+        <p:spPr/>
+        <p:txBody>
+          <a:bodyPr/>
+          <a:lstStyle/>
+          <a:p>
+            <a:r>
+              <a:rPr lang="fr-FR" dirty="0"/>
+              <a:t>Recommandations</a:t>
+            </a:r>
+          </a:p>
+        </p:txBody>
+      </p:sp>
+      <p:sp>
+        <p:nvSpPr>
+          <p:cNvPr id="9" name="ZoneTexte 8">
+            <a:extLst>
+              <a:ext uri="{FF2B5EF4-FFF2-40B4-BE49-F238E27FC236}">
+                <a16:creationId xmlns:a16="http://schemas.microsoft.com/office/drawing/2014/main" id="{75565FA7-057A-D318-9F88-58A0701CB287}"/>
+              </a:ext>
+            </a:extLst>
+          </p:cNvPr>
+          <p:cNvSpPr txBox="1"/>
+          <p:nvPr/>
+        </p:nvSpPr>
+        <p:spPr>
+          <a:xfrm>
+            <a:off x="428792" y="2277420"/>
+            <a:ext cx="11182016" cy="1754326"/>
+          </a:xfrm>
+          <a:prstGeom prst="rect">
+            <a:avLst/>
+          </a:prstGeom>
+          <a:noFill/>
+        </p:spPr>
+        <p:txBody>
+          <a:bodyPr wrap="square">
+            <a:spAutoFit/>
+          </a:bodyPr>
+          <a:lstStyle>
+            <a:defPPr rtl="0">
+              <a:defRPr lang="fr-FR"/>
+            </a:defPPr>
+            <a:lvl1pPr marL="285750" indent="-285750">
+              <a:buFont typeface="Arial" panose="020B0604020202020204" pitchFamily="34" charset="0"/>
+              <a:buChar char="•"/>
+              <a:defRPr>
+                <a:latin typeface="Arial" panose="020B0604020202020204" pitchFamily="34" charset="0"/>
+                <a:cs typeface="Arial" panose="020B0604020202020204" pitchFamily="34" charset="0"/>
+              </a:defRPr>
+            </a:lvl1pPr>
+          </a:lstStyle>
+          <a:p>
+            <a:r>
+              <a:rPr lang="fr-FR" b="1" dirty="0">
+                <a:solidFill>
+                  <a:schemeClr val="accent1">
+                    <a:lumMod val="60000"/>
+                    <a:lumOff val="40000"/>
+                  </a:schemeClr>
+                </a:solidFill>
+              </a:rPr>
+              <a:t>Le modèle aide à la prédiction des départs mais ne doivent pas être interprétées comme des causes certaines de départ.</a:t>
+            </a:r>
+          </a:p>
+          <a:p>
+            <a:endParaRPr lang="fr-FR" b="1" dirty="0">
+              <a:solidFill>
+                <a:schemeClr val="accent1">
+                  <a:lumMod val="60000"/>
+                  <a:lumOff val="40000"/>
+                </a:schemeClr>
+              </a:solidFill>
+            </a:endParaRPr>
+          </a:p>
+          <a:p>
+            <a:r>
+              <a:rPr lang="fr-FR" b="1" dirty="0">
+                <a:solidFill>
+                  <a:schemeClr val="accent5">
+                    <a:lumMod val="50000"/>
+                  </a:schemeClr>
+                </a:solidFill>
+              </a:rPr>
+              <a:t>Les analyses montrent que participation PEE, la pression au travail, la satisfaction professionnelle et les heures supplémentaires figurent parmi les variables ayant le plus d'influence sur la prédiction du risque de départ</a:t>
+            </a:r>
+            <a:endParaRPr lang="fr-FR" sz="1400" b="1" dirty="0">
+              <a:solidFill>
+                <a:schemeClr val="accent5">
+                  <a:lumMod val="50000"/>
+                </a:schemeClr>
+              </a:solidFill>
+              <a:latin typeface="Arial" panose="020B0604020202020204" pitchFamily="34" charset="0"/>
+              <a:cs typeface="Arial" panose="020B0604020202020204" pitchFamily="34" charset="0"/>
+            </a:endParaRPr>
+          </a:p>
+        </p:txBody>
+      </p:sp>
+      <p:sp>
+        <p:nvSpPr>
+          <p:cNvPr id="5" name="ZoneTexte 4">
+            <a:extLst>
+              <a:ext uri="{FF2B5EF4-FFF2-40B4-BE49-F238E27FC236}">
+                <a16:creationId xmlns:a16="http://schemas.microsoft.com/office/drawing/2014/main" id="{2D68F42B-7567-F45A-F4F9-6C6EBEA9F0A5}"/>
+              </a:ext>
+            </a:extLst>
+          </p:cNvPr>
+          <p:cNvSpPr txBox="1"/>
+          <p:nvPr/>
+        </p:nvSpPr>
+        <p:spPr>
+          <a:xfrm>
+            <a:off x="428792" y="4598246"/>
+            <a:ext cx="4800601" cy="1384995"/>
+          </a:xfrm>
+          <a:prstGeom prst="rect">
+            <a:avLst/>
+          </a:prstGeom>
+          <a:noFill/>
+        </p:spPr>
+        <p:txBody>
+          <a:bodyPr wrap="square">
+            <a:spAutoFit/>
+          </a:bodyPr>
+          <a:lstStyle/>
+          <a:p>
+            <a:endParaRPr lang="fr-FR" dirty="0">
+              <a:ln w="0"/>
+              <a:solidFill>
+                <a:schemeClr val="accent1"/>
+              </a:solidFill>
+              <a:effectLst>
+                <a:outerShdw blurRad="38100" dist="25400" dir="5400000" algn="ctr" rotWithShape="0">
+                  <a:srgbClr val="6E747A">
+                    <a:alpha val="43000"/>
+                  </a:srgbClr>
+                </a:outerShdw>
+              </a:effectLst>
+            </a:endParaRPr>
+          </a:p>
+          <a:p>
+            <a:pPr marL="0" indent="0">
+              <a:buNone/>
+            </a:pPr>
+            <a:r>
+              <a:rPr lang="fr-FR" dirty="0">
+                <a:ln w="0"/>
+                <a:solidFill>
+                  <a:schemeClr val="accent1"/>
+                </a:solidFill>
+                <a:effectLst>
+                  <a:outerShdw blurRad="38100" dist="25400" dir="5400000" algn="ctr" rotWithShape="0">
+                    <a:srgbClr val="6E747A">
+                      <a:alpha val="43000"/>
+                    </a:srgbClr>
+                  </a:outerShdw>
+                </a:effectLst>
+              </a:rPr>
+              <a:t>Créer des indicateurs de suivi : </a:t>
+            </a:r>
+          </a:p>
+          <a:p>
+            <a:pPr marL="857250" indent="-285750">
+              <a:buFont typeface="Arial" panose="020B0604020202020204" pitchFamily="34" charset="0"/>
+              <a:buChar char="•"/>
+            </a:pPr>
+            <a:r>
+              <a:rPr lang="fr-FR" sz="1600" dirty="0">
+                <a:ln w="0"/>
+                <a:solidFill>
+                  <a:schemeClr val="accent1"/>
+                </a:solidFill>
+                <a:effectLst>
+                  <a:outerShdw blurRad="38100" dist="25400" dir="5400000" algn="ctr" rotWithShape="0">
+                    <a:srgbClr val="6E747A">
+                      <a:alpha val="43000"/>
+                    </a:srgbClr>
+                  </a:outerShdw>
+                </a:effectLst>
+                <a:latin typeface="Arial" panose="020B0604020202020204" pitchFamily="34" charset="0"/>
+                <a:cs typeface="Arial" panose="020B0604020202020204" pitchFamily="34" charset="0"/>
+              </a:rPr>
+              <a:t>évolution des heures supplémentaires</a:t>
+            </a:r>
+          </a:p>
+          <a:p>
+            <a:pPr marL="857250" indent="-285750">
+              <a:buFont typeface="Arial" panose="020B0604020202020204" pitchFamily="34" charset="0"/>
+              <a:buChar char="•"/>
+            </a:pPr>
+            <a:r>
+              <a:rPr lang="fr-FR" sz="1600" dirty="0">
+                <a:ln w="0"/>
+                <a:solidFill>
+                  <a:schemeClr val="accent1"/>
+                </a:solidFill>
+                <a:effectLst>
+                  <a:outerShdw blurRad="38100" dist="25400" dir="5400000" algn="ctr" rotWithShape="0">
+                    <a:srgbClr val="6E747A">
+                      <a:alpha val="43000"/>
+                    </a:srgbClr>
+                  </a:outerShdw>
+                </a:effectLst>
+                <a:latin typeface="Arial" panose="020B0604020202020204" pitchFamily="34" charset="0"/>
+                <a:cs typeface="Arial" panose="020B0604020202020204" pitchFamily="34" charset="0"/>
+              </a:rPr>
+              <a:t>score de satisfaction</a:t>
+            </a:r>
+          </a:p>
+          <a:p>
+            <a:pPr marL="857250" indent="-285750">
+              <a:buFont typeface="Arial" panose="020B0604020202020204" pitchFamily="34" charset="0"/>
+              <a:buChar char="•"/>
+            </a:pPr>
+            <a:r>
+              <a:rPr lang="fr-FR" sz="1600" dirty="0">
+                <a:ln w="0"/>
+                <a:solidFill>
+                  <a:schemeClr val="accent1"/>
+                </a:solidFill>
+                <a:effectLst>
+                  <a:outerShdw blurRad="38100" dist="25400" dir="5400000" algn="ctr" rotWithShape="0">
+                    <a:srgbClr val="6E747A">
+                      <a:alpha val="43000"/>
+                    </a:srgbClr>
+                  </a:outerShdw>
+                </a:effectLst>
+                <a:latin typeface="Arial" panose="020B0604020202020204" pitchFamily="34" charset="0"/>
+                <a:cs typeface="Arial" panose="020B0604020202020204" pitchFamily="34" charset="0"/>
+              </a:rPr>
+              <a:t>taux de départs</a:t>
+            </a:r>
+            <a:endParaRPr lang="fr-FR" sz="1600" dirty="0">
+              <a:ln w="0"/>
+              <a:solidFill>
+                <a:schemeClr val="accent1"/>
+              </a:solidFill>
+              <a:effectLst>
+                <a:outerShdw blurRad="38100" dist="25400" dir="5400000" algn="ctr" rotWithShape="0">
+                  <a:srgbClr val="6E747A">
+                    <a:alpha val="43000"/>
+                  </a:srgbClr>
+                </a:outerShdw>
+              </a:effectLst>
+            </a:endParaRPr>
+          </a:p>
+        </p:txBody>
+      </p:sp>
+      <p:sp>
+        <p:nvSpPr>
+          <p:cNvPr id="6" name="ZoneTexte 5">
+            <a:extLst>
+              <a:ext uri="{FF2B5EF4-FFF2-40B4-BE49-F238E27FC236}">
+                <a16:creationId xmlns:a16="http://schemas.microsoft.com/office/drawing/2014/main" id="{3E89F014-BDA8-5981-1706-3062C32ECF1C}"/>
+              </a:ext>
+            </a:extLst>
+          </p:cNvPr>
+          <p:cNvSpPr txBox="1"/>
+          <p:nvPr/>
+        </p:nvSpPr>
+        <p:spPr>
+          <a:xfrm>
+            <a:off x="5572125" y="4598245"/>
+            <a:ext cx="6734175" cy="1877437"/>
+          </a:xfrm>
+          <a:prstGeom prst="rect">
+            <a:avLst/>
+          </a:prstGeom>
+          <a:noFill/>
+        </p:spPr>
+        <p:txBody>
+          <a:bodyPr wrap="square">
+            <a:spAutoFit/>
+          </a:bodyPr>
+          <a:lstStyle/>
+          <a:p>
+            <a:endParaRPr lang="fr-FR" dirty="0">
+              <a:ln w="0"/>
+              <a:solidFill>
+                <a:schemeClr val="accent1"/>
+              </a:solidFill>
+              <a:effectLst>
+                <a:outerShdw blurRad="38100" dist="25400" dir="5400000" algn="ctr" rotWithShape="0">
+                  <a:srgbClr val="6E747A">
+                    <a:alpha val="43000"/>
+                  </a:srgbClr>
+                </a:outerShdw>
+              </a:effectLst>
+            </a:endParaRPr>
+          </a:p>
+          <a:p>
+            <a:pPr marL="0" indent="0">
+              <a:buNone/>
+            </a:pPr>
+            <a:r>
+              <a:rPr lang="fr-FR" dirty="0">
+                <a:ln w="0"/>
+                <a:solidFill>
+                  <a:schemeClr val="accent1"/>
+                </a:solidFill>
+                <a:effectLst>
+                  <a:outerShdw blurRad="38100" dist="25400" dir="5400000" algn="ctr" rotWithShape="0">
+                    <a:srgbClr val="6E747A">
+                      <a:alpha val="43000"/>
+                    </a:srgbClr>
+                  </a:outerShdw>
+                </a:effectLst>
+              </a:rPr>
+              <a:t>Mettre en place un plan d’actions : </a:t>
+            </a:r>
+          </a:p>
+          <a:p>
+            <a:pPr marL="857250" indent="-285750">
+              <a:buFont typeface="Arial" panose="020B0604020202020204" pitchFamily="34" charset="0"/>
+              <a:buChar char="•"/>
+            </a:pPr>
+            <a:r>
+              <a:rPr lang="fr-FR" sz="1600" dirty="0">
+                <a:ln w="0"/>
+                <a:solidFill>
+                  <a:schemeClr val="accent1"/>
+                </a:solidFill>
+                <a:effectLst>
+                  <a:outerShdw blurRad="38100" dist="25400" dir="5400000" algn="ctr" rotWithShape="0">
+                    <a:srgbClr val="6E747A">
+                      <a:alpha val="43000"/>
+                    </a:srgbClr>
+                  </a:outerShdw>
+                </a:effectLst>
+                <a:latin typeface="Arial" panose="020B0604020202020204" pitchFamily="34" charset="0"/>
+                <a:cs typeface="Arial" panose="020B0604020202020204" pitchFamily="34" charset="0"/>
+              </a:rPr>
+              <a:t>identification précoce des situations de surcharge</a:t>
+            </a:r>
+          </a:p>
+          <a:p>
+            <a:pPr marL="857250" indent="-285750">
+              <a:buFont typeface="Arial" panose="020B0604020202020204" pitchFamily="34" charset="0"/>
+              <a:buChar char="•"/>
+            </a:pPr>
+            <a:r>
+              <a:rPr lang="fr-FR" sz="1600" dirty="0">
+                <a:ln w="0"/>
+                <a:solidFill>
+                  <a:schemeClr val="accent1"/>
+                </a:solidFill>
+                <a:effectLst>
+                  <a:outerShdw blurRad="38100" dist="25400" dir="5400000" algn="ctr" rotWithShape="0">
+                    <a:srgbClr val="6E747A">
+                      <a:alpha val="43000"/>
+                    </a:srgbClr>
+                  </a:outerShdw>
+                </a:effectLst>
+                <a:latin typeface="Arial" panose="020B0604020202020204" pitchFamily="34" charset="0"/>
+                <a:cs typeface="Arial" panose="020B0604020202020204" pitchFamily="34" charset="0"/>
+              </a:rPr>
+              <a:t>analyser les équipes présentant un volume élevé d'heures supplémentaires</a:t>
+            </a:r>
+          </a:p>
+          <a:p>
+            <a:pPr marL="857250" indent="-285750">
+              <a:buFont typeface="Arial" panose="020B0604020202020204" pitchFamily="34" charset="0"/>
+              <a:buChar char="•"/>
+            </a:pPr>
+            <a:r>
+              <a:rPr lang="fr-FR" sz="1600" dirty="0">
+                <a:ln w="0"/>
+                <a:solidFill>
+                  <a:schemeClr val="accent1"/>
+                </a:solidFill>
+                <a:effectLst>
+                  <a:outerShdw blurRad="38100" dist="25400" dir="5400000" algn="ctr" rotWithShape="0">
+                    <a:srgbClr val="6E747A">
+                      <a:alpha val="43000"/>
+                    </a:srgbClr>
+                  </a:outerShdw>
+                </a:effectLst>
+                <a:latin typeface="Arial" panose="020B0604020202020204" pitchFamily="34" charset="0"/>
+                <a:cs typeface="Arial" panose="020B0604020202020204" pitchFamily="34" charset="0"/>
+              </a:rPr>
+              <a:t>proposer un rééquilibrage des charges lorsque cela est nécessaire</a:t>
+            </a:r>
+          </a:p>
+        </p:txBody>
+      </p:sp>
+    </p:spTree>
+    <p:extLst>
+      <p:ext uri="{BB962C8B-B14F-4D97-AF65-F5344CB8AC3E}">
+        <p14:creationId xmlns:p14="http://schemas.microsoft.com/office/powerpoint/2010/main" val="1914701374"/>
+      </p:ext>
+    </p:extLst>
+  </p:cSld>
+  <p:clrMapOvr>
+    <a:masterClrMapping/>
+  </p:clrMapOvr>
+</p:sld>
+</file>
+
+<file path=ppt/slides/slide45.xml><?xml version="1.0" encoding="utf-8"?>
+<p:sld xmlns:a="http://schemas.openxmlformats.org/drawingml/2006/main" xmlns:r="http://schemas.openxmlformats.org/officeDocument/2006/relationships" xmlns:p="http://schemas.openxmlformats.org/presentationml/2006/main">
+  <p:cSld>
+    <p:spTree>
+      <p:nvGrpSpPr>
+        <p:cNvPr id="1" name="">
+          <a:extLst>
+            <a:ext uri="{FF2B5EF4-FFF2-40B4-BE49-F238E27FC236}">
+              <a16:creationId xmlns:a16="http://schemas.microsoft.com/office/drawing/2014/main" id="{AE0BF4E3-7AEA-C2D0-9BD7-C81D15B27943}"/>
+            </a:ext>
+          </a:extLst>
+        </p:cNvPr>
+        <p:cNvGrpSpPr/>
+        <p:nvPr/>
+      </p:nvGrpSpPr>
+      <p:grpSpPr>
+        <a:xfrm>
+          <a:off x="0" y="0"/>
+          <a:ext cx="0" cy="0"/>
+          <a:chOff x="0" y="0"/>
+          <a:chExt cx="0" cy="0"/>
+        </a:xfrm>
+      </p:grpSpPr>
+      <p:sp>
+        <p:nvSpPr>
+          <p:cNvPr id="2" name="Titre 1">
+            <a:extLst>
+              <a:ext uri="{FF2B5EF4-FFF2-40B4-BE49-F238E27FC236}">
+                <a16:creationId xmlns:a16="http://schemas.microsoft.com/office/drawing/2014/main" id="{C3A7C98A-4F90-ED76-274C-0D2366AD029F}"/>
+              </a:ext>
+            </a:extLst>
+          </p:cNvPr>
+          <p:cNvSpPr>
+            <a:spLocks noGrp="1"/>
+          </p:cNvSpPr>
+          <p:nvPr>
+            <p:ph type="title"/>
+          </p:nvPr>
+        </p:nvSpPr>
+        <p:spPr/>
+        <p:txBody>
+          <a:bodyPr/>
+          <a:lstStyle/>
+          <a:p>
+            <a:r>
+              <a:rPr lang="fr-FR" dirty="0"/>
+              <a:t>Avertissement</a:t>
+            </a:r>
+          </a:p>
+        </p:txBody>
+      </p:sp>
+      <p:sp>
+        <p:nvSpPr>
+          <p:cNvPr id="4" name="ZoneTexte 3">
+            <a:extLst>
+              <a:ext uri="{FF2B5EF4-FFF2-40B4-BE49-F238E27FC236}">
+                <a16:creationId xmlns:a16="http://schemas.microsoft.com/office/drawing/2014/main" id="{86472822-40DF-488E-5438-C028AB871E31}"/>
+              </a:ext>
+            </a:extLst>
+          </p:cNvPr>
+          <p:cNvSpPr txBox="1"/>
+          <p:nvPr/>
+        </p:nvSpPr>
+        <p:spPr>
+          <a:xfrm>
+            <a:off x="1600200" y="3395590"/>
+            <a:ext cx="9201150" cy="1200329"/>
+          </a:xfrm>
+          <a:prstGeom prst="rect">
+            <a:avLst/>
+          </a:prstGeom>
+          <a:noFill/>
+        </p:spPr>
+        <p:txBody>
+          <a:bodyPr wrap="square">
+            <a:spAutoFit/>
+          </a:bodyPr>
+          <a:lstStyle/>
+          <a:p>
+            <a:pPr algn="just"/>
+            <a:r>
+              <a:rPr lang="fr-FR" dirty="0"/>
+              <a:t>Les recommandations proposées reposent sur les facteurs associés aux prédictions du modèle. Elles ne doivent pas être interprétées comme des causes certaines de départ. Une validation complémentaire par des analyses RH qualitatives (entretiens, enquêtes internes) est nécessaire avant toute décision opérationnelle.</a:t>
+            </a:r>
+          </a:p>
+        </p:txBody>
+      </p:sp>
+    </p:spTree>
+    <p:extLst>
+      <p:ext uri="{BB962C8B-B14F-4D97-AF65-F5344CB8AC3E}">
+        <p14:creationId xmlns:p14="http://schemas.microsoft.com/office/powerpoint/2010/main" val="1890865514"/>
+      </p:ext>
+    </p:extLst>
+  </p:cSld>
+  <p:clrMapOvr>
+    <a:masterClrMapping/>
+  </p:clrMapOvr>
+</p:sld>
+</file>
+
+<file path=ppt/slides/slide46.xml><?xml version="1.0" encoding="utf-8"?>
 <p:sld xmlns:a="http://schemas.openxmlformats.org/drawingml/2006/main" xmlns:r="http://schemas.openxmlformats.org/officeDocument/2006/relationships" xmlns:p="http://schemas.openxmlformats.org/presentationml/2006/main">
   <p:cSld>
     <p:bg>

</xml_diff>